<commit_message>
Clase 2: slides de texto aligeradas y tablas de malas preguntas e hipótesis reparadas
Co-Authored-By: Claude Fable 5 <noreply@anthropic.com>
</commit_message>
<xml_diff>
--- a/presentaciones/clase02_eda_descriptiva.pptx
+++ b/presentaciones/clase02_eda_descriptiva.pptx
@@ -33,6 +33,8 @@
     <p:sldId id="281" r:id="rId32"/>
     <p:sldId id="282" r:id="rId33"/>
     <p:sldId id="283" r:id="rId34"/>
+    <p:sldId id="284" r:id="rId35"/>
+    <p:sldId id="285" r:id="rId36"/>
   </p:sldIdLst>
   <p:sldSz cx="9144000" cy="5138928" type="screen4x3"/>
   <p:notesSz cx="6858000" cy="9144000"/>
@@ -4177,7 +4179,7 @@
                 </a:solidFill>
                 <a:latin typeface="Fira Sans"/>
               </a:rPr>
-              <a:t>Se detectan con isna().sum() por columna, o comparando el count de describe() con el largo de la tabla.</a:t>
+              <a:t>Detección: isna().sum(), o el count de describe() contra len.</a:t>
             </a:r>
           </a:p>
           <a:p>
@@ -4205,7 +4207,7 @@
                 </a:solidFill>
                 <a:latin typeface="Fira Sans"/>
               </a:rPr>
-              <a:t>En la EOD, TiempoViaje tiene 278 faltantes entre 113.591 viajes.</a:t>
+              <a:t>En la EOD: TiempoViaje tiene 278 faltantes entre 113.591 viajes.</a:t>
             </a:r>
           </a:p>
           <a:p>
@@ -4233,7 +4235,7 @@
                 </a:solidFill>
                 <a:latin typeface="Fira Sans"/>
               </a:rPr>
-              <a:t>Un NaN no siempre es un error: en los factores de expansión significa "no aplica" (cada persona respondió por un solo tipo de día).</a:t>
+              <a:t>Un NaN no siempre es error: en los factores de expansión significa "no aplica".</a:t>
             </a:r>
           </a:p>
           <a:p>
@@ -4261,7 +4263,7 @@
                 </a:solidFill>
                 <a:latin typeface="Fira Sans"/>
               </a:rPr>
-              <a:t>Opciones: eliminar las filas, imputar un valor, o dejarlos y que cada cálculo los excluya. Cualquiera sirve; lo obligatorio es decidirlo explícitamente y documentarlo.</a:t>
+              <a:t>Opciones: eliminar, imputar o dejar que cada cálculo los excluya. Lo obligatorio: decidir y documentar.</a:t>
             </a:r>
           </a:p>
         </p:txBody>
@@ -4436,7 +4438,7 @@
                 </a:solidFill>
                 <a:latin typeface="Fira Sans"/>
               </a:rPr>
-              <a:t>Conviene revisar dos niveles: la fila completa y la llave que debería ser única (por ejemplo, el identificador del viaje).</a:t>
+              <a:t>Dos niveles: la fila completa y la llave que debería ser única.</a:t>
             </a:r>
           </a:p>
           <a:p>
@@ -4464,7 +4466,7 @@
                 </a:solidFill>
                 <a:latin typeface="Fira Sans"/>
               </a:rPr>
-              <a:t>En la EOD ambas revisiones dan cero. Un chequeo que da cero también es un hallazgo: queda descartada una fuente de error.</a:t>
+              <a:t>En la EOD ambos chequeos dan cero; un cero también es un hallazgo.</a:t>
             </a:r>
           </a:p>
           <a:p>
@@ -4492,7 +4494,7 @@
                 </a:solidFill>
                 <a:latin typeface="Fira Sans"/>
               </a:rPr>
-              <a:t>Los duplicados aparecen sobre todo al combinar tablas: un merge con llaves repetidas multiplica filas.</a:t>
+              <a:t>El riesgo típico: un merge con llaves repetidas multiplica filas.</a:t>
             </a:r>
           </a:p>
         </p:txBody>
@@ -6057,7 +6059,7 @@
                 </a:solidFill>
                 <a:latin typeface="Fira Sans"/>
               </a:rPr>
-              <a:t>De interés real para alguien: una audiencia concreta que usaría la respuesta (Peng y Matsui, 2015).</a:t>
+              <a:t>De interés real: una audiencia concreta usaría la respuesta (Peng y Matsui, 2015).</a:t>
             </a:r>
           </a:p>
           <a:p>
@@ -6170,34 +6172,6 @@
                 <a:latin typeface="Fira Sans"/>
               </a:rPr>
               <a:t>Específica: nombra variables y población, no generalidades.</a:t>
-            </a:r>
-          </a:p>
-          <a:p>
-            <a:pPr>
-              <a:lnSpc>
-                <a:spcPct val="112000"/>
-              </a:lnSpc>
-              <a:spcAft>
-                <a:spcPts val="900"/>
-              </a:spcAft>
-            </a:pPr>
-            <a:r>
-              <a:rPr sz="1800" b="1">
-                <a:solidFill>
-                  <a:srgbClr val="E0A437"/>
-                </a:solidFill>
-                <a:latin typeface="Fira Sans"/>
-              </a:rPr>
-              <a:t>▸ </a:t>
-            </a:r>
-            <a:r>
-              <a:rPr sz="1800" b="1">
-                <a:solidFill>
-                  <a:srgbClr val="1D3557"/>
-                </a:solidFill>
-                <a:latin typeface="Fira Sans"/>
-              </a:rPr>
-              <a:t>Contraste: "¿cómo mejorar las ventas?" no cumple; "¿qué categorías de producto caen en invierno en las sucursales del sur?" sí.</a:t>
             </a:r>
           </a:p>
         </p:txBody>
@@ -6293,35 +6267,370 @@
                 </a:solidFill>
                 <a:latin typeface="Fira Sans"/>
               </a:rPr>
-              <a:t>El ciclo PPDAC</a:t>
-            </a:r>
-          </a:p>
-        </p:txBody>
-      </p:sp>
-      <p:pic>
-        <p:nvPicPr>
-          <p:cNvPr id="4" name="Picture 3" descr="07_ppdac.png"/>
-          <p:cNvPicPr>
-            <a:picLocks noChangeAspect="1"/>
-          </p:cNvPicPr>
+              <a:t>Malas preguntas, reparadas</a:t>
+            </a:r>
+          </a:p>
+        </p:txBody>
+      </p:sp>
+      <p:graphicFrame>
+        <p:nvGraphicFramePr>
+          <p:cNvPr id="4" name="Table 3"/>
+          <p:cNvGraphicFramePr>
+            <a:graphicFrameLocks noGrp="1"/>
+          </p:cNvGraphicFramePr>
           <p:nvPr/>
-        </p:nvPicPr>
-        <p:blipFill>
-          <a:blip r:embed="rId2"/>
-          <a:stretch>
-            <a:fillRect/>
-          </a:stretch>
-        </p:blipFill>
-        <p:spPr>
-          <a:xfrm>
-            <a:off x="1417319" y="1143000"/>
-            <a:ext cx="6309360" cy="2477421"/>
-          </a:xfrm>
-          <a:prstGeom prst="rect">
-            <a:avLst/>
-          </a:prstGeom>
-        </p:spPr>
-      </p:pic>
+        </p:nvGraphicFramePr>
+        <p:xfrm>
+          <a:off x="502920" y="1188720"/>
+          <a:ext cx="8138160" cy="2880360"/>
+        </p:xfrm>
+        <a:graphic>
+          <a:graphicData uri="http://schemas.openxmlformats.org/drawingml/2006/table">
+            <a:tbl>
+              <a:tblPr firstRow="1" bandRow="1">
+                <a:tableStyleId>{5C22544A-7EE6-4342-B048-85BDC9FD1C3A}</a:tableStyleId>
+              </a:tblPr>
+              <a:tblGrid>
+                <a:gridCol w="2286000"/>
+                <a:gridCol w="2377440"/>
+                <a:gridCol w="3474720"/>
+              </a:tblGrid>
+              <a:tr h="411480">
+                <a:tc>
+                  <a:txBody>
+                    <a:bodyPr wrap="square"/>
+                    <a:lstStyle/>
+                    <a:p>
+                      <a:pPr>
+                        <a:lnSpc>
+                          <a:spcPct val="108000"/>
+                        </a:lnSpc>
+                      </a:pPr>
+                      <a:r>
+                        <a:rPr sz="1350" b="1">
+                          <a:solidFill>
+                            <a:srgbClr val="FFFFFF"/>
+                          </a:solidFill>
+                          <a:latin typeface="Fira Sans"/>
+                        </a:rPr>
+                        <a:t>La pregunta</a:t>
+                      </a:r>
+                    </a:p>
+                  </a:txBody>
+                  <a:tcPr>
+                    <a:solidFill>
+                      <a:srgbClr val="1D3557"/>
+                    </a:solidFill>
+                  </a:tcPr>
+                </a:tc>
+                <a:tc>
+                  <a:txBody>
+                    <a:bodyPr wrap="square"/>
+                    <a:lstStyle/>
+                    <a:p>
+                      <a:pPr>
+                        <a:lnSpc>
+                          <a:spcPct val="108000"/>
+                        </a:lnSpc>
+                      </a:pPr>
+                      <a:r>
+                        <a:rPr sz="1350" b="1">
+                          <a:solidFill>
+                            <a:srgbClr val="FFFFFF"/>
+                          </a:solidFill>
+                          <a:latin typeface="Fira Sans"/>
+                        </a:rPr>
+                        <a:t>El problema</a:t>
+                      </a:r>
+                    </a:p>
+                  </a:txBody>
+                  <a:tcPr>
+                    <a:solidFill>
+                      <a:srgbClr val="1D3557"/>
+                    </a:solidFill>
+                  </a:tcPr>
+                </a:tc>
+                <a:tc>
+                  <a:txBody>
+                    <a:bodyPr wrap="square"/>
+                    <a:lstStyle/>
+                    <a:p>
+                      <a:pPr>
+                        <a:lnSpc>
+                          <a:spcPct val="108000"/>
+                        </a:lnSpc>
+                      </a:pPr>
+                      <a:r>
+                        <a:rPr sz="1350" b="1">
+                          <a:solidFill>
+                            <a:srgbClr val="FFFFFF"/>
+                          </a:solidFill>
+                          <a:latin typeface="Fira Sans"/>
+                        </a:rPr>
+                        <a:t>Una versión que funciona</a:t>
+                      </a:r>
+                    </a:p>
+                  </a:txBody>
+                  <a:tcPr>
+                    <a:solidFill>
+                      <a:srgbClr val="1D3557"/>
+                    </a:solidFill>
+                  </a:tcPr>
+                </a:tc>
+              </a:tr>
+              <a:tr h="822960">
+                <a:tc>
+                  <a:txBody>
+                    <a:bodyPr wrap="square"/>
+                    <a:lstStyle/>
+                    <a:p>
+                      <a:pPr>
+                        <a:lnSpc>
+                          <a:spcPct val="108000"/>
+                        </a:lnSpc>
+                      </a:pPr>
+                      <a:r>
+                        <a:rPr sz="1250" b="0">
+                          <a:solidFill>
+                            <a:srgbClr val="000000"/>
+                          </a:solidFill>
+                          <a:latin typeface="Fira Sans"/>
+                        </a:rPr>
+                        <a:t>¿Cómo mejorar las ventas?</a:t>
+                      </a:r>
+                    </a:p>
+                  </a:txBody>
+                  <a:tcPr>
+                    <a:solidFill>
+                      <a:srgbClr val="FFFFFF"/>
+                    </a:solidFill>
+                  </a:tcPr>
+                </a:tc>
+                <a:tc>
+                  <a:txBody>
+                    <a:bodyPr wrap="square"/>
+                    <a:lstStyle/>
+                    <a:p>
+                      <a:pPr>
+                        <a:lnSpc>
+                          <a:spcPct val="108000"/>
+                        </a:lnSpc>
+                      </a:pPr>
+                      <a:r>
+                        <a:rPr sz="1250" b="0">
+                          <a:solidFill>
+                            <a:srgbClr val="000000"/>
+                          </a:solidFill>
+                          <a:latin typeface="Fira Sans"/>
+                        </a:rPr>
+                        <a:t>No dice qué medir ni dónde</a:t>
+                      </a:r>
+                    </a:p>
+                  </a:txBody>
+                  <a:tcPr>
+                    <a:solidFill>
+                      <a:srgbClr val="FFFFFF"/>
+                    </a:solidFill>
+                  </a:tcPr>
+                </a:tc>
+                <a:tc>
+                  <a:txBody>
+                    <a:bodyPr wrap="square"/>
+                    <a:lstStyle/>
+                    <a:p>
+                      <a:pPr>
+                        <a:lnSpc>
+                          <a:spcPct val="108000"/>
+                        </a:lnSpc>
+                      </a:pPr>
+                      <a:r>
+                        <a:rPr sz="1250" b="0">
+                          <a:solidFill>
+                            <a:srgbClr val="000000"/>
+                          </a:solidFill>
+                          <a:latin typeface="Fira Sans"/>
+                        </a:rPr>
+                        <a:t>¿Qué categorías de producto caen en invierno en las sucursales del sur?</a:t>
+                      </a:r>
+                    </a:p>
+                  </a:txBody>
+                  <a:tcPr>
+                    <a:solidFill>
+                      <a:srgbClr val="FFFFFF"/>
+                    </a:solidFill>
+                  </a:tcPr>
+                </a:tc>
+              </a:tr>
+              <a:tr h="822960">
+                <a:tc>
+                  <a:txBody>
+                    <a:bodyPr wrap="square"/>
+                    <a:lstStyle/>
+                    <a:p>
+                      <a:pPr>
+                        <a:lnSpc>
+                          <a:spcPct val="108000"/>
+                        </a:lnSpc>
+                      </a:pPr>
+                      <a:r>
+                        <a:rPr sz="1250" b="0">
+                          <a:solidFill>
+                            <a:srgbClr val="000000"/>
+                          </a:solidFill>
+                          <a:latin typeface="Fira Sans"/>
+                        </a:rPr>
+                        <a:t>¿Sirve la IA para mi empresa?</a:t>
+                      </a:r>
+                    </a:p>
+                  </a:txBody>
+                  <a:tcPr>
+                    <a:solidFill>
+                      <a:srgbClr val="FFFFFF"/>
+                    </a:solidFill>
+                  </a:tcPr>
+                </a:tc>
+                <a:tc>
+                  <a:txBody>
+                    <a:bodyPr wrap="square"/>
+                    <a:lstStyle/>
+                    <a:p>
+                      <a:pPr>
+                        <a:lnSpc>
+                          <a:spcPct val="108000"/>
+                        </a:lnSpc>
+                      </a:pPr>
+                      <a:r>
+                        <a:rPr sz="1250" b="0">
+                          <a:solidFill>
+                            <a:srgbClr val="000000"/>
+                          </a:solidFill>
+                          <a:latin typeface="Fira Sans"/>
+                        </a:rPr>
+                        <a:t>Sin variables ni población definidas</a:t>
+                      </a:r>
+                    </a:p>
+                  </a:txBody>
+                  <a:tcPr>
+                    <a:solidFill>
+                      <a:srgbClr val="FFFFFF"/>
+                    </a:solidFill>
+                  </a:tcPr>
+                </a:tc>
+                <a:tc>
+                  <a:txBody>
+                    <a:bodyPr wrap="square"/>
+                    <a:lstStyle/>
+                    <a:p>
+                      <a:pPr>
+                        <a:lnSpc>
+                          <a:spcPct val="108000"/>
+                        </a:lnSpc>
+                      </a:pPr>
+                      <a:r>
+                        <a:rPr sz="1250" b="0">
+                          <a:solidFill>
+                            <a:srgbClr val="000000"/>
+                          </a:solidFill>
+                          <a:latin typeface="Fira Sans"/>
+                        </a:rPr>
+                        <a:t>¿Cuántas horas de revisión manual ahorra clasificar los reclamos automáticamente?</a:t>
+                      </a:r>
+                    </a:p>
+                  </a:txBody>
+                  <a:tcPr>
+                    <a:solidFill>
+                      <a:srgbClr val="FFFFFF"/>
+                    </a:solidFill>
+                  </a:tcPr>
+                </a:tc>
+              </a:tr>
+              <a:tr h="822960">
+                <a:tc>
+                  <a:txBody>
+                    <a:bodyPr wrap="square"/>
+                    <a:lstStyle/>
+                    <a:p>
+                      <a:pPr>
+                        <a:lnSpc>
+                          <a:spcPct val="108000"/>
+                        </a:lnSpc>
+                      </a:pPr>
+                      <a:r>
+                        <a:rPr sz="1250" b="0">
+                          <a:solidFill>
+                            <a:srgbClr val="000000"/>
+                          </a:solidFill>
+                          <a:latin typeface="Fira Sans"/>
+                        </a:rPr>
+                        <a:t>¿Por qué renuncian los empleados?</a:t>
+                      </a:r>
+                    </a:p>
+                  </a:txBody>
+                  <a:tcPr>
+                    <a:solidFill>
+                      <a:srgbClr val="FFFFFF"/>
+                    </a:solidFill>
+                  </a:tcPr>
+                </a:tc>
+                <a:tc>
+                  <a:txBody>
+                    <a:bodyPr wrap="square"/>
+                    <a:lstStyle/>
+                    <a:p>
+                      <a:pPr>
+                        <a:lnSpc>
+                          <a:spcPct val="108000"/>
+                        </a:lnSpc>
+                      </a:pPr>
+                      <a:r>
+                        <a:rPr sz="1250" b="0">
+                          <a:solidFill>
+                            <a:srgbClr val="000000"/>
+                          </a:solidFill>
+                          <a:latin typeface="Fira Sans"/>
+                        </a:rPr>
+                        <a:t>Causal; los datos solo permiten explorar</a:t>
+                      </a:r>
+                    </a:p>
+                  </a:txBody>
+                  <a:tcPr>
+                    <a:solidFill>
+                      <a:srgbClr val="FFFFFF"/>
+                    </a:solidFill>
+                  </a:tcPr>
+                </a:tc>
+                <a:tc>
+                  <a:txBody>
+                    <a:bodyPr wrap="square"/>
+                    <a:lstStyle/>
+                    <a:p>
+                      <a:pPr>
+                        <a:lnSpc>
+                          <a:spcPct val="108000"/>
+                        </a:lnSpc>
+                      </a:pPr>
+                      <a:r>
+                        <a:rPr sz="1250" b="0">
+                          <a:solidFill>
+                            <a:srgbClr val="000000"/>
+                          </a:solidFill>
+                          <a:latin typeface="Fira Sans"/>
+                        </a:rPr>
+                        <a:t>¿Qué características comparten quienes renunciaron durante 2025?</a:t>
+                      </a:r>
+                    </a:p>
+                  </a:txBody>
+                  <a:tcPr>
+                    <a:solidFill>
+                      <a:srgbClr val="FFFFFF"/>
+                    </a:solidFill>
+                  </a:tcPr>
+                </a:tc>
+              </a:tr>
+            </a:tbl>
+          </a:graphicData>
+        </a:graphic>
+      </p:graphicFrame>
       <p:sp>
         <p:nvSpPr>
           <p:cNvPr id="5" name="TextBox 4"/>
@@ -6330,8 +6639,8 @@
         </p:nvSpPr>
         <p:spPr>
           <a:xfrm>
-            <a:off x="704088" y="4434840"/>
-            <a:ext cx="7744968" cy="457200"/>
+            <a:off x="502920" y="4434840"/>
+            <a:ext cx="8138160" cy="548640"/>
           </a:xfrm>
           <a:prstGeom prst="rect">
             <a:avLst/>
@@ -6351,7 +6660,7 @@
                 </a:solidFill>
                 <a:latin typeface="Fira Sans"/>
               </a:rPr>
-              <a:t>Problema, plan, datos, análisis y conclusión (Wild y Pfannkuch, 1999): la formulación del Capstone es la etapa de problema y plan de este ciclo.</a:t>
+              <a:t>La reparación típica: nombrar la variable, la población y el periodo, y bajar la ambición causal al tipo de pregunta que los datos permiten.</a:t>
             </a:r>
           </a:p>
         </p:txBody>
@@ -6447,21 +6756,380 @@
                 </a:solidFill>
                 <a:latin typeface="Fira Sans"/>
               </a:rPr>
-              <a:t>De la pregunta a la hipótesis</a:t>
-            </a:r>
-          </a:p>
-        </p:txBody>
-      </p:sp>
-      <p:sp>
-        <p:nvSpPr>
-          <p:cNvPr id="4" name="TextBox 3"/>
+              <a:t>Malas hipótesis, reparadas</a:t>
+            </a:r>
+          </a:p>
+        </p:txBody>
+      </p:sp>
+      <p:graphicFrame>
+        <p:nvGraphicFramePr>
+          <p:cNvPr id="4" name="Table 3"/>
+          <p:cNvGraphicFramePr>
+            <a:graphicFrameLocks noGrp="1"/>
+          </p:cNvGraphicFramePr>
+          <p:nvPr/>
+        </p:nvGraphicFramePr>
+        <p:xfrm>
+          <a:off x="502920" y="1188720"/>
+          <a:ext cx="8138160" cy="2880360"/>
+        </p:xfrm>
+        <a:graphic>
+          <a:graphicData uri="http://schemas.openxmlformats.org/drawingml/2006/table">
+            <a:tbl>
+              <a:tblPr firstRow="1" bandRow="1">
+                <a:tableStyleId>{5C22544A-7EE6-4342-B048-85BDC9FD1C3A}</a:tableStyleId>
+              </a:tblPr>
+              <a:tblGrid>
+                <a:gridCol w="2286000"/>
+                <a:gridCol w="2377440"/>
+                <a:gridCol w="3474720"/>
+              </a:tblGrid>
+              <a:tr h="411480">
+                <a:tc>
+                  <a:txBody>
+                    <a:bodyPr wrap="square"/>
+                    <a:lstStyle/>
+                    <a:p>
+                      <a:pPr>
+                        <a:lnSpc>
+                          <a:spcPct val="108000"/>
+                        </a:lnSpc>
+                      </a:pPr>
+                      <a:r>
+                        <a:rPr sz="1350" b="1">
+                          <a:solidFill>
+                            <a:srgbClr val="FFFFFF"/>
+                          </a:solidFill>
+                          <a:latin typeface="Fira Sans"/>
+                        </a:rPr>
+                        <a:t>La hipótesis</a:t>
+                      </a:r>
+                    </a:p>
+                  </a:txBody>
+                  <a:tcPr>
+                    <a:solidFill>
+                      <a:srgbClr val="1D3557"/>
+                    </a:solidFill>
+                  </a:tcPr>
+                </a:tc>
+                <a:tc>
+                  <a:txBody>
+                    <a:bodyPr wrap="square"/>
+                    <a:lstStyle/>
+                    <a:p>
+                      <a:pPr>
+                        <a:lnSpc>
+                          <a:spcPct val="108000"/>
+                        </a:lnSpc>
+                      </a:pPr>
+                      <a:r>
+                        <a:rPr sz="1350" b="1">
+                          <a:solidFill>
+                            <a:srgbClr val="FFFFFF"/>
+                          </a:solidFill>
+                          <a:latin typeface="Fira Sans"/>
+                        </a:rPr>
+                        <a:t>El problema</a:t>
+                      </a:r>
+                    </a:p>
+                  </a:txBody>
+                  <a:tcPr>
+                    <a:solidFill>
+                      <a:srgbClr val="1D3557"/>
+                    </a:solidFill>
+                  </a:tcPr>
+                </a:tc>
+                <a:tc>
+                  <a:txBody>
+                    <a:bodyPr wrap="square"/>
+                    <a:lstStyle/>
+                    <a:p>
+                      <a:pPr>
+                        <a:lnSpc>
+                          <a:spcPct val="108000"/>
+                        </a:lnSpc>
+                      </a:pPr>
+                      <a:r>
+                        <a:rPr sz="1350" b="1">
+                          <a:solidFill>
+                            <a:srgbClr val="FFFFFF"/>
+                          </a:solidFill>
+                          <a:latin typeface="Fira Sans"/>
+                        </a:rPr>
+                        <a:t>Una versión verificable</a:t>
+                      </a:r>
+                    </a:p>
+                  </a:txBody>
+                  <a:tcPr>
+                    <a:solidFill>
+                      <a:srgbClr val="1D3557"/>
+                    </a:solidFill>
+                  </a:tcPr>
+                </a:tc>
+              </a:tr>
+              <a:tr h="822960">
+                <a:tc>
+                  <a:txBody>
+                    <a:bodyPr wrap="square"/>
+                    <a:lstStyle/>
+                    <a:p>
+                      <a:pPr>
+                        <a:lnSpc>
+                          <a:spcPct val="108000"/>
+                        </a:lnSpc>
+                      </a:pPr>
+                      <a:r>
+                        <a:rPr sz="1250" b="0">
+                          <a:solidFill>
+                            <a:srgbClr val="000000"/>
+                          </a:solidFill>
+                          <a:latin typeface="Fira Sans"/>
+                        </a:rPr>
+                        <a:t>El marketing influye en las ventas</a:t>
+                      </a:r>
+                    </a:p>
+                  </a:txBody>
+                  <a:tcPr>
+                    <a:solidFill>
+                      <a:srgbClr val="FFFFFF"/>
+                    </a:solidFill>
+                  </a:tcPr>
+                </a:tc>
+                <a:tc>
+                  <a:txBody>
+                    <a:bodyPr wrap="square"/>
+                    <a:lstStyle/>
+                    <a:p>
+                      <a:pPr>
+                        <a:lnSpc>
+                          <a:spcPct val="108000"/>
+                        </a:lnSpc>
+                      </a:pPr>
+                      <a:r>
+                        <a:rPr sz="1250" b="0">
+                          <a:solidFill>
+                            <a:srgbClr val="000000"/>
+                          </a:solidFill>
+                          <a:latin typeface="Fira Sans"/>
+                        </a:rPr>
+                        <a:t>No dice qué marketing ni qué ventas</a:t>
+                      </a:r>
+                    </a:p>
+                  </a:txBody>
+                  <a:tcPr>
+                    <a:solidFill>
+                      <a:srgbClr val="FFFFFF"/>
+                    </a:solidFill>
+                  </a:tcPr>
+                </a:tc>
+                <a:tc>
+                  <a:txBody>
+                    <a:bodyPr wrap="square"/>
+                    <a:lstStyle/>
+                    <a:p>
+                      <a:pPr>
+                        <a:lnSpc>
+                          <a:spcPct val="108000"/>
+                        </a:lnSpc>
+                      </a:pPr>
+                      <a:r>
+                        <a:rPr sz="1250" b="0">
+                          <a:solidFill>
+                            <a:srgbClr val="000000"/>
+                          </a:solidFill>
+                          <a:latin typeface="Fira Sans"/>
+                        </a:rPr>
+                        <a:t>Las semanas con campaña activa venden más que las semanas sin campaña, en la misma sucursal</a:t>
+                      </a:r>
+                    </a:p>
+                  </a:txBody>
+                  <a:tcPr>
+                    <a:solidFill>
+                      <a:srgbClr val="FFFFFF"/>
+                    </a:solidFill>
+                  </a:tcPr>
+                </a:tc>
+              </a:tr>
+              <a:tr h="822960">
+                <a:tc>
+                  <a:txBody>
+                    <a:bodyPr wrap="square"/>
+                    <a:lstStyle/>
+                    <a:p>
+                      <a:pPr>
+                        <a:lnSpc>
+                          <a:spcPct val="108000"/>
+                        </a:lnSpc>
+                      </a:pPr>
+                      <a:r>
+                        <a:rPr sz="1250" b="0">
+                          <a:solidFill>
+                            <a:srgbClr val="000000"/>
+                          </a:solidFill>
+                          <a:latin typeface="Fira Sans"/>
+                        </a:rPr>
+                        <a:t>Los datos mostrarán patrones interesantes</a:t>
+                      </a:r>
+                    </a:p>
+                  </a:txBody>
+                  <a:tcPr>
+                    <a:solidFill>
+                      <a:srgbClr val="FFFFFF"/>
+                    </a:solidFill>
+                  </a:tcPr>
+                </a:tc>
+                <a:tc>
+                  <a:txBody>
+                    <a:bodyPr wrap="square"/>
+                    <a:lstStyle/>
+                    <a:p>
+                      <a:pPr>
+                        <a:lnSpc>
+                          <a:spcPct val="108000"/>
+                        </a:lnSpc>
+                      </a:pPr>
+                      <a:r>
+                        <a:rPr sz="1250" b="0">
+                          <a:solidFill>
+                            <a:srgbClr val="000000"/>
+                          </a:solidFill>
+                          <a:latin typeface="Fira Sans"/>
+                        </a:rPr>
+                        <a:t>No es falsable: cualquier cosa la confirma</a:t>
+                      </a:r>
+                    </a:p>
+                  </a:txBody>
+                  <a:tcPr>
+                    <a:solidFill>
+                      <a:srgbClr val="FFFFFF"/>
+                    </a:solidFill>
+                  </a:tcPr>
+                </a:tc>
+                <a:tc>
+                  <a:txBody>
+                    <a:bodyPr wrap="square"/>
+                    <a:lstStyle/>
+                    <a:p>
+                      <a:pPr>
+                        <a:lnSpc>
+                          <a:spcPct val="108000"/>
+                        </a:lnSpc>
+                      </a:pPr>
+                      <a:r>
+                        <a:rPr sz="1250" b="0">
+                          <a:solidFill>
+                            <a:srgbClr val="000000"/>
+                          </a:solidFill>
+                          <a:latin typeface="Fira Sans"/>
+                        </a:rPr>
+                        <a:t>Los reclamos aumentan en los meses de mayor demanda</a:t>
+                      </a:r>
+                    </a:p>
+                  </a:txBody>
+                  <a:tcPr>
+                    <a:solidFill>
+                      <a:srgbClr val="FFFFFF"/>
+                    </a:solidFill>
+                  </a:tcPr>
+                </a:tc>
+              </a:tr>
+              <a:tr h="822960">
+                <a:tc>
+                  <a:txBody>
+                    <a:bodyPr wrap="square"/>
+                    <a:lstStyle/>
+                    <a:p>
+                      <a:pPr>
+                        <a:lnSpc>
+                          <a:spcPct val="108000"/>
+                        </a:lnSpc>
+                      </a:pPr>
+                      <a:r>
+                        <a:rPr sz="1250" b="0">
+                          <a:solidFill>
+                            <a:srgbClr val="000000"/>
+                          </a:solidFill>
+                          <a:latin typeface="Fira Sans"/>
+                        </a:rPr>
+                        <a:t>Los viajes largos son culpa del transporte público</a:t>
+                      </a:r>
+                    </a:p>
+                  </a:txBody>
+                  <a:tcPr>
+                    <a:solidFill>
+                      <a:srgbClr val="FFFFFF"/>
+                    </a:solidFill>
+                  </a:tcPr>
+                </a:tc>
+                <a:tc>
+                  <a:txBody>
+                    <a:bodyPr wrap="square"/>
+                    <a:lstStyle/>
+                    <a:p>
+                      <a:pPr>
+                        <a:lnSpc>
+                          <a:spcPct val="108000"/>
+                        </a:lnSpc>
+                      </a:pPr>
+                      <a:r>
+                        <a:rPr sz="1250" b="0">
+                          <a:solidFill>
+                            <a:srgbClr val="000000"/>
+                          </a:solidFill>
+                          <a:latin typeface="Fira Sans"/>
+                        </a:rPr>
+                        <a:t>Atribuye causa donde solo hay asociación</a:t>
+                      </a:r>
+                    </a:p>
+                  </a:txBody>
+                  <a:tcPr>
+                    <a:solidFill>
+                      <a:srgbClr val="FFFFFF"/>
+                    </a:solidFill>
+                  </a:tcPr>
+                </a:tc>
+                <a:tc>
+                  <a:txBody>
+                    <a:bodyPr wrap="square"/>
+                    <a:lstStyle/>
+                    <a:p>
+                      <a:pPr>
+                        <a:lnSpc>
+                          <a:spcPct val="108000"/>
+                        </a:lnSpc>
+                      </a:pPr>
+                      <a:r>
+                        <a:rPr sz="1250" b="0">
+                          <a:solidFill>
+                            <a:srgbClr val="000000"/>
+                          </a:solidFill>
+                          <a:latin typeface="Fira Sans"/>
+                        </a:rPr>
+                        <a:t>Los viajes en transporte público duran en promedio más que los viajes en auto</a:t>
+                      </a:r>
+                    </a:p>
+                  </a:txBody>
+                  <a:tcPr>
+                    <a:solidFill>
+                      <a:srgbClr val="FFFFFF"/>
+                    </a:solidFill>
+                  </a:tcPr>
+                </a:tc>
+              </a:tr>
+            </a:tbl>
+          </a:graphicData>
+        </a:graphic>
+      </p:graphicFrame>
+      <p:sp>
+        <p:nvSpPr>
+          <p:cNvPr id="5" name="TextBox 4"/>
           <p:cNvSpPr txBox="1"/>
           <p:nvPr/>
         </p:nvSpPr>
         <p:spPr>
           <a:xfrm>
-            <a:off x="704088" y="1353312"/>
-            <a:ext cx="7744968" cy="3300984"/>
+            <a:off x="502920" y="4434840"/>
+            <a:ext cx="8138160" cy="548640"/>
           </a:xfrm>
           <a:prstGeom prst="rect">
             <a:avLst/>
@@ -6474,143 +7142,14 @@
           </a:bodyPr>
           <a:lstStyle/>
           <a:p>
-            <a:pPr>
-              <a:lnSpc>
-                <a:spcPct val="112000"/>
-              </a:lnSpc>
-              <a:spcAft>
-                <a:spcPts val="900"/>
-              </a:spcAft>
-            </a:pPr>
-            <a:r>
-              <a:rPr sz="1800" b="1">
-                <a:solidFill>
-                  <a:srgbClr val="E0A437"/>
-                </a:solidFill>
-                <a:latin typeface="Fira Sans"/>
-              </a:rPr>
-              <a:t>▸ </a:t>
-            </a:r>
-            <a:r>
-              <a:rPr sz="1800" b="0">
-                <a:solidFill>
-                  <a:srgbClr val="000000"/>
-                </a:solidFill>
-                <a:latin typeface="Fira Sans"/>
-              </a:rPr>
-              <a:t>Una hipótesis es una afirmación verificable: nombra variables medibles y la relación esperada entre ellas.</a:t>
-            </a:r>
-          </a:p>
-          <a:p>
-            <a:pPr>
-              <a:lnSpc>
-                <a:spcPct val="112000"/>
-              </a:lnSpc>
-              <a:spcAft>
-                <a:spcPts val="900"/>
-              </a:spcAft>
-            </a:pPr>
-            <a:r>
-              <a:rPr sz="1800" b="1">
-                <a:solidFill>
-                  <a:srgbClr val="E0A437"/>
-                </a:solidFill>
-                <a:latin typeface="Fira Sans"/>
-              </a:rPr>
-              <a:t>▸ </a:t>
-            </a:r>
-            <a:r>
-              <a:rPr sz="1800" b="0">
-                <a:solidFill>
-                  <a:srgbClr val="000000"/>
-                </a:solidFill>
-                <a:latin typeface="Fira Sans"/>
-              </a:rPr>
-              <a:t>Pregunta: ¿la duración del viaje depende del modo de transporte?</a:t>
-            </a:r>
-          </a:p>
-          <a:p>
-            <a:pPr>
-              <a:lnSpc>
-                <a:spcPct val="112000"/>
-              </a:lnSpc>
-              <a:spcAft>
-                <a:spcPts val="900"/>
-              </a:spcAft>
-            </a:pPr>
-            <a:r>
-              <a:rPr sz="1800" b="1">
-                <a:solidFill>
-                  <a:srgbClr val="E0A437"/>
-                </a:solidFill>
-                <a:latin typeface="Fira Sans"/>
-              </a:rPr>
-              <a:t>▸ </a:t>
-            </a:r>
-            <a:r>
-              <a:rPr sz="1800" b="0">
-                <a:solidFill>
-                  <a:srgbClr val="000000"/>
-                </a:solidFill>
-                <a:latin typeface="Fira Sans"/>
-              </a:rPr>
-              <a:t>Hipótesis: los viajes en transporte público duran en promedio más que los viajes en auto.</a:t>
-            </a:r>
-          </a:p>
-          <a:p>
-            <a:pPr>
-              <a:lnSpc>
-                <a:spcPct val="112000"/>
-              </a:lnSpc>
-              <a:spcAft>
-                <a:spcPts val="900"/>
-              </a:spcAft>
-            </a:pPr>
-            <a:r>
-              <a:rPr sz="1800" b="1">
-                <a:solidFill>
-                  <a:srgbClr val="E0A437"/>
-                </a:solidFill>
-                <a:latin typeface="Fira Sans"/>
-              </a:rPr>
-              <a:t>▸ </a:t>
-            </a:r>
-            <a:r>
-              <a:rPr sz="1800" b="0">
-                <a:solidFill>
-                  <a:srgbClr val="000000"/>
-                </a:solidFill>
-                <a:latin typeface="Fira Sans"/>
-              </a:rPr>
-              <a:t>Variables: ModoAgrupado (cualitativa) y TiempoViaje (continua); el contraste es una comparación de medias, que la clase 5 formaliza.</a:t>
-            </a:r>
-          </a:p>
-          <a:p>
-            <a:pPr>
-              <a:lnSpc>
-                <a:spcPct val="112000"/>
-              </a:lnSpc>
-              <a:spcAft>
-                <a:spcPts val="900"/>
-              </a:spcAft>
-            </a:pPr>
-            <a:r>
-              <a:rPr sz="1800" b="1">
-                <a:solidFill>
-                  <a:srgbClr val="E0A437"/>
-                </a:solidFill>
-                <a:latin typeface="Fira Sans"/>
-              </a:rPr>
-              <a:t>▸ </a:t>
-            </a:r>
-            <a:r>
-              <a:rPr sz="1800" b="1">
-                <a:solidFill>
-                  <a:srgbClr val="1D3557"/>
-                </a:solidFill>
-                <a:latin typeface="Fira Sans"/>
-              </a:rPr>
-              <a:t>Si la hipótesis no dice qué medir ni qué comparar, todavía es una intuición, no una hipótesis.</a:t>
+            <a:r>
+              <a:rPr sz="1300" b="0">
+                <a:solidFill>
+                  <a:srgbClr val="333333"/>
+                </a:solidFill>
+                <a:latin typeface="Fira Sans"/>
+              </a:rPr>
+              <a:t>Una hipótesis verificable nombra variables medibles y una comparación concreta; la tercera es la que contrastaremos con la EOD.</a:t>
             </a:r>
           </a:p>
         </p:txBody>
@@ -6706,21 +7245,45 @@
                 </a:solidFill>
                 <a:latin typeface="Fira Sans"/>
               </a:rPr>
-              <a:t>La formulación del proyecto Capstone</a:t>
-            </a:r>
-          </a:p>
-        </p:txBody>
-      </p:sp>
-      <p:sp>
-        <p:nvSpPr>
-          <p:cNvPr id="4" name="TextBox 3"/>
+              <a:t>El ciclo PPDAC</a:t>
+            </a:r>
+          </a:p>
+        </p:txBody>
+      </p:sp>
+      <p:pic>
+        <p:nvPicPr>
+          <p:cNvPr id="4" name="Picture 3" descr="07_ppdac.png"/>
+          <p:cNvPicPr>
+            <a:picLocks noChangeAspect="1"/>
+          </p:cNvPicPr>
+          <p:nvPr/>
+        </p:nvPicPr>
+        <p:blipFill>
+          <a:blip r:embed="rId2"/>
+          <a:stretch>
+            <a:fillRect/>
+          </a:stretch>
+        </p:blipFill>
+        <p:spPr>
+          <a:xfrm>
+            <a:off x="1417319" y="1143000"/>
+            <a:ext cx="6309360" cy="2477421"/>
+          </a:xfrm>
+          <a:prstGeom prst="rect">
+            <a:avLst/>
+          </a:prstGeom>
+        </p:spPr>
+      </p:pic>
+      <p:sp>
+        <p:nvSpPr>
+          <p:cNvPr id="5" name="TextBox 4"/>
           <p:cNvSpPr txBox="1"/>
           <p:nvPr/>
         </p:nvSpPr>
         <p:spPr>
           <a:xfrm>
-            <a:off x="704088" y="1353312"/>
-            <a:ext cx="7744968" cy="3300984"/>
+            <a:off x="704088" y="4434840"/>
+            <a:ext cx="7744968" cy="457200"/>
           </a:xfrm>
           <a:prstGeom prst="rect">
             <a:avLst/>
@@ -6733,115 +7296,14 @@
           </a:bodyPr>
           <a:lstStyle/>
           <a:p>
-            <a:pPr>
-              <a:lnSpc>
-                <a:spcPct val="112000"/>
-              </a:lnSpc>
-              <a:spcAft>
-                <a:spcPts val="900"/>
-              </a:spcAft>
-            </a:pPr>
-            <a:r>
-              <a:rPr sz="1800" b="1">
-                <a:solidFill>
-                  <a:srgbClr val="E0A437"/>
-                </a:solidFill>
-                <a:latin typeface="Fira Sans"/>
-              </a:rPr>
-              <a:t>▸ </a:t>
-            </a:r>
-            <a:r>
-              <a:rPr sz="1800" b="0">
-                <a:solidFill>
-                  <a:srgbClr val="000000"/>
-                </a:solidFill>
-                <a:latin typeface="Fira Sans"/>
-              </a:rPr>
-              <a:t>Se publica hoy la rúbrica, con seis criterios: problema (20 pts), datos y metadatos (20), estrategia de obtención (15), novedad (15), viabilidad técnica (15) e impacto esperado (15).</a:t>
-            </a:r>
-          </a:p>
-          <a:p>
-            <a:pPr>
-              <a:lnSpc>
-                <a:spcPct val="112000"/>
-              </a:lnSpc>
-              <a:spcAft>
-                <a:spcPts val="900"/>
-              </a:spcAft>
-            </a:pPr>
-            <a:r>
-              <a:rPr sz="1800" b="1">
-                <a:solidFill>
-                  <a:srgbClr val="E0A437"/>
-                </a:solidFill>
-                <a:latin typeface="Fira Sans"/>
-              </a:rPr>
-              <a:t>▸ </a:t>
-            </a:r>
-            <a:r>
-              <a:rPr sz="1800" b="0">
-                <a:solidFill>
-                  <a:srgbClr val="000000"/>
-                </a:solidFill>
-                <a:latin typeface="Fira Sans"/>
-              </a:rPr>
-              <a:t>Documento de 2 a 3 páginas, un envío por equipo (máximo 2 personas), por el aula virtual.</a:t>
-            </a:r>
-          </a:p>
-          <a:p>
-            <a:pPr>
-              <a:lnSpc>
-                <a:spcPct val="112000"/>
-              </a:lnSpc>
-              <a:spcAft>
-                <a:spcPts val="900"/>
-              </a:spcAft>
-            </a:pPr>
-            <a:r>
-              <a:rPr sz="1800" b="1">
-                <a:solidFill>
-                  <a:srgbClr val="E0A437"/>
-                </a:solidFill>
-                <a:latin typeface="Fira Sans"/>
-              </a:rPr>
-              <a:t>▸ </a:t>
-            </a:r>
-            <a:r>
-              <a:rPr sz="1800" b="1">
-                <a:solidFill>
-                  <a:srgbClr val="1D3557"/>
-                </a:solidFill>
-                <a:latin typeface="Fira Sans"/>
-              </a:rPr>
-              <a:t>Entrega: lunes 7 de septiembre. Presentación breve de la idea: jueves 3, con retroalimentación y sin nota.</a:t>
-            </a:r>
-          </a:p>
-          <a:p>
-            <a:pPr>
-              <a:lnSpc>
-                <a:spcPct val="112000"/>
-              </a:lnSpc>
-              <a:spcAft>
-                <a:spcPts val="900"/>
-              </a:spcAft>
-            </a:pPr>
-            <a:r>
-              <a:rPr sz="1800" b="1">
-                <a:solidFill>
-                  <a:srgbClr val="E0A437"/>
-                </a:solidFill>
-                <a:latin typeface="Fira Sans"/>
-              </a:rPr>
-              <a:t>▸ </a:t>
-            </a:r>
-            <a:r>
-              <a:rPr sz="1800" b="0">
-                <a:solidFill>
-                  <a:srgbClr val="000000"/>
-                </a:solidFill>
-                <a:latin typeface="Fira Sans"/>
-              </a:rPr>
-              <a:t>Quienes no usen datos de su trabajo pueden partir de la lista de datos sugeridos del repositorio.</a:t>
+            <a:r>
+              <a:rPr sz="1300" b="0">
+                <a:solidFill>
+                  <a:srgbClr val="333333"/>
+                </a:solidFill>
+                <a:latin typeface="Fira Sans"/>
+              </a:rPr>
+              <a:t>Problema, plan, datos, análisis y conclusión (Wild y Pfannkuch, 1999): la formulación del Capstone es la etapa de problema y plan de este ciclo.</a:t>
             </a:r>
           </a:p>
         </p:txBody>
@@ -6937,7 +7399,7 @@
                 </a:solidFill>
                 <a:latin typeface="Fira Sans"/>
               </a:rPr>
-              <a:t>Síntesis</a:t>
+              <a:t>De la pregunta a la hipótesis</a:t>
             </a:r>
           </a:p>
         </p:txBody>
@@ -6988,7 +7450,7 @@
                 </a:solidFill>
                 <a:latin typeface="Fira Sans"/>
               </a:rPr>
-              <a:t>Describir una variable exige tres miradas: centro (media, mediana), dispersión (desviación, IQR) y forma (histograma, boxplot).</a:t>
+              <a:t>Hipótesis: una afirmación verificable, con variables medibles y una relación esperada.</a:t>
             </a:r>
           </a:p>
           <a:p>
@@ -7016,7 +7478,7 @@
                 </a:solidFill>
                 <a:latin typeface="Fira Sans"/>
               </a:rPr>
-              <a:t>Con asimetría, la mediana acompaña o reemplaza a la media.</a:t>
+              <a:t>Pregunta: ¿la duración del viaje depende del modo de transporte?</a:t>
             </a:r>
           </a:p>
           <a:p>
@@ -7044,7 +7506,7 @@
                 </a:solidFill>
                 <a:latin typeface="Fira Sans"/>
               </a:rPr>
-              <a:t>La limpieza es parte del análisis: faltantes, duplicados, rangos válidos y merges verificados, con decisiones documentadas.</a:t>
+              <a:t>Hipótesis: los viajes en transporte público duran en promedio más que en auto.</a:t>
             </a:r>
           </a:p>
           <a:p>
@@ -7072,7 +7534,7 @@
                 </a:solidFill>
                 <a:latin typeface="Fira Sans"/>
               </a:rPr>
-              <a:t>La pregunta del proyecto debe ser específica y la hipótesis, verificable con variables medibles.</a:t>
+              <a:t>Variables: ModoAgrupado y TiempoViaje; el contraste es una comparación de medias (clase 5).</a:t>
             </a:r>
           </a:p>
           <a:p>
@@ -7094,13 +7556,13 @@
               <a:t>▸ </a:t>
             </a:r>
             <a:r>
-              <a:rPr sz="1800" b="0">
-                <a:solidFill>
-                  <a:srgbClr val="000000"/>
-                </a:solidFill>
-                <a:latin typeface="Fira Sans"/>
-              </a:rPr>
-              <a:t>Próxima clase (martes 01-sep): EDA II, relaciones entre variables y correlación.</a:t>
+              <a:rPr sz="1800" b="1">
+                <a:solidFill>
+                  <a:srgbClr val="1D3557"/>
+                </a:solidFill>
+                <a:latin typeface="Fira Sans"/>
+              </a:rPr>
+              <a:t>Sin qué medir ni qué comparar, es una intuición, no una hipótesis.</a:t>
             </a:r>
           </a:p>
         </p:txBody>
@@ -7196,7 +7658,7 @@
                 </a:solidFill>
                 <a:latin typeface="Fira Sans"/>
               </a:rPr>
-              <a:t>Referencias</a:t>
+              <a:t>La formulación del proyecto Capstone</a:t>
             </a:r>
           </a:p>
         </p:txBody>
@@ -7209,8 +7671,8 @@
         </p:nvSpPr>
         <p:spPr>
           <a:xfrm>
-            <a:off x="704088" y="1234440"/>
-            <a:ext cx="7744968" cy="3566160"/>
+            <a:off x="704088" y="1353312"/>
+            <a:ext cx="7744968" cy="3300984"/>
           </a:xfrm>
           <a:prstGeom prst="rect">
             <a:avLst/>
@@ -7225,96 +7687,372 @@
           <a:p>
             <a:pPr>
               <a:lnSpc>
-                <a:spcPct val="115000"/>
+                <a:spcPct val="112000"/>
               </a:lnSpc>
               <a:spcAft>
-                <a:spcPts val="700"/>
+                <a:spcPts val="900"/>
               </a:spcAft>
             </a:pPr>
             <a:r>
-              <a:rPr sz="1300" b="0">
-                <a:solidFill>
-                  <a:srgbClr val="333333"/>
-                </a:solidFill>
-                <a:latin typeface="Fira Sans"/>
-              </a:rPr>
-              <a:t>Tukey, J. W. (1977). Exploratory Data Analysis. Addison-Wesley.</a:t>
+              <a:rPr sz="1800" b="1">
+                <a:solidFill>
+                  <a:srgbClr val="E0A437"/>
+                </a:solidFill>
+                <a:latin typeface="Fira Sans"/>
+              </a:rPr>
+              <a:t>▸ </a:t>
+            </a:r>
+            <a:r>
+              <a:rPr sz="1800" b="0">
+                <a:solidFill>
+                  <a:srgbClr val="000000"/>
+                </a:solidFill>
+                <a:latin typeface="Fira Sans"/>
+              </a:rPr>
+              <a:t>Se publica hoy la rúbrica, con seis criterios: problema (20 pts), datos y metadatos (20), estrategia de obtención (15), novedad (15), viabilidad técnica (15) e impacto esperado (15).</a:t>
             </a:r>
           </a:p>
           <a:p>
             <a:pPr>
               <a:lnSpc>
-                <a:spcPct val="115000"/>
+                <a:spcPct val="112000"/>
               </a:lnSpc>
               <a:spcAft>
-                <a:spcPts val="700"/>
+                <a:spcPts val="900"/>
               </a:spcAft>
             </a:pPr>
             <a:r>
-              <a:rPr sz="1300" b="0">
-                <a:solidFill>
-                  <a:srgbClr val="333333"/>
-                </a:solidFill>
-                <a:latin typeface="Fira Sans"/>
-              </a:rPr>
-              <a:t>Leek, J. T. y Peng, R. D. (2015). What is the question? Science, 347(6228), 1314-1315.</a:t>
+              <a:rPr sz="1800" b="1">
+                <a:solidFill>
+                  <a:srgbClr val="E0A437"/>
+                </a:solidFill>
+                <a:latin typeface="Fira Sans"/>
+              </a:rPr>
+              <a:t>▸ </a:t>
+            </a:r>
+            <a:r>
+              <a:rPr sz="1800" b="0">
+                <a:solidFill>
+                  <a:srgbClr val="000000"/>
+                </a:solidFill>
+                <a:latin typeface="Fira Sans"/>
+              </a:rPr>
+              <a:t>Documento de 2 a 3 páginas, un envío por equipo (máximo 2 personas), por el aula virtual.</a:t>
             </a:r>
           </a:p>
           <a:p>
             <a:pPr>
               <a:lnSpc>
-                <a:spcPct val="115000"/>
+                <a:spcPct val="112000"/>
               </a:lnSpc>
               <a:spcAft>
-                <a:spcPts val="700"/>
+                <a:spcPts val="900"/>
               </a:spcAft>
             </a:pPr>
             <a:r>
-              <a:rPr sz="1300" b="0">
-                <a:solidFill>
-                  <a:srgbClr val="333333"/>
-                </a:solidFill>
-                <a:latin typeface="Fira Sans"/>
-              </a:rPr>
-              <a:t>Peng, R. D. y Matsui, E. (2015). The Art of Data Science. Versión en línea: bookdown.org/rdpeng/artofdatascience</a:t>
+              <a:rPr sz="1800" b="1">
+                <a:solidFill>
+                  <a:srgbClr val="E0A437"/>
+                </a:solidFill>
+                <a:latin typeface="Fira Sans"/>
+              </a:rPr>
+              <a:t>▸ </a:t>
+            </a:r>
+            <a:r>
+              <a:rPr sz="1800" b="1">
+                <a:solidFill>
+                  <a:srgbClr val="1D3557"/>
+                </a:solidFill>
+                <a:latin typeface="Fira Sans"/>
+              </a:rPr>
+              <a:t>Entrega: lunes 7 de septiembre. Presentación breve de la idea: jueves 3, con retroalimentación y sin nota.</a:t>
             </a:r>
           </a:p>
           <a:p>
             <a:pPr>
               <a:lnSpc>
-                <a:spcPct val="115000"/>
+                <a:spcPct val="112000"/>
               </a:lnSpc>
               <a:spcAft>
-                <a:spcPts val="700"/>
+                <a:spcPts val="900"/>
               </a:spcAft>
             </a:pPr>
             <a:r>
-              <a:rPr sz="1300" b="0">
-                <a:solidFill>
-                  <a:srgbClr val="333333"/>
-                </a:solidFill>
-                <a:latin typeface="Fira Sans"/>
-              </a:rPr>
-              <a:t>Wild, C. J. y Pfannkuch, M. (1999). Statistical Thinking in Empirical Enquiry. International Statistical Review, 67(3), 223-248.</a:t>
-            </a:r>
-          </a:p>
+              <a:rPr sz="1800" b="1">
+                <a:solidFill>
+                  <a:srgbClr val="E0A437"/>
+                </a:solidFill>
+                <a:latin typeface="Fira Sans"/>
+              </a:rPr>
+              <a:t>▸ </a:t>
+            </a:r>
+            <a:r>
+              <a:rPr sz="1800" b="0">
+                <a:solidFill>
+                  <a:srgbClr val="000000"/>
+                </a:solidFill>
+                <a:latin typeface="Fira Sans"/>
+              </a:rPr>
+              <a:t>Quienes no usen datos de su trabajo pueden partir de la lista de datos sugeridos del repositorio.</a:t>
+            </a:r>
+          </a:p>
+        </p:txBody>
+      </p:sp>
+    </p:spTree>
+  </p:cSld>
+  <p:clrMapOvr>
+    <a:masterClrMapping/>
+  </p:clrMapOvr>
+</p:sld>
+</file>
+
+<file path=ppt/slides/slide29.xml><?xml version="1.0" encoding="utf-8"?>
+<p:sld xmlns:a="http://schemas.openxmlformats.org/drawingml/2006/main" xmlns:p="http://schemas.openxmlformats.org/presentationml/2006/main" xmlns:r="http://schemas.openxmlformats.org/officeDocument/2006/relationships">
+  <p:cSld>
+    <p:spTree>
+      <p:nvGrpSpPr>
+        <p:cNvPr id="1" name=""/>
+        <p:cNvGrpSpPr/>
+        <p:nvPr/>
+      </p:nvGrpSpPr>
+      <p:grpSpPr/>
+      <p:sp>
+        <p:nvSpPr>
+          <p:cNvPr id="2" name="Rectangle 1"/>
+          <p:cNvSpPr/>
+          <p:nvPr/>
+        </p:nvSpPr>
+        <p:spPr>
+          <a:xfrm>
+            <a:off x="0" y="0"/>
+            <a:ext cx="9144000" cy="5138928"/>
+          </a:xfrm>
+          <a:prstGeom prst="rect">
+            <a:avLst/>
+          </a:prstGeom>
+          <a:solidFill>
+            <a:srgbClr val="FAFBFC"/>
+          </a:solidFill>
+          <a:ln>
+            <a:noFill/>
+          </a:ln>
+          <a:effectLst/>
+        </p:spPr>
+        <p:style>
+          <a:lnRef idx="1">
+            <a:schemeClr val="accent1"/>
+          </a:lnRef>
+          <a:fillRef idx="3">
+            <a:schemeClr val="accent1"/>
+          </a:fillRef>
+          <a:effectRef idx="2">
+            <a:schemeClr val="accent1"/>
+          </a:effectRef>
+          <a:fontRef idx="minor">
+            <a:schemeClr val="lt1"/>
+          </a:fontRef>
+        </p:style>
+        <p:txBody>
+          <a:bodyPr rtlCol="0" anchor="ctr"/>
+          <a:lstStyle/>
+          <a:p>
+            <a:pPr algn="ctr"/>
+          </a:p>
+        </p:txBody>
+      </p:sp>
+      <p:sp>
+        <p:nvSpPr>
+          <p:cNvPr id="3" name="TextBox 2"/>
+          <p:cNvSpPr txBox="1"/>
+          <p:nvPr/>
+        </p:nvSpPr>
+        <p:spPr>
+          <a:xfrm>
+            <a:off x="402336" y="301752"/>
+            <a:ext cx="8348472" cy="795528"/>
+          </a:xfrm>
+          <a:prstGeom prst="rect">
+            <a:avLst/>
+          </a:prstGeom>
+          <a:noFill/>
+        </p:spPr>
+        <p:txBody>
+          <a:bodyPr wrap="square">
+            <a:spAutoFit/>
+          </a:bodyPr>
+          <a:lstStyle/>
+          <a:p>
+            <a:r>
+              <a:rPr sz="2800" b="1">
+                <a:solidFill>
+                  <a:srgbClr val="0F0F0F"/>
+                </a:solidFill>
+                <a:latin typeface="Fira Sans"/>
+              </a:rPr>
+              <a:t>Síntesis</a:t>
+            </a:r>
+          </a:p>
+        </p:txBody>
+      </p:sp>
+      <p:sp>
+        <p:nvSpPr>
+          <p:cNvPr id="4" name="TextBox 3"/>
+          <p:cNvSpPr txBox="1"/>
+          <p:nvPr/>
+        </p:nvSpPr>
+        <p:spPr>
+          <a:xfrm>
+            <a:off x="704088" y="1353312"/>
+            <a:ext cx="7744968" cy="3300984"/>
+          </a:xfrm>
+          <a:prstGeom prst="rect">
+            <a:avLst/>
+          </a:prstGeom>
+          <a:noFill/>
+        </p:spPr>
+        <p:txBody>
+          <a:bodyPr wrap="square">
+            <a:spAutoFit/>
+          </a:bodyPr>
+          <a:lstStyle/>
           <a:p>
             <a:pPr>
               <a:lnSpc>
-                <a:spcPct val="115000"/>
+                <a:spcPct val="112000"/>
               </a:lnSpc>
               <a:spcAft>
-                <a:spcPts val="700"/>
+                <a:spcPts val="900"/>
               </a:spcAft>
             </a:pPr>
             <a:r>
-              <a:rPr sz="1300" b="0">
-                <a:solidFill>
-                  <a:srgbClr val="333333"/>
-                </a:solidFill>
-                <a:latin typeface="Fira Sans"/>
-              </a:rPr>
-              <a:t>Anaconda (2020). 2020 State of Data Science. Reporte de encuesta (n=2.360). anaconda.com/resources/whitepaper/state-of-data-science-2020</a:t>
+              <a:rPr sz="1800" b="1">
+                <a:solidFill>
+                  <a:srgbClr val="E0A437"/>
+                </a:solidFill>
+                <a:latin typeface="Fira Sans"/>
+              </a:rPr>
+              <a:t>▸ </a:t>
+            </a:r>
+            <a:r>
+              <a:rPr sz="1800" b="0">
+                <a:solidFill>
+                  <a:srgbClr val="000000"/>
+                </a:solidFill>
+                <a:latin typeface="Fira Sans"/>
+              </a:rPr>
+              <a:t>Describir una variable exige tres miradas: centro (media, mediana), dispersión (desviación, IQR) y forma (histograma, boxplot).</a:t>
+            </a:r>
+          </a:p>
+          <a:p>
+            <a:pPr>
+              <a:lnSpc>
+                <a:spcPct val="112000"/>
+              </a:lnSpc>
+              <a:spcAft>
+                <a:spcPts val="900"/>
+              </a:spcAft>
+            </a:pPr>
+            <a:r>
+              <a:rPr sz="1800" b="1">
+                <a:solidFill>
+                  <a:srgbClr val="E0A437"/>
+                </a:solidFill>
+                <a:latin typeface="Fira Sans"/>
+              </a:rPr>
+              <a:t>▸ </a:t>
+            </a:r>
+            <a:r>
+              <a:rPr sz="1800" b="0">
+                <a:solidFill>
+                  <a:srgbClr val="000000"/>
+                </a:solidFill>
+                <a:latin typeface="Fira Sans"/>
+              </a:rPr>
+              <a:t>Con asimetría, la mediana acompaña o reemplaza a la media.</a:t>
+            </a:r>
+          </a:p>
+          <a:p>
+            <a:pPr>
+              <a:lnSpc>
+                <a:spcPct val="112000"/>
+              </a:lnSpc>
+              <a:spcAft>
+                <a:spcPts val="900"/>
+              </a:spcAft>
+            </a:pPr>
+            <a:r>
+              <a:rPr sz="1800" b="1">
+                <a:solidFill>
+                  <a:srgbClr val="E0A437"/>
+                </a:solidFill>
+                <a:latin typeface="Fira Sans"/>
+              </a:rPr>
+              <a:t>▸ </a:t>
+            </a:r>
+            <a:r>
+              <a:rPr sz="1800" b="0">
+                <a:solidFill>
+                  <a:srgbClr val="000000"/>
+                </a:solidFill>
+                <a:latin typeface="Fira Sans"/>
+              </a:rPr>
+              <a:t>La limpieza es parte del análisis: faltantes, duplicados, rangos válidos y merges verificados, con decisiones documentadas.</a:t>
+            </a:r>
+          </a:p>
+          <a:p>
+            <a:pPr>
+              <a:lnSpc>
+                <a:spcPct val="112000"/>
+              </a:lnSpc>
+              <a:spcAft>
+                <a:spcPts val="900"/>
+              </a:spcAft>
+            </a:pPr>
+            <a:r>
+              <a:rPr sz="1800" b="1">
+                <a:solidFill>
+                  <a:srgbClr val="E0A437"/>
+                </a:solidFill>
+                <a:latin typeface="Fira Sans"/>
+              </a:rPr>
+              <a:t>▸ </a:t>
+            </a:r>
+            <a:r>
+              <a:rPr sz="1800" b="0">
+                <a:solidFill>
+                  <a:srgbClr val="000000"/>
+                </a:solidFill>
+                <a:latin typeface="Fira Sans"/>
+              </a:rPr>
+              <a:t>La pregunta del proyecto debe ser específica y la hipótesis, verificable con variables medibles.</a:t>
+            </a:r>
+          </a:p>
+          <a:p>
+            <a:pPr>
+              <a:lnSpc>
+                <a:spcPct val="112000"/>
+              </a:lnSpc>
+              <a:spcAft>
+                <a:spcPts val="900"/>
+              </a:spcAft>
+            </a:pPr>
+            <a:r>
+              <a:rPr sz="1800" b="1">
+                <a:solidFill>
+                  <a:srgbClr val="E0A437"/>
+                </a:solidFill>
+                <a:latin typeface="Fira Sans"/>
+              </a:rPr>
+              <a:t>▸ </a:t>
+            </a:r>
+            <a:r>
+              <a:rPr sz="1800" b="0">
+                <a:solidFill>
+                  <a:srgbClr val="000000"/>
+                </a:solidFill>
+                <a:latin typeface="Fira Sans"/>
+              </a:rPr>
+              <a:t>Próxima clase (martes 01-sep): EDA II, relaciones entre variables y correlación.</a:t>
             </a:r>
           </a:p>
         </p:txBody>
@@ -7434,6 +8172,220 @@
 </p:sld>
 </file>
 
+<file path=ppt/slides/slide30.xml><?xml version="1.0" encoding="utf-8"?>
+<p:sld xmlns:a="http://schemas.openxmlformats.org/drawingml/2006/main" xmlns:p="http://schemas.openxmlformats.org/presentationml/2006/main" xmlns:r="http://schemas.openxmlformats.org/officeDocument/2006/relationships">
+  <p:cSld>
+    <p:spTree>
+      <p:nvGrpSpPr>
+        <p:cNvPr id="1" name=""/>
+        <p:cNvGrpSpPr/>
+        <p:nvPr/>
+      </p:nvGrpSpPr>
+      <p:grpSpPr/>
+      <p:sp>
+        <p:nvSpPr>
+          <p:cNvPr id="2" name="Rectangle 1"/>
+          <p:cNvSpPr/>
+          <p:nvPr/>
+        </p:nvSpPr>
+        <p:spPr>
+          <a:xfrm>
+            <a:off x="0" y="0"/>
+            <a:ext cx="9144000" cy="5138928"/>
+          </a:xfrm>
+          <a:prstGeom prst="rect">
+            <a:avLst/>
+          </a:prstGeom>
+          <a:solidFill>
+            <a:srgbClr val="FAFBFC"/>
+          </a:solidFill>
+          <a:ln>
+            <a:noFill/>
+          </a:ln>
+          <a:effectLst/>
+        </p:spPr>
+        <p:style>
+          <a:lnRef idx="1">
+            <a:schemeClr val="accent1"/>
+          </a:lnRef>
+          <a:fillRef idx="3">
+            <a:schemeClr val="accent1"/>
+          </a:fillRef>
+          <a:effectRef idx="2">
+            <a:schemeClr val="accent1"/>
+          </a:effectRef>
+          <a:fontRef idx="minor">
+            <a:schemeClr val="lt1"/>
+          </a:fontRef>
+        </p:style>
+        <p:txBody>
+          <a:bodyPr rtlCol="0" anchor="ctr"/>
+          <a:lstStyle/>
+          <a:p>
+            <a:pPr algn="ctr"/>
+          </a:p>
+        </p:txBody>
+      </p:sp>
+      <p:sp>
+        <p:nvSpPr>
+          <p:cNvPr id="3" name="TextBox 2"/>
+          <p:cNvSpPr txBox="1"/>
+          <p:nvPr/>
+        </p:nvSpPr>
+        <p:spPr>
+          <a:xfrm>
+            <a:off x="402336" y="301752"/>
+            <a:ext cx="8348472" cy="795528"/>
+          </a:xfrm>
+          <a:prstGeom prst="rect">
+            <a:avLst/>
+          </a:prstGeom>
+          <a:noFill/>
+        </p:spPr>
+        <p:txBody>
+          <a:bodyPr wrap="square">
+            <a:spAutoFit/>
+          </a:bodyPr>
+          <a:lstStyle/>
+          <a:p>
+            <a:r>
+              <a:rPr sz="2800" b="1">
+                <a:solidFill>
+                  <a:srgbClr val="0F0F0F"/>
+                </a:solidFill>
+                <a:latin typeface="Fira Sans"/>
+              </a:rPr>
+              <a:t>Referencias</a:t>
+            </a:r>
+          </a:p>
+        </p:txBody>
+      </p:sp>
+      <p:sp>
+        <p:nvSpPr>
+          <p:cNvPr id="4" name="TextBox 3"/>
+          <p:cNvSpPr txBox="1"/>
+          <p:nvPr/>
+        </p:nvSpPr>
+        <p:spPr>
+          <a:xfrm>
+            <a:off x="704088" y="1234440"/>
+            <a:ext cx="7744968" cy="3566160"/>
+          </a:xfrm>
+          <a:prstGeom prst="rect">
+            <a:avLst/>
+          </a:prstGeom>
+          <a:noFill/>
+        </p:spPr>
+        <p:txBody>
+          <a:bodyPr wrap="square">
+            <a:spAutoFit/>
+          </a:bodyPr>
+          <a:lstStyle/>
+          <a:p>
+            <a:pPr>
+              <a:lnSpc>
+                <a:spcPct val="115000"/>
+              </a:lnSpc>
+              <a:spcAft>
+                <a:spcPts val="700"/>
+              </a:spcAft>
+            </a:pPr>
+            <a:r>
+              <a:rPr sz="1300" b="0">
+                <a:solidFill>
+                  <a:srgbClr val="333333"/>
+                </a:solidFill>
+                <a:latin typeface="Fira Sans"/>
+              </a:rPr>
+              <a:t>Tukey, J. W. (1977). Exploratory Data Analysis. Addison-Wesley.</a:t>
+            </a:r>
+          </a:p>
+          <a:p>
+            <a:pPr>
+              <a:lnSpc>
+                <a:spcPct val="115000"/>
+              </a:lnSpc>
+              <a:spcAft>
+                <a:spcPts val="700"/>
+              </a:spcAft>
+            </a:pPr>
+            <a:r>
+              <a:rPr sz="1300" b="0">
+                <a:solidFill>
+                  <a:srgbClr val="333333"/>
+                </a:solidFill>
+                <a:latin typeface="Fira Sans"/>
+              </a:rPr>
+              <a:t>Leek, J. T. y Peng, R. D. (2015). What is the question? Science, 347(6228), 1314-1315.</a:t>
+            </a:r>
+          </a:p>
+          <a:p>
+            <a:pPr>
+              <a:lnSpc>
+                <a:spcPct val="115000"/>
+              </a:lnSpc>
+              <a:spcAft>
+                <a:spcPts val="700"/>
+              </a:spcAft>
+            </a:pPr>
+            <a:r>
+              <a:rPr sz="1300" b="0">
+                <a:solidFill>
+                  <a:srgbClr val="333333"/>
+                </a:solidFill>
+                <a:latin typeface="Fira Sans"/>
+              </a:rPr>
+              <a:t>Peng, R. D. y Matsui, E. (2015). The Art of Data Science. Versión en línea: bookdown.org/rdpeng/artofdatascience</a:t>
+            </a:r>
+          </a:p>
+          <a:p>
+            <a:pPr>
+              <a:lnSpc>
+                <a:spcPct val="115000"/>
+              </a:lnSpc>
+              <a:spcAft>
+                <a:spcPts val="700"/>
+              </a:spcAft>
+            </a:pPr>
+            <a:r>
+              <a:rPr sz="1300" b="0">
+                <a:solidFill>
+                  <a:srgbClr val="333333"/>
+                </a:solidFill>
+                <a:latin typeface="Fira Sans"/>
+              </a:rPr>
+              <a:t>Wild, C. J. y Pfannkuch, M. (1999). Statistical Thinking in Empirical Enquiry. International Statistical Review, 67(3), 223-248.</a:t>
+            </a:r>
+          </a:p>
+          <a:p>
+            <a:pPr>
+              <a:lnSpc>
+                <a:spcPct val="115000"/>
+              </a:lnSpc>
+              <a:spcAft>
+                <a:spcPts val="700"/>
+              </a:spcAft>
+            </a:pPr>
+            <a:r>
+              <a:rPr sz="1300" b="0">
+                <a:solidFill>
+                  <a:srgbClr val="333333"/>
+                </a:solidFill>
+                <a:latin typeface="Fira Sans"/>
+              </a:rPr>
+              <a:t>Anaconda (2020). 2020 State of Data Science. Reporte de encuesta (n=2.360). anaconda.com/resources/whitepaper/state-of-data-science-2020</a:t>
+            </a:r>
+          </a:p>
+        </p:txBody>
+      </p:sp>
+    </p:spTree>
+  </p:cSld>
+  <p:clrMapOvr>
+    <a:masterClrMapping/>
+  </p:clrMapOvr>
+</p:sld>
+</file>
+
 <file path=ppt/slides/slide4.xml><?xml version="1.0" encoding="utf-8"?>
 <p:sld xmlns:a="http://schemas.openxmlformats.org/drawingml/2006/main" xmlns:p="http://schemas.openxmlformats.org/presentationml/2006/main" xmlns:r="http://schemas.openxmlformats.org/officeDocument/2006/relationships">
   <p:cSld>
@@ -7568,7 +8520,7 @@
                 </a:solidFill>
                 <a:latin typeface="Fira Sans"/>
               </a:rPr>
-              <a:t>Examinar los datos antes de modelar: resumirlos, graficarlos y detectar sus problemas y patrones.</a:t>
+              <a:t>Examinar los datos antes de modelar: resumirlos, graficarlos y detectar sus problemas.</a:t>
             </a:r>
           </a:p>
           <a:p>
@@ -7596,7 +8548,7 @@
                 </a:solidFill>
                 <a:latin typeface="Fira Sans"/>
               </a:rPr>
-              <a:t>El término y el enfoque vienen de Tukey (1977): el análisis exploratorio es trabajo estadístico serio, no un trámite previo.</a:t>
+              <a:t>El término viene de Tukey (1977): explorar es trabajo estadístico serio, no un trámite previo.</a:t>
             </a:r>
           </a:p>
           <a:p>
@@ -7624,7 +8576,7 @@
                 </a:solidFill>
                 <a:latin typeface="Fira Sans"/>
               </a:rPr>
-              <a:t>Hoy, EDA I: describir una variable a la vez (univariado) y revisar la calidad de los datos.</a:t>
+              <a:t>Hoy: una variable a la vez, más calidad de los datos. El martes: relaciones entre variables.</a:t>
             </a:r>
           </a:p>
           <a:p>
@@ -7652,35 +8604,7 @@
                 </a:solidFill>
                 <a:latin typeface="Fira Sans"/>
               </a:rPr>
-              <a:t>El martes, EDA II: relaciones entre variables (bivariado), correlación y visualización.</a:t>
-            </a:r>
-          </a:p>
-          <a:p>
-            <a:pPr>
-              <a:lnSpc>
-                <a:spcPct val="112000"/>
-              </a:lnSpc>
-              <a:spcAft>
-                <a:spcPts val="900"/>
-              </a:spcAft>
-            </a:pPr>
-            <a:r>
-              <a:rPr sz="1800" b="1">
-                <a:solidFill>
-                  <a:srgbClr val="E0A437"/>
-                </a:solidFill>
-                <a:latin typeface="Fira Sans"/>
-              </a:rPr>
-              <a:t>▸ </a:t>
-            </a:r>
-            <a:r>
-              <a:rPr sz="1800" b="0">
-                <a:solidFill>
-                  <a:srgbClr val="000000"/>
-                </a:solidFill>
-                <a:latin typeface="Fira Sans"/>
-              </a:rPr>
-              <a:t>Es exactamente lo que exige el primer entregable evaluado del módulo: el análisis exploratorio del proyecto (40%).</a:t>
+              <a:t>Es lo que exige el entregable del 40%: el análisis exploratorio del proyecto.</a:t>
             </a:r>
           </a:p>
         </p:txBody>
@@ -8426,7 +9350,7 @@
                 </a:solidFill>
                 <a:latin typeface="Fira Sans"/>
               </a:rPr>
-              <a:t>Rango: máximo menos mínimo; simple pero dominado por los extremos.</a:t>
+              <a:t>Rango: máximo menos mínimo; dominado por los extremos.</a:t>
             </a:r>
           </a:p>
           <a:p>
@@ -8454,7 +9378,7 @@
                 </a:solidFill>
                 <a:latin typeface="Fira Sans"/>
               </a:rPr>
-              <a:t>Varianza: el promedio de las desviaciones al cuadrado respecto de la media. Su raíz es la desviación estándar, en las unidades originales.</a:t>
+              <a:t>Desviación estándar: raíz de la varianza, en las unidades originales. En la EOD: 36,1 minutos, casi tan grande como la media.</a:t>
             </a:r>
           </a:p>
           <a:p>
@@ -8482,7 +9406,7 @@
                 </a:solidFill>
                 <a:latin typeface="Fira Sans"/>
               </a:rPr>
-              <a:t>En la EOD, la duración tiene desviación estándar de 36,1 minutos, casi tan grande como su media: los viajes son muy heterogéneos.</a:t>
+              <a:t>Percentiles: el valor bajo el cual queda un porcentaje de los datos.</a:t>
             </a:r>
           </a:p>
           <a:p>
@@ -8510,7 +9434,7 @@
                 </a:solidFill>
                 <a:latin typeface="Fira Sans"/>
               </a:rPr>
-              <a:t>Percentiles: el valor bajo el cual queda un porcentaje de los datos. El rango intercuartílico IQR = Q3 menos Q1 concentra el 50% central: en la EOD, de 15 a 50 minutos.</a:t>
+              <a:t>IQR = Q3 menos Q1: el tramo del 50% central. En la EOD, de 15 a 50 minutos.</a:t>
             </a:r>
           </a:p>
         </p:txBody>

</xml_diff>

<commit_message>
Clase 2 reestructurada: los conceptos con iris y la aplicación con la EOD, en slides y notebooks
Co-Authored-By: Claude Fable 5 <noreply@anthropic.com>
</commit_message>
<xml_diff>
--- a/presentaciones/clase02_eda_descriptiva.pptx
+++ b/presentaciones/clase02_eda_descriptiva.pptx
@@ -35,6 +35,12 @@
     <p:sldId id="283" r:id="rId34"/>
     <p:sldId id="284" r:id="rId35"/>
     <p:sldId id="285" r:id="rId36"/>
+    <p:sldId id="286" r:id="rId37"/>
+    <p:sldId id="287" r:id="rId38"/>
+    <p:sldId id="288" r:id="rId39"/>
+    <p:sldId id="289" r:id="rId40"/>
+    <p:sldId id="290" r:id="rId41"/>
+    <p:sldId id="291" r:id="rId42"/>
   </p:sldIdLst>
   <p:sldSz cx="9144000" cy="5138928" type="screen4x3"/>
   <p:notesSz cx="6858000" cy="9144000"/>
@@ -3452,14 +3458,14 @@
                 </a:solidFill>
                 <a:latin typeface="Fira Sans"/>
               </a:rPr>
-              <a:t>La media no basta</a:t>
+              <a:t>Iris: el caso simétrico</a:t>
             </a:r>
           </a:p>
         </p:txBody>
       </p:sp>
       <p:pic>
         <p:nvPicPr>
-          <p:cNvPr id="4" name="Picture 3" descr="02_dispersion_comunas.png"/>
+          <p:cNvPr id="4" name="Picture 3" descr="08_iris_simetrica.png"/>
           <p:cNvPicPr>
             <a:picLocks noChangeAspect="1"/>
           </p:cNvPicPr>
@@ -3473,8 +3479,8 @@
         </p:blipFill>
         <p:spPr>
           <a:xfrm>
-            <a:off x="1822348" y="1143000"/>
-            <a:ext cx="5499302" cy="3154680"/>
+            <a:off x="1837387" y="1143000"/>
+            <a:ext cx="5469224" cy="3154680"/>
           </a:xfrm>
           <a:prstGeom prst="rect">
             <a:avLst/>
@@ -3510,7 +3516,7 @@
                 </a:solidFill>
                 <a:latin typeface="Fira Sans"/>
               </a:rPr>
-              <a:t>Providencia y Talagante tienen la misma duración media de viaje (40,7 minutos), pero la desviación estándar de Talagante es el doble: dos realidades distintas detrás del mismo promedio.</a:t>
+              <a:t>En una distribución simétrica, media y mediana cuentan la misma historia.</a:t>
             </a:r>
           </a:p>
         </p:txBody>
@@ -3606,14 +3612,14 @@
                 </a:solidFill>
                 <a:latin typeface="Fira Sans"/>
               </a:rPr>
-              <a:t>El boxplot</a:t>
+              <a:t>La EOD: el caso asimétrico</a:t>
             </a:r>
           </a:p>
         </p:txBody>
       </p:sp>
       <p:pic>
         <p:nvPicPr>
-          <p:cNvPr id="4" name="Picture 3" descr="03_boxplot_anatomia.png"/>
+          <p:cNvPr id="4" name="Picture 3" descr="01_media_mediana_ingreso.png"/>
           <p:cNvPicPr>
             <a:picLocks noChangeAspect="1"/>
           </p:cNvPicPr>
@@ -3627,8 +3633,8 @@
         </p:blipFill>
         <p:spPr>
           <a:xfrm>
-            <a:off x="1740020" y="1143000"/>
-            <a:ext cx="5663958" cy="3154680"/>
+            <a:off x="1874481" y="1143000"/>
+            <a:ext cx="5395037" cy="3154680"/>
           </a:xfrm>
           <a:prstGeom prst="rect">
             <a:avLst/>
@@ -3664,7 +3670,7 @@
                 </a:solidFill>
                 <a:latin typeface="Fira Sans"/>
               </a:rPr>
-              <a:t>Cinco números en un solo gráfico: mediana, cuartiles, bigotes y valores atípicos. La regla de los bigotes (1,5 veces el IQR) es una convención para marcar valores inusuales, no un veredicto.</a:t>
+              <a:t>Ingresos de los hogares de la EOD: mediana $0,51 millones, media $0,69 millones. La cola de ingresos altos arrastra la media; por eso el ingreso se reporta con la mediana.</a:t>
             </a:r>
           </a:p>
         </p:txBody>
@@ -3702,7 +3708,7 @@
             <a:avLst/>
           </a:prstGeom>
           <a:solidFill>
-            <a:srgbClr val="FAFBFC"/>
+            <a:srgbClr val="1D3557"/>
           </a:solidFill>
           <a:ln>
             <a:noFill/>
@@ -3739,8 +3745,8 @@
         </p:nvSpPr>
         <p:spPr>
           <a:xfrm>
-            <a:off x="402336" y="301752"/>
-            <a:ext cx="8348472" cy="795528"/>
+            <a:off x="603504" y="1847088"/>
+            <a:ext cx="7946136" cy="1399032"/>
           </a:xfrm>
           <a:prstGeom prst="rect">
             <a:avLst/>
@@ -3754,71 +3760,24 @@
           <a:lstStyle/>
           <a:p>
             <a:r>
-              <a:rPr sz="2800" b="1">
-                <a:solidFill>
-                  <a:srgbClr val="0F0F0F"/>
-                </a:solidFill>
-                <a:latin typeface="Fira Sans"/>
-              </a:rPr>
-              <a:t>Boxplots para comparar grupos</a:t>
-            </a:r>
-          </a:p>
-        </p:txBody>
-      </p:sp>
-      <p:pic>
-        <p:nvPicPr>
-          <p:cNvPr id="4" name="Picture 3" descr="04_boxplot_modos.png"/>
-          <p:cNvPicPr>
-            <a:picLocks noChangeAspect="1"/>
-          </p:cNvPicPr>
-          <p:nvPr/>
-        </p:nvPicPr>
-        <p:blipFill>
-          <a:blip r:embed="rId2"/>
-          <a:stretch>
-            <a:fillRect/>
-          </a:stretch>
-        </p:blipFill>
-        <p:spPr>
-          <a:xfrm>
-            <a:off x="1417319" y="1143000"/>
-            <a:ext cx="6309360" cy="2899161"/>
-          </a:xfrm>
-          <a:prstGeom prst="rect">
-            <a:avLst/>
-          </a:prstGeom>
-        </p:spPr>
-      </p:pic>
-      <p:sp>
-        <p:nvSpPr>
-          <p:cNvPr id="5" name="TextBox 4"/>
-          <p:cNvSpPr txBox="1"/>
-          <p:nvPr/>
-        </p:nvSpPr>
-        <p:spPr>
-          <a:xfrm>
-            <a:off x="704088" y="4434840"/>
-            <a:ext cx="7744968" cy="457200"/>
-          </a:xfrm>
-          <a:prstGeom prst="rect">
-            <a:avLst/>
-          </a:prstGeom>
-          <a:noFill/>
-        </p:spPr>
-        <p:txBody>
-          <a:bodyPr wrap="square">
-            <a:spAutoFit/>
-          </a:bodyPr>
-          <a:lstStyle/>
-          <a:p>
-            <a:r>
-              <a:rPr sz="1300" b="0">
-                <a:solidFill>
-                  <a:srgbClr val="333333"/>
-                </a:solidFill>
-                <a:latin typeface="Fira Sans"/>
-              </a:rPr>
-              <a:t>La duración del viaje según el modo: centros y dispersiones distintas en una sola figura. Es el gráfico estándar para comparar una variable cuantitativa entre categorías.</a:t>
+              <a:rPr sz="3400" b="1">
+                <a:solidFill>
+                  <a:srgbClr val="FFFFFF"/>
+                </a:solidFill>
+                <a:latin typeface="Fira Sans"/>
+              </a:rPr>
+              <a:t>Dispersión y forma</a:t>
+            </a:r>
+          </a:p>
+          <a:p>
+            <a:r>
+              <a:rPr sz="1800" b="0">
+                <a:solidFill>
+                  <a:srgbClr val="E0A437"/>
+                </a:solidFill>
+                <a:latin typeface="Fira Sans"/>
+              </a:rPr>
+              <a:t>Cuánto varían los datos alrededor del centro</a:t>
             </a:r>
           </a:p>
         </p:txBody>
@@ -3856,7 +3815,7 @@
             <a:avLst/>
           </a:prstGeom>
           <a:solidFill>
-            <a:srgbClr val="1D3557"/>
+            <a:srgbClr val="FAFBFC"/>
           </a:solidFill>
           <a:ln>
             <a:noFill/>
@@ -3893,8 +3852,8 @@
         </p:nvSpPr>
         <p:spPr>
           <a:xfrm>
-            <a:off x="603504" y="1847088"/>
-            <a:ext cx="7946136" cy="1399032"/>
+            <a:off x="402336" y="301752"/>
+            <a:ext cx="8348472" cy="795528"/>
           </a:xfrm>
           <a:prstGeom prst="rect">
             <a:avLst/>
@@ -3908,24 +3867,148 @@
           <a:lstStyle/>
           <a:p>
             <a:r>
-              <a:rPr sz="3400" b="1">
-                <a:solidFill>
-                  <a:srgbClr val="FFFFFF"/>
-                </a:solidFill>
-                <a:latin typeface="Fira Sans"/>
-              </a:rPr>
-              <a:t>Recreo</a:t>
-            </a:r>
-          </a:p>
-          <a:p>
+              <a:rPr sz="2800" b="1">
+                <a:solidFill>
+                  <a:srgbClr val="0F0F0F"/>
+                </a:solidFill>
+                <a:latin typeface="Fira Sans"/>
+              </a:rPr>
+              <a:t>Medir la dispersión</a:t>
+            </a:r>
+          </a:p>
+        </p:txBody>
+      </p:sp>
+      <p:sp>
+        <p:nvSpPr>
+          <p:cNvPr id="4" name="TextBox 3"/>
+          <p:cNvSpPr txBox="1"/>
+          <p:nvPr/>
+        </p:nvSpPr>
+        <p:spPr>
+          <a:xfrm>
+            <a:off x="704088" y="1353312"/>
+            <a:ext cx="7744968" cy="3300984"/>
+          </a:xfrm>
+          <a:prstGeom prst="rect">
+            <a:avLst/>
+          </a:prstGeom>
+          <a:noFill/>
+        </p:spPr>
+        <p:txBody>
+          <a:bodyPr wrap="square">
+            <a:spAutoFit/>
+          </a:bodyPr>
+          <a:lstStyle/>
+          <a:p>
+            <a:pPr>
+              <a:lnSpc>
+                <a:spcPct val="112000"/>
+              </a:lnSpc>
+              <a:spcAft>
+                <a:spcPts val="900"/>
+              </a:spcAft>
+            </a:pPr>
+            <a:r>
+              <a:rPr sz="1800" b="1">
+                <a:solidFill>
+                  <a:srgbClr val="E0A437"/>
+                </a:solidFill>
+                <a:latin typeface="Fira Sans"/>
+              </a:rPr>
+              <a:t>▸ </a:t>
+            </a:r>
             <a:r>
               <a:rPr sz="1800" b="0">
                 <a:solidFill>
+                  <a:srgbClr val="000000"/>
+                </a:solidFill>
+                <a:latin typeface="Fira Sans"/>
+              </a:rPr>
+              <a:t>Rango: máximo menos mínimo; dominado por los extremos.</a:t>
+            </a:r>
+          </a:p>
+          <a:p>
+            <a:pPr>
+              <a:lnSpc>
+                <a:spcPct val="112000"/>
+              </a:lnSpc>
+              <a:spcAft>
+                <a:spcPts val="900"/>
+              </a:spcAft>
+            </a:pPr>
+            <a:r>
+              <a:rPr sz="1800" b="1">
+                <a:solidFill>
                   <a:srgbClr val="E0A437"/>
                 </a:solidFill>
                 <a:latin typeface="Fira Sans"/>
               </a:rPr>
-              <a:t>10 minutos</a:t>
+              <a:t>▸ </a:t>
+            </a:r>
+            <a:r>
+              <a:rPr sz="1800" b="0">
+                <a:solidFill>
+                  <a:srgbClr val="000000"/>
+                </a:solidFill>
+                <a:latin typeface="Fira Sans"/>
+              </a:rPr>
+              <a:t>Desviación estándar: raíz de la varianza, en las unidades originales. En iris, 0,83 cm; en la EOD, 36,1 minutos, casi tan grande como la media.</a:t>
+            </a:r>
+          </a:p>
+          <a:p>
+            <a:pPr>
+              <a:lnSpc>
+                <a:spcPct val="112000"/>
+              </a:lnSpc>
+              <a:spcAft>
+                <a:spcPts val="900"/>
+              </a:spcAft>
+            </a:pPr>
+            <a:r>
+              <a:rPr sz="1800" b="1">
+                <a:solidFill>
+                  <a:srgbClr val="E0A437"/>
+                </a:solidFill>
+                <a:latin typeface="Fira Sans"/>
+              </a:rPr>
+              <a:t>▸ </a:t>
+            </a:r>
+            <a:r>
+              <a:rPr sz="1800" b="0">
+                <a:solidFill>
+                  <a:srgbClr val="000000"/>
+                </a:solidFill>
+                <a:latin typeface="Fira Sans"/>
+              </a:rPr>
+              <a:t>Percentiles: el valor bajo el cual queda un porcentaje de los datos. En iris, quantile([0, .25, .5, .75, 1]) da 4,3 · 5,1 · 5,8 · 6,4 · 7,9.</a:t>
+            </a:r>
+          </a:p>
+          <a:p>
+            <a:pPr>
+              <a:lnSpc>
+                <a:spcPct val="112000"/>
+              </a:lnSpc>
+              <a:spcAft>
+                <a:spcPts val="900"/>
+              </a:spcAft>
+            </a:pPr>
+            <a:r>
+              <a:rPr sz="1800" b="1">
+                <a:solidFill>
+                  <a:srgbClr val="E0A437"/>
+                </a:solidFill>
+                <a:latin typeface="Fira Sans"/>
+              </a:rPr>
+              <a:t>▸ </a:t>
+            </a:r>
+            <a:r>
+              <a:rPr sz="1800" b="0">
+                <a:solidFill>
+                  <a:srgbClr val="000000"/>
+                </a:solidFill>
+                <a:latin typeface="Fira Sans"/>
+              </a:rPr>
+              <a:t>IQR = Q3 menos Q1: el tramo del 50% central. En la EOD, de 15 a 50 minutos.</a:t>
             </a:r>
           </a:p>
         </p:txBody>
@@ -3963,7 +4046,7 @@
             <a:avLst/>
           </a:prstGeom>
           <a:solidFill>
-            <a:srgbClr val="1D3557"/>
+            <a:srgbClr val="FAFBFC"/>
           </a:solidFill>
           <a:ln>
             <a:noFill/>
@@ -4000,8 +4083,8 @@
         </p:nvSpPr>
         <p:spPr>
           <a:xfrm>
-            <a:off x="603504" y="1847088"/>
-            <a:ext cx="7946136" cy="1399032"/>
+            <a:off x="402336" y="301752"/>
+            <a:ext cx="8348472" cy="795528"/>
           </a:xfrm>
           <a:prstGeom prst="rect">
             <a:avLst/>
@@ -4015,24 +4098,71 @@
           <a:lstStyle/>
           <a:p>
             <a:r>
-              <a:rPr sz="3400" b="1">
-                <a:solidFill>
-                  <a:srgbClr val="FFFFFF"/>
-                </a:solidFill>
-                <a:latin typeface="Fira Sans"/>
-              </a:rPr>
-              <a:t>Calidad y limpieza de datos</a:t>
-            </a:r>
-          </a:p>
-          <a:p>
-            <a:r>
-              <a:rPr sz="1800" b="0">
-                <a:solidFill>
-                  <a:srgbClr val="E0A437"/>
-                </a:solidFill>
-                <a:latin typeface="Fira Sans"/>
-              </a:rPr>
-              <a:t>Los resúmenes valen lo que valen los datos</a:t>
+              <a:rPr sz="2800" b="1">
+                <a:solidFill>
+                  <a:srgbClr val="0F0F0F"/>
+                </a:solidFill>
+                <a:latin typeface="Fira Sans"/>
+              </a:rPr>
+              <a:t>La media no basta</a:t>
+            </a:r>
+          </a:p>
+        </p:txBody>
+      </p:sp>
+      <p:pic>
+        <p:nvPicPr>
+          <p:cNvPr id="4" name="Picture 3" descr="02_dispersion_comunas.png"/>
+          <p:cNvPicPr>
+            <a:picLocks noChangeAspect="1"/>
+          </p:cNvPicPr>
+          <p:nvPr/>
+        </p:nvPicPr>
+        <p:blipFill>
+          <a:blip r:embed="rId2"/>
+          <a:stretch>
+            <a:fillRect/>
+          </a:stretch>
+        </p:blipFill>
+        <p:spPr>
+          <a:xfrm>
+            <a:off x="1822348" y="1143000"/>
+            <a:ext cx="5499302" cy="3154680"/>
+          </a:xfrm>
+          <a:prstGeom prst="rect">
+            <a:avLst/>
+          </a:prstGeom>
+        </p:spPr>
+      </p:pic>
+      <p:sp>
+        <p:nvSpPr>
+          <p:cNvPr id="5" name="TextBox 4"/>
+          <p:cNvSpPr txBox="1"/>
+          <p:nvPr/>
+        </p:nvSpPr>
+        <p:spPr>
+          <a:xfrm>
+            <a:off x="704088" y="4434840"/>
+            <a:ext cx="7744968" cy="457200"/>
+          </a:xfrm>
+          <a:prstGeom prst="rect">
+            <a:avLst/>
+          </a:prstGeom>
+          <a:noFill/>
+        </p:spPr>
+        <p:txBody>
+          <a:bodyPr wrap="square">
+            <a:spAutoFit/>
+          </a:bodyPr>
+          <a:lstStyle/>
+          <a:p>
+            <a:r>
+              <a:rPr sz="1300" b="0">
+                <a:solidFill>
+                  <a:srgbClr val="333333"/>
+                </a:solidFill>
+                <a:latin typeface="Fira Sans"/>
+              </a:rPr>
+              <a:t>Providencia y Talagante tienen la misma duración media de viaje (40,7 minutos), pero la desviación estándar de Talagante es el doble: dos realidades distintas detrás del mismo promedio.</a:t>
             </a:r>
           </a:p>
         </p:txBody>
@@ -4128,21 +4258,45 @@
                 </a:solidFill>
                 <a:latin typeface="Fira Sans"/>
               </a:rPr>
-              <a:t>Valores faltantes</a:t>
-            </a:r>
-          </a:p>
-        </p:txBody>
-      </p:sp>
-      <p:sp>
-        <p:nvSpPr>
-          <p:cNvPr id="4" name="TextBox 3"/>
+              <a:t>El boxplot</a:t>
+            </a:r>
+          </a:p>
+        </p:txBody>
+      </p:sp>
+      <p:pic>
+        <p:nvPicPr>
+          <p:cNvPr id="4" name="Picture 3" descr="03_boxplot_anatomia.png"/>
+          <p:cNvPicPr>
+            <a:picLocks noChangeAspect="1"/>
+          </p:cNvPicPr>
+          <p:nvPr/>
+        </p:nvPicPr>
+        <p:blipFill>
+          <a:blip r:embed="rId2"/>
+          <a:stretch>
+            <a:fillRect/>
+          </a:stretch>
+        </p:blipFill>
+        <p:spPr>
+          <a:xfrm>
+            <a:off x="1740020" y="1143000"/>
+            <a:ext cx="5663958" cy="3154680"/>
+          </a:xfrm>
+          <a:prstGeom prst="rect">
+            <a:avLst/>
+          </a:prstGeom>
+        </p:spPr>
+      </p:pic>
+      <p:sp>
+        <p:nvSpPr>
+          <p:cNvPr id="5" name="TextBox 4"/>
           <p:cNvSpPr txBox="1"/>
           <p:nvPr/>
         </p:nvSpPr>
         <p:spPr>
           <a:xfrm>
-            <a:off x="704088" y="1353312"/>
-            <a:ext cx="7744968" cy="3300984"/>
+            <a:off x="704088" y="4434840"/>
+            <a:ext cx="7744968" cy="457200"/>
           </a:xfrm>
           <a:prstGeom prst="rect">
             <a:avLst/>
@@ -4155,115 +4309,14 @@
           </a:bodyPr>
           <a:lstStyle/>
           <a:p>
-            <a:pPr>
-              <a:lnSpc>
-                <a:spcPct val="112000"/>
-              </a:lnSpc>
-              <a:spcAft>
-                <a:spcPts val="900"/>
-              </a:spcAft>
-            </a:pPr>
-            <a:r>
-              <a:rPr sz="1800" b="1">
-                <a:solidFill>
-                  <a:srgbClr val="E0A437"/>
-                </a:solidFill>
-                <a:latin typeface="Fira Sans"/>
-              </a:rPr>
-              <a:t>▸ </a:t>
-            </a:r>
-            <a:r>
-              <a:rPr sz="1800" b="0">
-                <a:solidFill>
-                  <a:srgbClr val="000000"/>
-                </a:solidFill>
-                <a:latin typeface="Fira Sans"/>
-              </a:rPr>
-              <a:t>Detección: isna().sum(), o el count de describe() contra len.</a:t>
-            </a:r>
-          </a:p>
-          <a:p>
-            <a:pPr>
-              <a:lnSpc>
-                <a:spcPct val="112000"/>
-              </a:lnSpc>
-              <a:spcAft>
-                <a:spcPts val="900"/>
-              </a:spcAft>
-            </a:pPr>
-            <a:r>
-              <a:rPr sz="1800" b="1">
-                <a:solidFill>
-                  <a:srgbClr val="E0A437"/>
-                </a:solidFill>
-                <a:latin typeface="Fira Sans"/>
-              </a:rPr>
-              <a:t>▸ </a:t>
-            </a:r>
-            <a:r>
-              <a:rPr sz="1800" b="0">
-                <a:solidFill>
-                  <a:srgbClr val="000000"/>
-                </a:solidFill>
-                <a:latin typeface="Fira Sans"/>
-              </a:rPr>
-              <a:t>En la EOD: TiempoViaje tiene 278 faltantes entre 113.591 viajes.</a:t>
-            </a:r>
-          </a:p>
-          <a:p>
-            <a:pPr>
-              <a:lnSpc>
-                <a:spcPct val="112000"/>
-              </a:lnSpc>
-              <a:spcAft>
-                <a:spcPts val="900"/>
-              </a:spcAft>
-            </a:pPr>
-            <a:r>
-              <a:rPr sz="1800" b="1">
-                <a:solidFill>
-                  <a:srgbClr val="E0A437"/>
-                </a:solidFill>
-                <a:latin typeface="Fira Sans"/>
-              </a:rPr>
-              <a:t>▸ </a:t>
-            </a:r>
-            <a:r>
-              <a:rPr sz="1800" b="1">
-                <a:solidFill>
-                  <a:srgbClr val="1D3557"/>
-                </a:solidFill>
-                <a:latin typeface="Fira Sans"/>
-              </a:rPr>
-              <a:t>Un NaN no siempre es error: en los factores de expansión significa "no aplica".</a:t>
-            </a:r>
-          </a:p>
-          <a:p>
-            <a:pPr>
-              <a:lnSpc>
-                <a:spcPct val="112000"/>
-              </a:lnSpc>
-              <a:spcAft>
-                <a:spcPts val="900"/>
-              </a:spcAft>
-            </a:pPr>
-            <a:r>
-              <a:rPr sz="1800" b="1">
-                <a:solidFill>
-                  <a:srgbClr val="E0A437"/>
-                </a:solidFill>
-                <a:latin typeface="Fira Sans"/>
-              </a:rPr>
-              <a:t>▸ </a:t>
-            </a:r>
-            <a:r>
-              <a:rPr sz="1800" b="0">
-                <a:solidFill>
-                  <a:srgbClr val="000000"/>
-                </a:solidFill>
-                <a:latin typeface="Fira Sans"/>
-              </a:rPr>
-              <a:t>Opciones: eliminar, imputar o dejar que cada cálculo los excluya. Lo obligatorio: decidir y documentar.</a:t>
+            <a:r>
+              <a:rPr sz="1300" b="0">
+                <a:solidFill>
+                  <a:srgbClr val="333333"/>
+                </a:solidFill>
+                <a:latin typeface="Fira Sans"/>
+              </a:rPr>
+              <a:t>Cinco números en un solo gráfico: mediana, cuartiles, bigotes y valores atípicos. La regla de los bigotes (1,5 veces el IQR) es una convención para marcar valores inusuales, no un veredicto.</a:t>
             </a:r>
           </a:p>
         </p:txBody>
@@ -4359,21 +4412,45 @@
                 </a:solidFill>
                 <a:latin typeface="Fira Sans"/>
               </a:rPr>
-              <a:t>Duplicados</a:t>
-            </a:r>
-          </a:p>
-        </p:txBody>
-      </p:sp>
-      <p:sp>
-        <p:nvSpPr>
-          <p:cNvPr id="4" name="TextBox 3"/>
+              <a:t>Boxplots para comparar grupos: iris</a:t>
+            </a:r>
+          </a:p>
+        </p:txBody>
+      </p:sp>
+      <p:pic>
+        <p:nvPicPr>
+          <p:cNvPr id="4" name="Picture 3" descr="09_iris_boxplot.png"/>
+          <p:cNvPicPr>
+            <a:picLocks noChangeAspect="1"/>
+          </p:cNvPicPr>
+          <p:nvPr/>
+        </p:nvPicPr>
+        <p:blipFill>
+          <a:blip r:embed="rId2"/>
+          <a:stretch>
+            <a:fillRect/>
+          </a:stretch>
+        </p:blipFill>
+        <p:spPr>
+          <a:xfrm>
+            <a:off x="1602889" y="1143000"/>
+            <a:ext cx="5938221" cy="3154680"/>
+          </a:xfrm>
+          <a:prstGeom prst="rect">
+            <a:avLst/>
+          </a:prstGeom>
+        </p:spPr>
+      </p:pic>
+      <p:sp>
+        <p:nvSpPr>
+          <p:cNvPr id="5" name="TextBox 4"/>
           <p:cNvSpPr txBox="1"/>
           <p:nvPr/>
         </p:nvSpPr>
         <p:spPr>
           <a:xfrm>
-            <a:off x="704088" y="1353312"/>
-            <a:ext cx="7744968" cy="3300984"/>
+            <a:off x="704088" y="4434840"/>
+            <a:ext cx="7744968" cy="457200"/>
           </a:xfrm>
           <a:prstGeom prst="rect">
             <a:avLst/>
@@ -4386,115 +4463,14 @@
           </a:bodyPr>
           <a:lstStyle/>
           <a:p>
-            <a:pPr>
-              <a:lnSpc>
-                <a:spcPct val="112000"/>
-              </a:lnSpc>
-              <a:spcAft>
-                <a:spcPts val="900"/>
-              </a:spcAft>
-            </a:pPr>
-            <a:r>
-              <a:rPr sz="1800" b="1">
-                <a:solidFill>
-                  <a:srgbClr val="E0A437"/>
-                </a:solidFill>
-                <a:latin typeface="Fira Sans"/>
-              </a:rPr>
-              <a:t>▸ </a:t>
-            </a:r>
-            <a:r>
-              <a:rPr sz="1800" b="0">
-                <a:solidFill>
-                  <a:srgbClr val="000000"/>
-                </a:solidFill>
-                <a:latin typeface="Fira Sans"/>
-              </a:rPr>
-              <a:t>duplicated() marca filas repetidas; drop_duplicates() las elimina.</a:t>
-            </a:r>
-          </a:p>
-          <a:p>
-            <a:pPr>
-              <a:lnSpc>
-                <a:spcPct val="112000"/>
-              </a:lnSpc>
-              <a:spcAft>
-                <a:spcPts val="900"/>
-              </a:spcAft>
-            </a:pPr>
-            <a:r>
-              <a:rPr sz="1800" b="1">
-                <a:solidFill>
-                  <a:srgbClr val="E0A437"/>
-                </a:solidFill>
-                <a:latin typeface="Fira Sans"/>
-              </a:rPr>
-              <a:t>▸ </a:t>
-            </a:r>
-            <a:r>
-              <a:rPr sz="1800" b="0">
-                <a:solidFill>
-                  <a:srgbClr val="000000"/>
-                </a:solidFill>
-                <a:latin typeface="Fira Sans"/>
-              </a:rPr>
-              <a:t>Dos niveles: la fila completa y la llave que debería ser única.</a:t>
-            </a:r>
-          </a:p>
-          <a:p>
-            <a:pPr>
-              <a:lnSpc>
-                <a:spcPct val="112000"/>
-              </a:lnSpc>
-              <a:spcAft>
-                <a:spcPts val="900"/>
-              </a:spcAft>
-            </a:pPr>
-            <a:r>
-              <a:rPr sz="1800" b="1">
-                <a:solidFill>
-                  <a:srgbClr val="E0A437"/>
-                </a:solidFill>
-                <a:latin typeface="Fira Sans"/>
-              </a:rPr>
-              <a:t>▸ </a:t>
-            </a:r>
-            <a:r>
-              <a:rPr sz="1800" b="0">
-                <a:solidFill>
-                  <a:srgbClr val="000000"/>
-                </a:solidFill>
-                <a:latin typeface="Fira Sans"/>
-              </a:rPr>
-              <a:t>En la EOD ambos chequeos dan cero; un cero también es un hallazgo.</a:t>
-            </a:r>
-          </a:p>
-          <a:p>
-            <a:pPr>
-              <a:lnSpc>
-                <a:spcPct val="112000"/>
-              </a:lnSpc>
-              <a:spcAft>
-                <a:spcPts val="900"/>
-              </a:spcAft>
-            </a:pPr>
-            <a:r>
-              <a:rPr sz="1800" b="1">
-                <a:solidFill>
-                  <a:srgbClr val="E0A437"/>
-                </a:solidFill>
-                <a:latin typeface="Fira Sans"/>
-              </a:rPr>
-              <a:t>▸ </a:t>
-            </a:r>
-            <a:r>
-              <a:rPr sz="1800" b="0">
-                <a:solidFill>
-                  <a:srgbClr val="000000"/>
-                </a:solidFill>
-                <a:latin typeface="Fira Sans"/>
-              </a:rPr>
-              <a:t>El riesgo típico: un merge con llaves repetidas multiplica filas.</a:t>
+            <a:r>
+              <a:rPr sz="1300" b="0">
+                <a:solidFill>
+                  <a:srgbClr val="333333"/>
+                </a:solidFill>
+                <a:latin typeface="Fira Sans"/>
+              </a:rPr>
+              <a:t>El largo del pétalo separa casi perfectamente a las tres especies: centros y dispersiones distintas en una sola figura.</a:t>
             </a:r>
           </a:p>
         </p:txBody>
@@ -4590,14 +4566,14 @@
                 </a:solidFill>
                 <a:latin typeface="Fira Sans"/>
               </a:rPr>
-              <a:t>Valores sospechosos</a:t>
+              <a:t>Boxplots para comparar grupos: la EOD</a:t>
             </a:r>
           </a:p>
         </p:txBody>
       </p:sp>
       <p:pic>
         <p:nvPicPr>
-          <p:cNvPr id="4" name="Picture 3" descr="05_cola_imposibles.png"/>
+          <p:cNvPr id="4" name="Picture 3" descr="04_boxplot_modos.png"/>
           <p:cNvPicPr>
             <a:picLocks noChangeAspect="1"/>
           </p:cNvPicPr>
@@ -4611,8 +4587,8 @@
         </p:blipFill>
         <p:spPr>
           <a:xfrm>
-            <a:off x="1648218" y="1143000"/>
-            <a:ext cx="5847563" cy="3154680"/>
+            <a:off x="1417319" y="1143000"/>
+            <a:ext cx="6309360" cy="2899161"/>
           </a:xfrm>
           <a:prstGeom prst="rect">
             <a:avLst/>
@@ -4648,7 +4624,7 @@
                 </a:solidFill>
                 <a:latin typeface="Fira Sans"/>
               </a:rPr>
-              <a:t>116 viajes declaran más de 5 horas y el máximo es de 22 horas. ¿Error de registro o viaje real? La respuesta exige criterio del dominio; la decisión (mantener, corregir o excluir) se toma en el código y se documenta.</a:t>
+              <a:t>La duración del viaje según el modo: centros y dispersiones distintas en una sola figura. Es el gráfico estándar para comparar una variable cuantitativa entre categorías.</a:t>
             </a:r>
           </a:p>
         </p:txBody>
@@ -4686,7 +4662,7 @@
             <a:avLst/>
           </a:prstGeom>
           <a:solidFill>
-            <a:srgbClr val="FAFBFC"/>
+            <a:srgbClr val="1D3557"/>
           </a:solidFill>
           <a:ln>
             <a:noFill/>
@@ -4723,8 +4699,8 @@
         </p:nvSpPr>
         <p:spPr>
           <a:xfrm>
-            <a:off x="402336" y="301752"/>
-            <a:ext cx="8348472" cy="795528"/>
+            <a:off x="603504" y="1847088"/>
+            <a:ext cx="7946136" cy="1399032"/>
           </a:xfrm>
           <a:prstGeom prst="rect">
             <a:avLst/>
@@ -4738,143 +4714,24 @@
           <a:lstStyle/>
           <a:p>
             <a:r>
-              <a:rPr sz="2800" b="1">
-                <a:solidFill>
-                  <a:srgbClr val="0F0F0F"/>
-                </a:solidFill>
-                <a:latin typeface="Fira Sans"/>
-              </a:rPr>
-              <a:t>Tapar valores con mask</a:t>
-            </a:r>
-          </a:p>
-        </p:txBody>
-      </p:sp>
-      <p:sp>
-        <p:nvSpPr>
-          <p:cNvPr id="4" name="Rectangle 3"/>
-          <p:cNvSpPr/>
-          <p:nvPr/>
-        </p:nvSpPr>
-        <p:spPr>
-          <a:xfrm>
-            <a:off x="704088" y="1280160"/>
-            <a:ext cx="7744968" cy="1874520"/>
-          </a:xfrm>
-          <a:prstGeom prst="rect">
-            <a:avLst/>
-          </a:prstGeom>
-          <a:solidFill>
-            <a:srgbClr val="F0F2F5"/>
-          </a:solidFill>
-          <a:ln>
-            <a:solidFill>
-              <a:srgbClr val="D8DDE3"/>
-            </a:solidFill>
-          </a:ln>
-          <a:effectLst/>
-        </p:spPr>
-        <p:style>
-          <a:lnRef idx="1">
-            <a:schemeClr val="accent1"/>
-          </a:lnRef>
-          <a:fillRef idx="3">
-            <a:schemeClr val="accent1"/>
-          </a:fillRef>
-          <a:effectRef idx="2">
-            <a:schemeClr val="accent1"/>
-          </a:effectRef>
-          <a:fontRef idx="minor">
-            <a:schemeClr val="lt1"/>
-          </a:fontRef>
-        </p:style>
-        <p:txBody>
-          <a:bodyPr rtlCol="0" anchor="ctr" wrap="square" lIns="228600" tIns="137160"/>
-          <a:lstStyle/>
-          <a:p>
-            <a:pPr/>
-            <a:r>
-              <a:rPr sz="1500" b="0">
-                <a:solidFill>
-                  <a:srgbClr val="1D3557"/>
-                </a:solidFill>
-                <a:latin typeface="Menlo"/>
-              </a:rPr>
-              <a:t># donde la condición se cumple, reemplaza (aquí, por NaN)</a:t>
-            </a:r>
-          </a:p>
-          <a:p>
-            <a:pPr/>
-            <a:r>
-              <a:rPr sz="1500" b="0">
-                <a:solidFill>
-                  <a:srgbClr val="1D3557"/>
-                </a:solidFill>
-                <a:latin typeface="Menlo"/>
-              </a:rPr>
-              <a:t>viajes["TiempoViaje"] = viajes["TiempoViaje"].mask(</a:t>
-            </a:r>
-          </a:p>
-          <a:p>
-            <a:pPr/>
-            <a:r>
-              <a:rPr sz="1500" b="0">
-                <a:solidFill>
-                  <a:srgbClr val="1D3557"/>
-                </a:solidFill>
-                <a:latin typeface="Menlo"/>
-              </a:rPr>
-              <a:t>    viajes["TiempoViaje"] &gt; 300)</a:t>
-            </a:r>
-          </a:p>
-        </p:txBody>
-      </p:sp>
-      <p:sp>
-        <p:nvSpPr>
-          <p:cNvPr id="5" name="TextBox 4"/>
-          <p:cNvSpPr txBox="1"/>
-          <p:nvPr/>
-        </p:nvSpPr>
-        <p:spPr>
-          <a:xfrm>
-            <a:off x="704088" y="3383279"/>
-            <a:ext cx="7744968" cy="1097280"/>
-          </a:xfrm>
-          <a:prstGeom prst="rect">
-            <a:avLst/>
-          </a:prstGeom>
-          <a:noFill/>
-        </p:spPr>
-        <p:txBody>
-          <a:bodyPr wrap="square">
-            <a:spAutoFit/>
-          </a:bodyPr>
-          <a:lstStyle/>
-          <a:p>
-            <a:pPr>
-              <a:lnSpc>
-                <a:spcPct val="112000"/>
-              </a:lnSpc>
-              <a:spcAft>
-                <a:spcPts val="900"/>
-              </a:spcAft>
-            </a:pPr>
-            <a:r>
-              <a:rPr sz="1600" b="1">
+              <a:rPr sz="3400" b="1">
+                <a:solidFill>
+                  <a:srgbClr val="FFFFFF"/>
+                </a:solidFill>
+                <a:latin typeface="Fira Sans"/>
+              </a:rPr>
+              <a:t>Recreo</a:t>
+            </a:r>
+          </a:p>
+          <a:p>
+            <a:r>
+              <a:rPr sz="1800" b="0">
                 <a:solidFill>
                   <a:srgbClr val="E0A437"/>
                 </a:solidFill>
                 <a:latin typeface="Fira Sans"/>
               </a:rPr>
-              <a:t>▸ </a:t>
-            </a:r>
-            <a:r>
-              <a:rPr sz="1600" b="0">
-                <a:solidFill>
-                  <a:srgbClr val="000000"/>
-                </a:solidFill>
-                <a:latin typeface="Fira Sans"/>
-              </a:rPr>
-              <a:t>mask reemplaza donde la condición es verdadera; where, su espejo, conserva donde es verdadera y reemplaza el resto. Regla nemotécnica: mask es dónde tapar, where es dónde quedarse.</a:t>
+              <a:t>10 minutos</a:t>
             </a:r>
           </a:p>
         </p:txBody>
@@ -4912,7 +4769,7 @@
             <a:avLst/>
           </a:prstGeom>
           <a:solidFill>
-            <a:srgbClr val="FAFBFC"/>
+            <a:srgbClr val="1D3557"/>
           </a:solidFill>
           <a:ln>
             <a:noFill/>
@@ -4949,8 +4806,8 @@
         </p:nvSpPr>
         <p:spPr>
           <a:xfrm>
-            <a:off x="402336" y="301752"/>
-            <a:ext cx="8348472" cy="795528"/>
+            <a:off x="603504" y="1847088"/>
+            <a:ext cx="7946136" cy="1399032"/>
           </a:xfrm>
           <a:prstGeom prst="rect">
             <a:avLst/>
@@ -4964,120 +4821,24 @@
           <a:lstStyle/>
           <a:p>
             <a:r>
-              <a:rPr sz="2800" b="1">
-                <a:solidFill>
-                  <a:srgbClr val="0F0F0F"/>
-                </a:solidFill>
-                <a:latin typeface="Fira Sans"/>
-              </a:rPr>
-              <a:t>Revisar cada merge</a:t>
-            </a:r>
-          </a:p>
-        </p:txBody>
-      </p:sp>
-      <p:sp>
-        <p:nvSpPr>
-          <p:cNvPr id="4" name="TextBox 3"/>
-          <p:cNvSpPr txBox="1"/>
-          <p:nvPr/>
-        </p:nvSpPr>
-        <p:spPr>
-          <a:xfrm>
-            <a:off x="704088" y="1353312"/>
-            <a:ext cx="7744968" cy="3300984"/>
-          </a:xfrm>
-          <a:prstGeom prst="rect">
-            <a:avLst/>
-          </a:prstGeom>
-          <a:noFill/>
-        </p:spPr>
-        <p:txBody>
-          <a:bodyPr wrap="square">
-            <a:spAutoFit/>
-          </a:bodyPr>
-          <a:lstStyle/>
-          <a:p>
-            <a:pPr>
-              <a:lnSpc>
-                <a:spcPct val="112000"/>
-              </a:lnSpc>
-              <a:spcAft>
-                <a:spcPts val="900"/>
-              </a:spcAft>
-            </a:pPr>
-            <a:r>
-              <a:rPr sz="1800" b="1">
+              <a:rPr sz="3400" b="1">
+                <a:solidFill>
+                  <a:srgbClr val="FFFFFF"/>
+                </a:solidFill>
+                <a:latin typeface="Fira Sans"/>
+              </a:rPr>
+              <a:t>Calidad y limpieza de datos</a:t>
+            </a:r>
+          </a:p>
+          <a:p>
+            <a:r>
+              <a:rPr sz="1800" b="0">
                 <a:solidFill>
                   <a:srgbClr val="E0A437"/>
                 </a:solidFill>
                 <a:latin typeface="Fira Sans"/>
               </a:rPr>
-              <a:t>▸ </a:t>
-            </a:r>
-            <a:r>
-              <a:rPr sz="1800" b="0">
-                <a:solidFill>
-                  <a:srgbClr val="000000"/>
-                </a:solidFill>
-                <a:latin typeface="Fira Sans"/>
-              </a:rPr>
-              <a:t>Comparar el número de filas antes y después: un inner descarta las filas sin pareja; en la clase 1, 113.591 viajes quedaron en 111.393.</a:t>
-            </a:r>
-          </a:p>
-          <a:p>
-            <a:pPr>
-              <a:lnSpc>
-                <a:spcPct val="112000"/>
-              </a:lnSpc>
-              <a:spcAft>
-                <a:spcPts val="900"/>
-              </a:spcAft>
-            </a:pPr>
-            <a:r>
-              <a:rPr sz="1800" b="1">
-                <a:solidFill>
-                  <a:srgbClr val="E0A437"/>
-                </a:solidFill>
-                <a:latin typeface="Fira Sans"/>
-              </a:rPr>
-              <a:t>▸ </a:t>
-            </a:r>
-            <a:r>
-              <a:rPr sz="1800" b="0">
-                <a:solidFill>
-                  <a:srgbClr val="000000"/>
-                </a:solidFill>
-                <a:latin typeface="Fira Sans"/>
-              </a:rPr>
-              <a:t>Contar los NaN de las columnas nuevas cuando se usa how="left": ahí quedan visibles las filas sin correspondencia (2.198 comunas).</a:t>
-            </a:r>
-          </a:p>
-          <a:p>
-            <a:pPr>
-              <a:lnSpc>
-                <a:spcPct val="112000"/>
-              </a:lnSpc>
-              <a:spcAft>
-                <a:spcPts val="900"/>
-              </a:spcAft>
-            </a:pPr>
-            <a:r>
-              <a:rPr sz="1800" b="1">
-                <a:solidFill>
-                  <a:srgbClr val="E0A437"/>
-                </a:solidFill>
-                <a:latin typeface="Fira Sans"/>
-              </a:rPr>
-              <a:t>▸ </a:t>
-            </a:r>
-            <a:r>
-              <a:rPr sz="1800" b="0">
-                <a:solidFill>
-                  <a:srgbClr val="000000"/>
-                </a:solidFill>
-                <a:latin typeface="Fira Sans"/>
-              </a:rPr>
-              <a:t>Verificar que la llave sea única en la tabla de parámetros: si está repetida, el merge multiplica filas.</a:t>
+              <a:t>Los resúmenes valen lo que valen los datos</a:t>
             </a:r>
           </a:p>
         </p:txBody>
@@ -5460,7 +5221,7 @@
                 </a:solidFill>
                 <a:latin typeface="Fira Sans"/>
               </a:rPr>
-              <a:t>Checklist de calidad antes de analizar</a:t>
+              <a:t>iris viene casi limpio; los datos reales, no</a:t>
             </a:r>
           </a:p>
         </p:txBody>
@@ -5511,7 +5272,7 @@
                 </a:solidFill>
                 <a:latin typeface="Fira Sans"/>
               </a:rPr>
-              <a:t>Dimensiones y tipos: shape, info().</a:t>
+              <a:t>iris: cero faltantes en sus 150 filas... y aun así tiene una fila duplicada. Hasta el dataset más famoso trae un problema de calidad.</a:t>
             </a:r>
           </a:p>
           <a:p>
@@ -5539,7 +5300,7 @@
                 </a:solidFill>
                 <a:latin typeface="Fira Sans"/>
               </a:rPr>
-              <a:t>Faltantes por columna relevante: isna().sum(), count contra len.</a:t>
+              <a:t>La EOD: 278 duraciones faltantes, códigos que traducir, colas sospechosas y factores que son NaN por diseño.</a:t>
             </a:r>
           </a:p>
           <a:p>
@@ -5561,97 +5322,13 @@
               <a:t>▸ </a:t>
             </a:r>
             <a:r>
-              <a:rPr sz="1800" b="0">
-                <a:solidFill>
-                  <a:srgbClr val="000000"/>
-                </a:solidFill>
-                <a:latin typeface="Fira Sans"/>
-              </a:rPr>
-              <a:t>Duplicados: fila completa y llave única.</a:t>
-            </a:r>
-          </a:p>
-          <a:p>
-            <a:pPr>
-              <a:lnSpc>
-                <a:spcPct val="112000"/>
-              </a:lnSpc>
-              <a:spcAft>
-                <a:spcPts val="900"/>
-              </a:spcAft>
-            </a:pPr>
-            <a:r>
               <a:rPr sz="1800" b="1">
                 <a:solidFill>
-                  <a:srgbClr val="E0A437"/>
-                </a:solidFill>
-                <a:latin typeface="Fira Sans"/>
-              </a:rPr>
-              <a:t>▸ </a:t>
-            </a:r>
-            <a:r>
-              <a:rPr sz="1800" b="0">
-                <a:solidFill>
-                  <a:srgbClr val="000000"/>
-                </a:solidFill>
-                <a:latin typeface="Fira Sans"/>
-              </a:rPr>
-              <a:t>Rangos válidos de cada variable cuantitativa: min, max, valores sospechosos.</a:t>
-            </a:r>
-          </a:p>
-          <a:p>
-            <a:pPr>
-              <a:lnSpc>
-                <a:spcPct val="112000"/>
-              </a:lnSpc>
-              <a:spcAft>
-                <a:spcPts val="900"/>
-              </a:spcAft>
-            </a:pPr>
-            <a:r>
-              <a:rPr sz="1800" b="1">
-                <a:solidFill>
-                  <a:srgbClr val="E0A437"/>
-                </a:solidFill>
-                <a:latin typeface="Fira Sans"/>
-              </a:rPr>
-              <a:t>▸ </a:t>
-            </a:r>
-            <a:r>
-              <a:rPr sz="1800" b="0">
-                <a:solidFill>
-                  <a:srgbClr val="000000"/>
-                </a:solidFill>
-                <a:latin typeface="Fira Sans"/>
-              </a:rPr>
-              <a:t>Merges verificados: filas, NaN nuevos, llaves únicas.</a:t>
-            </a:r>
-          </a:p>
-          <a:p>
-            <a:pPr>
-              <a:lnSpc>
-                <a:spcPct val="112000"/>
-              </a:lnSpc>
-              <a:spcAft>
-                <a:spcPts val="900"/>
-              </a:spcAft>
-            </a:pPr>
-            <a:r>
-              <a:rPr sz="1800" b="1">
-                <a:solidFill>
-                  <a:srgbClr val="E0A437"/>
-                </a:solidFill>
-                <a:latin typeface="Fira Sans"/>
-              </a:rPr>
-              <a:t>▸ </a:t>
-            </a:r>
-            <a:r>
-              <a:rPr sz="1800" b="1">
-                <a:solidFill>
                   <a:srgbClr val="1D3557"/>
                 </a:solidFill>
                 <a:latin typeface="Fira Sans"/>
               </a:rPr>
-              <a:t>Cada decisión de limpieza queda escrita en el código, con su justificación.</a:t>
+              <a:t>Por eso el checklist de calidad se aplica siempre, también al dataset del proyecto.</a:t>
             </a:r>
           </a:p>
         </p:txBody>
@@ -5689,7 +5366,7 @@
             <a:avLst/>
           </a:prstGeom>
           <a:solidFill>
-            <a:srgbClr val="1D3557"/>
+            <a:srgbClr val="FAFBFC"/>
           </a:solidFill>
           <a:ln>
             <a:noFill/>
@@ -5726,8 +5403,8 @@
         </p:nvSpPr>
         <p:spPr>
           <a:xfrm>
-            <a:off x="603504" y="1847088"/>
-            <a:ext cx="7946136" cy="1399032"/>
+            <a:off x="402336" y="301752"/>
+            <a:ext cx="8348472" cy="795528"/>
           </a:xfrm>
           <a:prstGeom prst="rect">
             <a:avLst/>
@@ -5741,24 +5418,148 @@
           <a:lstStyle/>
           <a:p>
             <a:r>
-              <a:rPr sz="3400" b="1">
-                <a:solidFill>
-                  <a:srgbClr val="FFFFFF"/>
-                </a:solidFill>
-                <a:latin typeface="Fira Sans"/>
-              </a:rPr>
-              <a:t>La pregunta y la hipótesis</a:t>
-            </a:r>
-          </a:p>
-          <a:p>
+              <a:rPr sz="2800" b="1">
+                <a:solidFill>
+                  <a:srgbClr val="0F0F0F"/>
+                </a:solidFill>
+                <a:latin typeface="Fira Sans"/>
+              </a:rPr>
+              <a:t>Valores faltantes</a:t>
+            </a:r>
+          </a:p>
+        </p:txBody>
+      </p:sp>
+      <p:sp>
+        <p:nvSpPr>
+          <p:cNvPr id="4" name="TextBox 3"/>
+          <p:cNvSpPr txBox="1"/>
+          <p:nvPr/>
+        </p:nvSpPr>
+        <p:spPr>
+          <a:xfrm>
+            <a:off x="704088" y="1353312"/>
+            <a:ext cx="7744968" cy="3300984"/>
+          </a:xfrm>
+          <a:prstGeom prst="rect">
+            <a:avLst/>
+          </a:prstGeom>
+          <a:noFill/>
+        </p:spPr>
+        <p:txBody>
+          <a:bodyPr wrap="square">
+            <a:spAutoFit/>
+          </a:bodyPr>
+          <a:lstStyle/>
+          <a:p>
+            <a:pPr>
+              <a:lnSpc>
+                <a:spcPct val="112000"/>
+              </a:lnSpc>
+              <a:spcAft>
+                <a:spcPts val="900"/>
+              </a:spcAft>
+            </a:pPr>
+            <a:r>
+              <a:rPr sz="1800" b="1">
+                <a:solidFill>
+                  <a:srgbClr val="E0A437"/>
+                </a:solidFill>
+                <a:latin typeface="Fira Sans"/>
+              </a:rPr>
+              <a:t>▸ </a:t>
+            </a:r>
             <a:r>
               <a:rPr sz="1800" b="0">
                 <a:solidFill>
+                  <a:srgbClr val="000000"/>
+                </a:solidFill>
+                <a:latin typeface="Fira Sans"/>
+              </a:rPr>
+              <a:t>Detección: isna().sum(), o el count de describe() contra len.</a:t>
+            </a:r>
+          </a:p>
+          <a:p>
+            <a:pPr>
+              <a:lnSpc>
+                <a:spcPct val="112000"/>
+              </a:lnSpc>
+              <a:spcAft>
+                <a:spcPts val="900"/>
+              </a:spcAft>
+            </a:pPr>
+            <a:r>
+              <a:rPr sz="1800" b="1">
+                <a:solidFill>
                   <a:srgbClr val="E0A437"/>
                 </a:solidFill>
                 <a:latin typeface="Fira Sans"/>
               </a:rPr>
-              <a:t>Formular el proyecto antes de analizarlo</a:t>
+              <a:t>▸ </a:t>
+            </a:r>
+            <a:r>
+              <a:rPr sz="1800" b="0">
+                <a:solidFill>
+                  <a:srgbClr val="000000"/>
+                </a:solidFill>
+                <a:latin typeface="Fira Sans"/>
+              </a:rPr>
+              <a:t>En la EOD: TiempoViaje tiene 278 faltantes entre 113.591 viajes.</a:t>
+            </a:r>
+          </a:p>
+          <a:p>
+            <a:pPr>
+              <a:lnSpc>
+                <a:spcPct val="112000"/>
+              </a:lnSpc>
+              <a:spcAft>
+                <a:spcPts val="900"/>
+              </a:spcAft>
+            </a:pPr>
+            <a:r>
+              <a:rPr sz="1800" b="1">
+                <a:solidFill>
+                  <a:srgbClr val="E0A437"/>
+                </a:solidFill>
+                <a:latin typeface="Fira Sans"/>
+              </a:rPr>
+              <a:t>▸ </a:t>
+            </a:r>
+            <a:r>
+              <a:rPr sz="1800" b="1">
+                <a:solidFill>
+                  <a:srgbClr val="1D3557"/>
+                </a:solidFill>
+                <a:latin typeface="Fira Sans"/>
+              </a:rPr>
+              <a:t>Un NaN no siempre es error: en los factores de expansión significa "no aplica".</a:t>
+            </a:r>
+          </a:p>
+          <a:p>
+            <a:pPr>
+              <a:lnSpc>
+                <a:spcPct val="112000"/>
+              </a:lnSpc>
+              <a:spcAft>
+                <a:spcPts val="900"/>
+              </a:spcAft>
+            </a:pPr>
+            <a:r>
+              <a:rPr sz="1800" b="1">
+                <a:solidFill>
+                  <a:srgbClr val="E0A437"/>
+                </a:solidFill>
+                <a:latin typeface="Fira Sans"/>
+              </a:rPr>
+              <a:t>▸ </a:t>
+            </a:r>
+            <a:r>
+              <a:rPr sz="1800" b="0">
+                <a:solidFill>
+                  <a:srgbClr val="000000"/>
+                </a:solidFill>
+                <a:latin typeface="Fira Sans"/>
+              </a:rPr>
+              <a:t>Opciones: eliminar, imputar o dejar que cada cálculo los excluya. Lo obligatorio: decidir y documentar.</a:t>
             </a:r>
           </a:p>
         </p:txBody>
@@ -5854,45 +5655,21 @@
                 </a:solidFill>
                 <a:latin typeface="Fira Sans"/>
               </a:rPr>
-              <a:t>Seis tipos de pregunta</a:t>
-            </a:r>
-          </a:p>
-        </p:txBody>
-      </p:sp>
-      <p:pic>
-        <p:nvPicPr>
-          <p:cNvPr id="4" name="Picture 3" descr="06_tipos_preguntas.png"/>
-          <p:cNvPicPr>
-            <a:picLocks noChangeAspect="1"/>
-          </p:cNvPicPr>
-          <p:nvPr/>
-        </p:nvPicPr>
-        <p:blipFill>
-          <a:blip r:embed="rId2"/>
-          <a:stretch>
-            <a:fillRect/>
-          </a:stretch>
-        </p:blipFill>
-        <p:spPr>
-          <a:xfrm>
-            <a:off x="1417319" y="1143000"/>
-            <a:ext cx="6309360" cy="3121297"/>
-          </a:xfrm>
-          <a:prstGeom prst="rect">
-            <a:avLst/>
-          </a:prstGeom>
-        </p:spPr>
-      </p:pic>
-      <p:sp>
-        <p:nvSpPr>
-          <p:cNvPr id="5" name="TextBox 4"/>
+              <a:t>Duplicados</a:t>
+            </a:r>
+          </a:p>
+        </p:txBody>
+      </p:sp>
+      <p:sp>
+        <p:nvSpPr>
+          <p:cNvPr id="4" name="TextBox 3"/>
           <p:cNvSpPr txBox="1"/>
           <p:nvPr/>
         </p:nvSpPr>
         <p:spPr>
           <a:xfrm>
-            <a:off x="704088" y="4434840"/>
-            <a:ext cx="7744968" cy="457200"/>
+            <a:off x="704088" y="1353312"/>
+            <a:ext cx="7744968" cy="3300984"/>
           </a:xfrm>
           <a:prstGeom prst="rect">
             <a:avLst/>
@@ -5905,14 +5682,115 @@
           </a:bodyPr>
           <a:lstStyle/>
           <a:p>
-            <a:r>
-              <a:rPr sz="1300" b="0">
-                <a:solidFill>
-                  <a:srgbClr val="333333"/>
-                </a:solidFill>
-                <a:latin typeface="Fira Sans"/>
-              </a:rPr>
-              <a:t>El módulo cubre los cuatro primeros tipos. El error más común de un análisis es responder un tipo de pregunta creyendo que se responde otro (Leek y Peng, 2015).</a:t>
+            <a:pPr>
+              <a:lnSpc>
+                <a:spcPct val="112000"/>
+              </a:lnSpc>
+              <a:spcAft>
+                <a:spcPts val="900"/>
+              </a:spcAft>
+            </a:pPr>
+            <a:r>
+              <a:rPr sz="1800" b="1">
+                <a:solidFill>
+                  <a:srgbClr val="E0A437"/>
+                </a:solidFill>
+                <a:latin typeface="Fira Sans"/>
+              </a:rPr>
+              <a:t>▸ </a:t>
+            </a:r>
+            <a:r>
+              <a:rPr sz="1800" b="0">
+                <a:solidFill>
+                  <a:srgbClr val="000000"/>
+                </a:solidFill>
+                <a:latin typeface="Fira Sans"/>
+              </a:rPr>
+              <a:t>duplicated() marca filas repetidas; drop_duplicates() las elimina.</a:t>
+            </a:r>
+          </a:p>
+          <a:p>
+            <a:pPr>
+              <a:lnSpc>
+                <a:spcPct val="112000"/>
+              </a:lnSpc>
+              <a:spcAft>
+                <a:spcPts val="900"/>
+              </a:spcAft>
+            </a:pPr>
+            <a:r>
+              <a:rPr sz="1800" b="1">
+                <a:solidFill>
+                  <a:srgbClr val="E0A437"/>
+                </a:solidFill>
+                <a:latin typeface="Fira Sans"/>
+              </a:rPr>
+              <a:t>▸ </a:t>
+            </a:r>
+            <a:r>
+              <a:rPr sz="1800" b="0">
+                <a:solidFill>
+                  <a:srgbClr val="000000"/>
+                </a:solidFill>
+                <a:latin typeface="Fira Sans"/>
+              </a:rPr>
+              <a:t>Dos niveles: la fila completa y la llave que debería ser única.</a:t>
+            </a:r>
+          </a:p>
+          <a:p>
+            <a:pPr>
+              <a:lnSpc>
+                <a:spcPct val="112000"/>
+              </a:lnSpc>
+              <a:spcAft>
+                <a:spcPts val="900"/>
+              </a:spcAft>
+            </a:pPr>
+            <a:r>
+              <a:rPr sz="1800" b="1">
+                <a:solidFill>
+                  <a:srgbClr val="E0A437"/>
+                </a:solidFill>
+                <a:latin typeface="Fira Sans"/>
+              </a:rPr>
+              <a:t>▸ </a:t>
+            </a:r>
+            <a:r>
+              <a:rPr sz="1800" b="0">
+                <a:solidFill>
+                  <a:srgbClr val="000000"/>
+                </a:solidFill>
+                <a:latin typeface="Fira Sans"/>
+              </a:rPr>
+              <a:t>En la EOD ambos chequeos dan cero; un cero también es un hallazgo.</a:t>
+            </a:r>
+          </a:p>
+          <a:p>
+            <a:pPr>
+              <a:lnSpc>
+                <a:spcPct val="112000"/>
+              </a:lnSpc>
+              <a:spcAft>
+                <a:spcPts val="900"/>
+              </a:spcAft>
+            </a:pPr>
+            <a:r>
+              <a:rPr sz="1800" b="1">
+                <a:solidFill>
+                  <a:srgbClr val="E0A437"/>
+                </a:solidFill>
+                <a:latin typeface="Fira Sans"/>
+              </a:rPr>
+              <a:t>▸ </a:t>
+            </a:r>
+            <a:r>
+              <a:rPr sz="1800" b="0">
+                <a:solidFill>
+                  <a:srgbClr val="000000"/>
+                </a:solidFill>
+                <a:latin typeface="Fira Sans"/>
+              </a:rPr>
+              <a:t>El riesgo típico: un merge con llaves repetidas multiplica filas.</a:t>
             </a:r>
           </a:p>
         </p:txBody>
@@ -6008,21 +5886,45 @@
                 </a:solidFill>
                 <a:latin typeface="Fira Sans"/>
               </a:rPr>
-              <a:t>Qué hace buena a una pregunta</a:t>
-            </a:r>
-          </a:p>
-        </p:txBody>
-      </p:sp>
-      <p:sp>
-        <p:nvSpPr>
-          <p:cNvPr id="4" name="TextBox 3"/>
+              <a:t>Valores sospechosos</a:t>
+            </a:r>
+          </a:p>
+        </p:txBody>
+      </p:sp>
+      <p:pic>
+        <p:nvPicPr>
+          <p:cNvPr id="4" name="Picture 3" descr="05_cola_imposibles.png"/>
+          <p:cNvPicPr>
+            <a:picLocks noChangeAspect="1"/>
+          </p:cNvPicPr>
+          <p:nvPr/>
+        </p:nvPicPr>
+        <p:blipFill>
+          <a:blip r:embed="rId2"/>
+          <a:stretch>
+            <a:fillRect/>
+          </a:stretch>
+        </p:blipFill>
+        <p:spPr>
+          <a:xfrm>
+            <a:off x="1648218" y="1143000"/>
+            <a:ext cx="5847563" cy="3154680"/>
+          </a:xfrm>
+          <a:prstGeom prst="rect">
+            <a:avLst/>
+          </a:prstGeom>
+        </p:spPr>
+      </p:pic>
+      <p:sp>
+        <p:nvSpPr>
+          <p:cNvPr id="5" name="TextBox 4"/>
           <p:cNvSpPr txBox="1"/>
           <p:nvPr/>
         </p:nvSpPr>
         <p:spPr>
           <a:xfrm>
-            <a:off x="704088" y="1353312"/>
-            <a:ext cx="7744968" cy="3300984"/>
+            <a:off x="704088" y="4434840"/>
+            <a:ext cx="7744968" cy="457200"/>
           </a:xfrm>
           <a:prstGeom prst="rect">
             <a:avLst/>
@@ -6035,143 +5937,14 @@
           </a:bodyPr>
           <a:lstStyle/>
           <a:p>
-            <a:pPr>
-              <a:lnSpc>
-                <a:spcPct val="112000"/>
-              </a:lnSpc>
-              <a:spcAft>
-                <a:spcPts val="900"/>
-              </a:spcAft>
-            </a:pPr>
-            <a:r>
-              <a:rPr sz="1800" b="1">
-                <a:solidFill>
-                  <a:srgbClr val="E0A437"/>
-                </a:solidFill>
-                <a:latin typeface="Fira Sans"/>
-              </a:rPr>
-              <a:t>▸ </a:t>
-            </a:r>
-            <a:r>
-              <a:rPr sz="1800" b="0">
-                <a:solidFill>
-                  <a:srgbClr val="000000"/>
-                </a:solidFill>
-                <a:latin typeface="Fira Sans"/>
-              </a:rPr>
-              <a:t>De interés real: una audiencia concreta usaría la respuesta (Peng y Matsui, 2015).</a:t>
-            </a:r>
-          </a:p>
-          <a:p>
-            <a:pPr>
-              <a:lnSpc>
-                <a:spcPct val="112000"/>
-              </a:lnSpc>
-              <a:spcAft>
-                <a:spcPts val="900"/>
-              </a:spcAft>
-            </a:pPr>
-            <a:r>
-              <a:rPr sz="1800" b="1">
-                <a:solidFill>
-                  <a:srgbClr val="E0A437"/>
-                </a:solidFill>
-                <a:latin typeface="Fira Sans"/>
-              </a:rPr>
-              <a:t>▸ </a:t>
-            </a:r>
-            <a:r>
-              <a:rPr sz="1800" b="0">
-                <a:solidFill>
-                  <a:srgbClr val="000000"/>
-                </a:solidFill>
-                <a:latin typeface="Fira Sans"/>
-              </a:rPr>
-              <a:t>No respondida ya: revisar qué existe antes de empezar.</a:t>
-            </a:r>
-          </a:p>
-          <a:p>
-            <a:pPr>
-              <a:lnSpc>
-                <a:spcPct val="112000"/>
-              </a:lnSpc>
-              <a:spcAft>
-                <a:spcPts val="900"/>
-              </a:spcAft>
-            </a:pPr>
-            <a:r>
-              <a:rPr sz="1800" b="1">
-                <a:solidFill>
-                  <a:srgbClr val="E0A437"/>
-                </a:solidFill>
-                <a:latin typeface="Fira Sans"/>
-              </a:rPr>
-              <a:t>▸ </a:t>
-            </a:r>
-            <a:r>
-              <a:rPr sz="1800" b="0">
-                <a:solidFill>
-                  <a:srgbClr val="000000"/>
-                </a:solidFill>
-                <a:latin typeface="Fira Sans"/>
-              </a:rPr>
-              <a:t>Plausible: la respuesta esperada tiene un mecanismo creíble.</a:t>
-            </a:r>
-          </a:p>
-          <a:p>
-            <a:pPr>
-              <a:lnSpc>
-                <a:spcPct val="112000"/>
-              </a:lnSpc>
-              <a:spcAft>
-                <a:spcPts val="900"/>
-              </a:spcAft>
-            </a:pPr>
-            <a:r>
-              <a:rPr sz="1800" b="1">
-                <a:solidFill>
-                  <a:srgbClr val="E0A437"/>
-                </a:solidFill>
-                <a:latin typeface="Fira Sans"/>
-              </a:rPr>
-              <a:t>▸ </a:t>
-            </a:r>
-            <a:r>
-              <a:rPr sz="1800" b="0">
-                <a:solidFill>
-                  <a:srgbClr val="000000"/>
-                </a:solidFill>
-                <a:latin typeface="Fira Sans"/>
-              </a:rPr>
-              <a:t>Respondible: los datos necesarios existen y son obtenibles.</a:t>
-            </a:r>
-          </a:p>
-          <a:p>
-            <a:pPr>
-              <a:lnSpc>
-                <a:spcPct val="112000"/>
-              </a:lnSpc>
-              <a:spcAft>
-                <a:spcPts val="900"/>
-              </a:spcAft>
-            </a:pPr>
-            <a:r>
-              <a:rPr sz="1800" b="1">
-                <a:solidFill>
-                  <a:srgbClr val="E0A437"/>
-                </a:solidFill>
-                <a:latin typeface="Fira Sans"/>
-              </a:rPr>
-              <a:t>▸ </a:t>
-            </a:r>
-            <a:r>
-              <a:rPr sz="1800" b="0">
-                <a:solidFill>
-                  <a:srgbClr val="000000"/>
-                </a:solidFill>
-                <a:latin typeface="Fira Sans"/>
-              </a:rPr>
-              <a:t>Específica: nombra variables y población, no generalidades.</a:t>
+            <a:r>
+              <a:rPr sz="1300" b="0">
+                <a:solidFill>
+                  <a:srgbClr val="333333"/>
+                </a:solidFill>
+                <a:latin typeface="Fira Sans"/>
+              </a:rPr>
+              <a:t>116 viajes declaran más de 5 horas y el máximo es de 22 horas. ¿Error de registro o viaje real? La respuesta exige criterio del dominio; la decisión (mantener, corregir o excluir) se toma en el código y se documenta.</a:t>
             </a:r>
           </a:p>
         </p:txBody>
@@ -6185,6 +5958,1349 @@
 </file>
 
 <file path=ppt/slides/slide24.xml><?xml version="1.0" encoding="utf-8"?>
+<p:sld xmlns:a="http://schemas.openxmlformats.org/drawingml/2006/main" xmlns:p="http://schemas.openxmlformats.org/presentationml/2006/main" xmlns:r="http://schemas.openxmlformats.org/officeDocument/2006/relationships">
+  <p:cSld>
+    <p:spTree>
+      <p:nvGrpSpPr>
+        <p:cNvPr id="1" name=""/>
+        <p:cNvGrpSpPr/>
+        <p:nvPr/>
+      </p:nvGrpSpPr>
+      <p:grpSpPr/>
+      <p:sp>
+        <p:nvSpPr>
+          <p:cNvPr id="2" name="Rectangle 1"/>
+          <p:cNvSpPr/>
+          <p:nvPr/>
+        </p:nvSpPr>
+        <p:spPr>
+          <a:xfrm>
+            <a:off x="0" y="0"/>
+            <a:ext cx="9144000" cy="5138928"/>
+          </a:xfrm>
+          <a:prstGeom prst="rect">
+            <a:avLst/>
+          </a:prstGeom>
+          <a:solidFill>
+            <a:srgbClr val="FAFBFC"/>
+          </a:solidFill>
+          <a:ln>
+            <a:noFill/>
+          </a:ln>
+          <a:effectLst/>
+        </p:spPr>
+        <p:style>
+          <a:lnRef idx="1">
+            <a:schemeClr val="accent1"/>
+          </a:lnRef>
+          <a:fillRef idx="3">
+            <a:schemeClr val="accent1"/>
+          </a:fillRef>
+          <a:effectRef idx="2">
+            <a:schemeClr val="accent1"/>
+          </a:effectRef>
+          <a:fontRef idx="minor">
+            <a:schemeClr val="lt1"/>
+          </a:fontRef>
+        </p:style>
+        <p:txBody>
+          <a:bodyPr rtlCol="0" anchor="ctr"/>
+          <a:lstStyle/>
+          <a:p>
+            <a:pPr algn="ctr"/>
+          </a:p>
+        </p:txBody>
+      </p:sp>
+      <p:sp>
+        <p:nvSpPr>
+          <p:cNvPr id="3" name="TextBox 2"/>
+          <p:cNvSpPr txBox="1"/>
+          <p:nvPr/>
+        </p:nvSpPr>
+        <p:spPr>
+          <a:xfrm>
+            <a:off x="402336" y="301752"/>
+            <a:ext cx="8348472" cy="795528"/>
+          </a:xfrm>
+          <a:prstGeom prst="rect">
+            <a:avLst/>
+          </a:prstGeom>
+          <a:noFill/>
+        </p:spPr>
+        <p:txBody>
+          <a:bodyPr wrap="square">
+            <a:spAutoFit/>
+          </a:bodyPr>
+          <a:lstStyle/>
+          <a:p>
+            <a:r>
+              <a:rPr sz="2800" b="1">
+                <a:solidFill>
+                  <a:srgbClr val="0F0F0F"/>
+                </a:solidFill>
+                <a:latin typeface="Fira Sans"/>
+              </a:rPr>
+              <a:t>Tapar valores con mask</a:t>
+            </a:r>
+          </a:p>
+        </p:txBody>
+      </p:sp>
+      <p:sp>
+        <p:nvSpPr>
+          <p:cNvPr id="4" name="Rectangle 3"/>
+          <p:cNvSpPr/>
+          <p:nvPr/>
+        </p:nvSpPr>
+        <p:spPr>
+          <a:xfrm>
+            <a:off x="704088" y="1280160"/>
+            <a:ext cx="7744968" cy="1874520"/>
+          </a:xfrm>
+          <a:prstGeom prst="rect">
+            <a:avLst/>
+          </a:prstGeom>
+          <a:solidFill>
+            <a:srgbClr val="F0F2F5"/>
+          </a:solidFill>
+          <a:ln>
+            <a:solidFill>
+              <a:srgbClr val="D8DDE3"/>
+            </a:solidFill>
+          </a:ln>
+          <a:effectLst/>
+        </p:spPr>
+        <p:style>
+          <a:lnRef idx="1">
+            <a:schemeClr val="accent1"/>
+          </a:lnRef>
+          <a:fillRef idx="3">
+            <a:schemeClr val="accent1"/>
+          </a:fillRef>
+          <a:effectRef idx="2">
+            <a:schemeClr val="accent1"/>
+          </a:effectRef>
+          <a:fontRef idx="minor">
+            <a:schemeClr val="lt1"/>
+          </a:fontRef>
+        </p:style>
+        <p:txBody>
+          <a:bodyPr rtlCol="0" anchor="ctr" wrap="square" lIns="228600" tIns="137160"/>
+          <a:lstStyle/>
+          <a:p>
+            <a:pPr/>
+            <a:r>
+              <a:rPr sz="1500" b="0">
+                <a:solidFill>
+                  <a:srgbClr val="1D3557"/>
+                </a:solidFill>
+                <a:latin typeface="Menlo"/>
+              </a:rPr>
+              <a:t># donde la condición se cumple, reemplaza (aquí, por NaN)</a:t>
+            </a:r>
+          </a:p>
+          <a:p>
+            <a:pPr/>
+            <a:r>
+              <a:rPr sz="1500" b="0">
+                <a:solidFill>
+                  <a:srgbClr val="1D3557"/>
+                </a:solidFill>
+                <a:latin typeface="Menlo"/>
+              </a:rPr>
+              <a:t>viajes["TiempoViaje"] = viajes["TiempoViaje"].mask(</a:t>
+            </a:r>
+          </a:p>
+          <a:p>
+            <a:pPr/>
+            <a:r>
+              <a:rPr sz="1500" b="0">
+                <a:solidFill>
+                  <a:srgbClr val="1D3557"/>
+                </a:solidFill>
+                <a:latin typeface="Menlo"/>
+              </a:rPr>
+              <a:t>    viajes["TiempoViaje"] &gt; 300)</a:t>
+            </a:r>
+          </a:p>
+        </p:txBody>
+      </p:sp>
+      <p:sp>
+        <p:nvSpPr>
+          <p:cNvPr id="5" name="TextBox 4"/>
+          <p:cNvSpPr txBox="1"/>
+          <p:nvPr/>
+        </p:nvSpPr>
+        <p:spPr>
+          <a:xfrm>
+            <a:off x="704088" y="3383279"/>
+            <a:ext cx="7744968" cy="1097280"/>
+          </a:xfrm>
+          <a:prstGeom prst="rect">
+            <a:avLst/>
+          </a:prstGeom>
+          <a:noFill/>
+        </p:spPr>
+        <p:txBody>
+          <a:bodyPr wrap="square">
+            <a:spAutoFit/>
+          </a:bodyPr>
+          <a:lstStyle/>
+          <a:p>
+            <a:pPr>
+              <a:lnSpc>
+                <a:spcPct val="112000"/>
+              </a:lnSpc>
+              <a:spcAft>
+                <a:spcPts val="900"/>
+              </a:spcAft>
+            </a:pPr>
+            <a:r>
+              <a:rPr sz="1600" b="1">
+                <a:solidFill>
+                  <a:srgbClr val="E0A437"/>
+                </a:solidFill>
+                <a:latin typeface="Fira Sans"/>
+              </a:rPr>
+              <a:t>▸ </a:t>
+            </a:r>
+            <a:r>
+              <a:rPr sz="1600" b="0">
+                <a:solidFill>
+                  <a:srgbClr val="000000"/>
+                </a:solidFill>
+                <a:latin typeface="Fira Sans"/>
+              </a:rPr>
+              <a:t>mask reemplaza donde la condición es verdadera; where, su espejo, conserva donde es verdadera y reemplaza el resto. Regla nemotécnica: mask es dónde tapar, where es dónde quedarse.</a:t>
+            </a:r>
+          </a:p>
+        </p:txBody>
+      </p:sp>
+    </p:spTree>
+  </p:cSld>
+  <p:clrMapOvr>
+    <a:masterClrMapping/>
+  </p:clrMapOvr>
+</p:sld>
+</file>
+
+<file path=ppt/slides/slide25.xml><?xml version="1.0" encoding="utf-8"?>
+<p:sld xmlns:a="http://schemas.openxmlformats.org/drawingml/2006/main" xmlns:p="http://schemas.openxmlformats.org/presentationml/2006/main" xmlns:r="http://schemas.openxmlformats.org/officeDocument/2006/relationships">
+  <p:cSld>
+    <p:spTree>
+      <p:nvGrpSpPr>
+        <p:cNvPr id="1" name=""/>
+        <p:cNvGrpSpPr/>
+        <p:nvPr/>
+      </p:nvGrpSpPr>
+      <p:grpSpPr/>
+      <p:sp>
+        <p:nvSpPr>
+          <p:cNvPr id="2" name="Rectangle 1"/>
+          <p:cNvSpPr/>
+          <p:nvPr/>
+        </p:nvSpPr>
+        <p:spPr>
+          <a:xfrm>
+            <a:off x="0" y="0"/>
+            <a:ext cx="9144000" cy="5138928"/>
+          </a:xfrm>
+          <a:prstGeom prst="rect">
+            <a:avLst/>
+          </a:prstGeom>
+          <a:solidFill>
+            <a:srgbClr val="FAFBFC"/>
+          </a:solidFill>
+          <a:ln>
+            <a:noFill/>
+          </a:ln>
+          <a:effectLst/>
+        </p:spPr>
+        <p:style>
+          <a:lnRef idx="1">
+            <a:schemeClr val="accent1"/>
+          </a:lnRef>
+          <a:fillRef idx="3">
+            <a:schemeClr val="accent1"/>
+          </a:fillRef>
+          <a:effectRef idx="2">
+            <a:schemeClr val="accent1"/>
+          </a:effectRef>
+          <a:fontRef idx="minor">
+            <a:schemeClr val="lt1"/>
+          </a:fontRef>
+        </p:style>
+        <p:txBody>
+          <a:bodyPr rtlCol="0" anchor="ctr"/>
+          <a:lstStyle/>
+          <a:p>
+            <a:pPr algn="ctr"/>
+          </a:p>
+        </p:txBody>
+      </p:sp>
+      <p:sp>
+        <p:nvSpPr>
+          <p:cNvPr id="3" name="TextBox 2"/>
+          <p:cNvSpPr txBox="1"/>
+          <p:nvPr/>
+        </p:nvSpPr>
+        <p:spPr>
+          <a:xfrm>
+            <a:off x="402336" y="301752"/>
+            <a:ext cx="8348472" cy="795528"/>
+          </a:xfrm>
+          <a:prstGeom prst="rect">
+            <a:avLst/>
+          </a:prstGeom>
+          <a:noFill/>
+        </p:spPr>
+        <p:txBody>
+          <a:bodyPr wrap="square">
+            <a:spAutoFit/>
+          </a:bodyPr>
+          <a:lstStyle/>
+          <a:p>
+            <a:r>
+              <a:rPr sz="2800" b="1">
+                <a:solidFill>
+                  <a:srgbClr val="0F0F0F"/>
+                </a:solidFill>
+                <a:latin typeface="Fira Sans"/>
+              </a:rPr>
+              <a:t>Revisar cada merge</a:t>
+            </a:r>
+          </a:p>
+        </p:txBody>
+      </p:sp>
+      <p:sp>
+        <p:nvSpPr>
+          <p:cNvPr id="4" name="TextBox 3"/>
+          <p:cNvSpPr txBox="1"/>
+          <p:nvPr/>
+        </p:nvSpPr>
+        <p:spPr>
+          <a:xfrm>
+            <a:off x="704088" y="1353312"/>
+            <a:ext cx="7744968" cy="3300984"/>
+          </a:xfrm>
+          <a:prstGeom prst="rect">
+            <a:avLst/>
+          </a:prstGeom>
+          <a:noFill/>
+        </p:spPr>
+        <p:txBody>
+          <a:bodyPr wrap="square">
+            <a:spAutoFit/>
+          </a:bodyPr>
+          <a:lstStyle/>
+          <a:p>
+            <a:pPr>
+              <a:lnSpc>
+                <a:spcPct val="112000"/>
+              </a:lnSpc>
+              <a:spcAft>
+                <a:spcPts val="900"/>
+              </a:spcAft>
+            </a:pPr>
+            <a:r>
+              <a:rPr sz="1800" b="1">
+                <a:solidFill>
+                  <a:srgbClr val="E0A437"/>
+                </a:solidFill>
+                <a:latin typeface="Fira Sans"/>
+              </a:rPr>
+              <a:t>▸ </a:t>
+            </a:r>
+            <a:r>
+              <a:rPr sz="1800" b="0">
+                <a:solidFill>
+                  <a:srgbClr val="000000"/>
+                </a:solidFill>
+                <a:latin typeface="Fira Sans"/>
+              </a:rPr>
+              <a:t>Comparar el número de filas antes y después: un inner descarta las filas sin pareja; en la clase 1, 113.591 viajes quedaron en 111.393.</a:t>
+            </a:r>
+          </a:p>
+          <a:p>
+            <a:pPr>
+              <a:lnSpc>
+                <a:spcPct val="112000"/>
+              </a:lnSpc>
+              <a:spcAft>
+                <a:spcPts val="900"/>
+              </a:spcAft>
+            </a:pPr>
+            <a:r>
+              <a:rPr sz="1800" b="1">
+                <a:solidFill>
+                  <a:srgbClr val="E0A437"/>
+                </a:solidFill>
+                <a:latin typeface="Fira Sans"/>
+              </a:rPr>
+              <a:t>▸ </a:t>
+            </a:r>
+            <a:r>
+              <a:rPr sz="1800" b="0">
+                <a:solidFill>
+                  <a:srgbClr val="000000"/>
+                </a:solidFill>
+                <a:latin typeface="Fira Sans"/>
+              </a:rPr>
+              <a:t>Contar los NaN de las columnas nuevas cuando se usa how="left": ahí quedan visibles las filas sin correspondencia (2.198 comunas).</a:t>
+            </a:r>
+          </a:p>
+          <a:p>
+            <a:pPr>
+              <a:lnSpc>
+                <a:spcPct val="112000"/>
+              </a:lnSpc>
+              <a:spcAft>
+                <a:spcPts val="900"/>
+              </a:spcAft>
+            </a:pPr>
+            <a:r>
+              <a:rPr sz="1800" b="1">
+                <a:solidFill>
+                  <a:srgbClr val="E0A437"/>
+                </a:solidFill>
+                <a:latin typeface="Fira Sans"/>
+              </a:rPr>
+              <a:t>▸ </a:t>
+            </a:r>
+            <a:r>
+              <a:rPr sz="1800" b="0">
+                <a:solidFill>
+                  <a:srgbClr val="000000"/>
+                </a:solidFill>
+                <a:latin typeface="Fira Sans"/>
+              </a:rPr>
+              <a:t>Verificar que la llave sea única en la tabla de parámetros: si está repetida, el merge multiplica filas.</a:t>
+            </a:r>
+          </a:p>
+        </p:txBody>
+      </p:sp>
+    </p:spTree>
+  </p:cSld>
+  <p:clrMapOvr>
+    <a:masterClrMapping/>
+  </p:clrMapOvr>
+</p:sld>
+</file>
+
+<file path=ppt/slides/slide26.xml><?xml version="1.0" encoding="utf-8"?>
+<p:sld xmlns:a="http://schemas.openxmlformats.org/drawingml/2006/main" xmlns:p="http://schemas.openxmlformats.org/presentationml/2006/main" xmlns:r="http://schemas.openxmlformats.org/officeDocument/2006/relationships">
+  <p:cSld>
+    <p:spTree>
+      <p:nvGrpSpPr>
+        <p:cNvPr id="1" name=""/>
+        <p:cNvGrpSpPr/>
+        <p:nvPr/>
+      </p:nvGrpSpPr>
+      <p:grpSpPr/>
+      <p:sp>
+        <p:nvSpPr>
+          <p:cNvPr id="2" name="Rectangle 1"/>
+          <p:cNvSpPr/>
+          <p:nvPr/>
+        </p:nvSpPr>
+        <p:spPr>
+          <a:xfrm>
+            <a:off x="0" y="0"/>
+            <a:ext cx="9144000" cy="5138928"/>
+          </a:xfrm>
+          <a:prstGeom prst="rect">
+            <a:avLst/>
+          </a:prstGeom>
+          <a:solidFill>
+            <a:srgbClr val="FAFBFC"/>
+          </a:solidFill>
+          <a:ln>
+            <a:noFill/>
+          </a:ln>
+          <a:effectLst/>
+        </p:spPr>
+        <p:style>
+          <a:lnRef idx="1">
+            <a:schemeClr val="accent1"/>
+          </a:lnRef>
+          <a:fillRef idx="3">
+            <a:schemeClr val="accent1"/>
+          </a:fillRef>
+          <a:effectRef idx="2">
+            <a:schemeClr val="accent1"/>
+          </a:effectRef>
+          <a:fontRef idx="minor">
+            <a:schemeClr val="lt1"/>
+          </a:fontRef>
+        </p:style>
+        <p:txBody>
+          <a:bodyPr rtlCol="0" anchor="ctr"/>
+          <a:lstStyle/>
+          <a:p>
+            <a:pPr algn="ctr"/>
+          </a:p>
+        </p:txBody>
+      </p:sp>
+      <p:sp>
+        <p:nvSpPr>
+          <p:cNvPr id="3" name="TextBox 2"/>
+          <p:cNvSpPr txBox="1"/>
+          <p:nvPr/>
+        </p:nvSpPr>
+        <p:spPr>
+          <a:xfrm>
+            <a:off x="402336" y="301752"/>
+            <a:ext cx="8348472" cy="795528"/>
+          </a:xfrm>
+          <a:prstGeom prst="rect">
+            <a:avLst/>
+          </a:prstGeom>
+          <a:noFill/>
+        </p:spPr>
+        <p:txBody>
+          <a:bodyPr wrap="square">
+            <a:spAutoFit/>
+          </a:bodyPr>
+          <a:lstStyle/>
+          <a:p>
+            <a:r>
+              <a:rPr sz="2800" b="1">
+                <a:solidFill>
+                  <a:srgbClr val="0F0F0F"/>
+                </a:solidFill>
+                <a:latin typeface="Fira Sans"/>
+              </a:rPr>
+              <a:t>Checklist de calidad antes de analizar</a:t>
+            </a:r>
+          </a:p>
+        </p:txBody>
+      </p:sp>
+      <p:sp>
+        <p:nvSpPr>
+          <p:cNvPr id="4" name="TextBox 3"/>
+          <p:cNvSpPr txBox="1"/>
+          <p:nvPr/>
+        </p:nvSpPr>
+        <p:spPr>
+          <a:xfrm>
+            <a:off x="704088" y="1353312"/>
+            <a:ext cx="7744968" cy="3300984"/>
+          </a:xfrm>
+          <a:prstGeom prst="rect">
+            <a:avLst/>
+          </a:prstGeom>
+          <a:noFill/>
+        </p:spPr>
+        <p:txBody>
+          <a:bodyPr wrap="square">
+            <a:spAutoFit/>
+          </a:bodyPr>
+          <a:lstStyle/>
+          <a:p>
+            <a:pPr>
+              <a:lnSpc>
+                <a:spcPct val="112000"/>
+              </a:lnSpc>
+              <a:spcAft>
+                <a:spcPts val="900"/>
+              </a:spcAft>
+            </a:pPr>
+            <a:r>
+              <a:rPr sz="1800" b="1">
+                <a:solidFill>
+                  <a:srgbClr val="E0A437"/>
+                </a:solidFill>
+                <a:latin typeface="Fira Sans"/>
+              </a:rPr>
+              <a:t>▸ </a:t>
+            </a:r>
+            <a:r>
+              <a:rPr sz="1800" b="0">
+                <a:solidFill>
+                  <a:srgbClr val="000000"/>
+                </a:solidFill>
+                <a:latin typeface="Fira Sans"/>
+              </a:rPr>
+              <a:t>Dimensiones y tipos: shape, info().</a:t>
+            </a:r>
+          </a:p>
+          <a:p>
+            <a:pPr>
+              <a:lnSpc>
+                <a:spcPct val="112000"/>
+              </a:lnSpc>
+              <a:spcAft>
+                <a:spcPts val="900"/>
+              </a:spcAft>
+            </a:pPr>
+            <a:r>
+              <a:rPr sz="1800" b="1">
+                <a:solidFill>
+                  <a:srgbClr val="E0A437"/>
+                </a:solidFill>
+                <a:latin typeface="Fira Sans"/>
+              </a:rPr>
+              <a:t>▸ </a:t>
+            </a:r>
+            <a:r>
+              <a:rPr sz="1800" b="0">
+                <a:solidFill>
+                  <a:srgbClr val="000000"/>
+                </a:solidFill>
+                <a:latin typeface="Fira Sans"/>
+              </a:rPr>
+              <a:t>Faltantes por columna relevante: isna().sum(), count contra len.</a:t>
+            </a:r>
+          </a:p>
+          <a:p>
+            <a:pPr>
+              <a:lnSpc>
+                <a:spcPct val="112000"/>
+              </a:lnSpc>
+              <a:spcAft>
+                <a:spcPts val="900"/>
+              </a:spcAft>
+            </a:pPr>
+            <a:r>
+              <a:rPr sz="1800" b="1">
+                <a:solidFill>
+                  <a:srgbClr val="E0A437"/>
+                </a:solidFill>
+                <a:latin typeface="Fira Sans"/>
+              </a:rPr>
+              <a:t>▸ </a:t>
+            </a:r>
+            <a:r>
+              <a:rPr sz="1800" b="0">
+                <a:solidFill>
+                  <a:srgbClr val="000000"/>
+                </a:solidFill>
+                <a:latin typeface="Fira Sans"/>
+              </a:rPr>
+              <a:t>Duplicados: fila completa y llave única.</a:t>
+            </a:r>
+          </a:p>
+          <a:p>
+            <a:pPr>
+              <a:lnSpc>
+                <a:spcPct val="112000"/>
+              </a:lnSpc>
+              <a:spcAft>
+                <a:spcPts val="900"/>
+              </a:spcAft>
+            </a:pPr>
+            <a:r>
+              <a:rPr sz="1800" b="1">
+                <a:solidFill>
+                  <a:srgbClr val="E0A437"/>
+                </a:solidFill>
+                <a:latin typeface="Fira Sans"/>
+              </a:rPr>
+              <a:t>▸ </a:t>
+            </a:r>
+            <a:r>
+              <a:rPr sz="1800" b="0">
+                <a:solidFill>
+                  <a:srgbClr val="000000"/>
+                </a:solidFill>
+                <a:latin typeface="Fira Sans"/>
+              </a:rPr>
+              <a:t>Rangos válidos de cada variable cuantitativa: min, max, valores sospechosos.</a:t>
+            </a:r>
+          </a:p>
+          <a:p>
+            <a:pPr>
+              <a:lnSpc>
+                <a:spcPct val="112000"/>
+              </a:lnSpc>
+              <a:spcAft>
+                <a:spcPts val="900"/>
+              </a:spcAft>
+            </a:pPr>
+            <a:r>
+              <a:rPr sz="1800" b="1">
+                <a:solidFill>
+                  <a:srgbClr val="E0A437"/>
+                </a:solidFill>
+                <a:latin typeface="Fira Sans"/>
+              </a:rPr>
+              <a:t>▸ </a:t>
+            </a:r>
+            <a:r>
+              <a:rPr sz="1800" b="0">
+                <a:solidFill>
+                  <a:srgbClr val="000000"/>
+                </a:solidFill>
+                <a:latin typeface="Fira Sans"/>
+              </a:rPr>
+              <a:t>Merges verificados: filas, NaN nuevos, llaves únicas.</a:t>
+            </a:r>
+          </a:p>
+          <a:p>
+            <a:pPr>
+              <a:lnSpc>
+                <a:spcPct val="112000"/>
+              </a:lnSpc>
+              <a:spcAft>
+                <a:spcPts val="900"/>
+              </a:spcAft>
+            </a:pPr>
+            <a:r>
+              <a:rPr sz="1800" b="1">
+                <a:solidFill>
+                  <a:srgbClr val="E0A437"/>
+                </a:solidFill>
+                <a:latin typeface="Fira Sans"/>
+              </a:rPr>
+              <a:t>▸ </a:t>
+            </a:r>
+            <a:r>
+              <a:rPr sz="1800" b="1">
+                <a:solidFill>
+                  <a:srgbClr val="1D3557"/>
+                </a:solidFill>
+                <a:latin typeface="Fira Sans"/>
+              </a:rPr>
+              <a:t>Cada decisión de limpieza queda escrita en el código, con su justificación.</a:t>
+            </a:r>
+          </a:p>
+        </p:txBody>
+      </p:sp>
+    </p:spTree>
+  </p:cSld>
+  <p:clrMapOvr>
+    <a:masterClrMapping/>
+  </p:clrMapOvr>
+</p:sld>
+</file>
+
+<file path=ppt/slides/slide27.xml><?xml version="1.0" encoding="utf-8"?>
+<p:sld xmlns:a="http://schemas.openxmlformats.org/drawingml/2006/main" xmlns:p="http://schemas.openxmlformats.org/presentationml/2006/main" xmlns:r="http://schemas.openxmlformats.org/officeDocument/2006/relationships">
+  <p:cSld>
+    <p:spTree>
+      <p:nvGrpSpPr>
+        <p:cNvPr id="1" name=""/>
+        <p:cNvGrpSpPr/>
+        <p:nvPr/>
+      </p:nvGrpSpPr>
+      <p:grpSpPr/>
+      <p:sp>
+        <p:nvSpPr>
+          <p:cNvPr id="2" name="Rectangle 1"/>
+          <p:cNvSpPr/>
+          <p:nvPr/>
+        </p:nvSpPr>
+        <p:spPr>
+          <a:xfrm>
+            <a:off x="0" y="0"/>
+            <a:ext cx="9144000" cy="5138928"/>
+          </a:xfrm>
+          <a:prstGeom prst="rect">
+            <a:avLst/>
+          </a:prstGeom>
+          <a:solidFill>
+            <a:srgbClr val="1D3557"/>
+          </a:solidFill>
+          <a:ln>
+            <a:noFill/>
+          </a:ln>
+          <a:effectLst/>
+        </p:spPr>
+        <p:style>
+          <a:lnRef idx="1">
+            <a:schemeClr val="accent1"/>
+          </a:lnRef>
+          <a:fillRef idx="3">
+            <a:schemeClr val="accent1"/>
+          </a:fillRef>
+          <a:effectRef idx="2">
+            <a:schemeClr val="accent1"/>
+          </a:effectRef>
+          <a:fontRef idx="minor">
+            <a:schemeClr val="lt1"/>
+          </a:fontRef>
+        </p:style>
+        <p:txBody>
+          <a:bodyPr rtlCol="0" anchor="ctr"/>
+          <a:lstStyle/>
+          <a:p>
+            <a:pPr algn="ctr"/>
+          </a:p>
+        </p:txBody>
+      </p:sp>
+      <p:sp>
+        <p:nvSpPr>
+          <p:cNvPr id="3" name="TextBox 2"/>
+          <p:cNvSpPr txBox="1"/>
+          <p:nvPr/>
+        </p:nvSpPr>
+        <p:spPr>
+          <a:xfrm>
+            <a:off x="603504" y="1847088"/>
+            <a:ext cx="7946136" cy="1399032"/>
+          </a:xfrm>
+          <a:prstGeom prst="rect">
+            <a:avLst/>
+          </a:prstGeom>
+          <a:noFill/>
+        </p:spPr>
+        <p:txBody>
+          <a:bodyPr wrap="square">
+            <a:spAutoFit/>
+          </a:bodyPr>
+          <a:lstStyle/>
+          <a:p>
+            <a:r>
+              <a:rPr sz="3400" b="1">
+                <a:solidFill>
+                  <a:srgbClr val="FFFFFF"/>
+                </a:solidFill>
+                <a:latin typeface="Fira Sans"/>
+              </a:rPr>
+              <a:t>La pregunta y la hipótesis</a:t>
+            </a:r>
+          </a:p>
+          <a:p>
+            <a:r>
+              <a:rPr sz="1800" b="0">
+                <a:solidFill>
+                  <a:srgbClr val="E0A437"/>
+                </a:solidFill>
+                <a:latin typeface="Fira Sans"/>
+              </a:rPr>
+              <a:t>Formular el proyecto antes de analizarlo</a:t>
+            </a:r>
+          </a:p>
+        </p:txBody>
+      </p:sp>
+    </p:spTree>
+  </p:cSld>
+  <p:clrMapOvr>
+    <a:masterClrMapping/>
+  </p:clrMapOvr>
+</p:sld>
+</file>
+
+<file path=ppt/slides/slide28.xml><?xml version="1.0" encoding="utf-8"?>
+<p:sld xmlns:a="http://schemas.openxmlformats.org/drawingml/2006/main" xmlns:p="http://schemas.openxmlformats.org/presentationml/2006/main" xmlns:r="http://schemas.openxmlformats.org/officeDocument/2006/relationships">
+  <p:cSld>
+    <p:spTree>
+      <p:nvGrpSpPr>
+        <p:cNvPr id="1" name=""/>
+        <p:cNvGrpSpPr/>
+        <p:nvPr/>
+      </p:nvGrpSpPr>
+      <p:grpSpPr/>
+      <p:sp>
+        <p:nvSpPr>
+          <p:cNvPr id="2" name="Rectangle 1"/>
+          <p:cNvSpPr/>
+          <p:nvPr/>
+        </p:nvSpPr>
+        <p:spPr>
+          <a:xfrm>
+            <a:off x="0" y="0"/>
+            <a:ext cx="9144000" cy="5138928"/>
+          </a:xfrm>
+          <a:prstGeom prst="rect">
+            <a:avLst/>
+          </a:prstGeom>
+          <a:solidFill>
+            <a:srgbClr val="FAFBFC"/>
+          </a:solidFill>
+          <a:ln>
+            <a:noFill/>
+          </a:ln>
+          <a:effectLst/>
+        </p:spPr>
+        <p:style>
+          <a:lnRef idx="1">
+            <a:schemeClr val="accent1"/>
+          </a:lnRef>
+          <a:fillRef idx="3">
+            <a:schemeClr val="accent1"/>
+          </a:fillRef>
+          <a:effectRef idx="2">
+            <a:schemeClr val="accent1"/>
+          </a:effectRef>
+          <a:fontRef idx="minor">
+            <a:schemeClr val="lt1"/>
+          </a:fontRef>
+        </p:style>
+        <p:txBody>
+          <a:bodyPr rtlCol="0" anchor="ctr"/>
+          <a:lstStyle/>
+          <a:p>
+            <a:pPr algn="ctr"/>
+          </a:p>
+        </p:txBody>
+      </p:sp>
+      <p:sp>
+        <p:nvSpPr>
+          <p:cNvPr id="3" name="TextBox 2"/>
+          <p:cNvSpPr txBox="1"/>
+          <p:nvPr/>
+        </p:nvSpPr>
+        <p:spPr>
+          <a:xfrm>
+            <a:off x="402336" y="301752"/>
+            <a:ext cx="8348472" cy="795528"/>
+          </a:xfrm>
+          <a:prstGeom prst="rect">
+            <a:avLst/>
+          </a:prstGeom>
+          <a:noFill/>
+        </p:spPr>
+        <p:txBody>
+          <a:bodyPr wrap="square">
+            <a:spAutoFit/>
+          </a:bodyPr>
+          <a:lstStyle/>
+          <a:p>
+            <a:r>
+              <a:rPr sz="2800" b="1">
+                <a:solidFill>
+                  <a:srgbClr val="0F0F0F"/>
+                </a:solidFill>
+                <a:latin typeface="Fira Sans"/>
+              </a:rPr>
+              <a:t>Seis tipos de pregunta</a:t>
+            </a:r>
+          </a:p>
+        </p:txBody>
+      </p:sp>
+      <p:pic>
+        <p:nvPicPr>
+          <p:cNvPr id="4" name="Picture 3" descr="06_tipos_preguntas.png"/>
+          <p:cNvPicPr>
+            <a:picLocks noChangeAspect="1"/>
+          </p:cNvPicPr>
+          <p:nvPr/>
+        </p:nvPicPr>
+        <p:blipFill>
+          <a:blip r:embed="rId2"/>
+          <a:stretch>
+            <a:fillRect/>
+          </a:stretch>
+        </p:blipFill>
+        <p:spPr>
+          <a:xfrm>
+            <a:off x="1417319" y="1143000"/>
+            <a:ext cx="6309360" cy="3121297"/>
+          </a:xfrm>
+          <a:prstGeom prst="rect">
+            <a:avLst/>
+          </a:prstGeom>
+        </p:spPr>
+      </p:pic>
+      <p:sp>
+        <p:nvSpPr>
+          <p:cNvPr id="5" name="TextBox 4"/>
+          <p:cNvSpPr txBox="1"/>
+          <p:nvPr/>
+        </p:nvSpPr>
+        <p:spPr>
+          <a:xfrm>
+            <a:off x="704088" y="4434840"/>
+            <a:ext cx="7744968" cy="457200"/>
+          </a:xfrm>
+          <a:prstGeom prst="rect">
+            <a:avLst/>
+          </a:prstGeom>
+          <a:noFill/>
+        </p:spPr>
+        <p:txBody>
+          <a:bodyPr wrap="square">
+            <a:spAutoFit/>
+          </a:bodyPr>
+          <a:lstStyle/>
+          <a:p>
+            <a:r>
+              <a:rPr sz="1300" b="0">
+                <a:solidFill>
+                  <a:srgbClr val="333333"/>
+                </a:solidFill>
+                <a:latin typeface="Fira Sans"/>
+              </a:rPr>
+              <a:t>El módulo cubre los cuatro primeros tipos. El error más común de un análisis es responder un tipo de pregunta creyendo que se responde otro (Leek y Peng, 2015).</a:t>
+            </a:r>
+          </a:p>
+        </p:txBody>
+      </p:sp>
+    </p:spTree>
+  </p:cSld>
+  <p:clrMapOvr>
+    <a:masterClrMapping/>
+  </p:clrMapOvr>
+</p:sld>
+</file>
+
+<file path=ppt/slides/slide29.xml><?xml version="1.0" encoding="utf-8"?>
+<p:sld xmlns:a="http://schemas.openxmlformats.org/drawingml/2006/main" xmlns:p="http://schemas.openxmlformats.org/presentationml/2006/main" xmlns:r="http://schemas.openxmlformats.org/officeDocument/2006/relationships">
+  <p:cSld>
+    <p:spTree>
+      <p:nvGrpSpPr>
+        <p:cNvPr id="1" name=""/>
+        <p:cNvGrpSpPr/>
+        <p:nvPr/>
+      </p:nvGrpSpPr>
+      <p:grpSpPr/>
+      <p:sp>
+        <p:nvSpPr>
+          <p:cNvPr id="2" name="Rectangle 1"/>
+          <p:cNvSpPr/>
+          <p:nvPr/>
+        </p:nvSpPr>
+        <p:spPr>
+          <a:xfrm>
+            <a:off x="0" y="0"/>
+            <a:ext cx="9144000" cy="5138928"/>
+          </a:xfrm>
+          <a:prstGeom prst="rect">
+            <a:avLst/>
+          </a:prstGeom>
+          <a:solidFill>
+            <a:srgbClr val="FAFBFC"/>
+          </a:solidFill>
+          <a:ln>
+            <a:noFill/>
+          </a:ln>
+          <a:effectLst/>
+        </p:spPr>
+        <p:style>
+          <a:lnRef idx="1">
+            <a:schemeClr val="accent1"/>
+          </a:lnRef>
+          <a:fillRef idx="3">
+            <a:schemeClr val="accent1"/>
+          </a:fillRef>
+          <a:effectRef idx="2">
+            <a:schemeClr val="accent1"/>
+          </a:effectRef>
+          <a:fontRef idx="minor">
+            <a:schemeClr val="lt1"/>
+          </a:fontRef>
+        </p:style>
+        <p:txBody>
+          <a:bodyPr rtlCol="0" anchor="ctr"/>
+          <a:lstStyle/>
+          <a:p>
+            <a:pPr algn="ctr"/>
+          </a:p>
+        </p:txBody>
+      </p:sp>
+      <p:sp>
+        <p:nvSpPr>
+          <p:cNvPr id="3" name="TextBox 2"/>
+          <p:cNvSpPr txBox="1"/>
+          <p:nvPr/>
+        </p:nvSpPr>
+        <p:spPr>
+          <a:xfrm>
+            <a:off x="402336" y="301752"/>
+            <a:ext cx="8348472" cy="795528"/>
+          </a:xfrm>
+          <a:prstGeom prst="rect">
+            <a:avLst/>
+          </a:prstGeom>
+          <a:noFill/>
+        </p:spPr>
+        <p:txBody>
+          <a:bodyPr wrap="square">
+            <a:spAutoFit/>
+          </a:bodyPr>
+          <a:lstStyle/>
+          <a:p>
+            <a:r>
+              <a:rPr sz="2800" b="1">
+                <a:solidFill>
+                  <a:srgbClr val="0F0F0F"/>
+                </a:solidFill>
+                <a:latin typeface="Fira Sans"/>
+              </a:rPr>
+              <a:t>Qué hace buena a una pregunta</a:t>
+            </a:r>
+          </a:p>
+        </p:txBody>
+      </p:sp>
+      <p:sp>
+        <p:nvSpPr>
+          <p:cNvPr id="4" name="TextBox 3"/>
+          <p:cNvSpPr txBox="1"/>
+          <p:nvPr/>
+        </p:nvSpPr>
+        <p:spPr>
+          <a:xfrm>
+            <a:off x="704088" y="1353312"/>
+            <a:ext cx="7744968" cy="3300984"/>
+          </a:xfrm>
+          <a:prstGeom prst="rect">
+            <a:avLst/>
+          </a:prstGeom>
+          <a:noFill/>
+        </p:spPr>
+        <p:txBody>
+          <a:bodyPr wrap="square">
+            <a:spAutoFit/>
+          </a:bodyPr>
+          <a:lstStyle/>
+          <a:p>
+            <a:pPr>
+              <a:lnSpc>
+                <a:spcPct val="112000"/>
+              </a:lnSpc>
+              <a:spcAft>
+                <a:spcPts val="900"/>
+              </a:spcAft>
+            </a:pPr>
+            <a:r>
+              <a:rPr sz="1800" b="1">
+                <a:solidFill>
+                  <a:srgbClr val="E0A437"/>
+                </a:solidFill>
+                <a:latin typeface="Fira Sans"/>
+              </a:rPr>
+              <a:t>▸ </a:t>
+            </a:r>
+            <a:r>
+              <a:rPr sz="1800" b="0">
+                <a:solidFill>
+                  <a:srgbClr val="000000"/>
+                </a:solidFill>
+                <a:latin typeface="Fira Sans"/>
+              </a:rPr>
+              <a:t>De interés real: una audiencia concreta usaría la respuesta (Peng y Matsui, 2015).</a:t>
+            </a:r>
+          </a:p>
+          <a:p>
+            <a:pPr>
+              <a:lnSpc>
+                <a:spcPct val="112000"/>
+              </a:lnSpc>
+              <a:spcAft>
+                <a:spcPts val="900"/>
+              </a:spcAft>
+            </a:pPr>
+            <a:r>
+              <a:rPr sz="1800" b="1">
+                <a:solidFill>
+                  <a:srgbClr val="E0A437"/>
+                </a:solidFill>
+                <a:latin typeface="Fira Sans"/>
+              </a:rPr>
+              <a:t>▸ </a:t>
+            </a:r>
+            <a:r>
+              <a:rPr sz="1800" b="0">
+                <a:solidFill>
+                  <a:srgbClr val="000000"/>
+                </a:solidFill>
+                <a:latin typeface="Fira Sans"/>
+              </a:rPr>
+              <a:t>No respondida ya: revisar qué existe antes de empezar.</a:t>
+            </a:r>
+          </a:p>
+          <a:p>
+            <a:pPr>
+              <a:lnSpc>
+                <a:spcPct val="112000"/>
+              </a:lnSpc>
+              <a:spcAft>
+                <a:spcPts val="900"/>
+              </a:spcAft>
+            </a:pPr>
+            <a:r>
+              <a:rPr sz="1800" b="1">
+                <a:solidFill>
+                  <a:srgbClr val="E0A437"/>
+                </a:solidFill>
+                <a:latin typeface="Fira Sans"/>
+              </a:rPr>
+              <a:t>▸ </a:t>
+            </a:r>
+            <a:r>
+              <a:rPr sz="1800" b="0">
+                <a:solidFill>
+                  <a:srgbClr val="000000"/>
+                </a:solidFill>
+                <a:latin typeface="Fira Sans"/>
+              </a:rPr>
+              <a:t>Plausible: la respuesta esperada tiene un mecanismo creíble.</a:t>
+            </a:r>
+          </a:p>
+          <a:p>
+            <a:pPr>
+              <a:lnSpc>
+                <a:spcPct val="112000"/>
+              </a:lnSpc>
+              <a:spcAft>
+                <a:spcPts val="900"/>
+              </a:spcAft>
+            </a:pPr>
+            <a:r>
+              <a:rPr sz="1800" b="1">
+                <a:solidFill>
+                  <a:srgbClr val="E0A437"/>
+                </a:solidFill>
+                <a:latin typeface="Fira Sans"/>
+              </a:rPr>
+              <a:t>▸ </a:t>
+            </a:r>
+            <a:r>
+              <a:rPr sz="1800" b="0">
+                <a:solidFill>
+                  <a:srgbClr val="000000"/>
+                </a:solidFill>
+                <a:latin typeface="Fira Sans"/>
+              </a:rPr>
+              <a:t>Respondible: los datos necesarios existen y son obtenibles.</a:t>
+            </a:r>
+          </a:p>
+          <a:p>
+            <a:pPr>
+              <a:lnSpc>
+                <a:spcPct val="112000"/>
+              </a:lnSpc>
+              <a:spcAft>
+                <a:spcPts val="900"/>
+              </a:spcAft>
+            </a:pPr>
+            <a:r>
+              <a:rPr sz="1800" b="1">
+                <a:solidFill>
+                  <a:srgbClr val="E0A437"/>
+                </a:solidFill>
+                <a:latin typeface="Fira Sans"/>
+              </a:rPr>
+              <a:t>▸ </a:t>
+            </a:r>
+            <a:r>
+              <a:rPr sz="1800" b="0">
+                <a:solidFill>
+                  <a:srgbClr val="000000"/>
+                </a:solidFill>
+                <a:latin typeface="Fira Sans"/>
+              </a:rPr>
+              <a:t>Específica: nombra variables y población, no generalidades.</a:t>
+            </a:r>
+          </a:p>
+        </p:txBody>
+      </p:sp>
+    </p:spTree>
+  </p:cSld>
+  <p:clrMapOvr>
+    <a:masterClrMapping/>
+  </p:clrMapOvr>
+</p:sld>
+</file>
+
+<file path=ppt/slides/slide3.xml><?xml version="1.0" encoding="utf-8"?>
+<p:sld xmlns:a="http://schemas.openxmlformats.org/drawingml/2006/main" xmlns:p="http://schemas.openxmlformats.org/presentationml/2006/main" xmlns:r="http://schemas.openxmlformats.org/officeDocument/2006/relationships">
+  <p:cSld>
+    <p:spTree>
+      <p:nvGrpSpPr>
+        <p:cNvPr id="1" name=""/>
+        <p:cNvGrpSpPr/>
+        <p:nvPr/>
+      </p:nvGrpSpPr>
+      <p:grpSpPr/>
+      <p:sp>
+        <p:nvSpPr>
+          <p:cNvPr id="2" name="Rectangle 1"/>
+          <p:cNvSpPr/>
+          <p:nvPr/>
+        </p:nvSpPr>
+        <p:spPr>
+          <a:xfrm>
+            <a:off x="0" y="0"/>
+            <a:ext cx="9144000" cy="5138928"/>
+          </a:xfrm>
+          <a:prstGeom prst="rect">
+            <a:avLst/>
+          </a:prstGeom>
+          <a:solidFill>
+            <a:srgbClr val="1D3557"/>
+          </a:solidFill>
+          <a:ln>
+            <a:noFill/>
+          </a:ln>
+          <a:effectLst/>
+        </p:spPr>
+        <p:style>
+          <a:lnRef idx="1">
+            <a:schemeClr val="accent1"/>
+          </a:lnRef>
+          <a:fillRef idx="3">
+            <a:schemeClr val="accent1"/>
+          </a:fillRef>
+          <a:effectRef idx="2">
+            <a:schemeClr val="accent1"/>
+          </a:effectRef>
+          <a:fontRef idx="minor">
+            <a:schemeClr val="lt1"/>
+          </a:fontRef>
+        </p:style>
+        <p:txBody>
+          <a:bodyPr rtlCol="0" anchor="ctr"/>
+          <a:lstStyle/>
+          <a:p>
+            <a:pPr algn="ctr"/>
+          </a:p>
+        </p:txBody>
+      </p:sp>
+      <p:sp>
+        <p:nvSpPr>
+          <p:cNvPr id="3" name="TextBox 2"/>
+          <p:cNvSpPr txBox="1"/>
+          <p:nvPr/>
+        </p:nvSpPr>
+        <p:spPr>
+          <a:xfrm>
+            <a:off x="603504" y="1847088"/>
+            <a:ext cx="7946136" cy="1399032"/>
+          </a:xfrm>
+          <a:prstGeom prst="rect">
+            <a:avLst/>
+          </a:prstGeom>
+          <a:noFill/>
+        </p:spPr>
+        <p:txBody>
+          <a:bodyPr wrap="square">
+            <a:spAutoFit/>
+          </a:bodyPr>
+          <a:lstStyle/>
+          <a:p>
+            <a:r>
+              <a:rPr sz="3400" b="1">
+                <a:solidFill>
+                  <a:srgbClr val="FFFFFF"/>
+                </a:solidFill>
+                <a:latin typeface="Fira Sans"/>
+              </a:rPr>
+              <a:t>El análisis exploratorio de datos</a:t>
+            </a:r>
+          </a:p>
+          <a:p>
+            <a:r>
+              <a:rPr sz="1800" b="0">
+                <a:solidFill>
+                  <a:srgbClr val="E0A437"/>
+                </a:solidFill>
+                <a:latin typeface="Fira Sans"/>
+              </a:rPr>
+              <a:t>Qué es y por qué se hace primero</a:t>
+            </a:r>
+          </a:p>
+        </p:txBody>
+      </p:sp>
+    </p:spTree>
+  </p:cSld>
+  <p:clrMapOvr>
+    <a:masterClrMapping/>
+  </p:clrMapOvr>
+</p:sld>
+</file>
+
+<file path=ppt/slides/slide30.xml><?xml version="1.0" encoding="utf-8"?>
 <p:sld xmlns:a="http://schemas.openxmlformats.org/drawingml/2006/main" xmlns:p="http://schemas.openxmlformats.org/presentationml/2006/main" xmlns:r="http://schemas.openxmlformats.org/officeDocument/2006/relationships">
   <p:cSld>
     <p:spTree>
@@ -6673,7 +7789,7 @@
 </p:sld>
 </file>
 
-<file path=ppt/slides/slide25.xml><?xml version="1.0" encoding="utf-8"?>
+<file path=ppt/slides/slide31.xml><?xml version="1.0" encoding="utf-8"?>
 <p:sld xmlns:a="http://schemas.openxmlformats.org/drawingml/2006/main" xmlns:p="http://schemas.openxmlformats.org/presentationml/2006/main" xmlns:r="http://schemas.openxmlformats.org/officeDocument/2006/relationships">
   <p:cSld>
     <p:spTree>
@@ -7162,7 +8278,7 @@
 </p:sld>
 </file>
 
-<file path=ppt/slides/slide26.xml><?xml version="1.0" encoding="utf-8"?>
+<file path=ppt/slides/slide32.xml><?xml version="1.0" encoding="utf-8"?>
 <p:sld xmlns:a="http://schemas.openxmlformats.org/drawingml/2006/main" xmlns:p="http://schemas.openxmlformats.org/presentationml/2006/main" xmlns:r="http://schemas.openxmlformats.org/officeDocument/2006/relationships">
   <p:cSld>
     <p:spTree>
@@ -7316,7 +8432,7 @@
 </p:sld>
 </file>
 
-<file path=ppt/slides/slide27.xml><?xml version="1.0" encoding="utf-8"?>
+<file path=ppt/slides/slide33.xml><?xml version="1.0" encoding="utf-8"?>
 <p:sld xmlns:a="http://schemas.openxmlformats.org/drawingml/2006/main" xmlns:p="http://schemas.openxmlformats.org/presentationml/2006/main" xmlns:r="http://schemas.openxmlformats.org/officeDocument/2006/relationships">
   <p:cSld>
     <p:spTree>
@@ -7575,7 +8691,7 @@
 </p:sld>
 </file>
 
-<file path=ppt/slides/slide28.xml><?xml version="1.0" encoding="utf-8"?>
+<file path=ppt/slides/slide34.xml><?xml version="1.0" encoding="utf-8"?>
 <p:sld xmlns:a="http://schemas.openxmlformats.org/drawingml/2006/main" xmlns:p="http://schemas.openxmlformats.org/presentationml/2006/main" xmlns:r="http://schemas.openxmlformats.org/officeDocument/2006/relationships">
   <p:cSld>
     <p:spTree>
@@ -7806,7 +8922,7 @@
 </p:sld>
 </file>
 
-<file path=ppt/slides/slide29.xml><?xml version="1.0" encoding="utf-8"?>
+<file path=ppt/slides/slide35.xml><?xml version="1.0" encoding="utf-8"?>
 <p:sld xmlns:a="http://schemas.openxmlformats.org/drawingml/2006/main" xmlns:p="http://schemas.openxmlformats.org/presentationml/2006/main" xmlns:r="http://schemas.openxmlformats.org/officeDocument/2006/relationships">
   <p:cSld>
     <p:spTree>
@@ -8065,7 +9181,7 @@
 </p:sld>
 </file>
 
-<file path=ppt/slides/slide3.xml><?xml version="1.0" encoding="utf-8"?>
+<file path=ppt/slides/slide36.xml><?xml version="1.0" encoding="utf-8"?>
 <p:sld xmlns:a="http://schemas.openxmlformats.org/drawingml/2006/main" xmlns:p="http://schemas.openxmlformats.org/presentationml/2006/main" xmlns:r="http://schemas.openxmlformats.org/officeDocument/2006/relationships">
   <p:cSld>
     <p:spTree>
@@ -8090,113 +9206,6 @@
             <a:avLst/>
           </a:prstGeom>
           <a:solidFill>
-            <a:srgbClr val="1D3557"/>
-          </a:solidFill>
-          <a:ln>
-            <a:noFill/>
-          </a:ln>
-          <a:effectLst/>
-        </p:spPr>
-        <p:style>
-          <a:lnRef idx="1">
-            <a:schemeClr val="accent1"/>
-          </a:lnRef>
-          <a:fillRef idx="3">
-            <a:schemeClr val="accent1"/>
-          </a:fillRef>
-          <a:effectRef idx="2">
-            <a:schemeClr val="accent1"/>
-          </a:effectRef>
-          <a:fontRef idx="minor">
-            <a:schemeClr val="lt1"/>
-          </a:fontRef>
-        </p:style>
-        <p:txBody>
-          <a:bodyPr rtlCol="0" anchor="ctr"/>
-          <a:lstStyle/>
-          <a:p>
-            <a:pPr algn="ctr"/>
-          </a:p>
-        </p:txBody>
-      </p:sp>
-      <p:sp>
-        <p:nvSpPr>
-          <p:cNvPr id="3" name="TextBox 2"/>
-          <p:cNvSpPr txBox="1"/>
-          <p:nvPr/>
-        </p:nvSpPr>
-        <p:spPr>
-          <a:xfrm>
-            <a:off x="603504" y="1847088"/>
-            <a:ext cx="7946136" cy="1399032"/>
-          </a:xfrm>
-          <a:prstGeom prst="rect">
-            <a:avLst/>
-          </a:prstGeom>
-          <a:noFill/>
-        </p:spPr>
-        <p:txBody>
-          <a:bodyPr wrap="square">
-            <a:spAutoFit/>
-          </a:bodyPr>
-          <a:lstStyle/>
-          <a:p>
-            <a:r>
-              <a:rPr sz="3400" b="1">
-                <a:solidFill>
-                  <a:srgbClr val="FFFFFF"/>
-                </a:solidFill>
-                <a:latin typeface="Fira Sans"/>
-              </a:rPr>
-              <a:t>El análisis exploratorio de datos</a:t>
-            </a:r>
-          </a:p>
-          <a:p>
-            <a:r>
-              <a:rPr sz="1800" b="0">
-                <a:solidFill>
-                  <a:srgbClr val="E0A437"/>
-                </a:solidFill>
-                <a:latin typeface="Fira Sans"/>
-              </a:rPr>
-              <a:t>Qué es y por qué se hace primero</a:t>
-            </a:r>
-          </a:p>
-        </p:txBody>
-      </p:sp>
-    </p:spTree>
-  </p:cSld>
-  <p:clrMapOvr>
-    <a:masterClrMapping/>
-  </p:clrMapOvr>
-</p:sld>
-</file>
-
-<file path=ppt/slides/slide30.xml><?xml version="1.0" encoding="utf-8"?>
-<p:sld xmlns:a="http://schemas.openxmlformats.org/drawingml/2006/main" xmlns:p="http://schemas.openxmlformats.org/presentationml/2006/main" xmlns:r="http://schemas.openxmlformats.org/officeDocument/2006/relationships">
-  <p:cSld>
-    <p:spTree>
-      <p:nvGrpSpPr>
-        <p:cNvPr id="1" name=""/>
-        <p:cNvGrpSpPr/>
-        <p:nvPr/>
-      </p:nvGrpSpPr>
-      <p:grpSpPr/>
-      <p:sp>
-        <p:nvSpPr>
-          <p:cNvPr id="2" name="Rectangle 1"/>
-          <p:cNvSpPr/>
-          <p:nvPr/>
-        </p:nvSpPr>
-        <p:spPr>
-          <a:xfrm>
-            <a:off x="0" y="0"/>
-            <a:ext cx="9144000" cy="5138928"/>
-          </a:xfrm>
-          <a:prstGeom prst="rect">
-            <a:avLst/>
-          </a:prstGeom>
-          <a:solidFill>
             <a:srgbClr val="FAFBFC"/>
           </a:solidFill>
           <a:ln>
@@ -8281,6 +9290,25 @@
             <a:spAutoFit/>
           </a:bodyPr>
           <a:lstStyle/>
+          <a:p>
+            <a:pPr>
+              <a:lnSpc>
+                <a:spcPct val="115000"/>
+              </a:lnSpc>
+              <a:spcAft>
+                <a:spcPts val="700"/>
+              </a:spcAft>
+            </a:pPr>
+            <a:r>
+              <a:rPr sz="1300" b="0">
+                <a:solidFill>
+                  <a:srgbClr val="333333"/>
+                </a:solidFill>
+                <a:latin typeface="Fira Sans"/>
+              </a:rPr>
+              <a:t>Fisher, R. A. (1936). The Use of Multiple Measurements in Taxonomic Problems. Annals of Eugenics, 7(2), 179-188.</a:t>
+            </a:r>
+          </a:p>
           <a:p>
             <a:pPr>
               <a:lnSpc>
@@ -8642,7 +9670,7 @@
             <a:avLst/>
           </a:prstGeom>
           <a:solidFill>
-            <a:srgbClr val="1D3557"/>
+            <a:srgbClr val="FAFBFC"/>
           </a:solidFill>
           <a:ln>
             <a:noFill/>
@@ -8679,8 +9707,8 @@
         </p:nvSpPr>
         <p:spPr>
           <a:xfrm>
-            <a:off x="603504" y="1847088"/>
-            <a:ext cx="7946136" cy="1399032"/>
+            <a:off x="402336" y="301752"/>
+            <a:ext cx="8348472" cy="795528"/>
           </a:xfrm>
           <a:prstGeom prst="rect">
             <a:avLst/>
@@ -8694,24 +9722,148 @@
           <a:lstStyle/>
           <a:p>
             <a:r>
-              <a:rPr sz="3400" b="1">
-                <a:solidFill>
-                  <a:srgbClr val="FFFFFF"/>
-                </a:solidFill>
-                <a:latin typeface="Fira Sans"/>
-              </a:rPr>
-              <a:t>Tendencia central</a:t>
-            </a:r>
-          </a:p>
-          <a:p>
+              <a:rPr sz="2800" b="1">
+                <a:solidFill>
+                  <a:srgbClr val="0F0F0F"/>
+                </a:solidFill>
+                <a:latin typeface="Fira Sans"/>
+              </a:rPr>
+              <a:t>Los datos de la clase: iris y la EOD</a:t>
+            </a:r>
+          </a:p>
+        </p:txBody>
+      </p:sp>
+      <p:sp>
+        <p:nvSpPr>
+          <p:cNvPr id="4" name="TextBox 3"/>
+          <p:cNvSpPr txBox="1"/>
+          <p:nvPr/>
+        </p:nvSpPr>
+        <p:spPr>
+          <a:xfrm>
+            <a:off x="704088" y="1353312"/>
+            <a:ext cx="7744968" cy="3300984"/>
+          </a:xfrm>
+          <a:prstGeom prst="rect">
+            <a:avLst/>
+          </a:prstGeom>
+          <a:noFill/>
+        </p:spPr>
+        <p:txBody>
+          <a:bodyPr wrap="square">
+            <a:spAutoFit/>
+          </a:bodyPr>
+          <a:lstStyle/>
+          <a:p>
+            <a:pPr>
+              <a:lnSpc>
+                <a:spcPct val="112000"/>
+              </a:lnSpc>
+              <a:spcAft>
+                <a:spcPts val="900"/>
+              </a:spcAft>
+            </a:pPr>
+            <a:r>
+              <a:rPr sz="1800" b="1">
+                <a:solidFill>
+                  <a:srgbClr val="E0A437"/>
+                </a:solidFill>
+                <a:latin typeface="Fira Sans"/>
+              </a:rPr>
+              <a:t>▸ </a:t>
+            </a:r>
+            <a:r>
+              <a:rPr sz="1800" b="1">
+                <a:solidFill>
+                  <a:srgbClr val="1D3557"/>
+                </a:solidFill>
+                <a:latin typeface="Fira Sans"/>
+              </a:rPr>
+              <a:t>iris para aprender los conceptos; la EOD para aplicarlos a datos reales.</a:t>
+            </a:r>
+          </a:p>
+          <a:p>
+            <a:pPr>
+              <a:lnSpc>
+                <a:spcPct val="112000"/>
+              </a:lnSpc>
+              <a:spcAft>
+                <a:spcPts val="900"/>
+              </a:spcAft>
+            </a:pPr>
+            <a:r>
+              <a:rPr sz="1800" b="1">
+                <a:solidFill>
+                  <a:srgbClr val="E0A437"/>
+                </a:solidFill>
+                <a:latin typeface="Fira Sans"/>
+              </a:rPr>
+              <a:t>▸ </a:t>
+            </a:r>
             <a:r>
               <a:rPr sz="1800" b="0">
                 <a:solidFill>
+                  <a:srgbClr val="000000"/>
+                </a:solidFill>
+                <a:latin typeface="Fira Sans"/>
+              </a:rPr>
+              <a:t>iris: 150 flores de tres especies (setosa, versicolor, virginica), con cuatro medidas en centímetros (largo y ancho de pétalo y sépalo). Publicado por Fisher (1936); el clásico de la estadística.</a:t>
+            </a:r>
+          </a:p>
+          <a:p>
+            <a:pPr>
+              <a:lnSpc>
+                <a:spcPct val="112000"/>
+              </a:lnSpc>
+              <a:spcAft>
+                <a:spcPts val="900"/>
+              </a:spcAft>
+            </a:pPr>
+            <a:r>
+              <a:rPr sz="1800" b="1">
+                <a:solidFill>
                   <a:srgbClr val="E0A437"/>
                 </a:solidFill>
                 <a:latin typeface="Fira Sans"/>
               </a:rPr>
-              <a:t>Un número para el centro de la variable</a:t>
+              <a:t>▸ </a:t>
+            </a:r>
+            <a:r>
+              <a:rPr sz="1800" b="0">
+                <a:solidFill>
+                  <a:srgbClr val="000000"/>
+                </a:solidFill>
+                <a:latin typeface="Fira Sans"/>
+              </a:rPr>
+              <a:t>Chico y ordenado: los resúmenes se pueden verificar a mano.</a:t>
+            </a:r>
+          </a:p>
+          <a:p>
+            <a:pPr>
+              <a:lnSpc>
+                <a:spcPct val="112000"/>
+              </a:lnSpc>
+              <a:spcAft>
+                <a:spcPts val="900"/>
+              </a:spcAft>
+            </a:pPr>
+            <a:r>
+              <a:rPr sz="1800" b="1">
+                <a:solidFill>
+                  <a:srgbClr val="E0A437"/>
+                </a:solidFill>
+                <a:latin typeface="Fira Sans"/>
+              </a:rPr>
+              <a:t>▸ </a:t>
+            </a:r>
+            <a:r>
+              <a:rPr sz="1800" b="0">
+                <a:solidFill>
+                  <a:srgbClr val="000000"/>
+                </a:solidFill>
+                <a:latin typeface="Fira Sans"/>
+              </a:rPr>
+              <a:t>La EOD ya la conocen: 113.591 viajes, con faltantes, colas y códigos. Lo que iris enseña, la EOD lo pone a prueba.</a:t>
             </a:r>
           </a:p>
         </p:txBody>
@@ -8807,21 +9959,112 @@
                 </a:solidFill>
                 <a:latin typeface="Fira Sans"/>
               </a:rPr>
-              <a:t>Tres resúmenes del centro</a:t>
-            </a:r>
-          </a:p>
-        </p:txBody>
-      </p:sp>
-      <p:sp>
-        <p:nvSpPr>
-          <p:cNvPr id="4" name="TextBox 3"/>
+              <a:t>Cargar iris</a:t>
+            </a:r>
+          </a:p>
+        </p:txBody>
+      </p:sp>
+      <p:sp>
+        <p:nvSpPr>
+          <p:cNvPr id="4" name="Rectangle 3"/>
+          <p:cNvSpPr/>
+          <p:nvPr/>
+        </p:nvSpPr>
+        <p:spPr>
+          <a:xfrm>
+            <a:off x="704088" y="1280160"/>
+            <a:ext cx="7744968" cy="2377440"/>
+          </a:xfrm>
+          <a:prstGeom prst="rect">
+            <a:avLst/>
+          </a:prstGeom>
+          <a:solidFill>
+            <a:srgbClr val="F0F2F5"/>
+          </a:solidFill>
+          <a:ln>
+            <a:solidFill>
+              <a:srgbClr val="D8DDE3"/>
+            </a:solidFill>
+          </a:ln>
+          <a:effectLst/>
+        </p:spPr>
+        <p:style>
+          <a:lnRef idx="1">
+            <a:schemeClr val="accent1"/>
+          </a:lnRef>
+          <a:fillRef idx="3">
+            <a:schemeClr val="accent1"/>
+          </a:fillRef>
+          <a:effectRef idx="2">
+            <a:schemeClr val="accent1"/>
+          </a:effectRef>
+          <a:fontRef idx="minor">
+            <a:schemeClr val="lt1"/>
+          </a:fontRef>
+        </p:style>
+        <p:txBody>
+          <a:bodyPr rtlCol="0" anchor="ctr" wrap="square" lIns="228600" tIns="137160"/>
+          <a:lstStyle/>
+          <a:p>
+            <a:pPr/>
+            <a:r>
+              <a:rPr sz="1500" b="0">
+                <a:solidFill>
+                  <a:srgbClr val="1D3557"/>
+                </a:solidFill>
+                <a:latin typeface="Menlo"/>
+              </a:rPr>
+              <a:t>from sklearn.datasets import load_iris</a:t>
+            </a:r>
+          </a:p>
+          <a:p>
+            <a:pPr/>
+            <a:r>
+              <a:rPr sz="1500" b="0">
+                <a:solidFill>
+                  <a:srgbClr val="1D3557"/>
+                </a:solidFill>
+                <a:latin typeface="Menlo"/>
+              </a:rPr>
+              <a:t>iris = load_iris()</a:t>
+            </a:r>
+          </a:p>
+          <a:p>
+            <a:pPr/>
+            <a:r>
+              <a:rPr sz="1500" b="0">
+                <a:solidFill>
+                  <a:srgbClr val="1D3557"/>
+                </a:solidFill>
+                <a:latin typeface="Menlo"/>
+              </a:rPr>
+              <a:t>iris_df = pd.DataFrame(iris.data, columns=iris.feature_names)</a:t>
+            </a:r>
+          </a:p>
+          <a:p>
+            <a:pPr/>
+            <a:r>
+              <a:rPr sz="1500" b="0">
+                <a:solidFill>
+                  <a:srgbClr val="1D3557"/>
+                </a:solidFill>
+                <a:latin typeface="Menlo"/>
+              </a:rPr>
+              <a:t>iris_df["species"] = pd.Categorical.from_codes(iris.target, iris.target_names)</a:t>
+            </a:r>
+          </a:p>
+        </p:txBody>
+      </p:sp>
+      <p:sp>
+        <p:nvSpPr>
+          <p:cNvPr id="5" name="TextBox 4"/>
           <p:cNvSpPr txBox="1"/>
           <p:nvPr/>
         </p:nvSpPr>
         <p:spPr>
           <a:xfrm>
-            <a:off x="704088" y="1353312"/>
-            <a:ext cx="7744968" cy="3300984"/>
+            <a:off x="704088" y="3886200"/>
+            <a:ext cx="7744968" cy="1097280"/>
           </a:xfrm>
           <a:prstGeom prst="rect">
             <a:avLst/>
@@ -8843,7 +10086,7 @@
               </a:spcAft>
             </a:pPr>
             <a:r>
-              <a:rPr sz="1800" b="1">
+              <a:rPr sz="1600" b="1">
                 <a:solidFill>
                   <a:srgbClr val="E0A437"/>
                 </a:solidFill>
@@ -8852,97 +10095,13 @@
               <a:t>▸ </a:t>
             </a:r>
             <a:r>
-              <a:rPr sz="1800" b="0">
+              <a:rPr sz="1600" b="0">
                 <a:solidFill>
                   <a:srgbClr val="000000"/>
                 </a:solidFill>
                 <a:latin typeface="Fira Sans"/>
               </a:rPr>
-              <a:t>Media: la suma dividida por el número de observaciones. En la EOD, la duración media de un viaje es 36,9 minutos.</a:t>
-            </a:r>
-          </a:p>
-          <a:p>
-            <a:pPr>
-              <a:lnSpc>
-                <a:spcPct val="112000"/>
-              </a:lnSpc>
-              <a:spcAft>
-                <a:spcPts val="900"/>
-              </a:spcAft>
-            </a:pPr>
-            <a:r>
-              <a:rPr sz="1800" b="1">
-                <a:solidFill>
-                  <a:srgbClr val="E0A437"/>
-                </a:solidFill>
-                <a:latin typeface="Fira Sans"/>
-              </a:rPr>
-              <a:t>▸ </a:t>
-            </a:r>
-            <a:r>
-              <a:rPr sz="1800" b="0">
-                <a:solidFill>
-                  <a:srgbClr val="000000"/>
-                </a:solidFill>
-                <a:latin typeface="Fira Sans"/>
-              </a:rPr>
-              <a:t>Mediana: el valor que deja la mitad de los datos a cada lado. En la EOD, 30 minutos.</a:t>
-            </a:r>
-          </a:p>
-          <a:p>
-            <a:pPr>
-              <a:lnSpc>
-                <a:spcPct val="112000"/>
-              </a:lnSpc>
-              <a:spcAft>
-                <a:spcPts val="900"/>
-              </a:spcAft>
-            </a:pPr>
-            <a:r>
-              <a:rPr sz="1800" b="1">
-                <a:solidFill>
-                  <a:srgbClr val="E0A437"/>
-                </a:solidFill>
-                <a:latin typeface="Fira Sans"/>
-              </a:rPr>
-              <a:t>▸ </a:t>
-            </a:r>
-            <a:r>
-              <a:rPr sz="1800" b="0">
-                <a:solidFill>
-                  <a:srgbClr val="000000"/>
-                </a:solidFill>
-                <a:latin typeface="Fira Sans"/>
-              </a:rPr>
-              <a:t>Moda: el valor más frecuente; útil también en variables cualitativas. En la EOD, 30 minutos.</a:t>
-            </a:r>
-          </a:p>
-          <a:p>
-            <a:pPr>
-              <a:lnSpc>
-                <a:spcPct val="112000"/>
-              </a:lnSpc>
-              <a:spcAft>
-                <a:spcPts val="900"/>
-              </a:spcAft>
-            </a:pPr>
-            <a:r>
-              <a:rPr sz="1800" b="1">
-                <a:solidFill>
-                  <a:srgbClr val="E0A437"/>
-                </a:solidFill>
-                <a:latin typeface="Fira Sans"/>
-              </a:rPr>
-              <a:t>▸ </a:t>
-            </a:r>
-            <a:r>
-              <a:rPr sz="1800" b="1">
-                <a:solidFill>
-                  <a:srgbClr val="1D3557"/>
-                </a:solidFill>
-                <a:latin typeface="Fira Sans"/>
-              </a:rPr>
-              <a:t>Cuando media y mediana difieren, la distribución es asimétrica: la media queda arrastrada hacia la cola.</a:t>
+              <a:t>Viene incluido en scikit-learn, así que no requiere descarga. La columna species queda como variable categórica de Pandas.</a:t>
             </a:r>
           </a:p>
         </p:txBody>
@@ -8980,7 +10139,7 @@
             <a:avLst/>
           </a:prstGeom>
           <a:solidFill>
-            <a:srgbClr val="FAFBFC"/>
+            <a:srgbClr val="1D3557"/>
           </a:solidFill>
           <a:ln>
             <a:noFill/>
@@ -9017,8 +10176,8 @@
         </p:nvSpPr>
         <p:spPr>
           <a:xfrm>
-            <a:off x="402336" y="301752"/>
-            <a:ext cx="8348472" cy="795528"/>
+            <a:off x="603504" y="1847088"/>
+            <a:ext cx="7946136" cy="1399032"/>
           </a:xfrm>
           <a:prstGeom prst="rect">
             <a:avLst/>
@@ -9032,71 +10191,24 @@
           <a:lstStyle/>
           <a:p>
             <a:r>
-              <a:rPr sz="2800" b="1">
-                <a:solidFill>
-                  <a:srgbClr val="0F0F0F"/>
-                </a:solidFill>
-                <a:latin typeface="Fira Sans"/>
-              </a:rPr>
-              <a:t>Media contra mediana: el ingreso de los hogares</a:t>
-            </a:r>
-          </a:p>
-        </p:txBody>
-      </p:sp>
-      <p:pic>
-        <p:nvPicPr>
-          <p:cNvPr id="4" name="Picture 3" descr="01_media_mediana_ingreso.png"/>
-          <p:cNvPicPr>
-            <a:picLocks noChangeAspect="1"/>
-          </p:cNvPicPr>
-          <p:nvPr/>
-        </p:nvPicPr>
-        <p:blipFill>
-          <a:blip r:embed="rId2"/>
-          <a:stretch>
-            <a:fillRect/>
-          </a:stretch>
-        </p:blipFill>
-        <p:spPr>
-          <a:xfrm>
-            <a:off x="1874481" y="1143000"/>
-            <a:ext cx="5395037" cy="3154680"/>
-          </a:xfrm>
-          <a:prstGeom prst="rect">
-            <a:avLst/>
-          </a:prstGeom>
-        </p:spPr>
-      </p:pic>
-      <p:sp>
-        <p:nvSpPr>
-          <p:cNvPr id="5" name="TextBox 4"/>
-          <p:cNvSpPr txBox="1"/>
-          <p:nvPr/>
-        </p:nvSpPr>
-        <p:spPr>
-          <a:xfrm>
-            <a:off x="704088" y="4434840"/>
-            <a:ext cx="7744968" cy="457200"/>
-          </a:xfrm>
-          <a:prstGeom prst="rect">
-            <a:avLst/>
-          </a:prstGeom>
-          <a:noFill/>
-        </p:spPr>
-        <p:txBody>
-          <a:bodyPr wrap="square">
-            <a:spAutoFit/>
-          </a:bodyPr>
-          <a:lstStyle/>
-          <a:p>
-            <a:r>
-              <a:rPr sz="1300" b="0">
-                <a:solidFill>
-                  <a:srgbClr val="333333"/>
-                </a:solidFill>
-                <a:latin typeface="Fira Sans"/>
-              </a:rPr>
-              <a:t>Ingresos de la muestra de la EOD: la mediana es $0,51 millones y la media $0,69 millones. La cola de ingresos altos arrastra la media; por eso el ingreso se reporta con la mediana.</a:t>
+              <a:rPr sz="3400" b="1">
+                <a:solidFill>
+                  <a:srgbClr val="FFFFFF"/>
+                </a:solidFill>
+                <a:latin typeface="Fira Sans"/>
+              </a:rPr>
+              <a:t>Tendencia central</a:t>
+            </a:r>
+          </a:p>
+          <a:p>
+            <a:r>
+              <a:rPr sz="1800" b="0">
+                <a:solidFill>
+                  <a:srgbClr val="E0A437"/>
+                </a:solidFill>
+                <a:latin typeface="Fira Sans"/>
+              </a:rPr>
+              <a:t>Un número para el centro de la variable</a:t>
             </a:r>
           </a:p>
         </p:txBody>
@@ -9134,7 +10246,7 @@
             <a:avLst/>
           </a:prstGeom>
           <a:solidFill>
-            <a:srgbClr val="1D3557"/>
+            <a:srgbClr val="FAFBFC"/>
           </a:solidFill>
           <a:ln>
             <a:noFill/>
@@ -9171,8 +10283,8 @@
         </p:nvSpPr>
         <p:spPr>
           <a:xfrm>
-            <a:off x="603504" y="1847088"/>
-            <a:ext cx="7946136" cy="1399032"/>
+            <a:off x="402336" y="301752"/>
+            <a:ext cx="8348472" cy="795528"/>
           </a:xfrm>
           <a:prstGeom prst="rect">
             <a:avLst/>
@@ -9186,24 +10298,148 @@
           <a:lstStyle/>
           <a:p>
             <a:r>
-              <a:rPr sz="3400" b="1">
-                <a:solidFill>
-                  <a:srgbClr val="FFFFFF"/>
-                </a:solidFill>
-                <a:latin typeface="Fira Sans"/>
-              </a:rPr>
-              <a:t>Dispersión y forma</a:t>
-            </a:r>
-          </a:p>
-          <a:p>
+              <a:rPr sz="2800" b="1">
+                <a:solidFill>
+                  <a:srgbClr val="0F0F0F"/>
+                </a:solidFill>
+                <a:latin typeface="Fira Sans"/>
+              </a:rPr>
+              <a:t>Frecuencia y moda</a:t>
+            </a:r>
+          </a:p>
+        </p:txBody>
+      </p:sp>
+      <p:sp>
+        <p:nvSpPr>
+          <p:cNvPr id="4" name="TextBox 3"/>
+          <p:cNvSpPr txBox="1"/>
+          <p:nvPr/>
+        </p:nvSpPr>
+        <p:spPr>
+          <a:xfrm>
+            <a:off x="704088" y="1353312"/>
+            <a:ext cx="7744968" cy="3300984"/>
+          </a:xfrm>
+          <a:prstGeom prst="rect">
+            <a:avLst/>
+          </a:prstGeom>
+          <a:noFill/>
+        </p:spPr>
+        <p:txBody>
+          <a:bodyPr wrap="square">
+            <a:spAutoFit/>
+          </a:bodyPr>
+          <a:lstStyle/>
+          <a:p>
+            <a:pPr>
+              <a:lnSpc>
+                <a:spcPct val="112000"/>
+              </a:lnSpc>
+              <a:spcAft>
+                <a:spcPts val="900"/>
+              </a:spcAft>
+            </a:pPr>
+            <a:r>
+              <a:rPr sz="1800" b="1">
+                <a:solidFill>
+                  <a:srgbClr val="E0A437"/>
+                </a:solidFill>
+                <a:latin typeface="Fira Sans"/>
+              </a:rPr>
+              <a:t>▸ </a:t>
+            </a:r>
             <a:r>
               <a:rPr sz="1800" b="0">
                 <a:solidFill>
+                  <a:srgbClr val="000000"/>
+                </a:solidFill>
+                <a:latin typeface="Fira Sans"/>
+              </a:rPr>
+              <a:t>Para una variable cualitativa, el resumen básico es la frecuencia de cada categoría: value_counts(), y en porcentaje con normalize=True.</a:t>
+            </a:r>
+          </a:p>
+          <a:p>
+            <a:pPr>
+              <a:lnSpc>
+                <a:spcPct val="112000"/>
+              </a:lnSpc>
+              <a:spcAft>
+                <a:spcPts val="900"/>
+              </a:spcAft>
+            </a:pPr>
+            <a:r>
+              <a:rPr sz="1800" b="1">
+                <a:solidFill>
                   <a:srgbClr val="E0A437"/>
                 </a:solidFill>
                 <a:latin typeface="Fira Sans"/>
               </a:rPr>
-              <a:t>Cuánto varían los datos alrededor del centro</a:t>
+              <a:t>▸ </a:t>
+            </a:r>
+            <a:r>
+              <a:rPr sz="1800" b="0">
+                <a:solidFill>
+                  <a:srgbClr val="000000"/>
+                </a:solidFill>
+                <a:latin typeface="Fira Sans"/>
+              </a:rPr>
+              <a:t>En iris: 50 flores de cada especie (un diseño balanceado).</a:t>
+            </a:r>
+          </a:p>
+          <a:p>
+            <a:pPr>
+              <a:lnSpc>
+                <a:spcPct val="112000"/>
+              </a:lnSpc>
+              <a:spcAft>
+                <a:spcPts val="900"/>
+              </a:spcAft>
+            </a:pPr>
+            <a:r>
+              <a:rPr sz="1800" b="1">
+                <a:solidFill>
+                  <a:srgbClr val="E0A437"/>
+                </a:solidFill>
+                <a:latin typeface="Fira Sans"/>
+              </a:rPr>
+              <a:t>▸ </a:t>
+            </a:r>
+            <a:r>
+              <a:rPr sz="1800" b="0">
+                <a:solidFill>
+                  <a:srgbClr val="000000"/>
+                </a:solidFill>
+                <a:latin typeface="Fira Sans"/>
+              </a:rPr>
+              <a:t>La moda es el valor más frecuente; es el único resumen de tendencia central que existe para variables cualitativas.</a:t>
+            </a:r>
+          </a:p>
+          <a:p>
+            <a:pPr>
+              <a:lnSpc>
+                <a:spcPct val="112000"/>
+              </a:lnSpc>
+              <a:spcAft>
+                <a:spcPts val="900"/>
+              </a:spcAft>
+            </a:pPr>
+            <a:r>
+              <a:rPr sz="1800" b="1">
+                <a:solidFill>
+                  <a:srgbClr val="E0A437"/>
+                </a:solidFill>
+                <a:latin typeface="Fira Sans"/>
+              </a:rPr>
+              <a:t>▸ </a:t>
+            </a:r>
+            <a:r>
+              <a:rPr sz="1800" b="0">
+                <a:solidFill>
+                  <a:srgbClr val="000000"/>
+                </a:solidFill>
+                <a:latin typeface="Fira Sans"/>
+              </a:rPr>
+              <a:t>En la EOD, la moda de la duración es 30 minutos: la gente declara tiempos redondeados.</a:t>
             </a:r>
           </a:p>
         </p:txBody>
@@ -9299,7 +10535,7 @@
                 </a:solidFill>
                 <a:latin typeface="Fira Sans"/>
               </a:rPr>
-              <a:t>Medir la dispersión</a:t>
+              <a:t>Media y mediana</a:t>
             </a:r>
           </a:p>
         </p:txBody>
@@ -9350,7 +10586,7 @@
                 </a:solidFill>
                 <a:latin typeface="Fira Sans"/>
               </a:rPr>
-              <a:t>Rango: máximo menos mínimo; dominado por los extremos.</a:t>
+              <a:t>Media: la suma dividida por el número de observaciones.</a:t>
             </a:r>
           </a:p>
           <a:p>
@@ -9378,7 +10614,7 @@
                 </a:solidFill>
                 <a:latin typeface="Fira Sans"/>
               </a:rPr>
-              <a:t>Desviación estándar: raíz de la varianza, en las unidades originales. En la EOD: 36,1 minutos, casi tan grande como la media.</a:t>
+              <a:t>Mediana: el valor que deja la mitad de los datos a cada lado.</a:t>
             </a:r>
           </a:p>
           <a:p>
@@ -9406,7 +10642,7 @@
                 </a:solidFill>
                 <a:latin typeface="Fira Sans"/>
               </a:rPr>
-              <a:t>Percentiles: el valor bajo el cual queda un porcentaje de los datos.</a:t>
+              <a:t>En iris, largo del sépalo: media 5,84 y mediana 5,80. Casi iguales: la distribución es simétrica.</a:t>
             </a:r>
           </a:p>
           <a:p>
@@ -9428,13 +10664,13 @@
               <a:t>▸ </a:t>
             </a:r>
             <a:r>
-              <a:rPr sz="1800" b="0">
-                <a:solidFill>
-                  <a:srgbClr val="000000"/>
-                </a:solidFill>
-                <a:latin typeface="Fira Sans"/>
-              </a:rPr>
-              <a:t>IQR = Q3 menos Q1: el tramo del 50% central. En la EOD, de 15 a 50 minutos.</a:t>
+              <a:rPr sz="1800" b="1">
+                <a:solidFill>
+                  <a:srgbClr val="1D3557"/>
+                </a:solidFill>
+                <a:latin typeface="Fira Sans"/>
+              </a:rPr>
+              <a:t>Cuando difieren, la distribución es asimétrica: la media queda arrastrada hacia la cola.</a:t>
             </a:r>
           </a:p>
         </p:txBody>

</xml_diff>

<commit_message>
La definición de hipótesis antes de la tabla de malas hipótesis, con falsabilidad explícita
Co-Authored-By: Claude Fable 5 <noreply@anthropic.com>
</commit_message>
<xml_diff>
--- a/presentaciones/clase02_eda_descriptiva.pptx
+++ b/presentaciones/clase02_eda_descriptiva.pptx
@@ -3380,6 +3380,237 @@
 </file>
 
 <file path=ppt/slides/slide10.xml><?xml version="1.0" encoding="utf-8"?>
+<p:sld xmlns:a="http://schemas.openxmlformats.org/drawingml/2006/main" xmlns:p="http://schemas.openxmlformats.org/presentationml/2006/main" xmlns:r="http://schemas.openxmlformats.org/officeDocument/2006/relationships">
+  <p:cSld>
+    <p:spTree>
+      <p:nvGrpSpPr>
+        <p:cNvPr id="1" name=""/>
+        <p:cNvGrpSpPr/>
+        <p:nvPr/>
+      </p:nvGrpSpPr>
+      <p:grpSpPr/>
+      <p:sp>
+        <p:nvSpPr>
+          <p:cNvPr id="2" name="Rectangle 1"/>
+          <p:cNvSpPr/>
+          <p:nvPr/>
+        </p:nvSpPr>
+        <p:spPr>
+          <a:xfrm>
+            <a:off x="0" y="0"/>
+            <a:ext cx="9144000" cy="5138928"/>
+          </a:xfrm>
+          <a:prstGeom prst="rect">
+            <a:avLst/>
+          </a:prstGeom>
+          <a:solidFill>
+            <a:srgbClr val="FAFBFC"/>
+          </a:solidFill>
+          <a:ln>
+            <a:noFill/>
+          </a:ln>
+          <a:effectLst/>
+        </p:spPr>
+        <p:style>
+          <a:lnRef idx="1">
+            <a:schemeClr val="accent1"/>
+          </a:lnRef>
+          <a:fillRef idx="3">
+            <a:schemeClr val="accent1"/>
+          </a:fillRef>
+          <a:effectRef idx="2">
+            <a:schemeClr val="accent1"/>
+          </a:effectRef>
+          <a:fontRef idx="minor">
+            <a:schemeClr val="lt1"/>
+          </a:fontRef>
+        </p:style>
+        <p:txBody>
+          <a:bodyPr rtlCol="0" anchor="ctr"/>
+          <a:lstStyle/>
+          <a:p>
+            <a:pPr algn="ctr"/>
+          </a:p>
+        </p:txBody>
+      </p:sp>
+      <p:sp>
+        <p:nvSpPr>
+          <p:cNvPr id="3" name="TextBox 2"/>
+          <p:cNvSpPr txBox="1"/>
+          <p:nvPr/>
+        </p:nvSpPr>
+        <p:spPr>
+          <a:xfrm>
+            <a:off x="402336" y="301752"/>
+            <a:ext cx="8348472" cy="795528"/>
+          </a:xfrm>
+          <a:prstGeom prst="rect">
+            <a:avLst/>
+          </a:prstGeom>
+          <a:noFill/>
+        </p:spPr>
+        <p:txBody>
+          <a:bodyPr wrap="square">
+            <a:spAutoFit/>
+          </a:bodyPr>
+          <a:lstStyle/>
+          <a:p>
+            <a:r>
+              <a:rPr sz="2800" b="1">
+                <a:solidFill>
+                  <a:srgbClr val="0F0F0F"/>
+                </a:solidFill>
+                <a:latin typeface="Fira Sans"/>
+              </a:rPr>
+              <a:t>De la pregunta a la hipótesis</a:t>
+            </a:r>
+          </a:p>
+        </p:txBody>
+      </p:sp>
+      <p:sp>
+        <p:nvSpPr>
+          <p:cNvPr id="4" name="TextBox 3"/>
+          <p:cNvSpPr txBox="1"/>
+          <p:nvPr/>
+        </p:nvSpPr>
+        <p:spPr>
+          <a:xfrm>
+            <a:off x="704088" y="1353312"/>
+            <a:ext cx="7744968" cy="3300984"/>
+          </a:xfrm>
+          <a:prstGeom prst="rect">
+            <a:avLst/>
+          </a:prstGeom>
+          <a:noFill/>
+        </p:spPr>
+        <p:txBody>
+          <a:bodyPr wrap="square">
+            <a:spAutoFit/>
+          </a:bodyPr>
+          <a:lstStyle/>
+          <a:p>
+            <a:pPr>
+              <a:lnSpc>
+                <a:spcPct val="112000"/>
+              </a:lnSpc>
+              <a:spcAft>
+                <a:spcPts val="900"/>
+              </a:spcAft>
+            </a:pPr>
+            <a:r>
+              <a:rPr sz="1800" b="1">
+                <a:solidFill>
+                  <a:srgbClr val="E0A437"/>
+                </a:solidFill>
+                <a:latin typeface="Fira Sans"/>
+              </a:rPr>
+              <a:t>▸ </a:t>
+            </a:r>
+            <a:r>
+              <a:rPr sz="1800" b="1">
+                <a:solidFill>
+                  <a:srgbClr val="1D3557"/>
+                </a:solidFill>
+                <a:latin typeface="Fira Sans"/>
+              </a:rPr>
+              <a:t>Hipótesis: una afirmación sobre la relación entre variables medibles, que los datos pueden confirmar o refutar.</a:t>
+            </a:r>
+          </a:p>
+          <a:p>
+            <a:pPr>
+              <a:lnSpc>
+                <a:spcPct val="112000"/>
+              </a:lnSpc>
+              <a:spcAft>
+                <a:spcPts val="900"/>
+              </a:spcAft>
+            </a:pPr>
+            <a:r>
+              <a:rPr sz="1800" b="1">
+                <a:solidFill>
+                  <a:srgbClr val="E0A437"/>
+                </a:solidFill>
+                <a:latin typeface="Fira Sans"/>
+              </a:rPr>
+              <a:t>▸ </a:t>
+            </a:r>
+            <a:r>
+              <a:rPr sz="1800" b="0">
+                <a:solidFill>
+                  <a:srgbClr val="000000"/>
+                </a:solidFill>
+                <a:latin typeface="Fira Sans"/>
+              </a:rPr>
+              <a:t>Si ningún resultado posible podría refutarla, no es una hipótesis.</a:t>
+            </a:r>
+          </a:p>
+          <a:p>
+            <a:pPr>
+              <a:lnSpc>
+                <a:spcPct val="112000"/>
+              </a:lnSpc>
+              <a:spcAft>
+                <a:spcPts val="900"/>
+              </a:spcAft>
+            </a:pPr>
+            <a:r>
+              <a:rPr sz="1800" b="1">
+                <a:solidFill>
+                  <a:srgbClr val="E0A437"/>
+                </a:solidFill>
+                <a:latin typeface="Fira Sans"/>
+              </a:rPr>
+              <a:t>▸ </a:t>
+            </a:r>
+            <a:r>
+              <a:rPr sz="1800" b="0">
+                <a:solidFill>
+                  <a:srgbClr val="000000"/>
+                </a:solidFill>
+                <a:latin typeface="Fira Sans"/>
+              </a:rPr>
+              <a:t>Pregunta: ¿la duración del viaje depende del modo de transporte?</a:t>
+            </a:r>
+          </a:p>
+          <a:p>
+            <a:pPr>
+              <a:lnSpc>
+                <a:spcPct val="112000"/>
+              </a:lnSpc>
+              <a:spcAft>
+                <a:spcPts val="900"/>
+              </a:spcAft>
+            </a:pPr>
+            <a:r>
+              <a:rPr sz="1800" b="1">
+                <a:solidFill>
+                  <a:srgbClr val="E0A437"/>
+                </a:solidFill>
+                <a:latin typeface="Fira Sans"/>
+              </a:rPr>
+              <a:t>▸ </a:t>
+            </a:r>
+            <a:r>
+              <a:rPr sz="1800" b="0">
+                <a:solidFill>
+                  <a:srgbClr val="000000"/>
+                </a:solidFill>
+                <a:latin typeface="Fira Sans"/>
+              </a:rPr>
+              <a:t>Hipótesis: los viajes en transporte público duran en promedio más que en auto. Variables: ModoAgrupado y TiempoViaje; el contraste, una comparación de medias (clase 5).</a:t>
+            </a:r>
+          </a:p>
+        </p:txBody>
+      </p:sp>
+    </p:spTree>
+  </p:cSld>
+  <p:clrMapOvr>
+    <a:masterClrMapping/>
+  </p:clrMapOvr>
+</p:sld>
+</file>
+
+<file path=ppt/slides/slide11.xml><?xml version="1.0" encoding="utf-8"?>
 <p:sld xmlns:a="http://schemas.openxmlformats.org/drawingml/2006/main" xmlns:p="http://schemas.openxmlformats.org/presentationml/2006/main" xmlns:r="http://schemas.openxmlformats.org/officeDocument/2006/relationships">
   <p:cSld>
     <p:spTree>
@@ -3868,160 +4099,6 @@
 </p:sld>
 </file>
 
-<file path=ppt/slides/slide11.xml><?xml version="1.0" encoding="utf-8"?>
-<p:sld xmlns:a="http://schemas.openxmlformats.org/drawingml/2006/main" xmlns:p="http://schemas.openxmlformats.org/presentationml/2006/main" xmlns:r="http://schemas.openxmlformats.org/officeDocument/2006/relationships">
-  <p:cSld>
-    <p:spTree>
-      <p:nvGrpSpPr>
-        <p:cNvPr id="1" name=""/>
-        <p:cNvGrpSpPr/>
-        <p:nvPr/>
-      </p:nvGrpSpPr>
-      <p:grpSpPr/>
-      <p:sp>
-        <p:nvSpPr>
-          <p:cNvPr id="2" name="Rectangle 1"/>
-          <p:cNvSpPr/>
-          <p:nvPr/>
-        </p:nvSpPr>
-        <p:spPr>
-          <a:xfrm>
-            <a:off x="0" y="0"/>
-            <a:ext cx="9144000" cy="5138928"/>
-          </a:xfrm>
-          <a:prstGeom prst="rect">
-            <a:avLst/>
-          </a:prstGeom>
-          <a:solidFill>
-            <a:srgbClr val="FAFBFC"/>
-          </a:solidFill>
-          <a:ln>
-            <a:noFill/>
-          </a:ln>
-          <a:effectLst/>
-        </p:spPr>
-        <p:style>
-          <a:lnRef idx="1">
-            <a:schemeClr val="accent1"/>
-          </a:lnRef>
-          <a:fillRef idx="3">
-            <a:schemeClr val="accent1"/>
-          </a:fillRef>
-          <a:effectRef idx="2">
-            <a:schemeClr val="accent1"/>
-          </a:effectRef>
-          <a:fontRef idx="minor">
-            <a:schemeClr val="lt1"/>
-          </a:fontRef>
-        </p:style>
-        <p:txBody>
-          <a:bodyPr rtlCol="0" anchor="ctr"/>
-          <a:lstStyle/>
-          <a:p>
-            <a:pPr algn="ctr"/>
-          </a:p>
-        </p:txBody>
-      </p:sp>
-      <p:sp>
-        <p:nvSpPr>
-          <p:cNvPr id="3" name="TextBox 2"/>
-          <p:cNvSpPr txBox="1"/>
-          <p:nvPr/>
-        </p:nvSpPr>
-        <p:spPr>
-          <a:xfrm>
-            <a:off x="402336" y="301752"/>
-            <a:ext cx="8348472" cy="795528"/>
-          </a:xfrm>
-          <a:prstGeom prst="rect">
-            <a:avLst/>
-          </a:prstGeom>
-          <a:noFill/>
-        </p:spPr>
-        <p:txBody>
-          <a:bodyPr wrap="square">
-            <a:spAutoFit/>
-          </a:bodyPr>
-          <a:lstStyle/>
-          <a:p>
-            <a:r>
-              <a:rPr sz="2800" b="1">
-                <a:solidFill>
-                  <a:srgbClr val="0F0F0F"/>
-                </a:solidFill>
-                <a:latin typeface="Fira Sans"/>
-              </a:rPr>
-              <a:t>El ciclo PPDAC</a:t>
-            </a:r>
-          </a:p>
-        </p:txBody>
-      </p:sp>
-      <p:pic>
-        <p:nvPicPr>
-          <p:cNvPr id="4" name="Picture 3" descr="07_ppdac.png"/>
-          <p:cNvPicPr>
-            <a:picLocks noChangeAspect="1"/>
-          </p:cNvPicPr>
-          <p:nvPr/>
-        </p:nvPicPr>
-        <p:blipFill>
-          <a:blip r:embed="rId2"/>
-          <a:stretch>
-            <a:fillRect/>
-          </a:stretch>
-        </p:blipFill>
-        <p:spPr>
-          <a:xfrm>
-            <a:off x="1417319" y="1143000"/>
-            <a:ext cx="6309360" cy="2477421"/>
-          </a:xfrm>
-          <a:prstGeom prst="rect">
-            <a:avLst/>
-          </a:prstGeom>
-        </p:spPr>
-      </p:pic>
-      <p:sp>
-        <p:nvSpPr>
-          <p:cNvPr id="5" name="TextBox 4"/>
-          <p:cNvSpPr txBox="1"/>
-          <p:nvPr/>
-        </p:nvSpPr>
-        <p:spPr>
-          <a:xfrm>
-            <a:off x="704088" y="4434840"/>
-            <a:ext cx="7744968" cy="457200"/>
-          </a:xfrm>
-          <a:prstGeom prst="rect">
-            <a:avLst/>
-          </a:prstGeom>
-          <a:noFill/>
-        </p:spPr>
-        <p:txBody>
-          <a:bodyPr wrap="square">
-            <a:spAutoFit/>
-          </a:bodyPr>
-          <a:lstStyle/>
-          <a:p>
-            <a:r>
-              <a:rPr sz="1300" b="0">
-                <a:solidFill>
-                  <a:srgbClr val="333333"/>
-                </a:solidFill>
-                <a:latin typeface="Fira Sans"/>
-              </a:rPr>
-              <a:t>Problema, plan, datos, análisis y conclusión (Wild y Pfannkuch, 1999): la formulación del Capstone es la etapa de problema y plan de este ciclo.</a:t>
-            </a:r>
-          </a:p>
-        </p:txBody>
-      </p:sp>
-    </p:spTree>
-  </p:cSld>
-  <p:clrMapOvr>
-    <a:masterClrMapping/>
-  </p:clrMapOvr>
-</p:sld>
-</file>
-
 <file path=ppt/slides/slide12.xml><?xml version="1.0" encoding="utf-8"?>
 <p:sld xmlns:a="http://schemas.openxmlformats.org/drawingml/2006/main" xmlns:p="http://schemas.openxmlformats.org/presentationml/2006/main" xmlns:r="http://schemas.openxmlformats.org/officeDocument/2006/relationships">
   <p:cSld>
@@ -4105,21 +4182,45 @@
                 </a:solidFill>
                 <a:latin typeface="Fira Sans"/>
               </a:rPr>
-              <a:t>De la pregunta a la hipótesis</a:t>
-            </a:r>
-          </a:p>
-        </p:txBody>
-      </p:sp>
-      <p:sp>
-        <p:nvSpPr>
-          <p:cNvPr id="4" name="TextBox 3"/>
+              <a:t>El ciclo PPDAC</a:t>
+            </a:r>
+          </a:p>
+        </p:txBody>
+      </p:sp>
+      <p:pic>
+        <p:nvPicPr>
+          <p:cNvPr id="4" name="Picture 3" descr="07_ppdac.png"/>
+          <p:cNvPicPr>
+            <a:picLocks noChangeAspect="1"/>
+          </p:cNvPicPr>
+          <p:nvPr/>
+        </p:nvPicPr>
+        <p:blipFill>
+          <a:blip r:embed="rId2"/>
+          <a:stretch>
+            <a:fillRect/>
+          </a:stretch>
+        </p:blipFill>
+        <p:spPr>
+          <a:xfrm>
+            <a:off x="1417319" y="1143000"/>
+            <a:ext cx="6309360" cy="2477421"/>
+          </a:xfrm>
+          <a:prstGeom prst="rect">
+            <a:avLst/>
+          </a:prstGeom>
+        </p:spPr>
+      </p:pic>
+      <p:sp>
+        <p:nvSpPr>
+          <p:cNvPr id="5" name="TextBox 4"/>
           <p:cNvSpPr txBox="1"/>
           <p:nvPr/>
         </p:nvSpPr>
         <p:spPr>
           <a:xfrm>
-            <a:off x="704088" y="1353312"/>
-            <a:ext cx="7744968" cy="3300984"/>
+            <a:off x="704088" y="4434840"/>
+            <a:ext cx="7744968" cy="457200"/>
           </a:xfrm>
           <a:prstGeom prst="rect">
             <a:avLst/>
@@ -4132,143 +4233,14 @@
           </a:bodyPr>
           <a:lstStyle/>
           <a:p>
-            <a:pPr>
-              <a:lnSpc>
-                <a:spcPct val="112000"/>
-              </a:lnSpc>
-              <a:spcAft>
-                <a:spcPts val="900"/>
-              </a:spcAft>
-            </a:pPr>
-            <a:r>
-              <a:rPr sz="1800" b="1">
-                <a:solidFill>
-                  <a:srgbClr val="E0A437"/>
-                </a:solidFill>
-                <a:latin typeface="Fira Sans"/>
-              </a:rPr>
-              <a:t>▸ </a:t>
-            </a:r>
-            <a:r>
-              <a:rPr sz="1800" b="0">
-                <a:solidFill>
-                  <a:srgbClr val="000000"/>
-                </a:solidFill>
-                <a:latin typeface="Fira Sans"/>
-              </a:rPr>
-              <a:t>Hipótesis: una afirmación verificable, con variables medibles y una relación esperada.</a:t>
-            </a:r>
-          </a:p>
-          <a:p>
-            <a:pPr>
-              <a:lnSpc>
-                <a:spcPct val="112000"/>
-              </a:lnSpc>
-              <a:spcAft>
-                <a:spcPts val="900"/>
-              </a:spcAft>
-            </a:pPr>
-            <a:r>
-              <a:rPr sz="1800" b="1">
-                <a:solidFill>
-                  <a:srgbClr val="E0A437"/>
-                </a:solidFill>
-                <a:latin typeface="Fira Sans"/>
-              </a:rPr>
-              <a:t>▸ </a:t>
-            </a:r>
-            <a:r>
-              <a:rPr sz="1800" b="0">
-                <a:solidFill>
-                  <a:srgbClr val="000000"/>
-                </a:solidFill>
-                <a:latin typeface="Fira Sans"/>
-              </a:rPr>
-              <a:t>Pregunta: ¿la duración del viaje depende del modo de transporte?</a:t>
-            </a:r>
-          </a:p>
-          <a:p>
-            <a:pPr>
-              <a:lnSpc>
-                <a:spcPct val="112000"/>
-              </a:lnSpc>
-              <a:spcAft>
-                <a:spcPts val="900"/>
-              </a:spcAft>
-            </a:pPr>
-            <a:r>
-              <a:rPr sz="1800" b="1">
-                <a:solidFill>
-                  <a:srgbClr val="E0A437"/>
-                </a:solidFill>
-                <a:latin typeface="Fira Sans"/>
-              </a:rPr>
-              <a:t>▸ </a:t>
-            </a:r>
-            <a:r>
-              <a:rPr sz="1800" b="0">
-                <a:solidFill>
-                  <a:srgbClr val="000000"/>
-                </a:solidFill>
-                <a:latin typeface="Fira Sans"/>
-              </a:rPr>
-              <a:t>Hipótesis: los viajes en transporte público duran en promedio más que en auto.</a:t>
-            </a:r>
-          </a:p>
-          <a:p>
-            <a:pPr>
-              <a:lnSpc>
-                <a:spcPct val="112000"/>
-              </a:lnSpc>
-              <a:spcAft>
-                <a:spcPts val="900"/>
-              </a:spcAft>
-            </a:pPr>
-            <a:r>
-              <a:rPr sz="1800" b="1">
-                <a:solidFill>
-                  <a:srgbClr val="E0A437"/>
-                </a:solidFill>
-                <a:latin typeface="Fira Sans"/>
-              </a:rPr>
-              <a:t>▸ </a:t>
-            </a:r>
-            <a:r>
-              <a:rPr sz="1800" b="0">
-                <a:solidFill>
-                  <a:srgbClr val="000000"/>
-                </a:solidFill>
-                <a:latin typeface="Fira Sans"/>
-              </a:rPr>
-              <a:t>Variables: ModoAgrupado y TiempoViaje; el contraste es una comparación de medias (clase 5).</a:t>
-            </a:r>
-          </a:p>
-          <a:p>
-            <a:pPr>
-              <a:lnSpc>
-                <a:spcPct val="112000"/>
-              </a:lnSpc>
-              <a:spcAft>
-                <a:spcPts val="900"/>
-              </a:spcAft>
-            </a:pPr>
-            <a:r>
-              <a:rPr sz="1800" b="1">
-                <a:solidFill>
-                  <a:srgbClr val="E0A437"/>
-                </a:solidFill>
-                <a:latin typeface="Fira Sans"/>
-              </a:rPr>
-              <a:t>▸ </a:t>
-            </a:r>
-            <a:r>
-              <a:rPr sz="1800" b="1">
-                <a:solidFill>
-                  <a:srgbClr val="1D3557"/>
-                </a:solidFill>
-                <a:latin typeface="Fira Sans"/>
-              </a:rPr>
-              <a:t>Sin qué medir ni qué comparar, es una intuición, no una hipótesis.</a:t>
+            <a:r>
+              <a:rPr sz="1300" b="0">
+                <a:solidFill>
+                  <a:srgbClr val="333333"/>
+                </a:solidFill>
+                <a:latin typeface="Fira Sans"/>
+              </a:rPr>
+              <a:t>Problema, plan, datos, análisis y conclusión (Wild y Pfannkuch, 1999): la formulación del Capstone es la etapa de problema y plan de este ciclo.</a:t>
             </a:r>
           </a:p>
         </p:txBody>

</xml_diff>

<commit_message>
Fórmulas de dispersión con layout legible y rango; slide de outliers con la regla de Tukey como convención y sin regla universal
Co-Authored-By: Claude Fable 5 <noreply@anthropic.com>
</commit_message>
<xml_diff>
--- a/presentaciones/clase02_eda_descriptiva.pptx
+++ b/presentaciones/clase02_eda_descriptiva.pptx
@@ -45,6 +45,7 @@
     <p:sldId id="293" r:id="rId44"/>
     <p:sldId id="294" r:id="rId45"/>
     <p:sldId id="295" r:id="rId46"/>
+    <p:sldId id="296" r:id="rId47"/>
   </p:sldIdLst>
   <p:sldSz cx="9144000" cy="5138928" type="screen4x3"/>
   <p:notesSz cx="6858000" cy="9144000"/>
@@ -6851,7 +6852,7 @@
         <p:spPr>
           <a:xfrm>
             <a:off x="1417319" y="1143000"/>
-            <a:ext cx="6309360" cy="2612286"/>
+            <a:ext cx="6309360" cy="3154680"/>
           </a:xfrm>
           <a:prstGeom prst="rect">
             <a:avLst/>
@@ -7291,45 +7292,21 @@
                 </a:solidFill>
                 <a:latin typeface="Fira Sans"/>
               </a:rPr>
-              <a:t>Boxplots para comparar grupos: iris</a:t>
-            </a:r>
-          </a:p>
-        </p:txBody>
-      </p:sp>
-      <p:pic>
-        <p:nvPicPr>
-          <p:cNvPr id="4" name="Picture 3" descr="09_iris_boxplot.png"/>
-          <p:cNvPicPr>
-            <a:picLocks noChangeAspect="1"/>
-          </p:cNvPicPr>
-          <p:nvPr/>
-        </p:nvPicPr>
-        <p:blipFill>
-          <a:blip r:embed="rId2"/>
-          <a:stretch>
-            <a:fillRect/>
-          </a:stretch>
-        </p:blipFill>
-        <p:spPr>
-          <a:xfrm>
-            <a:off x="1602889" y="1143000"/>
-            <a:ext cx="5938221" cy="3154680"/>
-          </a:xfrm>
-          <a:prstGeom prst="rect">
-            <a:avLst/>
-          </a:prstGeom>
-        </p:spPr>
-      </p:pic>
-      <p:sp>
-        <p:nvSpPr>
-          <p:cNvPr id="5" name="TextBox 4"/>
+              <a:t>Valores atípicos (outliers)</a:t>
+            </a:r>
+          </a:p>
+        </p:txBody>
+      </p:sp>
+      <p:sp>
+        <p:nvSpPr>
+          <p:cNvPr id="4" name="TextBox 3"/>
           <p:cNvSpPr txBox="1"/>
           <p:nvPr/>
         </p:nvSpPr>
         <p:spPr>
           <a:xfrm>
-            <a:off x="704088" y="4434840"/>
-            <a:ext cx="7744968" cy="457200"/>
+            <a:off x="704088" y="1353312"/>
+            <a:ext cx="7744968" cy="3300984"/>
           </a:xfrm>
           <a:prstGeom prst="rect">
             <a:avLst/>
@@ -7342,14 +7319,143 @@
           </a:bodyPr>
           <a:lstStyle/>
           <a:p>
-            <a:r>
-              <a:rPr sz="1300" b="0">
-                <a:solidFill>
-                  <a:srgbClr val="333333"/>
-                </a:solidFill>
-                <a:latin typeface="Fira Sans"/>
-              </a:rPr>
-              <a:t>El largo del pétalo separa casi perfectamente a las tres especies: centros y dispersiones distintas en una sola figura.</a:t>
+            <a:pPr>
+              <a:lnSpc>
+                <a:spcPct val="112000"/>
+              </a:lnSpc>
+              <a:spcAft>
+                <a:spcPts val="900"/>
+              </a:spcAft>
+            </a:pPr>
+            <a:r>
+              <a:rPr sz="1800" b="1">
+                <a:solidFill>
+                  <a:srgbClr val="E0A437"/>
+                </a:solidFill>
+                <a:latin typeface="Fira Sans"/>
+              </a:rPr>
+              <a:t>▸ </a:t>
+            </a:r>
+            <a:r>
+              <a:rPr sz="1800" b="1">
+                <a:solidFill>
+                  <a:srgbClr val="1D3557"/>
+                </a:solidFill>
+                <a:latin typeface="Fira Sans"/>
+              </a:rPr>
+              <a:t>Un valor atípico es una observación que se aleja notoriamente del resto de los datos.</a:t>
+            </a:r>
+          </a:p>
+          <a:p>
+            <a:pPr>
+              <a:lnSpc>
+                <a:spcPct val="112000"/>
+              </a:lnSpc>
+              <a:spcAft>
+                <a:spcPts val="900"/>
+              </a:spcAft>
+            </a:pPr>
+            <a:r>
+              <a:rPr sz="1800" b="1">
+                <a:solidFill>
+                  <a:srgbClr val="E0A437"/>
+                </a:solidFill>
+                <a:latin typeface="Fira Sans"/>
+              </a:rPr>
+              <a:t>▸ </a:t>
+            </a:r>
+            <a:r>
+              <a:rPr sz="1800" b="0">
+                <a:solidFill>
+                  <a:srgbClr val="000000"/>
+                </a:solidFill>
+                <a:latin typeface="Fira Sans"/>
+              </a:rPr>
+              <a:t>Regla operativa de Tukey: fuera de Q1 menos 1,5 por IQR y Q3 más 1,5 por IQR. Es una convención para marcar, no un veredicto.</a:t>
+            </a:r>
+          </a:p>
+          <a:p>
+            <a:pPr>
+              <a:lnSpc>
+                <a:spcPct val="112000"/>
+              </a:lnSpc>
+              <a:spcAft>
+                <a:spcPts val="900"/>
+              </a:spcAft>
+            </a:pPr>
+            <a:r>
+              <a:rPr sz="1800" b="1">
+                <a:solidFill>
+                  <a:srgbClr val="E0A437"/>
+                </a:solidFill>
+                <a:latin typeface="Fira Sans"/>
+              </a:rPr>
+              <a:t>▸ </a:t>
+            </a:r>
+            <a:r>
+              <a:rPr sz="1800" b="0">
+                <a:solidFill>
+                  <a:srgbClr val="000000"/>
+                </a:solidFill>
+                <a:latin typeface="Fira Sans"/>
+              </a:rPr>
+              <a:t>En la EOD: sobre 102 minutos quedan marcados 4.967 viajes (el 4,4%).</a:t>
+            </a:r>
+          </a:p>
+          <a:p>
+            <a:pPr>
+              <a:lnSpc>
+                <a:spcPct val="112000"/>
+              </a:lnSpc>
+              <a:spcAft>
+                <a:spcPts val="900"/>
+              </a:spcAft>
+            </a:pPr>
+            <a:r>
+              <a:rPr sz="1800" b="1">
+                <a:solidFill>
+                  <a:srgbClr val="E0A437"/>
+                </a:solidFill>
+                <a:latin typeface="Fira Sans"/>
+              </a:rPr>
+              <a:t>▸ </a:t>
+            </a:r>
+            <a:r>
+              <a:rPr sz="1800" b="0">
+                <a:solidFill>
+                  <a:srgbClr val="000000"/>
+                </a:solidFill>
+                <a:latin typeface="Fira Sans"/>
+              </a:rPr>
+              <a:t>Atípico no significa error: puede ser un caso real e informativo, o un error de registro. Distinguirlo exige criterio del dominio.</a:t>
+            </a:r>
+          </a:p>
+          <a:p>
+            <a:pPr>
+              <a:lnSpc>
+                <a:spcPct val="112000"/>
+              </a:lnSpc>
+              <a:spcAft>
+                <a:spcPts val="900"/>
+              </a:spcAft>
+            </a:pPr>
+            <a:r>
+              <a:rPr sz="1800" b="1">
+                <a:solidFill>
+                  <a:srgbClr val="E0A437"/>
+                </a:solidFill>
+                <a:latin typeface="Fira Sans"/>
+              </a:rPr>
+              <a:t>▸ </a:t>
+            </a:r>
+            <a:r>
+              <a:rPr sz="1800" b="0">
+                <a:solidFill>
+                  <a:srgbClr val="000000"/>
+                </a:solidFill>
+                <a:latin typeface="Fira Sans"/>
+              </a:rPr>
+              <a:t>No existe una regla universal para excluirlos: el tratamiento de colas y atípicos es materia de la estadística robusta, un área de investigación en sí misma.</a:t>
             </a:r>
           </a:p>
         </p:txBody>
@@ -7552,14 +7658,14 @@
                 </a:solidFill>
                 <a:latin typeface="Fira Sans"/>
               </a:rPr>
-              <a:t>Boxplots para comparar grupos: la EOD</a:t>
+              <a:t>Boxplots para comparar grupos: iris</a:t>
             </a:r>
           </a:p>
         </p:txBody>
       </p:sp>
       <p:pic>
         <p:nvPicPr>
-          <p:cNvPr id="4" name="Picture 3" descr="04_boxplot_modos.png"/>
+          <p:cNvPr id="4" name="Picture 3" descr="09_iris_boxplot.png"/>
           <p:cNvPicPr>
             <a:picLocks noChangeAspect="1"/>
           </p:cNvPicPr>
@@ -7573,8 +7679,8 @@
         </p:blipFill>
         <p:spPr>
           <a:xfrm>
-            <a:off x="1417319" y="1143000"/>
-            <a:ext cx="6309360" cy="2899161"/>
+            <a:off x="1602889" y="1143000"/>
+            <a:ext cx="5938221" cy="3154680"/>
           </a:xfrm>
           <a:prstGeom prst="rect">
             <a:avLst/>
@@ -7610,7 +7716,7 @@
                 </a:solidFill>
                 <a:latin typeface="Fira Sans"/>
               </a:rPr>
-              <a:t>La duración del viaje según el modo: centros y dispersiones distintas en una sola figura. Es el gráfico estándar para comparar una variable cuantitativa entre categorías.</a:t>
+              <a:t>El largo del pétalo separa casi perfectamente a las tres especies: centros y dispersiones distintas en una sola figura.</a:t>
             </a:r>
           </a:p>
         </p:txBody>
@@ -7648,7 +7754,7 @@
             <a:avLst/>
           </a:prstGeom>
           <a:solidFill>
-            <a:srgbClr val="1D3557"/>
+            <a:srgbClr val="FAFBFC"/>
           </a:solidFill>
           <a:ln>
             <a:noFill/>
@@ -7685,8 +7791,8 @@
         </p:nvSpPr>
         <p:spPr>
           <a:xfrm>
-            <a:off x="603504" y="1847088"/>
-            <a:ext cx="7946136" cy="1399032"/>
+            <a:off x="402336" y="301752"/>
+            <a:ext cx="8348472" cy="795528"/>
           </a:xfrm>
           <a:prstGeom prst="rect">
             <a:avLst/>
@@ -7700,24 +7806,71 @@
           <a:lstStyle/>
           <a:p>
             <a:r>
-              <a:rPr sz="3400" b="1">
-                <a:solidFill>
-                  <a:srgbClr val="FFFFFF"/>
-                </a:solidFill>
-                <a:latin typeface="Fira Sans"/>
-              </a:rPr>
-              <a:t>Calidad y limpieza de datos</a:t>
-            </a:r>
-          </a:p>
-          <a:p>
-            <a:r>
-              <a:rPr sz="1800" b="0">
-                <a:solidFill>
-                  <a:srgbClr val="E0A437"/>
-                </a:solidFill>
-                <a:latin typeface="Fira Sans"/>
-              </a:rPr>
-              <a:t>Los resúmenes valen lo que valen los datos</a:t>
+              <a:rPr sz="2800" b="1">
+                <a:solidFill>
+                  <a:srgbClr val="0F0F0F"/>
+                </a:solidFill>
+                <a:latin typeface="Fira Sans"/>
+              </a:rPr>
+              <a:t>Boxplots para comparar grupos: la EOD</a:t>
+            </a:r>
+          </a:p>
+        </p:txBody>
+      </p:sp>
+      <p:pic>
+        <p:nvPicPr>
+          <p:cNvPr id="4" name="Picture 3" descr="04_boxplot_modos.png"/>
+          <p:cNvPicPr>
+            <a:picLocks noChangeAspect="1"/>
+          </p:cNvPicPr>
+          <p:nvPr/>
+        </p:nvPicPr>
+        <p:blipFill>
+          <a:blip r:embed="rId2"/>
+          <a:stretch>
+            <a:fillRect/>
+          </a:stretch>
+        </p:blipFill>
+        <p:spPr>
+          <a:xfrm>
+            <a:off x="1417319" y="1143000"/>
+            <a:ext cx="6309360" cy="2899161"/>
+          </a:xfrm>
+          <a:prstGeom prst="rect">
+            <a:avLst/>
+          </a:prstGeom>
+        </p:spPr>
+      </p:pic>
+      <p:sp>
+        <p:nvSpPr>
+          <p:cNvPr id="5" name="TextBox 4"/>
+          <p:cNvSpPr txBox="1"/>
+          <p:nvPr/>
+        </p:nvSpPr>
+        <p:spPr>
+          <a:xfrm>
+            <a:off x="704088" y="4434840"/>
+            <a:ext cx="7744968" cy="457200"/>
+          </a:xfrm>
+          <a:prstGeom prst="rect">
+            <a:avLst/>
+          </a:prstGeom>
+          <a:noFill/>
+        </p:spPr>
+        <p:txBody>
+          <a:bodyPr wrap="square">
+            <a:spAutoFit/>
+          </a:bodyPr>
+          <a:lstStyle/>
+          <a:p>
+            <a:r>
+              <a:rPr sz="1300" b="0">
+                <a:solidFill>
+                  <a:srgbClr val="333333"/>
+                </a:solidFill>
+                <a:latin typeface="Fira Sans"/>
+              </a:rPr>
+              <a:t>La duración del viaje según el modo: centros y dispersiones distintas en una sola figura. Es el gráfico estándar para comparar una variable cuantitativa entre categorías.</a:t>
             </a:r>
           </a:p>
         </p:txBody>
@@ -7755,7 +7908,7 @@
             <a:avLst/>
           </a:prstGeom>
           <a:solidFill>
-            <a:srgbClr val="FAFBFC"/>
+            <a:srgbClr val="1D3557"/>
           </a:solidFill>
           <a:ln>
             <a:noFill/>
@@ -7792,8 +7945,8 @@
         </p:nvSpPr>
         <p:spPr>
           <a:xfrm>
-            <a:off x="402336" y="301752"/>
-            <a:ext cx="8348472" cy="795528"/>
+            <a:off x="603504" y="1847088"/>
+            <a:ext cx="7946136" cy="1399032"/>
           </a:xfrm>
           <a:prstGeom prst="rect">
             <a:avLst/>
@@ -7807,120 +7960,24 @@
           <a:lstStyle/>
           <a:p>
             <a:r>
-              <a:rPr sz="2800" b="1">
-                <a:solidFill>
-                  <a:srgbClr val="0F0F0F"/>
-                </a:solidFill>
-                <a:latin typeface="Fira Sans"/>
-              </a:rPr>
-              <a:t>iris viene casi limpio; los datos reales, no</a:t>
-            </a:r>
-          </a:p>
-        </p:txBody>
-      </p:sp>
-      <p:sp>
-        <p:nvSpPr>
-          <p:cNvPr id="4" name="TextBox 3"/>
-          <p:cNvSpPr txBox="1"/>
-          <p:nvPr/>
-        </p:nvSpPr>
-        <p:spPr>
-          <a:xfrm>
-            <a:off x="704088" y="1353312"/>
-            <a:ext cx="7744968" cy="3300984"/>
-          </a:xfrm>
-          <a:prstGeom prst="rect">
-            <a:avLst/>
-          </a:prstGeom>
-          <a:noFill/>
-        </p:spPr>
-        <p:txBody>
-          <a:bodyPr wrap="square">
-            <a:spAutoFit/>
-          </a:bodyPr>
-          <a:lstStyle/>
-          <a:p>
-            <a:pPr>
-              <a:lnSpc>
-                <a:spcPct val="112000"/>
-              </a:lnSpc>
-              <a:spcAft>
-                <a:spcPts val="900"/>
-              </a:spcAft>
-            </a:pPr>
-            <a:r>
-              <a:rPr sz="1800" b="1">
+              <a:rPr sz="3400" b="1">
+                <a:solidFill>
+                  <a:srgbClr val="FFFFFF"/>
+                </a:solidFill>
+                <a:latin typeface="Fira Sans"/>
+              </a:rPr>
+              <a:t>Calidad y limpieza de datos</a:t>
+            </a:r>
+          </a:p>
+          <a:p>
+            <a:r>
+              <a:rPr sz="1800" b="0">
                 <a:solidFill>
                   <a:srgbClr val="E0A437"/>
                 </a:solidFill>
                 <a:latin typeface="Fira Sans"/>
               </a:rPr>
-              <a:t>▸ </a:t>
-            </a:r>
-            <a:r>
-              <a:rPr sz="1800" b="0">
-                <a:solidFill>
-                  <a:srgbClr val="000000"/>
-                </a:solidFill>
-                <a:latin typeface="Fira Sans"/>
-              </a:rPr>
-              <a:t>iris: cero faltantes en sus 150 filas... y aun así tiene una fila duplicada. Hasta el dataset más famoso trae un problema de calidad.</a:t>
-            </a:r>
-          </a:p>
-          <a:p>
-            <a:pPr>
-              <a:lnSpc>
-                <a:spcPct val="112000"/>
-              </a:lnSpc>
-              <a:spcAft>
-                <a:spcPts val="900"/>
-              </a:spcAft>
-            </a:pPr>
-            <a:r>
-              <a:rPr sz="1800" b="1">
-                <a:solidFill>
-                  <a:srgbClr val="E0A437"/>
-                </a:solidFill>
-                <a:latin typeface="Fira Sans"/>
-              </a:rPr>
-              <a:t>▸ </a:t>
-            </a:r>
-            <a:r>
-              <a:rPr sz="1800" b="0">
-                <a:solidFill>
-                  <a:srgbClr val="000000"/>
-                </a:solidFill>
-                <a:latin typeface="Fira Sans"/>
-              </a:rPr>
-              <a:t>La EOD: 278 duraciones faltantes, códigos que traducir, colas sospechosas y factores que son NaN por diseño.</a:t>
-            </a:r>
-          </a:p>
-          <a:p>
-            <a:pPr>
-              <a:lnSpc>
-                <a:spcPct val="112000"/>
-              </a:lnSpc>
-              <a:spcAft>
-                <a:spcPts val="900"/>
-              </a:spcAft>
-            </a:pPr>
-            <a:r>
-              <a:rPr sz="1800" b="1">
-                <a:solidFill>
-                  <a:srgbClr val="E0A437"/>
-                </a:solidFill>
-                <a:latin typeface="Fira Sans"/>
-              </a:rPr>
-              <a:t>▸ </a:t>
-            </a:r>
-            <a:r>
-              <a:rPr sz="1800" b="1">
-                <a:solidFill>
-                  <a:srgbClr val="1D3557"/>
-                </a:solidFill>
-                <a:latin typeface="Fira Sans"/>
-              </a:rPr>
-              <a:t>Por eso el checklist de calidad se aplica siempre, también al dataset del proyecto.</a:t>
+              <a:t>Los resúmenes valen lo que valen los datos</a:t>
             </a:r>
           </a:p>
         </p:txBody>
@@ -8016,7 +8073,7 @@
                 </a:solidFill>
                 <a:latin typeface="Fira Sans"/>
               </a:rPr>
-              <a:t>Valores faltantes</a:t>
+              <a:t>iris viene casi limpio; los datos reales, no</a:t>
             </a:r>
           </a:p>
         </p:txBody>
@@ -8067,7 +8124,7 @@
                 </a:solidFill>
                 <a:latin typeface="Fira Sans"/>
               </a:rPr>
-              <a:t>Detección: isna().sum(), o el count de describe() contra len.</a:t>
+              <a:t>iris: cero faltantes en sus 150 filas... y aun así tiene una fila duplicada. Hasta el dataset más famoso trae un problema de calidad.</a:t>
             </a:r>
           </a:p>
           <a:p>
@@ -8095,7 +8152,7 @@
                 </a:solidFill>
                 <a:latin typeface="Fira Sans"/>
               </a:rPr>
-              <a:t>En la EOD: TiempoViaje tiene 278 faltantes entre 113.591 viajes.</a:t>
+              <a:t>La EOD: 278 duraciones faltantes, códigos que traducir, colas sospechosas y factores que son NaN por diseño.</a:t>
             </a:r>
           </a:p>
           <a:p>
@@ -8123,35 +8180,7 @@
                 </a:solidFill>
                 <a:latin typeface="Fira Sans"/>
               </a:rPr>
-              <a:t>Un NaN no siempre es error: en los factores de expansión significa "no aplica".</a:t>
-            </a:r>
-          </a:p>
-          <a:p>
-            <a:pPr>
-              <a:lnSpc>
-                <a:spcPct val="112000"/>
-              </a:lnSpc>
-              <a:spcAft>
-                <a:spcPts val="900"/>
-              </a:spcAft>
-            </a:pPr>
-            <a:r>
-              <a:rPr sz="1800" b="1">
-                <a:solidFill>
-                  <a:srgbClr val="E0A437"/>
-                </a:solidFill>
-                <a:latin typeface="Fira Sans"/>
-              </a:rPr>
-              <a:t>▸ </a:t>
-            </a:r>
-            <a:r>
-              <a:rPr sz="1800" b="0">
-                <a:solidFill>
-                  <a:srgbClr val="000000"/>
-                </a:solidFill>
-                <a:latin typeface="Fira Sans"/>
-              </a:rPr>
-              <a:t>Opciones: eliminar, imputar o dejar que cada cálculo los excluya. Lo obligatorio: decidir y documentar.</a:t>
+              <a:t>Por eso el checklist de calidad se aplica siempre, también al dataset del proyecto.</a:t>
             </a:r>
           </a:p>
         </p:txBody>
@@ -8247,7 +8276,7 @@
                 </a:solidFill>
                 <a:latin typeface="Fira Sans"/>
               </a:rPr>
-              <a:t>Duplicados</a:t>
+              <a:t>Valores faltantes</a:t>
             </a:r>
           </a:p>
         </p:txBody>
@@ -8298,7 +8327,7 @@
                 </a:solidFill>
                 <a:latin typeface="Fira Sans"/>
               </a:rPr>
-              <a:t>duplicated() marca filas repetidas; drop_duplicates() las elimina.</a:t>
+              <a:t>Detección: isna().sum(), o el count de describe() contra len.</a:t>
             </a:r>
           </a:p>
           <a:p>
@@ -8326,7 +8355,7 @@
                 </a:solidFill>
                 <a:latin typeface="Fira Sans"/>
               </a:rPr>
-              <a:t>Dos niveles: la fila completa y la llave que debería ser única.</a:t>
+              <a:t>En la EOD: TiempoViaje tiene 278 faltantes entre 113.591 viajes.</a:t>
             </a:r>
           </a:p>
           <a:p>
@@ -8348,13 +8377,13 @@
               <a:t>▸ </a:t>
             </a:r>
             <a:r>
-              <a:rPr sz="1800" b="0">
-                <a:solidFill>
-                  <a:srgbClr val="000000"/>
-                </a:solidFill>
-                <a:latin typeface="Fira Sans"/>
-              </a:rPr>
-              <a:t>En la EOD ambos chequeos dan cero; un cero también es un hallazgo.</a:t>
+              <a:rPr sz="1800" b="1">
+                <a:solidFill>
+                  <a:srgbClr val="1D3557"/>
+                </a:solidFill>
+                <a:latin typeface="Fira Sans"/>
+              </a:rPr>
+              <a:t>Un NaN no siempre es error: en los factores de expansión significa "no aplica".</a:t>
             </a:r>
           </a:p>
           <a:p>
@@ -8382,7 +8411,7 @@
                 </a:solidFill>
                 <a:latin typeface="Fira Sans"/>
               </a:rPr>
-              <a:t>El riesgo típico: un merge con llaves repetidas multiplica filas.</a:t>
+              <a:t>Opciones: eliminar, imputar o dejar que cada cálculo los excluya. Lo obligatorio: decidir y documentar.</a:t>
             </a:r>
           </a:p>
         </p:txBody>
@@ -8478,45 +8507,21 @@
                 </a:solidFill>
                 <a:latin typeface="Fira Sans"/>
               </a:rPr>
-              <a:t>Valores sospechosos</a:t>
-            </a:r>
-          </a:p>
-        </p:txBody>
-      </p:sp>
-      <p:pic>
-        <p:nvPicPr>
-          <p:cNvPr id="4" name="Picture 3" descr="05_cola_imposibles.png"/>
-          <p:cNvPicPr>
-            <a:picLocks noChangeAspect="1"/>
-          </p:cNvPicPr>
-          <p:nvPr/>
-        </p:nvPicPr>
-        <p:blipFill>
-          <a:blip r:embed="rId2"/>
-          <a:stretch>
-            <a:fillRect/>
-          </a:stretch>
-        </p:blipFill>
-        <p:spPr>
-          <a:xfrm>
-            <a:off x="1648218" y="1143000"/>
-            <a:ext cx="5847563" cy="3154680"/>
-          </a:xfrm>
-          <a:prstGeom prst="rect">
-            <a:avLst/>
-          </a:prstGeom>
-        </p:spPr>
-      </p:pic>
-      <p:sp>
-        <p:nvSpPr>
-          <p:cNvPr id="5" name="TextBox 4"/>
+              <a:t>Duplicados</a:t>
+            </a:r>
+          </a:p>
+        </p:txBody>
+      </p:sp>
+      <p:sp>
+        <p:nvSpPr>
+          <p:cNvPr id="4" name="TextBox 3"/>
           <p:cNvSpPr txBox="1"/>
           <p:nvPr/>
         </p:nvSpPr>
         <p:spPr>
           <a:xfrm>
-            <a:off x="704088" y="4434840"/>
-            <a:ext cx="7744968" cy="457200"/>
+            <a:off x="704088" y="1353312"/>
+            <a:ext cx="7744968" cy="3300984"/>
           </a:xfrm>
           <a:prstGeom prst="rect">
             <a:avLst/>
@@ -8529,14 +8534,115 @@
           </a:bodyPr>
           <a:lstStyle/>
           <a:p>
-            <a:r>
-              <a:rPr sz="1300" b="0">
-                <a:solidFill>
-                  <a:srgbClr val="333333"/>
-                </a:solidFill>
-                <a:latin typeface="Fira Sans"/>
-              </a:rPr>
-              <a:t>116 viajes declaran más de 5 horas y el máximo es de 22 horas. ¿Error de registro o viaje real? La respuesta exige criterio del dominio; la decisión (mantener, corregir o excluir) se toma en el código y se documenta.</a:t>
+            <a:pPr>
+              <a:lnSpc>
+                <a:spcPct val="112000"/>
+              </a:lnSpc>
+              <a:spcAft>
+                <a:spcPts val="900"/>
+              </a:spcAft>
+            </a:pPr>
+            <a:r>
+              <a:rPr sz="1800" b="1">
+                <a:solidFill>
+                  <a:srgbClr val="E0A437"/>
+                </a:solidFill>
+                <a:latin typeface="Fira Sans"/>
+              </a:rPr>
+              <a:t>▸ </a:t>
+            </a:r>
+            <a:r>
+              <a:rPr sz="1800" b="0">
+                <a:solidFill>
+                  <a:srgbClr val="000000"/>
+                </a:solidFill>
+                <a:latin typeface="Fira Sans"/>
+              </a:rPr>
+              <a:t>duplicated() marca filas repetidas; drop_duplicates() las elimina.</a:t>
+            </a:r>
+          </a:p>
+          <a:p>
+            <a:pPr>
+              <a:lnSpc>
+                <a:spcPct val="112000"/>
+              </a:lnSpc>
+              <a:spcAft>
+                <a:spcPts val="900"/>
+              </a:spcAft>
+            </a:pPr>
+            <a:r>
+              <a:rPr sz="1800" b="1">
+                <a:solidFill>
+                  <a:srgbClr val="E0A437"/>
+                </a:solidFill>
+                <a:latin typeface="Fira Sans"/>
+              </a:rPr>
+              <a:t>▸ </a:t>
+            </a:r>
+            <a:r>
+              <a:rPr sz="1800" b="0">
+                <a:solidFill>
+                  <a:srgbClr val="000000"/>
+                </a:solidFill>
+                <a:latin typeface="Fira Sans"/>
+              </a:rPr>
+              <a:t>Dos niveles: la fila completa y la llave que debería ser única.</a:t>
+            </a:r>
+          </a:p>
+          <a:p>
+            <a:pPr>
+              <a:lnSpc>
+                <a:spcPct val="112000"/>
+              </a:lnSpc>
+              <a:spcAft>
+                <a:spcPts val="900"/>
+              </a:spcAft>
+            </a:pPr>
+            <a:r>
+              <a:rPr sz="1800" b="1">
+                <a:solidFill>
+                  <a:srgbClr val="E0A437"/>
+                </a:solidFill>
+                <a:latin typeface="Fira Sans"/>
+              </a:rPr>
+              <a:t>▸ </a:t>
+            </a:r>
+            <a:r>
+              <a:rPr sz="1800" b="0">
+                <a:solidFill>
+                  <a:srgbClr val="000000"/>
+                </a:solidFill>
+                <a:latin typeface="Fira Sans"/>
+              </a:rPr>
+              <a:t>En la EOD ambos chequeos dan cero; un cero también es un hallazgo.</a:t>
+            </a:r>
+          </a:p>
+          <a:p>
+            <a:pPr>
+              <a:lnSpc>
+                <a:spcPct val="112000"/>
+              </a:lnSpc>
+              <a:spcAft>
+                <a:spcPts val="900"/>
+              </a:spcAft>
+            </a:pPr>
+            <a:r>
+              <a:rPr sz="1800" b="1">
+                <a:solidFill>
+                  <a:srgbClr val="E0A437"/>
+                </a:solidFill>
+                <a:latin typeface="Fira Sans"/>
+              </a:rPr>
+              <a:t>▸ </a:t>
+            </a:r>
+            <a:r>
+              <a:rPr sz="1800" b="0">
+                <a:solidFill>
+                  <a:srgbClr val="000000"/>
+                </a:solidFill>
+                <a:latin typeface="Fira Sans"/>
+              </a:rPr>
+              <a:t>El riesgo típico: un merge con llaves repetidas multiplica filas.</a:t>
             </a:r>
           </a:p>
         </p:txBody>
@@ -8632,90 +8738,35 @@
                 </a:solidFill>
                 <a:latin typeface="Fira Sans"/>
               </a:rPr>
-              <a:t>Tapar valores con mask</a:t>
-            </a:r>
-          </a:p>
-        </p:txBody>
-      </p:sp>
-      <p:sp>
-        <p:nvSpPr>
-          <p:cNvPr id="4" name="Rectangle 3"/>
-          <p:cNvSpPr/>
-          <p:nvPr/>
-        </p:nvSpPr>
-        <p:spPr>
-          <a:xfrm>
-            <a:off x="704088" y="1280160"/>
-            <a:ext cx="7744968" cy="1874520"/>
-          </a:xfrm>
-          <a:prstGeom prst="rect">
-            <a:avLst/>
-          </a:prstGeom>
-          <a:solidFill>
-            <a:srgbClr val="F0F2F5"/>
-          </a:solidFill>
-          <a:ln>
-            <a:solidFill>
-              <a:srgbClr val="D8DDE3"/>
-            </a:solidFill>
-          </a:ln>
-          <a:effectLst/>
-        </p:spPr>
-        <p:style>
-          <a:lnRef idx="1">
-            <a:schemeClr val="accent1"/>
-          </a:lnRef>
-          <a:fillRef idx="3">
-            <a:schemeClr val="accent1"/>
-          </a:fillRef>
-          <a:effectRef idx="2">
-            <a:schemeClr val="accent1"/>
-          </a:effectRef>
-          <a:fontRef idx="minor">
-            <a:schemeClr val="lt1"/>
-          </a:fontRef>
-        </p:style>
-        <p:txBody>
-          <a:bodyPr rtlCol="0" anchor="ctr" wrap="square" lIns="228600" tIns="137160"/>
-          <a:lstStyle/>
-          <a:p>
-            <a:pPr/>
-            <a:r>
-              <a:rPr sz="1500" b="0">
-                <a:solidFill>
-                  <a:srgbClr val="1D3557"/>
-                </a:solidFill>
-                <a:latin typeface="Menlo"/>
-              </a:rPr>
-              <a:t># donde la condición se cumple, reemplaza (aquí, por NaN)</a:t>
-            </a:r>
-          </a:p>
-          <a:p>
-            <a:pPr/>
-            <a:r>
-              <a:rPr sz="1500" b="0">
-                <a:solidFill>
-                  <a:srgbClr val="1D3557"/>
-                </a:solidFill>
-                <a:latin typeface="Menlo"/>
-              </a:rPr>
-              <a:t>viajes["TiempoViaje"] = viajes["TiempoViaje"].mask(</a:t>
-            </a:r>
-          </a:p>
-          <a:p>
-            <a:pPr/>
-            <a:r>
-              <a:rPr sz="1500" b="0">
-                <a:solidFill>
-                  <a:srgbClr val="1D3557"/>
-                </a:solidFill>
-                <a:latin typeface="Menlo"/>
-              </a:rPr>
-              <a:t>    viajes["TiempoViaje"] &gt; 300)</a:t>
-            </a:r>
-          </a:p>
-        </p:txBody>
-      </p:sp>
+              <a:t>Valores sospechosos</a:t>
+            </a:r>
+          </a:p>
+        </p:txBody>
+      </p:sp>
+      <p:pic>
+        <p:nvPicPr>
+          <p:cNvPr id="4" name="Picture 3" descr="05_cola_imposibles.png"/>
+          <p:cNvPicPr>
+            <a:picLocks noChangeAspect="1"/>
+          </p:cNvPicPr>
+          <p:nvPr/>
+        </p:nvPicPr>
+        <p:blipFill>
+          <a:blip r:embed="rId2"/>
+          <a:stretch>
+            <a:fillRect/>
+          </a:stretch>
+        </p:blipFill>
+        <p:spPr>
+          <a:xfrm>
+            <a:off x="1648218" y="1143000"/>
+            <a:ext cx="5847563" cy="3154680"/>
+          </a:xfrm>
+          <a:prstGeom prst="rect">
+            <a:avLst/>
+          </a:prstGeom>
+        </p:spPr>
+      </p:pic>
       <p:sp>
         <p:nvSpPr>
           <p:cNvPr id="5" name="TextBox 4"/>
@@ -8724,8 +8775,8 @@
         </p:nvSpPr>
         <p:spPr>
           <a:xfrm>
-            <a:off x="704088" y="3383279"/>
-            <a:ext cx="7744968" cy="1097280"/>
+            <a:off x="704088" y="4434840"/>
+            <a:ext cx="7744968" cy="457200"/>
           </a:xfrm>
           <a:prstGeom prst="rect">
             <a:avLst/>
@@ -8738,31 +8789,14 @@
           </a:bodyPr>
           <a:lstStyle/>
           <a:p>
-            <a:pPr>
-              <a:lnSpc>
-                <a:spcPct val="112000"/>
-              </a:lnSpc>
-              <a:spcAft>
-                <a:spcPts val="900"/>
-              </a:spcAft>
-            </a:pPr>
-            <a:r>
-              <a:rPr sz="1600" b="1">
-                <a:solidFill>
-                  <a:srgbClr val="E0A437"/>
-                </a:solidFill>
-                <a:latin typeface="Fira Sans"/>
-              </a:rPr>
-              <a:t>▸ </a:t>
-            </a:r>
-            <a:r>
-              <a:rPr sz="1600" b="0">
-                <a:solidFill>
-                  <a:srgbClr val="000000"/>
-                </a:solidFill>
-                <a:latin typeface="Fira Sans"/>
-              </a:rPr>
-              <a:t>mask reemplaza donde la condición es verdadera; where, su espejo, conserva donde es verdadera y reemplaza el resto. Regla nemotécnica: mask es dónde tapar, where es dónde quedarse.</a:t>
+            <a:r>
+              <a:rPr sz="1300" b="0">
+                <a:solidFill>
+                  <a:srgbClr val="333333"/>
+                </a:solidFill>
+                <a:latin typeface="Fira Sans"/>
+              </a:rPr>
+              <a:t>116 viajes declaran más de 5 horas y el máximo es de 22 horas. ¿Error de registro o viaje real? La respuesta exige criterio del dominio; la decisión (mantener, corregir o excluir) se toma en el código y se documenta.</a:t>
             </a:r>
           </a:p>
         </p:txBody>
@@ -8858,21 +8892,100 @@
                 </a:solidFill>
                 <a:latin typeface="Fira Sans"/>
               </a:rPr>
-              <a:t>Revisar cada merge</a:t>
-            </a:r>
-          </a:p>
-        </p:txBody>
-      </p:sp>
-      <p:sp>
-        <p:nvSpPr>
-          <p:cNvPr id="4" name="TextBox 3"/>
+              <a:t>Tapar valores con mask</a:t>
+            </a:r>
+          </a:p>
+        </p:txBody>
+      </p:sp>
+      <p:sp>
+        <p:nvSpPr>
+          <p:cNvPr id="4" name="Rectangle 3"/>
+          <p:cNvSpPr/>
+          <p:nvPr/>
+        </p:nvSpPr>
+        <p:spPr>
+          <a:xfrm>
+            <a:off x="704088" y="1280160"/>
+            <a:ext cx="7744968" cy="1874520"/>
+          </a:xfrm>
+          <a:prstGeom prst="rect">
+            <a:avLst/>
+          </a:prstGeom>
+          <a:solidFill>
+            <a:srgbClr val="F0F2F5"/>
+          </a:solidFill>
+          <a:ln>
+            <a:solidFill>
+              <a:srgbClr val="D8DDE3"/>
+            </a:solidFill>
+          </a:ln>
+          <a:effectLst/>
+        </p:spPr>
+        <p:style>
+          <a:lnRef idx="1">
+            <a:schemeClr val="accent1"/>
+          </a:lnRef>
+          <a:fillRef idx="3">
+            <a:schemeClr val="accent1"/>
+          </a:fillRef>
+          <a:effectRef idx="2">
+            <a:schemeClr val="accent1"/>
+          </a:effectRef>
+          <a:fontRef idx="minor">
+            <a:schemeClr val="lt1"/>
+          </a:fontRef>
+        </p:style>
+        <p:txBody>
+          <a:bodyPr rtlCol="0" anchor="ctr" wrap="square" lIns="228600" tIns="137160"/>
+          <a:lstStyle/>
+          <a:p>
+            <a:pPr/>
+            <a:r>
+              <a:rPr sz="1500" b="0">
+                <a:solidFill>
+                  <a:srgbClr val="1D3557"/>
+                </a:solidFill>
+                <a:latin typeface="Menlo"/>
+              </a:rPr>
+              <a:t># donde la condición se cumple, reemplaza (aquí, por NaN)</a:t>
+            </a:r>
+          </a:p>
+          <a:p>
+            <a:pPr/>
+            <a:r>
+              <a:rPr sz="1500" b="0">
+                <a:solidFill>
+                  <a:srgbClr val="1D3557"/>
+                </a:solidFill>
+                <a:latin typeface="Menlo"/>
+              </a:rPr>
+              <a:t>viajes["TiempoViaje"] = viajes["TiempoViaje"].mask(</a:t>
+            </a:r>
+          </a:p>
+          <a:p>
+            <a:pPr/>
+            <a:r>
+              <a:rPr sz="1500" b="0">
+                <a:solidFill>
+                  <a:srgbClr val="1D3557"/>
+                </a:solidFill>
+                <a:latin typeface="Menlo"/>
+              </a:rPr>
+              <a:t>    viajes["TiempoViaje"] &gt; 300)</a:t>
+            </a:r>
+          </a:p>
+        </p:txBody>
+      </p:sp>
+      <p:sp>
+        <p:nvSpPr>
+          <p:cNvPr id="5" name="TextBox 4"/>
           <p:cNvSpPr txBox="1"/>
           <p:nvPr/>
         </p:nvSpPr>
         <p:spPr>
           <a:xfrm>
-            <a:off x="704088" y="1353312"/>
-            <a:ext cx="7744968" cy="3300984"/>
+            <a:off x="704088" y="3383279"/>
+            <a:ext cx="7744968" cy="1097280"/>
           </a:xfrm>
           <a:prstGeom prst="rect">
             <a:avLst/>
@@ -8894,7 +9007,7 @@
               </a:spcAft>
             </a:pPr>
             <a:r>
-              <a:rPr sz="1800" b="1">
+              <a:rPr sz="1600" b="1">
                 <a:solidFill>
                   <a:srgbClr val="E0A437"/>
                 </a:solidFill>
@@ -8903,69 +9016,13 @@
               <a:t>▸ </a:t>
             </a:r>
             <a:r>
-              <a:rPr sz="1800" b="0">
+              <a:rPr sz="1600" b="0">
                 <a:solidFill>
                   <a:srgbClr val="000000"/>
                 </a:solidFill>
                 <a:latin typeface="Fira Sans"/>
               </a:rPr>
-              <a:t>Comparar el número de filas antes y después: un inner descarta las filas sin pareja; en la clase 1, 113.591 viajes quedaron en 111.393.</a:t>
-            </a:r>
-          </a:p>
-          <a:p>
-            <a:pPr>
-              <a:lnSpc>
-                <a:spcPct val="112000"/>
-              </a:lnSpc>
-              <a:spcAft>
-                <a:spcPts val="900"/>
-              </a:spcAft>
-            </a:pPr>
-            <a:r>
-              <a:rPr sz="1800" b="1">
-                <a:solidFill>
-                  <a:srgbClr val="E0A437"/>
-                </a:solidFill>
-                <a:latin typeface="Fira Sans"/>
-              </a:rPr>
-              <a:t>▸ </a:t>
-            </a:r>
-            <a:r>
-              <a:rPr sz="1800" b="0">
-                <a:solidFill>
-                  <a:srgbClr val="000000"/>
-                </a:solidFill>
-                <a:latin typeface="Fira Sans"/>
-              </a:rPr>
-              <a:t>Contar los NaN de las columnas nuevas cuando se usa how="left": ahí quedan visibles las filas sin correspondencia (2.198 comunas).</a:t>
-            </a:r>
-          </a:p>
-          <a:p>
-            <a:pPr>
-              <a:lnSpc>
-                <a:spcPct val="112000"/>
-              </a:lnSpc>
-              <a:spcAft>
-                <a:spcPts val="900"/>
-              </a:spcAft>
-            </a:pPr>
-            <a:r>
-              <a:rPr sz="1800" b="1">
-                <a:solidFill>
-                  <a:srgbClr val="E0A437"/>
-                </a:solidFill>
-                <a:latin typeface="Fira Sans"/>
-              </a:rPr>
-              <a:t>▸ </a:t>
-            </a:r>
-            <a:r>
-              <a:rPr sz="1800" b="0">
-                <a:solidFill>
-                  <a:srgbClr val="000000"/>
-                </a:solidFill>
-                <a:latin typeface="Fira Sans"/>
-              </a:rPr>
-              <a:t>Verificar que la llave sea única en la tabla de parámetros: si está repetida, el merge multiplica filas.</a:t>
+              <a:t>mask reemplaza donde la condición es verdadera; where, su espejo, conserva donde es verdadera y reemplaza el resto. Regla nemotécnica: mask es dónde tapar, where es dónde quedarse.</a:t>
             </a:r>
           </a:p>
         </p:txBody>
@@ -9061,7 +9118,7 @@
                 </a:solidFill>
                 <a:latin typeface="Fira Sans"/>
               </a:rPr>
-              <a:t>Checklist de calidad antes de analizar</a:t>
+              <a:t>Revisar cada merge</a:t>
             </a:r>
           </a:p>
         </p:txBody>
@@ -9112,7 +9169,7 @@
                 </a:solidFill>
                 <a:latin typeface="Fira Sans"/>
               </a:rPr>
-              <a:t>Dimensiones y tipos: shape, info().</a:t>
+              <a:t>Comparar el número de filas antes y después: un inner descarta las filas sin pareja; en la clase 1, 113.591 viajes quedaron en 111.393.</a:t>
             </a:r>
           </a:p>
           <a:p>
@@ -9140,7 +9197,7 @@
                 </a:solidFill>
                 <a:latin typeface="Fira Sans"/>
               </a:rPr>
-              <a:t>Faltantes por columna relevante: isna().sum(), count contra len.</a:t>
+              <a:t>Contar los NaN de las columnas nuevas cuando se usa how="left": ahí quedan visibles las filas sin correspondencia (2.198 comunas).</a:t>
             </a:r>
           </a:p>
           <a:p>
@@ -9168,91 +9225,7 @@
                 </a:solidFill>
                 <a:latin typeface="Fira Sans"/>
               </a:rPr>
-              <a:t>Duplicados: fila completa y llave única.</a:t>
-            </a:r>
-          </a:p>
-          <a:p>
-            <a:pPr>
-              <a:lnSpc>
-                <a:spcPct val="112000"/>
-              </a:lnSpc>
-              <a:spcAft>
-                <a:spcPts val="900"/>
-              </a:spcAft>
-            </a:pPr>
-            <a:r>
-              <a:rPr sz="1800" b="1">
-                <a:solidFill>
-                  <a:srgbClr val="E0A437"/>
-                </a:solidFill>
-                <a:latin typeface="Fira Sans"/>
-              </a:rPr>
-              <a:t>▸ </a:t>
-            </a:r>
-            <a:r>
-              <a:rPr sz="1800" b="0">
-                <a:solidFill>
-                  <a:srgbClr val="000000"/>
-                </a:solidFill>
-                <a:latin typeface="Fira Sans"/>
-              </a:rPr>
-              <a:t>Rangos válidos de cada variable cuantitativa: min, max, valores sospechosos.</a:t>
-            </a:r>
-          </a:p>
-          <a:p>
-            <a:pPr>
-              <a:lnSpc>
-                <a:spcPct val="112000"/>
-              </a:lnSpc>
-              <a:spcAft>
-                <a:spcPts val="900"/>
-              </a:spcAft>
-            </a:pPr>
-            <a:r>
-              <a:rPr sz="1800" b="1">
-                <a:solidFill>
-                  <a:srgbClr val="E0A437"/>
-                </a:solidFill>
-                <a:latin typeface="Fira Sans"/>
-              </a:rPr>
-              <a:t>▸ </a:t>
-            </a:r>
-            <a:r>
-              <a:rPr sz="1800" b="0">
-                <a:solidFill>
-                  <a:srgbClr val="000000"/>
-                </a:solidFill>
-                <a:latin typeface="Fira Sans"/>
-              </a:rPr>
-              <a:t>Merges verificados: filas, NaN nuevos, llaves únicas.</a:t>
-            </a:r>
-          </a:p>
-          <a:p>
-            <a:pPr>
-              <a:lnSpc>
-                <a:spcPct val="112000"/>
-              </a:lnSpc>
-              <a:spcAft>
-                <a:spcPts val="900"/>
-              </a:spcAft>
-            </a:pPr>
-            <a:r>
-              <a:rPr sz="1800" b="1">
-                <a:solidFill>
-                  <a:srgbClr val="E0A437"/>
-                </a:solidFill>
-                <a:latin typeface="Fira Sans"/>
-              </a:rPr>
-              <a:t>▸ </a:t>
-            </a:r>
-            <a:r>
-              <a:rPr sz="1800" b="1">
-                <a:solidFill>
-                  <a:srgbClr val="1D3557"/>
-                </a:solidFill>
-                <a:latin typeface="Fira Sans"/>
-              </a:rPr>
-              <a:t>Cada decisión de limpieza queda escrita en el código, con su justificación.</a:t>
+              <a:t>Verificar que la llave sea única en la tabla de parámetros: si está repetida, el merge multiplica filas.</a:t>
             </a:r>
           </a:p>
         </p:txBody>
@@ -9348,7 +9321,7 @@
                 </a:solidFill>
                 <a:latin typeface="Fira Sans"/>
               </a:rPr>
-              <a:t>Síntesis</a:t>
+              <a:t>Checklist de calidad antes de analizar</a:t>
             </a:r>
           </a:p>
         </p:txBody>
@@ -9399,7 +9372,7 @@
                 </a:solidFill>
                 <a:latin typeface="Fira Sans"/>
               </a:rPr>
-              <a:t>Describir una variable exige tres miradas: centro (media, mediana), dispersión (desviación, IQR) y forma (histograma, boxplot).</a:t>
+              <a:t>Dimensiones y tipos: shape, info().</a:t>
             </a:r>
           </a:p>
           <a:p>
@@ -9427,7 +9400,7 @@
                 </a:solidFill>
                 <a:latin typeface="Fira Sans"/>
               </a:rPr>
-              <a:t>Con asimetría, la mediana acompaña o reemplaza a la media.</a:t>
+              <a:t>Faltantes por columna relevante: isna().sum(), count contra len.</a:t>
             </a:r>
           </a:p>
           <a:p>
@@ -9455,7 +9428,7 @@
                 </a:solidFill>
                 <a:latin typeface="Fira Sans"/>
               </a:rPr>
-              <a:t>La limpieza es parte del análisis: faltantes, duplicados, rangos válidos y merges verificados, con decisiones documentadas.</a:t>
+              <a:t>Duplicados: fila completa y llave única.</a:t>
             </a:r>
           </a:p>
           <a:p>
@@ -9483,7 +9456,7 @@
                 </a:solidFill>
                 <a:latin typeface="Fira Sans"/>
               </a:rPr>
-              <a:t>La pregunta del proyecto debe ser específica y la hipótesis, verificable con variables medibles.</a:t>
+              <a:t>Rangos válidos de cada variable cuantitativa: min, max, valores sospechosos.</a:t>
             </a:r>
           </a:p>
           <a:p>
@@ -9511,7 +9484,35 @@
                 </a:solidFill>
                 <a:latin typeface="Fira Sans"/>
               </a:rPr>
-              <a:t>Próxima clase (martes 01-sep): EDA II, relaciones entre variables y correlación.</a:t>
+              <a:t>Merges verificados: filas, NaN nuevos, llaves únicas.</a:t>
+            </a:r>
+          </a:p>
+          <a:p>
+            <a:pPr>
+              <a:lnSpc>
+                <a:spcPct val="112000"/>
+              </a:lnSpc>
+              <a:spcAft>
+                <a:spcPts val="900"/>
+              </a:spcAft>
+            </a:pPr>
+            <a:r>
+              <a:rPr sz="1800" b="1">
+                <a:solidFill>
+                  <a:srgbClr val="E0A437"/>
+                </a:solidFill>
+                <a:latin typeface="Fira Sans"/>
+              </a:rPr>
+              <a:t>▸ </a:t>
+            </a:r>
+            <a:r>
+              <a:rPr sz="1800" b="1">
+                <a:solidFill>
+                  <a:srgbClr val="1D3557"/>
+                </a:solidFill>
+                <a:latin typeface="Fira Sans"/>
+              </a:rPr>
+              <a:t>Cada decisión de limpieza queda escrita en el código, con su justificación.</a:t>
             </a:r>
           </a:p>
         </p:txBody>
@@ -9679,6 +9680,265 @@
 </file>
 
 <file path=ppt/slides/slide40.xml><?xml version="1.0" encoding="utf-8"?>
+<p:sld xmlns:a="http://schemas.openxmlformats.org/drawingml/2006/main" xmlns:p="http://schemas.openxmlformats.org/presentationml/2006/main" xmlns:r="http://schemas.openxmlformats.org/officeDocument/2006/relationships">
+  <p:cSld>
+    <p:spTree>
+      <p:nvGrpSpPr>
+        <p:cNvPr id="1" name=""/>
+        <p:cNvGrpSpPr/>
+        <p:nvPr/>
+      </p:nvGrpSpPr>
+      <p:grpSpPr/>
+      <p:sp>
+        <p:nvSpPr>
+          <p:cNvPr id="2" name="Rectangle 1"/>
+          <p:cNvSpPr/>
+          <p:nvPr/>
+        </p:nvSpPr>
+        <p:spPr>
+          <a:xfrm>
+            <a:off x="0" y="0"/>
+            <a:ext cx="9144000" cy="5138928"/>
+          </a:xfrm>
+          <a:prstGeom prst="rect">
+            <a:avLst/>
+          </a:prstGeom>
+          <a:solidFill>
+            <a:srgbClr val="FAFBFC"/>
+          </a:solidFill>
+          <a:ln>
+            <a:noFill/>
+          </a:ln>
+          <a:effectLst/>
+        </p:spPr>
+        <p:style>
+          <a:lnRef idx="1">
+            <a:schemeClr val="accent1"/>
+          </a:lnRef>
+          <a:fillRef idx="3">
+            <a:schemeClr val="accent1"/>
+          </a:fillRef>
+          <a:effectRef idx="2">
+            <a:schemeClr val="accent1"/>
+          </a:effectRef>
+          <a:fontRef idx="minor">
+            <a:schemeClr val="lt1"/>
+          </a:fontRef>
+        </p:style>
+        <p:txBody>
+          <a:bodyPr rtlCol="0" anchor="ctr"/>
+          <a:lstStyle/>
+          <a:p>
+            <a:pPr algn="ctr"/>
+          </a:p>
+        </p:txBody>
+      </p:sp>
+      <p:sp>
+        <p:nvSpPr>
+          <p:cNvPr id="3" name="TextBox 2"/>
+          <p:cNvSpPr txBox="1"/>
+          <p:nvPr/>
+        </p:nvSpPr>
+        <p:spPr>
+          <a:xfrm>
+            <a:off x="402336" y="301752"/>
+            <a:ext cx="8348472" cy="795528"/>
+          </a:xfrm>
+          <a:prstGeom prst="rect">
+            <a:avLst/>
+          </a:prstGeom>
+          <a:noFill/>
+        </p:spPr>
+        <p:txBody>
+          <a:bodyPr wrap="square">
+            <a:spAutoFit/>
+          </a:bodyPr>
+          <a:lstStyle/>
+          <a:p>
+            <a:r>
+              <a:rPr sz="2800" b="1">
+                <a:solidFill>
+                  <a:srgbClr val="0F0F0F"/>
+                </a:solidFill>
+                <a:latin typeface="Fira Sans"/>
+              </a:rPr>
+              <a:t>Síntesis</a:t>
+            </a:r>
+          </a:p>
+        </p:txBody>
+      </p:sp>
+      <p:sp>
+        <p:nvSpPr>
+          <p:cNvPr id="4" name="TextBox 3"/>
+          <p:cNvSpPr txBox="1"/>
+          <p:nvPr/>
+        </p:nvSpPr>
+        <p:spPr>
+          <a:xfrm>
+            <a:off x="704088" y="1353312"/>
+            <a:ext cx="7744968" cy="3300984"/>
+          </a:xfrm>
+          <a:prstGeom prst="rect">
+            <a:avLst/>
+          </a:prstGeom>
+          <a:noFill/>
+        </p:spPr>
+        <p:txBody>
+          <a:bodyPr wrap="square">
+            <a:spAutoFit/>
+          </a:bodyPr>
+          <a:lstStyle/>
+          <a:p>
+            <a:pPr>
+              <a:lnSpc>
+                <a:spcPct val="112000"/>
+              </a:lnSpc>
+              <a:spcAft>
+                <a:spcPts val="900"/>
+              </a:spcAft>
+            </a:pPr>
+            <a:r>
+              <a:rPr sz="1800" b="1">
+                <a:solidFill>
+                  <a:srgbClr val="E0A437"/>
+                </a:solidFill>
+                <a:latin typeface="Fira Sans"/>
+              </a:rPr>
+              <a:t>▸ </a:t>
+            </a:r>
+            <a:r>
+              <a:rPr sz="1800" b="0">
+                <a:solidFill>
+                  <a:srgbClr val="000000"/>
+                </a:solidFill>
+                <a:latin typeface="Fira Sans"/>
+              </a:rPr>
+              <a:t>Describir una variable exige tres miradas: centro (media, mediana), dispersión (desviación, IQR) y forma (histograma, boxplot).</a:t>
+            </a:r>
+          </a:p>
+          <a:p>
+            <a:pPr>
+              <a:lnSpc>
+                <a:spcPct val="112000"/>
+              </a:lnSpc>
+              <a:spcAft>
+                <a:spcPts val="900"/>
+              </a:spcAft>
+            </a:pPr>
+            <a:r>
+              <a:rPr sz="1800" b="1">
+                <a:solidFill>
+                  <a:srgbClr val="E0A437"/>
+                </a:solidFill>
+                <a:latin typeface="Fira Sans"/>
+              </a:rPr>
+              <a:t>▸ </a:t>
+            </a:r>
+            <a:r>
+              <a:rPr sz="1800" b="0">
+                <a:solidFill>
+                  <a:srgbClr val="000000"/>
+                </a:solidFill>
+                <a:latin typeface="Fira Sans"/>
+              </a:rPr>
+              <a:t>Con asimetría, la mediana acompaña o reemplaza a la media.</a:t>
+            </a:r>
+          </a:p>
+          <a:p>
+            <a:pPr>
+              <a:lnSpc>
+                <a:spcPct val="112000"/>
+              </a:lnSpc>
+              <a:spcAft>
+                <a:spcPts val="900"/>
+              </a:spcAft>
+            </a:pPr>
+            <a:r>
+              <a:rPr sz="1800" b="1">
+                <a:solidFill>
+                  <a:srgbClr val="E0A437"/>
+                </a:solidFill>
+                <a:latin typeface="Fira Sans"/>
+              </a:rPr>
+              <a:t>▸ </a:t>
+            </a:r>
+            <a:r>
+              <a:rPr sz="1800" b="0">
+                <a:solidFill>
+                  <a:srgbClr val="000000"/>
+                </a:solidFill>
+                <a:latin typeface="Fira Sans"/>
+              </a:rPr>
+              <a:t>La limpieza es parte del análisis: faltantes, duplicados, rangos válidos y merges verificados, con decisiones documentadas.</a:t>
+            </a:r>
+          </a:p>
+          <a:p>
+            <a:pPr>
+              <a:lnSpc>
+                <a:spcPct val="112000"/>
+              </a:lnSpc>
+              <a:spcAft>
+                <a:spcPts val="900"/>
+              </a:spcAft>
+            </a:pPr>
+            <a:r>
+              <a:rPr sz="1800" b="1">
+                <a:solidFill>
+                  <a:srgbClr val="E0A437"/>
+                </a:solidFill>
+                <a:latin typeface="Fira Sans"/>
+              </a:rPr>
+              <a:t>▸ </a:t>
+            </a:r>
+            <a:r>
+              <a:rPr sz="1800" b="0">
+                <a:solidFill>
+                  <a:srgbClr val="000000"/>
+                </a:solidFill>
+                <a:latin typeface="Fira Sans"/>
+              </a:rPr>
+              <a:t>La pregunta del proyecto debe ser específica y la hipótesis, verificable con variables medibles.</a:t>
+            </a:r>
+          </a:p>
+          <a:p>
+            <a:pPr>
+              <a:lnSpc>
+                <a:spcPct val="112000"/>
+              </a:lnSpc>
+              <a:spcAft>
+                <a:spcPts val="900"/>
+              </a:spcAft>
+            </a:pPr>
+            <a:r>
+              <a:rPr sz="1800" b="1">
+                <a:solidFill>
+                  <a:srgbClr val="E0A437"/>
+                </a:solidFill>
+                <a:latin typeface="Fira Sans"/>
+              </a:rPr>
+              <a:t>▸ </a:t>
+            </a:r>
+            <a:r>
+              <a:rPr sz="1800" b="0">
+                <a:solidFill>
+                  <a:srgbClr val="000000"/>
+                </a:solidFill>
+                <a:latin typeface="Fira Sans"/>
+              </a:rPr>
+              <a:t>Próxima clase (martes 01-sep): EDA II, relaciones entre variables y correlación.</a:t>
+            </a:r>
+          </a:p>
+        </p:txBody>
+      </p:sp>
+    </p:spTree>
+  </p:cSld>
+  <p:clrMapOvr>
+    <a:masterClrMapping/>
+  </p:clrMapOvr>
+</p:sld>
+</file>
+
+<file path=ppt/slides/slide41.xml><?xml version="1.0" encoding="utf-8"?>
 <p:sld xmlns:a="http://schemas.openxmlformats.org/drawingml/2006/main" xmlns:p="http://schemas.openxmlformats.org/presentationml/2006/main" xmlns:r="http://schemas.openxmlformats.org/officeDocument/2006/relationships">
   <p:cSld>
     <p:spTree>

</xml_diff>

<commit_message>
Clase 2: diapo de percentiles y cuartiles con diagrama de la duracion real
Co-Authored-By: Claude Fable 5 <noreply@anthropic.com>
</commit_message>
<xml_diff>
--- a/presentaciones/clase02_eda_descriptiva.pptx
+++ b/presentaciones/clase02_eda_descriptiva.pptx
@@ -49,6 +49,7 @@
     <p:sldId id="297" r:id="rId48"/>
     <p:sldId id="298" r:id="rId49"/>
     <p:sldId id="299" r:id="rId50"/>
+    <p:sldId id="300" r:id="rId51"/>
   </p:sldIdLst>
   <p:sldSz cx="9144000" cy="5138928" type="screen4x3"/>
   <p:notesSz cx="6858000" cy="9144000"/>
@@ -7871,14 +7872,14 @@
                 </a:solidFill>
                 <a:latin typeface="Fira Sans"/>
               </a:rPr>
-              <a:t>Medir la dispersión</a:t>
+              <a:t>Percentiles y cuartiles</a:t>
             </a:r>
           </a:p>
         </p:txBody>
       </p:sp>
       <p:pic>
         <p:nvPicPr>
-          <p:cNvPr id="4" name="Picture 3" descr="12_formulas_dispersion.png"/>
+          <p:cNvPr id="4" name="Picture 3" descr="18_percentiles.png"/>
           <p:cNvPicPr>
             <a:picLocks noChangeAspect="1"/>
           </p:cNvPicPr>
@@ -7893,7 +7894,7 @@
         <p:spPr>
           <a:xfrm>
             <a:off x="1417319" y="1143000"/>
-            <a:ext cx="6309360" cy="3154680"/>
+            <a:ext cx="6309360" cy="2456026"/>
           </a:xfrm>
           <a:prstGeom prst="rect">
             <a:avLst/>
@@ -7929,7 +7930,7 @@
                 </a:solidFill>
                 <a:latin typeface="Fira Sans"/>
               </a:rPr>
-              <a:t>Los percentiles completan el cuadro: quantile([0, 0.25, 0.5, 0.75, 1]) entrega el mínimo, los cuartiles y el máximo (en iris: 4,3 · 5,1 · 5,8 · 6,4 · 7,9).</a:t>
+              <a:t>El percentil p es el valor bajo el cual queda el p% de los datos. Los cuartiles son los percentiles 25, 50 y 75: cortan los datos ordenados en cuatro partes con la misma cantidad de viajes cada una.</a:t>
             </a:r>
           </a:p>
         </p:txBody>
@@ -8132,14 +8133,14 @@
                 </a:solidFill>
                 <a:latin typeface="Fira Sans"/>
               </a:rPr>
-              <a:t>La media no basta</a:t>
+              <a:t>Medir la dispersión</a:t>
             </a:r>
           </a:p>
         </p:txBody>
       </p:sp>
       <p:pic>
         <p:nvPicPr>
-          <p:cNvPr id="4" name="Picture 3" descr="02_dispersion_comunas.png"/>
+          <p:cNvPr id="4" name="Picture 3" descr="12_formulas_dispersion.png"/>
           <p:cNvPicPr>
             <a:picLocks noChangeAspect="1"/>
           </p:cNvPicPr>
@@ -8153,8 +8154,8 @@
         </p:blipFill>
         <p:spPr>
           <a:xfrm>
-            <a:off x="1822348" y="1143000"/>
-            <a:ext cx="5499302" cy="3154680"/>
+            <a:off x="1417319" y="1143000"/>
+            <a:ext cx="6309360" cy="3154680"/>
           </a:xfrm>
           <a:prstGeom prst="rect">
             <a:avLst/>
@@ -8190,7 +8191,7 @@
                 </a:solidFill>
                 <a:latin typeface="Fira Sans"/>
               </a:rPr>
-              <a:t>Providencia y Talagante tienen la misma duración media de viaje (40,7 minutos), pero la desviación estándar de Talagante es el doble: dos realidades distintas detrás del mismo promedio.</a:t>
+              <a:t>Los percentiles completan el cuadro: quantile([0, 0.25, 0.5, 0.75, 1]) entrega el mínimo, los cuartiles y el máximo (en iris: 4,3 · 5,1 · 5,8 · 6,4 · 7,9).</a:t>
             </a:r>
           </a:p>
         </p:txBody>
@@ -8286,14 +8287,14 @@
                 </a:solidFill>
                 <a:latin typeface="Fira Sans"/>
               </a:rPr>
-              <a:t>El boxplot</a:t>
+              <a:t>La media no basta</a:t>
             </a:r>
           </a:p>
         </p:txBody>
       </p:sp>
       <p:pic>
         <p:nvPicPr>
-          <p:cNvPr id="4" name="Picture 3" descr="03_boxplot_anatomia.png"/>
+          <p:cNvPr id="4" name="Picture 3" descr="02_dispersion_comunas.png"/>
           <p:cNvPicPr>
             <a:picLocks noChangeAspect="1"/>
           </p:cNvPicPr>
@@ -8307,8 +8308,8 @@
         </p:blipFill>
         <p:spPr>
           <a:xfrm>
-            <a:off x="1740020" y="1143000"/>
-            <a:ext cx="5663958" cy="3154680"/>
+            <a:off x="1822348" y="1143000"/>
+            <a:ext cx="5499302" cy="3154680"/>
           </a:xfrm>
           <a:prstGeom prst="rect">
             <a:avLst/>
@@ -8344,7 +8345,7 @@
                 </a:solidFill>
                 <a:latin typeface="Fira Sans"/>
               </a:rPr>
-              <a:t>Cinco números en un solo gráfico: mediana, cuartiles, bigotes y valores atípicos. La regla de los bigotes (1,5 veces el IQR) es una convención para marcar valores inusuales, no un veredicto.</a:t>
+              <a:t>Providencia y Talagante tienen la misma duración media de viaje (40,7 minutos), pero la desviación estándar de Talagante es el doble: dos realidades distintas detrás del mismo promedio.</a:t>
             </a:r>
           </a:p>
         </p:txBody>
@@ -8440,149 +8441,14 @@
                 </a:solidFill>
                 <a:latin typeface="Fira Sans"/>
               </a:rPr>
-              <a:t>Valores atípicos (outliers)</a:t>
-            </a:r>
-          </a:p>
-        </p:txBody>
-      </p:sp>
-      <p:sp>
-        <p:nvSpPr>
-          <p:cNvPr id="4" name="TextBox 3"/>
-          <p:cNvSpPr txBox="1"/>
-          <p:nvPr/>
-        </p:nvSpPr>
-        <p:spPr>
-          <a:xfrm>
-            <a:off x="502920" y="1252728"/>
-            <a:ext cx="4023360" cy="3200400"/>
-          </a:xfrm>
-          <a:prstGeom prst="rect">
-            <a:avLst/>
-          </a:prstGeom>
-          <a:noFill/>
-        </p:spPr>
-        <p:txBody>
-          <a:bodyPr wrap="square">
-            <a:spAutoFit/>
-          </a:bodyPr>
-          <a:lstStyle/>
-          <a:p>
-            <a:pPr>
-              <a:lnSpc>
-                <a:spcPct val="112000"/>
-              </a:lnSpc>
-              <a:spcAft>
-                <a:spcPts val="900"/>
-              </a:spcAft>
-            </a:pPr>
-            <a:r>
-              <a:rPr sz="1500" b="1">
-                <a:solidFill>
-                  <a:srgbClr val="E0A437"/>
-                </a:solidFill>
-                <a:latin typeface="Fira Sans"/>
-              </a:rPr>
-              <a:t>▸ </a:t>
-            </a:r>
-            <a:r>
-              <a:rPr sz="1500" b="1">
-                <a:solidFill>
-                  <a:srgbClr val="1D3557"/>
-                </a:solidFill>
-                <a:latin typeface="Fira Sans"/>
-              </a:rPr>
-              <a:t>Un valor atípico es una observación que se aleja notoriamente del resto.</a:t>
-            </a:r>
-          </a:p>
-          <a:p>
-            <a:pPr>
-              <a:lnSpc>
-                <a:spcPct val="112000"/>
-              </a:lnSpc>
-              <a:spcAft>
-                <a:spcPts val="900"/>
-              </a:spcAft>
-            </a:pPr>
-            <a:r>
-              <a:rPr sz="1500" b="1">
-                <a:solidFill>
-                  <a:srgbClr val="E0A437"/>
-                </a:solidFill>
-                <a:latin typeface="Fira Sans"/>
-              </a:rPr>
-              <a:t>▸ </a:t>
-            </a:r>
-            <a:r>
-              <a:rPr sz="1500" b="0">
-                <a:solidFill>
-                  <a:srgbClr val="000000"/>
-                </a:solidFill>
-                <a:latin typeface="Fira Sans"/>
-              </a:rPr>
-              <a:t>Convención de Tukey: fuera de Q1 − 1,5·IQR y de Q3 + 1,5·IQR.</a:t>
-            </a:r>
-          </a:p>
-          <a:p>
-            <a:pPr>
-              <a:lnSpc>
-                <a:spcPct val="112000"/>
-              </a:lnSpc>
-              <a:spcAft>
-                <a:spcPts val="900"/>
-              </a:spcAft>
-            </a:pPr>
-            <a:r>
-              <a:rPr sz="1500" b="1">
-                <a:solidFill>
-                  <a:srgbClr val="E0A437"/>
-                </a:solidFill>
-                <a:latin typeface="Fira Sans"/>
-              </a:rPr>
-              <a:t>▸ </a:t>
-            </a:r>
-            <a:r>
-              <a:rPr sz="1500" b="0">
-                <a:solidFill>
-                  <a:srgbClr val="000000"/>
-                </a:solidFill>
-                <a:latin typeface="Fira Sans"/>
-              </a:rPr>
-              <a:t>Atípico no significa error: puede ser un caso real e informativo. Distinguirlo exige criterio del dominio.</a:t>
-            </a:r>
-          </a:p>
-          <a:p>
-            <a:pPr>
-              <a:lnSpc>
-                <a:spcPct val="112000"/>
-              </a:lnSpc>
-              <a:spcAft>
-                <a:spcPts val="900"/>
-              </a:spcAft>
-            </a:pPr>
-            <a:r>
-              <a:rPr sz="1500" b="1">
-                <a:solidFill>
-                  <a:srgbClr val="E0A437"/>
-                </a:solidFill>
-                <a:latin typeface="Fira Sans"/>
-              </a:rPr>
-              <a:t>▸ </a:t>
-            </a:r>
-            <a:r>
-              <a:rPr sz="1500" b="0">
-                <a:solidFill>
-                  <a:srgbClr val="000000"/>
-                </a:solidFill>
-                <a:latin typeface="Fira Sans"/>
-              </a:rPr>
-              <a:t>No hay una regla universal para excluirlos: es materia de la estadística robusta.</a:t>
+              <a:t>El boxplot</a:t>
             </a:r>
           </a:p>
         </p:txBody>
       </p:sp>
       <p:pic>
         <p:nvPicPr>
-          <p:cNvPr id="5" name="Picture 4" descr="15_outliers_tukey.png"/>
+          <p:cNvPr id="4" name="Picture 3" descr="03_boxplot_anatomia.png"/>
           <p:cNvPicPr>
             <a:picLocks noChangeAspect="1"/>
           </p:cNvPicPr>
@@ -8596,14 +8462,48 @@
         </p:blipFill>
         <p:spPr>
           <a:xfrm>
-            <a:off x="4892040" y="1371600"/>
-            <a:ext cx="3840480" cy="3136431"/>
+            <a:off x="1740020" y="1143000"/>
+            <a:ext cx="5663958" cy="3154680"/>
           </a:xfrm>
           <a:prstGeom prst="rect">
             <a:avLst/>
           </a:prstGeom>
         </p:spPr>
       </p:pic>
+      <p:sp>
+        <p:nvSpPr>
+          <p:cNvPr id="5" name="TextBox 4"/>
+          <p:cNvSpPr txBox="1"/>
+          <p:nvPr/>
+        </p:nvSpPr>
+        <p:spPr>
+          <a:xfrm>
+            <a:off x="704088" y="4434840"/>
+            <a:ext cx="7744968" cy="457200"/>
+          </a:xfrm>
+          <a:prstGeom prst="rect">
+            <a:avLst/>
+          </a:prstGeom>
+          <a:noFill/>
+        </p:spPr>
+        <p:txBody>
+          <a:bodyPr wrap="square">
+            <a:spAutoFit/>
+          </a:bodyPr>
+          <a:lstStyle/>
+          <a:p>
+            <a:r>
+              <a:rPr sz="1300" b="0">
+                <a:solidFill>
+                  <a:srgbClr val="333333"/>
+                </a:solidFill>
+                <a:latin typeface="Fira Sans"/>
+              </a:rPr>
+              <a:t>Cinco números en un solo gráfico: mediana, cuartiles, bigotes y valores atípicos. La regla de los bigotes (1,5 veces el IQR) es una convención para marcar valores inusuales, no un veredicto.</a:t>
+            </a:r>
+          </a:p>
+        </p:txBody>
+      </p:sp>
     </p:spTree>
   </p:cSld>
   <p:clrMapOvr>
@@ -8695,14 +8595,149 @@
                 </a:solidFill>
                 <a:latin typeface="Fira Sans"/>
               </a:rPr>
-              <a:t>Boxplots para comparar grupos: iris</a:t>
+              <a:t>Valores atípicos (outliers)</a:t>
+            </a:r>
+          </a:p>
+        </p:txBody>
+      </p:sp>
+      <p:sp>
+        <p:nvSpPr>
+          <p:cNvPr id="4" name="TextBox 3"/>
+          <p:cNvSpPr txBox="1"/>
+          <p:nvPr/>
+        </p:nvSpPr>
+        <p:spPr>
+          <a:xfrm>
+            <a:off x="502920" y="1252728"/>
+            <a:ext cx="4023360" cy="3200400"/>
+          </a:xfrm>
+          <a:prstGeom prst="rect">
+            <a:avLst/>
+          </a:prstGeom>
+          <a:noFill/>
+        </p:spPr>
+        <p:txBody>
+          <a:bodyPr wrap="square">
+            <a:spAutoFit/>
+          </a:bodyPr>
+          <a:lstStyle/>
+          <a:p>
+            <a:pPr>
+              <a:lnSpc>
+                <a:spcPct val="112000"/>
+              </a:lnSpc>
+              <a:spcAft>
+                <a:spcPts val="900"/>
+              </a:spcAft>
+            </a:pPr>
+            <a:r>
+              <a:rPr sz="1500" b="1">
+                <a:solidFill>
+                  <a:srgbClr val="E0A437"/>
+                </a:solidFill>
+                <a:latin typeface="Fira Sans"/>
+              </a:rPr>
+              <a:t>▸ </a:t>
+            </a:r>
+            <a:r>
+              <a:rPr sz="1500" b="1">
+                <a:solidFill>
+                  <a:srgbClr val="1D3557"/>
+                </a:solidFill>
+                <a:latin typeface="Fira Sans"/>
+              </a:rPr>
+              <a:t>Un valor atípico es una observación que se aleja notoriamente del resto.</a:t>
+            </a:r>
+          </a:p>
+          <a:p>
+            <a:pPr>
+              <a:lnSpc>
+                <a:spcPct val="112000"/>
+              </a:lnSpc>
+              <a:spcAft>
+                <a:spcPts val="900"/>
+              </a:spcAft>
+            </a:pPr>
+            <a:r>
+              <a:rPr sz="1500" b="1">
+                <a:solidFill>
+                  <a:srgbClr val="E0A437"/>
+                </a:solidFill>
+                <a:latin typeface="Fira Sans"/>
+              </a:rPr>
+              <a:t>▸ </a:t>
+            </a:r>
+            <a:r>
+              <a:rPr sz="1500" b="0">
+                <a:solidFill>
+                  <a:srgbClr val="000000"/>
+                </a:solidFill>
+                <a:latin typeface="Fira Sans"/>
+              </a:rPr>
+              <a:t>Convención de Tukey: fuera de Q1 − 1,5·IQR y de Q3 + 1,5·IQR.</a:t>
+            </a:r>
+          </a:p>
+          <a:p>
+            <a:pPr>
+              <a:lnSpc>
+                <a:spcPct val="112000"/>
+              </a:lnSpc>
+              <a:spcAft>
+                <a:spcPts val="900"/>
+              </a:spcAft>
+            </a:pPr>
+            <a:r>
+              <a:rPr sz="1500" b="1">
+                <a:solidFill>
+                  <a:srgbClr val="E0A437"/>
+                </a:solidFill>
+                <a:latin typeface="Fira Sans"/>
+              </a:rPr>
+              <a:t>▸ </a:t>
+            </a:r>
+            <a:r>
+              <a:rPr sz="1500" b="0">
+                <a:solidFill>
+                  <a:srgbClr val="000000"/>
+                </a:solidFill>
+                <a:latin typeface="Fira Sans"/>
+              </a:rPr>
+              <a:t>Atípico no significa error: puede ser un caso real e informativo. Distinguirlo exige criterio del dominio.</a:t>
+            </a:r>
+          </a:p>
+          <a:p>
+            <a:pPr>
+              <a:lnSpc>
+                <a:spcPct val="112000"/>
+              </a:lnSpc>
+              <a:spcAft>
+                <a:spcPts val="900"/>
+              </a:spcAft>
+            </a:pPr>
+            <a:r>
+              <a:rPr sz="1500" b="1">
+                <a:solidFill>
+                  <a:srgbClr val="E0A437"/>
+                </a:solidFill>
+                <a:latin typeface="Fira Sans"/>
+              </a:rPr>
+              <a:t>▸ </a:t>
+            </a:r>
+            <a:r>
+              <a:rPr sz="1500" b="0">
+                <a:solidFill>
+                  <a:srgbClr val="000000"/>
+                </a:solidFill>
+                <a:latin typeface="Fira Sans"/>
+              </a:rPr>
+              <a:t>No hay una regla universal para excluirlos: es materia de la estadística robusta.</a:t>
             </a:r>
           </a:p>
         </p:txBody>
       </p:sp>
       <p:pic>
         <p:nvPicPr>
-          <p:cNvPr id="4" name="Picture 3" descr="09_iris_boxplot.png"/>
+          <p:cNvPr id="5" name="Picture 4" descr="15_outliers_tukey.png"/>
           <p:cNvPicPr>
             <a:picLocks noChangeAspect="1"/>
           </p:cNvPicPr>
@@ -8716,48 +8751,14 @@
         </p:blipFill>
         <p:spPr>
           <a:xfrm>
-            <a:off x="1602889" y="1143000"/>
-            <a:ext cx="5938221" cy="3154680"/>
+            <a:off x="4892040" y="1371600"/>
+            <a:ext cx="3840480" cy="3136431"/>
           </a:xfrm>
           <a:prstGeom prst="rect">
             <a:avLst/>
           </a:prstGeom>
         </p:spPr>
       </p:pic>
-      <p:sp>
-        <p:nvSpPr>
-          <p:cNvPr id="5" name="TextBox 4"/>
-          <p:cNvSpPr txBox="1"/>
-          <p:nvPr/>
-        </p:nvSpPr>
-        <p:spPr>
-          <a:xfrm>
-            <a:off x="704088" y="4434840"/>
-            <a:ext cx="7744968" cy="457200"/>
-          </a:xfrm>
-          <a:prstGeom prst="rect">
-            <a:avLst/>
-          </a:prstGeom>
-          <a:noFill/>
-        </p:spPr>
-        <p:txBody>
-          <a:bodyPr wrap="square">
-            <a:spAutoFit/>
-          </a:bodyPr>
-          <a:lstStyle/>
-          <a:p>
-            <a:r>
-              <a:rPr sz="1300" b="0">
-                <a:solidFill>
-                  <a:srgbClr val="333333"/>
-                </a:solidFill>
-                <a:latin typeface="Fira Sans"/>
-              </a:rPr>
-              <a:t>El largo del pétalo separa casi perfectamente a las tres especies: centros y dispersiones distintas en una sola figura.</a:t>
-            </a:r>
-          </a:p>
-        </p:txBody>
-      </p:sp>
     </p:spTree>
   </p:cSld>
   <p:clrMapOvr>
@@ -8849,14 +8850,14 @@
                 </a:solidFill>
                 <a:latin typeface="Fira Sans"/>
               </a:rPr>
-              <a:t>Boxplots para comparar grupos: la EOD</a:t>
+              <a:t>Boxplots para comparar grupos: iris</a:t>
             </a:r>
           </a:p>
         </p:txBody>
       </p:sp>
       <p:pic>
         <p:nvPicPr>
-          <p:cNvPr id="4" name="Picture 3" descr="04_boxplot_modos.png"/>
+          <p:cNvPr id="4" name="Picture 3" descr="09_iris_boxplot.png"/>
           <p:cNvPicPr>
             <a:picLocks noChangeAspect="1"/>
           </p:cNvPicPr>
@@ -8870,8 +8871,8 @@
         </p:blipFill>
         <p:spPr>
           <a:xfrm>
-            <a:off x="1417319" y="1143000"/>
-            <a:ext cx="6309360" cy="2899161"/>
+            <a:off x="1602889" y="1143000"/>
+            <a:ext cx="5938221" cy="3154680"/>
           </a:xfrm>
           <a:prstGeom prst="rect">
             <a:avLst/>
@@ -8907,7 +8908,7 @@
                 </a:solidFill>
                 <a:latin typeface="Fira Sans"/>
               </a:rPr>
-              <a:t>La duración del viaje según el modo: centros y dispersiones distintas en una sola figura. Es el gráfico estándar para comparar una variable cuantitativa entre categorías.</a:t>
+              <a:t>El largo del pétalo separa casi perfectamente a las tres especies: centros y dispersiones distintas en una sola figura.</a:t>
             </a:r>
           </a:p>
         </p:txBody>
@@ -8945,7 +8946,7 @@
             <a:avLst/>
           </a:prstGeom>
           <a:solidFill>
-            <a:srgbClr val="1D3557"/>
+            <a:srgbClr val="FAFBFC"/>
           </a:solidFill>
           <a:ln>
             <a:noFill/>
@@ -8982,8 +8983,8 @@
         </p:nvSpPr>
         <p:spPr>
           <a:xfrm>
-            <a:off x="603504" y="1847088"/>
-            <a:ext cx="7946136" cy="1399032"/>
+            <a:off x="402336" y="301752"/>
+            <a:ext cx="8348472" cy="795528"/>
           </a:xfrm>
           <a:prstGeom prst="rect">
             <a:avLst/>
@@ -8997,24 +8998,71 @@
           <a:lstStyle/>
           <a:p>
             <a:r>
-              <a:rPr sz="3400" b="1">
-                <a:solidFill>
-                  <a:srgbClr val="FFFFFF"/>
-                </a:solidFill>
-                <a:latin typeface="Fira Sans"/>
-              </a:rPr>
-              <a:t>Calidad y limpieza de datos</a:t>
-            </a:r>
-          </a:p>
-          <a:p>
-            <a:r>
-              <a:rPr sz="1800" b="0">
-                <a:solidFill>
-                  <a:srgbClr val="E0A437"/>
-                </a:solidFill>
-                <a:latin typeface="Fira Sans"/>
-              </a:rPr>
-              <a:t>Los resúmenes valen lo que valen los datos</a:t>
+              <a:rPr sz="2800" b="1">
+                <a:solidFill>
+                  <a:srgbClr val="0F0F0F"/>
+                </a:solidFill>
+                <a:latin typeface="Fira Sans"/>
+              </a:rPr>
+              <a:t>Boxplots para comparar grupos: la EOD</a:t>
+            </a:r>
+          </a:p>
+        </p:txBody>
+      </p:sp>
+      <p:pic>
+        <p:nvPicPr>
+          <p:cNvPr id="4" name="Picture 3" descr="04_boxplot_modos.png"/>
+          <p:cNvPicPr>
+            <a:picLocks noChangeAspect="1"/>
+          </p:cNvPicPr>
+          <p:nvPr/>
+        </p:nvPicPr>
+        <p:blipFill>
+          <a:blip r:embed="rId2"/>
+          <a:stretch>
+            <a:fillRect/>
+          </a:stretch>
+        </p:blipFill>
+        <p:spPr>
+          <a:xfrm>
+            <a:off x="1417319" y="1143000"/>
+            <a:ext cx="6309360" cy="2899161"/>
+          </a:xfrm>
+          <a:prstGeom prst="rect">
+            <a:avLst/>
+          </a:prstGeom>
+        </p:spPr>
+      </p:pic>
+      <p:sp>
+        <p:nvSpPr>
+          <p:cNvPr id="5" name="TextBox 4"/>
+          <p:cNvSpPr txBox="1"/>
+          <p:nvPr/>
+        </p:nvSpPr>
+        <p:spPr>
+          <a:xfrm>
+            <a:off x="704088" y="4434840"/>
+            <a:ext cx="7744968" cy="457200"/>
+          </a:xfrm>
+          <a:prstGeom prst="rect">
+            <a:avLst/>
+          </a:prstGeom>
+          <a:noFill/>
+        </p:spPr>
+        <p:txBody>
+          <a:bodyPr wrap="square">
+            <a:spAutoFit/>
+          </a:bodyPr>
+          <a:lstStyle/>
+          <a:p>
+            <a:r>
+              <a:rPr sz="1300" b="0">
+                <a:solidFill>
+                  <a:srgbClr val="333333"/>
+                </a:solidFill>
+                <a:latin typeface="Fira Sans"/>
+              </a:rPr>
+              <a:t>La duración del viaje según el modo: centros y dispersiones distintas en una sola figura. Es el gráfico estándar para comparar una variable cuantitativa entre categorías.</a:t>
             </a:r>
           </a:p>
         </p:txBody>
@@ -9052,7 +9100,7 @@
             <a:avLst/>
           </a:prstGeom>
           <a:solidFill>
-            <a:srgbClr val="FAFBFC"/>
+            <a:srgbClr val="1D3557"/>
           </a:solidFill>
           <a:ln>
             <a:noFill/>
@@ -9089,8 +9137,8 @@
         </p:nvSpPr>
         <p:spPr>
           <a:xfrm>
-            <a:off x="402336" y="301752"/>
-            <a:ext cx="8348472" cy="795528"/>
+            <a:off x="603504" y="1847088"/>
+            <a:ext cx="7946136" cy="1399032"/>
           </a:xfrm>
           <a:prstGeom prst="rect">
             <a:avLst/>
@@ -9104,120 +9152,24 @@
           <a:lstStyle/>
           <a:p>
             <a:r>
-              <a:rPr sz="2800" b="1">
-                <a:solidFill>
-                  <a:srgbClr val="0F0F0F"/>
-                </a:solidFill>
-                <a:latin typeface="Fira Sans"/>
-              </a:rPr>
-              <a:t>iris viene casi limpio; los datos reales, no</a:t>
-            </a:r>
-          </a:p>
-        </p:txBody>
-      </p:sp>
-      <p:sp>
-        <p:nvSpPr>
-          <p:cNvPr id="4" name="TextBox 3"/>
-          <p:cNvSpPr txBox="1"/>
-          <p:nvPr/>
-        </p:nvSpPr>
-        <p:spPr>
-          <a:xfrm>
-            <a:off x="704088" y="1353312"/>
-            <a:ext cx="7744968" cy="3300984"/>
-          </a:xfrm>
-          <a:prstGeom prst="rect">
-            <a:avLst/>
-          </a:prstGeom>
-          <a:noFill/>
-        </p:spPr>
-        <p:txBody>
-          <a:bodyPr wrap="square">
-            <a:spAutoFit/>
-          </a:bodyPr>
-          <a:lstStyle/>
-          <a:p>
-            <a:pPr>
-              <a:lnSpc>
-                <a:spcPct val="112000"/>
-              </a:lnSpc>
-              <a:spcAft>
-                <a:spcPts val="900"/>
-              </a:spcAft>
-            </a:pPr>
-            <a:r>
-              <a:rPr sz="1800" b="1">
+              <a:rPr sz="3400" b="1">
+                <a:solidFill>
+                  <a:srgbClr val="FFFFFF"/>
+                </a:solidFill>
+                <a:latin typeface="Fira Sans"/>
+              </a:rPr>
+              <a:t>Calidad y limpieza de datos</a:t>
+            </a:r>
+          </a:p>
+          <a:p>
+            <a:r>
+              <a:rPr sz="1800" b="0">
                 <a:solidFill>
                   <a:srgbClr val="E0A437"/>
                 </a:solidFill>
                 <a:latin typeface="Fira Sans"/>
               </a:rPr>
-              <a:t>▸ </a:t>
-            </a:r>
-            <a:r>
-              <a:rPr sz="1800" b="0">
-                <a:solidFill>
-                  <a:srgbClr val="000000"/>
-                </a:solidFill>
-                <a:latin typeface="Fira Sans"/>
-              </a:rPr>
-              <a:t>iris: cero faltantes en sus 150 filas... y aun así tiene una fila duplicada. Hasta el dataset más famoso trae un problema de calidad.</a:t>
-            </a:r>
-          </a:p>
-          <a:p>
-            <a:pPr>
-              <a:lnSpc>
-                <a:spcPct val="112000"/>
-              </a:lnSpc>
-              <a:spcAft>
-                <a:spcPts val="900"/>
-              </a:spcAft>
-            </a:pPr>
-            <a:r>
-              <a:rPr sz="1800" b="1">
-                <a:solidFill>
-                  <a:srgbClr val="E0A437"/>
-                </a:solidFill>
-                <a:latin typeface="Fira Sans"/>
-              </a:rPr>
-              <a:t>▸ </a:t>
-            </a:r>
-            <a:r>
-              <a:rPr sz="1800" b="0">
-                <a:solidFill>
-                  <a:srgbClr val="000000"/>
-                </a:solidFill>
-                <a:latin typeface="Fira Sans"/>
-              </a:rPr>
-              <a:t>La EOD: 278 duraciones faltantes, códigos que traducir, colas sospechosas y factores que son NaN por diseño.</a:t>
-            </a:r>
-          </a:p>
-          <a:p>
-            <a:pPr>
-              <a:lnSpc>
-                <a:spcPct val="112000"/>
-              </a:lnSpc>
-              <a:spcAft>
-                <a:spcPts val="900"/>
-              </a:spcAft>
-            </a:pPr>
-            <a:r>
-              <a:rPr sz="1800" b="1">
-                <a:solidFill>
-                  <a:srgbClr val="E0A437"/>
-                </a:solidFill>
-                <a:latin typeface="Fira Sans"/>
-              </a:rPr>
-              <a:t>▸ </a:t>
-            </a:r>
-            <a:r>
-              <a:rPr sz="1800" b="1">
-                <a:solidFill>
-                  <a:srgbClr val="1D3557"/>
-                </a:solidFill>
-                <a:latin typeface="Fira Sans"/>
-              </a:rPr>
-              <a:t>Por eso el checklist de calidad se aplica siempre, también al dataset del proyecto.</a:t>
+              <a:t>Los resúmenes valen lo que valen los datos</a:t>
             </a:r>
           </a:p>
         </p:txBody>
@@ -9313,7 +9265,7 @@
                 </a:solidFill>
                 <a:latin typeface="Fira Sans"/>
               </a:rPr>
-              <a:t>Valores faltantes</a:t>
+              <a:t>iris viene casi limpio; los datos reales, no</a:t>
             </a:r>
           </a:p>
         </p:txBody>
@@ -9364,7 +9316,7 @@
                 </a:solidFill>
                 <a:latin typeface="Fira Sans"/>
               </a:rPr>
-              <a:t>Detección: isna().sum(), o el count de describe() contra len.</a:t>
+              <a:t>iris: cero faltantes en sus 150 filas... y aun así tiene una fila duplicada. Hasta el dataset más famoso trae un problema de calidad.</a:t>
             </a:r>
           </a:p>
           <a:p>
@@ -9392,7 +9344,7 @@
                 </a:solidFill>
                 <a:latin typeface="Fira Sans"/>
               </a:rPr>
-              <a:t>En la EOD: TiempoViaje tiene 278 faltantes entre 113.591 viajes.</a:t>
+              <a:t>La EOD: 278 duraciones faltantes, códigos que traducir, colas sospechosas y factores que son NaN por diseño.</a:t>
             </a:r>
           </a:p>
           <a:p>
@@ -9420,35 +9372,7 @@
                 </a:solidFill>
                 <a:latin typeface="Fira Sans"/>
               </a:rPr>
-              <a:t>Un NaN no siempre es error: en los factores de expansión significa "no aplica".</a:t>
-            </a:r>
-          </a:p>
-          <a:p>
-            <a:pPr>
-              <a:lnSpc>
-                <a:spcPct val="112000"/>
-              </a:lnSpc>
-              <a:spcAft>
-                <a:spcPts val="900"/>
-              </a:spcAft>
-            </a:pPr>
-            <a:r>
-              <a:rPr sz="1800" b="1">
-                <a:solidFill>
-                  <a:srgbClr val="E0A437"/>
-                </a:solidFill>
-                <a:latin typeface="Fira Sans"/>
-              </a:rPr>
-              <a:t>▸ </a:t>
-            </a:r>
-            <a:r>
-              <a:rPr sz="1800" b="0">
-                <a:solidFill>
-                  <a:srgbClr val="000000"/>
-                </a:solidFill>
-                <a:latin typeface="Fira Sans"/>
-              </a:rPr>
-              <a:t>Opciones: eliminar, imputar o dejar que cada cálculo los excluya. Lo obligatorio: decidir y documentar.</a:t>
+              <a:t>Por eso el checklist de calidad se aplica siempre, también al dataset del proyecto.</a:t>
             </a:r>
           </a:p>
         </p:txBody>
@@ -9544,7 +9468,7 @@
                 </a:solidFill>
                 <a:latin typeface="Fira Sans"/>
               </a:rPr>
-              <a:t>Duplicados</a:t>
+              <a:t>Valores faltantes</a:t>
             </a:r>
           </a:p>
         </p:txBody>
@@ -9595,7 +9519,7 @@
                 </a:solidFill>
                 <a:latin typeface="Fira Sans"/>
               </a:rPr>
-              <a:t>duplicated() marca filas repetidas; drop_duplicates() las elimina.</a:t>
+              <a:t>Detección: isna().sum(), o el count de describe() contra len.</a:t>
             </a:r>
           </a:p>
           <a:p>
@@ -9623,7 +9547,7 @@
                 </a:solidFill>
                 <a:latin typeface="Fira Sans"/>
               </a:rPr>
-              <a:t>Dos niveles: la fila completa y la llave que debería ser única.</a:t>
+              <a:t>En la EOD: TiempoViaje tiene 278 faltantes entre 113.591 viajes.</a:t>
             </a:r>
           </a:p>
           <a:p>
@@ -9645,13 +9569,13 @@
               <a:t>▸ </a:t>
             </a:r>
             <a:r>
-              <a:rPr sz="1800" b="0">
-                <a:solidFill>
-                  <a:srgbClr val="000000"/>
-                </a:solidFill>
-                <a:latin typeface="Fira Sans"/>
-              </a:rPr>
-              <a:t>En la EOD ambos chequeos dan cero; un cero también es un hallazgo.</a:t>
+              <a:rPr sz="1800" b="1">
+                <a:solidFill>
+                  <a:srgbClr val="1D3557"/>
+                </a:solidFill>
+                <a:latin typeface="Fira Sans"/>
+              </a:rPr>
+              <a:t>Un NaN no siempre es error: en los factores de expansión significa "no aplica".</a:t>
             </a:r>
           </a:p>
           <a:p>
@@ -9679,7 +9603,7 @@
                 </a:solidFill>
                 <a:latin typeface="Fira Sans"/>
               </a:rPr>
-              <a:t>El riesgo típico: un merge con llaves repetidas multiplica filas.</a:t>
+              <a:t>Opciones: eliminar, imputar o dejar que cada cálculo los excluya. Lo obligatorio: decidir y documentar.</a:t>
             </a:r>
           </a:p>
         </p:txBody>
@@ -9775,45 +9699,21 @@
                 </a:solidFill>
                 <a:latin typeface="Fira Sans"/>
               </a:rPr>
-              <a:t>Valores sospechosos</a:t>
-            </a:r>
-          </a:p>
-        </p:txBody>
-      </p:sp>
-      <p:pic>
-        <p:nvPicPr>
-          <p:cNvPr id="4" name="Picture 3" descr="05_cola_imposibles.png"/>
-          <p:cNvPicPr>
-            <a:picLocks noChangeAspect="1"/>
-          </p:cNvPicPr>
-          <p:nvPr/>
-        </p:nvPicPr>
-        <p:blipFill>
-          <a:blip r:embed="rId2"/>
-          <a:stretch>
-            <a:fillRect/>
-          </a:stretch>
-        </p:blipFill>
-        <p:spPr>
-          <a:xfrm>
-            <a:off x="1648218" y="1143000"/>
-            <a:ext cx="5847563" cy="3154680"/>
-          </a:xfrm>
-          <a:prstGeom prst="rect">
-            <a:avLst/>
-          </a:prstGeom>
-        </p:spPr>
-      </p:pic>
-      <p:sp>
-        <p:nvSpPr>
-          <p:cNvPr id="5" name="TextBox 4"/>
+              <a:t>Duplicados</a:t>
+            </a:r>
+          </a:p>
+        </p:txBody>
+      </p:sp>
+      <p:sp>
+        <p:nvSpPr>
+          <p:cNvPr id="4" name="TextBox 3"/>
           <p:cNvSpPr txBox="1"/>
           <p:nvPr/>
         </p:nvSpPr>
         <p:spPr>
           <a:xfrm>
-            <a:off x="704088" y="4434840"/>
-            <a:ext cx="7744968" cy="457200"/>
+            <a:off x="704088" y="1353312"/>
+            <a:ext cx="7744968" cy="3300984"/>
           </a:xfrm>
           <a:prstGeom prst="rect">
             <a:avLst/>
@@ -9826,14 +9726,115 @@
           </a:bodyPr>
           <a:lstStyle/>
           <a:p>
-            <a:r>
-              <a:rPr sz="1300" b="0">
-                <a:solidFill>
-                  <a:srgbClr val="333333"/>
-                </a:solidFill>
-                <a:latin typeface="Fira Sans"/>
-              </a:rPr>
-              <a:t>116 viajes declaran más de 5 horas y el máximo es de 22 horas. ¿Error de registro o viaje real? La respuesta exige criterio del dominio; la decisión (mantener, corregir o excluir) se toma en el código y se documenta.</a:t>
+            <a:pPr>
+              <a:lnSpc>
+                <a:spcPct val="112000"/>
+              </a:lnSpc>
+              <a:spcAft>
+                <a:spcPts val="900"/>
+              </a:spcAft>
+            </a:pPr>
+            <a:r>
+              <a:rPr sz="1800" b="1">
+                <a:solidFill>
+                  <a:srgbClr val="E0A437"/>
+                </a:solidFill>
+                <a:latin typeface="Fira Sans"/>
+              </a:rPr>
+              <a:t>▸ </a:t>
+            </a:r>
+            <a:r>
+              <a:rPr sz="1800" b="0">
+                <a:solidFill>
+                  <a:srgbClr val="000000"/>
+                </a:solidFill>
+                <a:latin typeface="Fira Sans"/>
+              </a:rPr>
+              <a:t>duplicated() marca filas repetidas; drop_duplicates() las elimina.</a:t>
+            </a:r>
+          </a:p>
+          <a:p>
+            <a:pPr>
+              <a:lnSpc>
+                <a:spcPct val="112000"/>
+              </a:lnSpc>
+              <a:spcAft>
+                <a:spcPts val="900"/>
+              </a:spcAft>
+            </a:pPr>
+            <a:r>
+              <a:rPr sz="1800" b="1">
+                <a:solidFill>
+                  <a:srgbClr val="E0A437"/>
+                </a:solidFill>
+                <a:latin typeface="Fira Sans"/>
+              </a:rPr>
+              <a:t>▸ </a:t>
+            </a:r>
+            <a:r>
+              <a:rPr sz="1800" b="0">
+                <a:solidFill>
+                  <a:srgbClr val="000000"/>
+                </a:solidFill>
+                <a:latin typeface="Fira Sans"/>
+              </a:rPr>
+              <a:t>Dos niveles: la fila completa y la llave que debería ser única.</a:t>
+            </a:r>
+          </a:p>
+          <a:p>
+            <a:pPr>
+              <a:lnSpc>
+                <a:spcPct val="112000"/>
+              </a:lnSpc>
+              <a:spcAft>
+                <a:spcPts val="900"/>
+              </a:spcAft>
+            </a:pPr>
+            <a:r>
+              <a:rPr sz="1800" b="1">
+                <a:solidFill>
+                  <a:srgbClr val="E0A437"/>
+                </a:solidFill>
+                <a:latin typeface="Fira Sans"/>
+              </a:rPr>
+              <a:t>▸ </a:t>
+            </a:r>
+            <a:r>
+              <a:rPr sz="1800" b="0">
+                <a:solidFill>
+                  <a:srgbClr val="000000"/>
+                </a:solidFill>
+                <a:latin typeface="Fira Sans"/>
+              </a:rPr>
+              <a:t>En la EOD ambos chequeos dan cero; un cero también es un hallazgo.</a:t>
+            </a:r>
+          </a:p>
+          <a:p>
+            <a:pPr>
+              <a:lnSpc>
+                <a:spcPct val="112000"/>
+              </a:lnSpc>
+              <a:spcAft>
+                <a:spcPts val="900"/>
+              </a:spcAft>
+            </a:pPr>
+            <a:r>
+              <a:rPr sz="1800" b="1">
+                <a:solidFill>
+                  <a:srgbClr val="E0A437"/>
+                </a:solidFill>
+                <a:latin typeface="Fira Sans"/>
+              </a:rPr>
+              <a:t>▸ </a:t>
+            </a:r>
+            <a:r>
+              <a:rPr sz="1800" b="0">
+                <a:solidFill>
+                  <a:srgbClr val="000000"/>
+                </a:solidFill>
+                <a:latin typeface="Fira Sans"/>
+              </a:rPr>
+              <a:t>El riesgo típico: un merge con llaves repetidas multiplica filas.</a:t>
             </a:r>
           </a:p>
         </p:txBody>
@@ -10083,90 +10084,35 @@
                 </a:solidFill>
                 <a:latin typeface="Fira Sans"/>
               </a:rPr>
-              <a:t>Tapar valores con mask</a:t>
-            </a:r>
-          </a:p>
-        </p:txBody>
-      </p:sp>
-      <p:sp>
-        <p:nvSpPr>
-          <p:cNvPr id="4" name="Rectangle 3"/>
-          <p:cNvSpPr/>
-          <p:nvPr/>
-        </p:nvSpPr>
-        <p:spPr>
-          <a:xfrm>
-            <a:off x="704088" y="1280160"/>
-            <a:ext cx="7744968" cy="1874520"/>
-          </a:xfrm>
-          <a:prstGeom prst="rect">
-            <a:avLst/>
-          </a:prstGeom>
-          <a:solidFill>
-            <a:srgbClr val="F0F2F5"/>
-          </a:solidFill>
-          <a:ln>
-            <a:solidFill>
-              <a:srgbClr val="D8DDE3"/>
-            </a:solidFill>
-          </a:ln>
-          <a:effectLst/>
-        </p:spPr>
-        <p:style>
-          <a:lnRef idx="1">
-            <a:schemeClr val="accent1"/>
-          </a:lnRef>
-          <a:fillRef idx="3">
-            <a:schemeClr val="accent1"/>
-          </a:fillRef>
-          <a:effectRef idx="2">
-            <a:schemeClr val="accent1"/>
-          </a:effectRef>
-          <a:fontRef idx="minor">
-            <a:schemeClr val="lt1"/>
-          </a:fontRef>
-        </p:style>
-        <p:txBody>
-          <a:bodyPr rtlCol="0" anchor="ctr" wrap="square" lIns="228600" tIns="137160"/>
-          <a:lstStyle/>
-          <a:p>
-            <a:pPr/>
-            <a:r>
-              <a:rPr sz="1500" b="0">
-                <a:solidFill>
-                  <a:srgbClr val="1D3557"/>
-                </a:solidFill>
-                <a:latin typeface="Menlo"/>
-              </a:rPr>
-              <a:t># donde la condición se cumple, reemplaza (aquí, por NaN)</a:t>
-            </a:r>
-          </a:p>
-          <a:p>
-            <a:pPr/>
-            <a:r>
-              <a:rPr sz="1500" b="0">
-                <a:solidFill>
-                  <a:srgbClr val="1D3557"/>
-                </a:solidFill>
-                <a:latin typeface="Menlo"/>
-              </a:rPr>
-              <a:t>viajes["TiempoViaje"] = viajes["TiempoViaje"].mask(</a:t>
-            </a:r>
-          </a:p>
-          <a:p>
-            <a:pPr/>
-            <a:r>
-              <a:rPr sz="1500" b="0">
-                <a:solidFill>
-                  <a:srgbClr val="1D3557"/>
-                </a:solidFill>
-                <a:latin typeface="Menlo"/>
-              </a:rPr>
-              <a:t>    viajes["TiempoViaje"] &gt; 300)</a:t>
-            </a:r>
-          </a:p>
-        </p:txBody>
-      </p:sp>
+              <a:t>Valores sospechosos</a:t>
+            </a:r>
+          </a:p>
+        </p:txBody>
+      </p:sp>
+      <p:pic>
+        <p:nvPicPr>
+          <p:cNvPr id="4" name="Picture 3" descr="05_cola_imposibles.png"/>
+          <p:cNvPicPr>
+            <a:picLocks noChangeAspect="1"/>
+          </p:cNvPicPr>
+          <p:nvPr/>
+        </p:nvPicPr>
+        <p:blipFill>
+          <a:blip r:embed="rId2"/>
+          <a:stretch>
+            <a:fillRect/>
+          </a:stretch>
+        </p:blipFill>
+        <p:spPr>
+          <a:xfrm>
+            <a:off x="1648218" y="1143000"/>
+            <a:ext cx="5847563" cy="3154680"/>
+          </a:xfrm>
+          <a:prstGeom prst="rect">
+            <a:avLst/>
+          </a:prstGeom>
+        </p:spPr>
+      </p:pic>
       <p:sp>
         <p:nvSpPr>
           <p:cNvPr id="5" name="TextBox 4"/>
@@ -10175,8 +10121,8 @@
         </p:nvSpPr>
         <p:spPr>
           <a:xfrm>
-            <a:off x="704088" y="3383279"/>
-            <a:ext cx="7744968" cy="1097280"/>
+            <a:off x="704088" y="4434840"/>
+            <a:ext cx="7744968" cy="457200"/>
           </a:xfrm>
           <a:prstGeom prst="rect">
             <a:avLst/>
@@ -10189,31 +10135,14 @@
           </a:bodyPr>
           <a:lstStyle/>
           <a:p>
-            <a:pPr>
-              <a:lnSpc>
-                <a:spcPct val="112000"/>
-              </a:lnSpc>
-              <a:spcAft>
-                <a:spcPts val="900"/>
-              </a:spcAft>
-            </a:pPr>
-            <a:r>
-              <a:rPr sz="1600" b="1">
-                <a:solidFill>
-                  <a:srgbClr val="E0A437"/>
-                </a:solidFill>
-                <a:latin typeface="Fira Sans"/>
-              </a:rPr>
-              <a:t>▸ </a:t>
-            </a:r>
-            <a:r>
-              <a:rPr sz="1600" b="0">
-                <a:solidFill>
-                  <a:srgbClr val="000000"/>
-                </a:solidFill>
-                <a:latin typeface="Fira Sans"/>
-              </a:rPr>
-              <a:t>mask reemplaza donde la condición es verdadera; where, su espejo, conserva donde es verdadera y reemplaza el resto. Regla nemotécnica: mask es dónde tapar, where es dónde quedarse.</a:t>
+            <a:r>
+              <a:rPr sz="1300" b="0">
+                <a:solidFill>
+                  <a:srgbClr val="333333"/>
+                </a:solidFill>
+                <a:latin typeface="Fira Sans"/>
+              </a:rPr>
+              <a:t>116 viajes declaran más de 5 horas y el máximo es de 22 horas. ¿Error de registro o viaje real? La respuesta exige criterio del dominio; la decisión (mantener, corregir o excluir) se toma en el código y se documenta.</a:t>
             </a:r>
           </a:p>
         </p:txBody>
@@ -10309,21 +10238,100 @@
                 </a:solidFill>
                 <a:latin typeface="Fira Sans"/>
               </a:rPr>
-              <a:t>Revisar cada merge</a:t>
-            </a:r>
-          </a:p>
-        </p:txBody>
-      </p:sp>
-      <p:sp>
-        <p:nvSpPr>
-          <p:cNvPr id="4" name="TextBox 3"/>
+              <a:t>Tapar valores con mask</a:t>
+            </a:r>
+          </a:p>
+        </p:txBody>
+      </p:sp>
+      <p:sp>
+        <p:nvSpPr>
+          <p:cNvPr id="4" name="Rectangle 3"/>
+          <p:cNvSpPr/>
+          <p:nvPr/>
+        </p:nvSpPr>
+        <p:spPr>
+          <a:xfrm>
+            <a:off x="704088" y="1280160"/>
+            <a:ext cx="7744968" cy="1874520"/>
+          </a:xfrm>
+          <a:prstGeom prst="rect">
+            <a:avLst/>
+          </a:prstGeom>
+          <a:solidFill>
+            <a:srgbClr val="F0F2F5"/>
+          </a:solidFill>
+          <a:ln>
+            <a:solidFill>
+              <a:srgbClr val="D8DDE3"/>
+            </a:solidFill>
+          </a:ln>
+          <a:effectLst/>
+        </p:spPr>
+        <p:style>
+          <a:lnRef idx="1">
+            <a:schemeClr val="accent1"/>
+          </a:lnRef>
+          <a:fillRef idx="3">
+            <a:schemeClr val="accent1"/>
+          </a:fillRef>
+          <a:effectRef idx="2">
+            <a:schemeClr val="accent1"/>
+          </a:effectRef>
+          <a:fontRef idx="minor">
+            <a:schemeClr val="lt1"/>
+          </a:fontRef>
+        </p:style>
+        <p:txBody>
+          <a:bodyPr rtlCol="0" anchor="ctr" wrap="square" lIns="228600" tIns="137160"/>
+          <a:lstStyle/>
+          <a:p>
+            <a:pPr/>
+            <a:r>
+              <a:rPr sz="1500" b="0">
+                <a:solidFill>
+                  <a:srgbClr val="1D3557"/>
+                </a:solidFill>
+                <a:latin typeface="Menlo"/>
+              </a:rPr>
+              <a:t># donde la condición se cumple, reemplaza (aquí, por NaN)</a:t>
+            </a:r>
+          </a:p>
+          <a:p>
+            <a:pPr/>
+            <a:r>
+              <a:rPr sz="1500" b="0">
+                <a:solidFill>
+                  <a:srgbClr val="1D3557"/>
+                </a:solidFill>
+                <a:latin typeface="Menlo"/>
+              </a:rPr>
+              <a:t>viajes["TiempoViaje"] = viajes["TiempoViaje"].mask(</a:t>
+            </a:r>
+          </a:p>
+          <a:p>
+            <a:pPr/>
+            <a:r>
+              <a:rPr sz="1500" b="0">
+                <a:solidFill>
+                  <a:srgbClr val="1D3557"/>
+                </a:solidFill>
+                <a:latin typeface="Menlo"/>
+              </a:rPr>
+              <a:t>    viajes["TiempoViaje"] &gt; 300)</a:t>
+            </a:r>
+          </a:p>
+        </p:txBody>
+      </p:sp>
+      <p:sp>
+        <p:nvSpPr>
+          <p:cNvPr id="5" name="TextBox 4"/>
           <p:cNvSpPr txBox="1"/>
           <p:nvPr/>
         </p:nvSpPr>
         <p:spPr>
           <a:xfrm>
-            <a:off x="704088" y="1353312"/>
-            <a:ext cx="7744968" cy="3300984"/>
+            <a:off x="704088" y="3383279"/>
+            <a:ext cx="7744968" cy="1097280"/>
           </a:xfrm>
           <a:prstGeom prst="rect">
             <a:avLst/>
@@ -10345,7 +10353,7 @@
               </a:spcAft>
             </a:pPr>
             <a:r>
-              <a:rPr sz="1800" b="1">
+              <a:rPr sz="1600" b="1">
                 <a:solidFill>
                   <a:srgbClr val="E0A437"/>
                 </a:solidFill>
@@ -10354,69 +10362,13 @@
               <a:t>▸ </a:t>
             </a:r>
             <a:r>
-              <a:rPr sz="1800" b="0">
+              <a:rPr sz="1600" b="0">
                 <a:solidFill>
                   <a:srgbClr val="000000"/>
                 </a:solidFill>
                 <a:latin typeface="Fira Sans"/>
               </a:rPr>
-              <a:t>Comparar el número de filas antes y después: un inner descarta las filas sin pareja; en la clase 1, 113.591 viajes quedaron en 111.393.</a:t>
-            </a:r>
-          </a:p>
-          <a:p>
-            <a:pPr>
-              <a:lnSpc>
-                <a:spcPct val="112000"/>
-              </a:lnSpc>
-              <a:spcAft>
-                <a:spcPts val="900"/>
-              </a:spcAft>
-            </a:pPr>
-            <a:r>
-              <a:rPr sz="1800" b="1">
-                <a:solidFill>
-                  <a:srgbClr val="E0A437"/>
-                </a:solidFill>
-                <a:latin typeface="Fira Sans"/>
-              </a:rPr>
-              <a:t>▸ </a:t>
-            </a:r>
-            <a:r>
-              <a:rPr sz="1800" b="0">
-                <a:solidFill>
-                  <a:srgbClr val="000000"/>
-                </a:solidFill>
-                <a:latin typeface="Fira Sans"/>
-              </a:rPr>
-              <a:t>Contar los NaN de las columnas nuevas cuando se usa how="left": ahí quedan visibles las filas sin correspondencia (2.198 comunas).</a:t>
-            </a:r>
-          </a:p>
-          <a:p>
-            <a:pPr>
-              <a:lnSpc>
-                <a:spcPct val="112000"/>
-              </a:lnSpc>
-              <a:spcAft>
-                <a:spcPts val="900"/>
-              </a:spcAft>
-            </a:pPr>
-            <a:r>
-              <a:rPr sz="1800" b="1">
-                <a:solidFill>
-                  <a:srgbClr val="E0A437"/>
-                </a:solidFill>
-                <a:latin typeface="Fira Sans"/>
-              </a:rPr>
-              <a:t>▸ </a:t>
-            </a:r>
-            <a:r>
-              <a:rPr sz="1800" b="0">
-                <a:solidFill>
-                  <a:srgbClr val="000000"/>
-                </a:solidFill>
-                <a:latin typeface="Fira Sans"/>
-              </a:rPr>
-              <a:t>Verificar que la llave sea única en la tabla de parámetros: si está repetida, el merge multiplica filas.</a:t>
+              <a:t>mask reemplaza donde la condición es verdadera; where, su espejo, conserva donde es verdadera y reemplaza el resto. Regla nemotécnica: mask es dónde tapar, where es dónde quedarse.</a:t>
             </a:r>
           </a:p>
         </p:txBody>
@@ -10430,6 +10382,209 @@
 </file>
 
 <file path=ppt/slides/slide42.xml><?xml version="1.0" encoding="utf-8"?>
+<p:sld xmlns:a="http://schemas.openxmlformats.org/drawingml/2006/main" xmlns:p="http://schemas.openxmlformats.org/presentationml/2006/main" xmlns:r="http://schemas.openxmlformats.org/officeDocument/2006/relationships">
+  <p:cSld>
+    <p:spTree>
+      <p:nvGrpSpPr>
+        <p:cNvPr id="1" name=""/>
+        <p:cNvGrpSpPr/>
+        <p:nvPr/>
+      </p:nvGrpSpPr>
+      <p:grpSpPr/>
+      <p:sp>
+        <p:nvSpPr>
+          <p:cNvPr id="2" name="Rectangle 1"/>
+          <p:cNvSpPr/>
+          <p:nvPr/>
+        </p:nvSpPr>
+        <p:spPr>
+          <a:xfrm>
+            <a:off x="0" y="0"/>
+            <a:ext cx="9144000" cy="5138928"/>
+          </a:xfrm>
+          <a:prstGeom prst="rect">
+            <a:avLst/>
+          </a:prstGeom>
+          <a:solidFill>
+            <a:srgbClr val="FAFBFC"/>
+          </a:solidFill>
+          <a:ln>
+            <a:noFill/>
+          </a:ln>
+          <a:effectLst/>
+        </p:spPr>
+        <p:style>
+          <a:lnRef idx="1">
+            <a:schemeClr val="accent1"/>
+          </a:lnRef>
+          <a:fillRef idx="3">
+            <a:schemeClr val="accent1"/>
+          </a:fillRef>
+          <a:effectRef idx="2">
+            <a:schemeClr val="accent1"/>
+          </a:effectRef>
+          <a:fontRef idx="minor">
+            <a:schemeClr val="lt1"/>
+          </a:fontRef>
+        </p:style>
+        <p:txBody>
+          <a:bodyPr rtlCol="0" anchor="ctr"/>
+          <a:lstStyle/>
+          <a:p>
+            <a:pPr algn="ctr"/>
+          </a:p>
+        </p:txBody>
+      </p:sp>
+      <p:sp>
+        <p:nvSpPr>
+          <p:cNvPr id="3" name="TextBox 2"/>
+          <p:cNvSpPr txBox="1"/>
+          <p:nvPr/>
+        </p:nvSpPr>
+        <p:spPr>
+          <a:xfrm>
+            <a:off x="402336" y="301752"/>
+            <a:ext cx="8348472" cy="795528"/>
+          </a:xfrm>
+          <a:prstGeom prst="rect">
+            <a:avLst/>
+          </a:prstGeom>
+          <a:noFill/>
+        </p:spPr>
+        <p:txBody>
+          <a:bodyPr wrap="square">
+            <a:spAutoFit/>
+          </a:bodyPr>
+          <a:lstStyle/>
+          <a:p>
+            <a:r>
+              <a:rPr sz="2800" b="1">
+                <a:solidFill>
+                  <a:srgbClr val="0F0F0F"/>
+                </a:solidFill>
+                <a:latin typeface="Fira Sans"/>
+              </a:rPr>
+              <a:t>Revisar cada merge</a:t>
+            </a:r>
+          </a:p>
+        </p:txBody>
+      </p:sp>
+      <p:sp>
+        <p:nvSpPr>
+          <p:cNvPr id="4" name="TextBox 3"/>
+          <p:cNvSpPr txBox="1"/>
+          <p:nvPr/>
+        </p:nvSpPr>
+        <p:spPr>
+          <a:xfrm>
+            <a:off x="704088" y="1353312"/>
+            <a:ext cx="7744968" cy="3300984"/>
+          </a:xfrm>
+          <a:prstGeom prst="rect">
+            <a:avLst/>
+          </a:prstGeom>
+          <a:noFill/>
+        </p:spPr>
+        <p:txBody>
+          <a:bodyPr wrap="square">
+            <a:spAutoFit/>
+          </a:bodyPr>
+          <a:lstStyle/>
+          <a:p>
+            <a:pPr>
+              <a:lnSpc>
+                <a:spcPct val="112000"/>
+              </a:lnSpc>
+              <a:spcAft>
+                <a:spcPts val="900"/>
+              </a:spcAft>
+            </a:pPr>
+            <a:r>
+              <a:rPr sz="1800" b="1">
+                <a:solidFill>
+                  <a:srgbClr val="E0A437"/>
+                </a:solidFill>
+                <a:latin typeface="Fira Sans"/>
+              </a:rPr>
+              <a:t>▸ </a:t>
+            </a:r>
+            <a:r>
+              <a:rPr sz="1800" b="0">
+                <a:solidFill>
+                  <a:srgbClr val="000000"/>
+                </a:solidFill>
+                <a:latin typeface="Fira Sans"/>
+              </a:rPr>
+              <a:t>Comparar el número de filas antes y después: un inner descarta las filas sin pareja; en la clase 1, 113.591 viajes quedaron en 111.393.</a:t>
+            </a:r>
+          </a:p>
+          <a:p>
+            <a:pPr>
+              <a:lnSpc>
+                <a:spcPct val="112000"/>
+              </a:lnSpc>
+              <a:spcAft>
+                <a:spcPts val="900"/>
+              </a:spcAft>
+            </a:pPr>
+            <a:r>
+              <a:rPr sz="1800" b="1">
+                <a:solidFill>
+                  <a:srgbClr val="E0A437"/>
+                </a:solidFill>
+                <a:latin typeface="Fira Sans"/>
+              </a:rPr>
+              <a:t>▸ </a:t>
+            </a:r>
+            <a:r>
+              <a:rPr sz="1800" b="0">
+                <a:solidFill>
+                  <a:srgbClr val="000000"/>
+                </a:solidFill>
+                <a:latin typeface="Fira Sans"/>
+              </a:rPr>
+              <a:t>Contar los NaN de las columnas nuevas cuando se usa how="left": ahí quedan visibles las filas sin correspondencia (2.198 comunas).</a:t>
+            </a:r>
+          </a:p>
+          <a:p>
+            <a:pPr>
+              <a:lnSpc>
+                <a:spcPct val="112000"/>
+              </a:lnSpc>
+              <a:spcAft>
+                <a:spcPts val="900"/>
+              </a:spcAft>
+            </a:pPr>
+            <a:r>
+              <a:rPr sz="1800" b="1">
+                <a:solidFill>
+                  <a:srgbClr val="E0A437"/>
+                </a:solidFill>
+                <a:latin typeface="Fira Sans"/>
+              </a:rPr>
+              <a:t>▸ </a:t>
+            </a:r>
+            <a:r>
+              <a:rPr sz="1800" b="0">
+                <a:solidFill>
+                  <a:srgbClr val="000000"/>
+                </a:solidFill>
+                <a:latin typeface="Fira Sans"/>
+              </a:rPr>
+              <a:t>Verificar que la llave sea única en la tabla de parámetros: si está repetida, el merge multiplica filas.</a:t>
+            </a:r>
+          </a:p>
+        </p:txBody>
+      </p:sp>
+    </p:spTree>
+  </p:cSld>
+  <p:clrMapOvr>
+    <a:masterClrMapping/>
+  </p:clrMapOvr>
+</p:sld>
+</file>
+
+<file path=ppt/slides/slide43.xml><?xml version="1.0" encoding="utf-8"?>
 <p:sld xmlns:a="http://schemas.openxmlformats.org/drawingml/2006/main" xmlns:p="http://schemas.openxmlformats.org/presentationml/2006/main" xmlns:r="http://schemas.openxmlformats.org/officeDocument/2006/relationships">
   <p:cSld>
     <p:spTree>
@@ -10921,7 +11076,7 @@
 </p:sld>
 </file>
 
-<file path=ppt/slides/slide43.xml><?xml version="1.0" encoding="utf-8"?>
+<file path=ppt/slides/slide44.xml><?xml version="1.0" encoding="utf-8"?>
 <p:sld xmlns:a="http://schemas.openxmlformats.org/drawingml/2006/main" xmlns:p="http://schemas.openxmlformats.org/presentationml/2006/main" xmlns:r="http://schemas.openxmlformats.org/officeDocument/2006/relationships">
   <p:cSld>
     <p:spTree>
@@ -11180,7 +11335,7 @@
 </p:sld>
 </file>
 
-<file path=ppt/slides/slide44.xml><?xml version="1.0" encoding="utf-8"?>
+<file path=ppt/slides/slide45.xml><?xml version="1.0" encoding="utf-8"?>
 <p:sld xmlns:a="http://schemas.openxmlformats.org/drawingml/2006/main" xmlns:p="http://schemas.openxmlformats.org/presentationml/2006/main" xmlns:r="http://schemas.openxmlformats.org/officeDocument/2006/relationships">
   <p:cSld>
     <p:spTree>

</xml_diff>

<commit_message>
Clase 2: diagrama de percentiles tambien con iris; iris primero y la EOD como aplicacion
Co-Authored-By: Claude Fable 5 <noreply@anthropic.com>
</commit_message>
<xml_diff>
--- a/presentaciones/clase02_eda_descriptiva.pptx
+++ b/presentaciones/clase02_eda_descriptiva.pptx
@@ -50,6 +50,7 @@
     <p:sldId id="298" r:id="rId49"/>
     <p:sldId id="299" r:id="rId50"/>
     <p:sldId id="300" r:id="rId51"/>
+    <p:sldId id="301" r:id="rId52"/>
   </p:sldIdLst>
   <p:sldSz cx="9144000" cy="5138928" type="screen4x3"/>
   <p:notesSz cx="6858000" cy="9144000"/>
@@ -7879,7 +7880,7 @@
       </p:sp>
       <p:pic>
         <p:nvPicPr>
-          <p:cNvPr id="4" name="Picture 3" descr="18_percentiles.png"/>
+          <p:cNvPr id="4" name="Picture 3" descr="19_percentiles_iris.png"/>
           <p:cNvPicPr>
             <a:picLocks noChangeAspect="1"/>
           </p:cNvPicPr>
@@ -7894,7 +7895,7 @@
         <p:spPr>
           <a:xfrm>
             <a:off x="1417319" y="1143000"/>
-            <a:ext cx="6309360" cy="2456026"/>
+            <a:ext cx="6309360" cy="2427830"/>
           </a:xfrm>
           <a:prstGeom prst="rect">
             <a:avLst/>
@@ -7930,7 +7931,7 @@
                 </a:solidFill>
                 <a:latin typeface="Fira Sans"/>
               </a:rPr>
-              <a:t>El percentil p es el valor bajo el cual queda el p% de los datos. Los cuartiles son los percentiles 25, 50 y 75: cortan los datos ordenados en cuatro partes con la misma cantidad de viajes cada una.</a:t>
+              <a:t>El percentil p es el valor bajo el cual queda el p% de los datos. Los cuartiles son los percentiles 25, 50 y 75: cortan los datos ordenados en cuatro partes con la misma cantidad de observaciones cada una.</a:t>
             </a:r>
           </a:p>
         </p:txBody>
@@ -8133,14 +8134,14 @@
                 </a:solidFill>
                 <a:latin typeface="Fira Sans"/>
               </a:rPr>
-              <a:t>Medir la dispersión</a:t>
+              <a:t>Los cuartiles de la duración</a:t>
             </a:r>
           </a:p>
         </p:txBody>
       </p:sp>
       <p:pic>
         <p:nvPicPr>
-          <p:cNvPr id="4" name="Picture 3" descr="12_formulas_dispersion.png"/>
+          <p:cNvPr id="4" name="Picture 3" descr="18_percentiles.png"/>
           <p:cNvPicPr>
             <a:picLocks noChangeAspect="1"/>
           </p:cNvPicPr>
@@ -8155,7 +8156,7 @@
         <p:spPr>
           <a:xfrm>
             <a:off x="1417319" y="1143000"/>
-            <a:ext cx="6309360" cy="3154680"/>
+            <a:ext cx="6309360" cy="2456026"/>
           </a:xfrm>
           <a:prstGeom prst="rect">
             <a:avLst/>
@@ -8191,7 +8192,7 @@
                 </a:solidFill>
                 <a:latin typeface="Fira Sans"/>
               </a:rPr>
-              <a:t>Los percentiles completan el cuadro: quantile([0, 0.25, 0.5, 0.75, 1]) entrega el mínimo, los cuartiles y el máximo (en iris: 4,3 · 5,1 · 5,8 · 6,4 · 7,9).</a:t>
+              <a:t>Los mismos cortes en la EOD: cada tramo tiene la misma cantidad de viajes, pero anchos muy distintos. La asimetría, contada por los percentiles.</a:t>
             </a:r>
           </a:p>
         </p:txBody>
@@ -8287,14 +8288,14 @@
                 </a:solidFill>
                 <a:latin typeface="Fira Sans"/>
               </a:rPr>
-              <a:t>La media no basta</a:t>
+              <a:t>Medir la dispersión</a:t>
             </a:r>
           </a:p>
         </p:txBody>
       </p:sp>
       <p:pic>
         <p:nvPicPr>
-          <p:cNvPr id="4" name="Picture 3" descr="02_dispersion_comunas.png"/>
+          <p:cNvPr id="4" name="Picture 3" descr="12_formulas_dispersion.png"/>
           <p:cNvPicPr>
             <a:picLocks noChangeAspect="1"/>
           </p:cNvPicPr>
@@ -8308,8 +8309,8 @@
         </p:blipFill>
         <p:spPr>
           <a:xfrm>
-            <a:off x="1822348" y="1143000"/>
-            <a:ext cx="5499302" cy="3154680"/>
+            <a:off x="1417319" y="1143000"/>
+            <a:ext cx="6309360" cy="3154680"/>
           </a:xfrm>
           <a:prstGeom prst="rect">
             <a:avLst/>
@@ -8345,7 +8346,7 @@
                 </a:solidFill>
                 <a:latin typeface="Fira Sans"/>
               </a:rPr>
-              <a:t>Providencia y Talagante tienen la misma duración media de viaje (40,7 minutos), pero la desviación estándar de Talagante es el doble: dos realidades distintas detrás del mismo promedio.</a:t>
+              <a:t>Los percentiles completan el cuadro: quantile([0, 0.25, 0.5, 0.75, 1]) entrega el mínimo, los cuartiles y el máximo (en iris: 4,3 · 5,1 · 5,8 · 6,4 · 7,9).</a:t>
             </a:r>
           </a:p>
         </p:txBody>
@@ -8441,14 +8442,14 @@
                 </a:solidFill>
                 <a:latin typeface="Fira Sans"/>
               </a:rPr>
-              <a:t>El boxplot</a:t>
+              <a:t>La media no basta</a:t>
             </a:r>
           </a:p>
         </p:txBody>
       </p:sp>
       <p:pic>
         <p:nvPicPr>
-          <p:cNvPr id="4" name="Picture 3" descr="03_boxplot_anatomia.png"/>
+          <p:cNvPr id="4" name="Picture 3" descr="02_dispersion_comunas.png"/>
           <p:cNvPicPr>
             <a:picLocks noChangeAspect="1"/>
           </p:cNvPicPr>
@@ -8462,8 +8463,8 @@
         </p:blipFill>
         <p:spPr>
           <a:xfrm>
-            <a:off x="1740020" y="1143000"/>
-            <a:ext cx="5663958" cy="3154680"/>
+            <a:off x="1822348" y="1143000"/>
+            <a:ext cx="5499302" cy="3154680"/>
           </a:xfrm>
           <a:prstGeom prst="rect">
             <a:avLst/>
@@ -8499,7 +8500,7 @@
                 </a:solidFill>
                 <a:latin typeface="Fira Sans"/>
               </a:rPr>
-              <a:t>Cinco números en un solo gráfico: mediana, cuartiles, bigotes y valores atípicos. La regla de los bigotes (1,5 veces el IQR) es una convención para marcar valores inusuales, no un veredicto.</a:t>
+              <a:t>Providencia y Talagante tienen la misma duración media de viaje (40,7 minutos), pero la desviación estándar de Talagante es el doble: dos realidades distintas detrás del mismo promedio.</a:t>
             </a:r>
           </a:p>
         </p:txBody>
@@ -8595,149 +8596,14 @@
                 </a:solidFill>
                 <a:latin typeface="Fira Sans"/>
               </a:rPr>
-              <a:t>Valores atípicos (outliers)</a:t>
-            </a:r>
-          </a:p>
-        </p:txBody>
-      </p:sp>
-      <p:sp>
-        <p:nvSpPr>
-          <p:cNvPr id="4" name="TextBox 3"/>
-          <p:cNvSpPr txBox="1"/>
-          <p:nvPr/>
-        </p:nvSpPr>
-        <p:spPr>
-          <a:xfrm>
-            <a:off x="502920" y="1252728"/>
-            <a:ext cx="4023360" cy="3200400"/>
-          </a:xfrm>
-          <a:prstGeom prst="rect">
-            <a:avLst/>
-          </a:prstGeom>
-          <a:noFill/>
-        </p:spPr>
-        <p:txBody>
-          <a:bodyPr wrap="square">
-            <a:spAutoFit/>
-          </a:bodyPr>
-          <a:lstStyle/>
-          <a:p>
-            <a:pPr>
-              <a:lnSpc>
-                <a:spcPct val="112000"/>
-              </a:lnSpc>
-              <a:spcAft>
-                <a:spcPts val="900"/>
-              </a:spcAft>
-            </a:pPr>
-            <a:r>
-              <a:rPr sz="1500" b="1">
-                <a:solidFill>
-                  <a:srgbClr val="E0A437"/>
-                </a:solidFill>
-                <a:latin typeface="Fira Sans"/>
-              </a:rPr>
-              <a:t>▸ </a:t>
-            </a:r>
-            <a:r>
-              <a:rPr sz="1500" b="1">
-                <a:solidFill>
-                  <a:srgbClr val="1D3557"/>
-                </a:solidFill>
-                <a:latin typeface="Fira Sans"/>
-              </a:rPr>
-              <a:t>Un valor atípico es una observación que se aleja notoriamente del resto.</a:t>
-            </a:r>
-          </a:p>
-          <a:p>
-            <a:pPr>
-              <a:lnSpc>
-                <a:spcPct val="112000"/>
-              </a:lnSpc>
-              <a:spcAft>
-                <a:spcPts val="900"/>
-              </a:spcAft>
-            </a:pPr>
-            <a:r>
-              <a:rPr sz="1500" b="1">
-                <a:solidFill>
-                  <a:srgbClr val="E0A437"/>
-                </a:solidFill>
-                <a:latin typeface="Fira Sans"/>
-              </a:rPr>
-              <a:t>▸ </a:t>
-            </a:r>
-            <a:r>
-              <a:rPr sz="1500" b="0">
-                <a:solidFill>
-                  <a:srgbClr val="000000"/>
-                </a:solidFill>
-                <a:latin typeface="Fira Sans"/>
-              </a:rPr>
-              <a:t>Convención de Tukey: fuera de Q1 − 1,5·IQR y de Q3 + 1,5·IQR.</a:t>
-            </a:r>
-          </a:p>
-          <a:p>
-            <a:pPr>
-              <a:lnSpc>
-                <a:spcPct val="112000"/>
-              </a:lnSpc>
-              <a:spcAft>
-                <a:spcPts val="900"/>
-              </a:spcAft>
-            </a:pPr>
-            <a:r>
-              <a:rPr sz="1500" b="1">
-                <a:solidFill>
-                  <a:srgbClr val="E0A437"/>
-                </a:solidFill>
-                <a:latin typeface="Fira Sans"/>
-              </a:rPr>
-              <a:t>▸ </a:t>
-            </a:r>
-            <a:r>
-              <a:rPr sz="1500" b="0">
-                <a:solidFill>
-                  <a:srgbClr val="000000"/>
-                </a:solidFill>
-                <a:latin typeface="Fira Sans"/>
-              </a:rPr>
-              <a:t>Atípico no significa error: puede ser un caso real e informativo. Distinguirlo exige criterio del dominio.</a:t>
-            </a:r>
-          </a:p>
-          <a:p>
-            <a:pPr>
-              <a:lnSpc>
-                <a:spcPct val="112000"/>
-              </a:lnSpc>
-              <a:spcAft>
-                <a:spcPts val="900"/>
-              </a:spcAft>
-            </a:pPr>
-            <a:r>
-              <a:rPr sz="1500" b="1">
-                <a:solidFill>
-                  <a:srgbClr val="E0A437"/>
-                </a:solidFill>
-                <a:latin typeface="Fira Sans"/>
-              </a:rPr>
-              <a:t>▸ </a:t>
-            </a:r>
-            <a:r>
-              <a:rPr sz="1500" b="0">
-                <a:solidFill>
-                  <a:srgbClr val="000000"/>
-                </a:solidFill>
-                <a:latin typeface="Fira Sans"/>
-              </a:rPr>
-              <a:t>No hay una regla universal para excluirlos: es materia de la estadística robusta.</a:t>
+              <a:t>El boxplot</a:t>
             </a:r>
           </a:p>
         </p:txBody>
       </p:sp>
       <p:pic>
         <p:nvPicPr>
-          <p:cNvPr id="5" name="Picture 4" descr="15_outliers_tukey.png"/>
+          <p:cNvPr id="4" name="Picture 3" descr="03_boxplot_anatomia.png"/>
           <p:cNvPicPr>
             <a:picLocks noChangeAspect="1"/>
           </p:cNvPicPr>
@@ -8751,14 +8617,48 @@
         </p:blipFill>
         <p:spPr>
           <a:xfrm>
-            <a:off x="4892040" y="1371600"/>
-            <a:ext cx="3840480" cy="3136431"/>
+            <a:off x="1740020" y="1143000"/>
+            <a:ext cx="5663958" cy="3154680"/>
           </a:xfrm>
           <a:prstGeom prst="rect">
             <a:avLst/>
           </a:prstGeom>
         </p:spPr>
       </p:pic>
+      <p:sp>
+        <p:nvSpPr>
+          <p:cNvPr id="5" name="TextBox 4"/>
+          <p:cNvSpPr txBox="1"/>
+          <p:nvPr/>
+        </p:nvSpPr>
+        <p:spPr>
+          <a:xfrm>
+            <a:off x="704088" y="4434840"/>
+            <a:ext cx="7744968" cy="457200"/>
+          </a:xfrm>
+          <a:prstGeom prst="rect">
+            <a:avLst/>
+          </a:prstGeom>
+          <a:noFill/>
+        </p:spPr>
+        <p:txBody>
+          <a:bodyPr wrap="square">
+            <a:spAutoFit/>
+          </a:bodyPr>
+          <a:lstStyle/>
+          <a:p>
+            <a:r>
+              <a:rPr sz="1300" b="0">
+                <a:solidFill>
+                  <a:srgbClr val="333333"/>
+                </a:solidFill>
+                <a:latin typeface="Fira Sans"/>
+              </a:rPr>
+              <a:t>Cinco números en un solo gráfico: mediana, cuartiles, bigotes y valores atípicos. La regla de los bigotes (1,5 veces el IQR) es una convención para marcar valores inusuales, no un veredicto.</a:t>
+            </a:r>
+          </a:p>
+        </p:txBody>
+      </p:sp>
     </p:spTree>
   </p:cSld>
   <p:clrMapOvr>
@@ -8850,14 +8750,149 @@
                 </a:solidFill>
                 <a:latin typeface="Fira Sans"/>
               </a:rPr>
-              <a:t>Boxplots para comparar grupos: iris</a:t>
+              <a:t>Valores atípicos (outliers)</a:t>
+            </a:r>
+          </a:p>
+        </p:txBody>
+      </p:sp>
+      <p:sp>
+        <p:nvSpPr>
+          <p:cNvPr id="4" name="TextBox 3"/>
+          <p:cNvSpPr txBox="1"/>
+          <p:nvPr/>
+        </p:nvSpPr>
+        <p:spPr>
+          <a:xfrm>
+            <a:off x="502920" y="1252728"/>
+            <a:ext cx="4023360" cy="3200400"/>
+          </a:xfrm>
+          <a:prstGeom prst="rect">
+            <a:avLst/>
+          </a:prstGeom>
+          <a:noFill/>
+        </p:spPr>
+        <p:txBody>
+          <a:bodyPr wrap="square">
+            <a:spAutoFit/>
+          </a:bodyPr>
+          <a:lstStyle/>
+          <a:p>
+            <a:pPr>
+              <a:lnSpc>
+                <a:spcPct val="112000"/>
+              </a:lnSpc>
+              <a:spcAft>
+                <a:spcPts val="900"/>
+              </a:spcAft>
+            </a:pPr>
+            <a:r>
+              <a:rPr sz="1500" b="1">
+                <a:solidFill>
+                  <a:srgbClr val="E0A437"/>
+                </a:solidFill>
+                <a:latin typeface="Fira Sans"/>
+              </a:rPr>
+              <a:t>▸ </a:t>
+            </a:r>
+            <a:r>
+              <a:rPr sz="1500" b="1">
+                <a:solidFill>
+                  <a:srgbClr val="1D3557"/>
+                </a:solidFill>
+                <a:latin typeface="Fira Sans"/>
+              </a:rPr>
+              <a:t>Un valor atípico es una observación que se aleja notoriamente del resto.</a:t>
+            </a:r>
+          </a:p>
+          <a:p>
+            <a:pPr>
+              <a:lnSpc>
+                <a:spcPct val="112000"/>
+              </a:lnSpc>
+              <a:spcAft>
+                <a:spcPts val="900"/>
+              </a:spcAft>
+            </a:pPr>
+            <a:r>
+              <a:rPr sz="1500" b="1">
+                <a:solidFill>
+                  <a:srgbClr val="E0A437"/>
+                </a:solidFill>
+                <a:latin typeface="Fira Sans"/>
+              </a:rPr>
+              <a:t>▸ </a:t>
+            </a:r>
+            <a:r>
+              <a:rPr sz="1500" b="0">
+                <a:solidFill>
+                  <a:srgbClr val="000000"/>
+                </a:solidFill>
+                <a:latin typeface="Fira Sans"/>
+              </a:rPr>
+              <a:t>Convención de Tukey: fuera de Q1 − 1,5·IQR y de Q3 + 1,5·IQR.</a:t>
+            </a:r>
+          </a:p>
+          <a:p>
+            <a:pPr>
+              <a:lnSpc>
+                <a:spcPct val="112000"/>
+              </a:lnSpc>
+              <a:spcAft>
+                <a:spcPts val="900"/>
+              </a:spcAft>
+            </a:pPr>
+            <a:r>
+              <a:rPr sz="1500" b="1">
+                <a:solidFill>
+                  <a:srgbClr val="E0A437"/>
+                </a:solidFill>
+                <a:latin typeface="Fira Sans"/>
+              </a:rPr>
+              <a:t>▸ </a:t>
+            </a:r>
+            <a:r>
+              <a:rPr sz="1500" b="0">
+                <a:solidFill>
+                  <a:srgbClr val="000000"/>
+                </a:solidFill>
+                <a:latin typeface="Fira Sans"/>
+              </a:rPr>
+              <a:t>Atípico no significa error: puede ser un caso real e informativo. Distinguirlo exige criterio del dominio.</a:t>
+            </a:r>
+          </a:p>
+          <a:p>
+            <a:pPr>
+              <a:lnSpc>
+                <a:spcPct val="112000"/>
+              </a:lnSpc>
+              <a:spcAft>
+                <a:spcPts val="900"/>
+              </a:spcAft>
+            </a:pPr>
+            <a:r>
+              <a:rPr sz="1500" b="1">
+                <a:solidFill>
+                  <a:srgbClr val="E0A437"/>
+                </a:solidFill>
+                <a:latin typeface="Fira Sans"/>
+              </a:rPr>
+              <a:t>▸ </a:t>
+            </a:r>
+            <a:r>
+              <a:rPr sz="1500" b="0">
+                <a:solidFill>
+                  <a:srgbClr val="000000"/>
+                </a:solidFill>
+                <a:latin typeface="Fira Sans"/>
+              </a:rPr>
+              <a:t>No hay una regla universal para excluirlos: es materia de la estadística robusta.</a:t>
             </a:r>
           </a:p>
         </p:txBody>
       </p:sp>
       <p:pic>
         <p:nvPicPr>
-          <p:cNvPr id="4" name="Picture 3" descr="09_iris_boxplot.png"/>
+          <p:cNvPr id="5" name="Picture 4" descr="15_outliers_tukey.png"/>
           <p:cNvPicPr>
             <a:picLocks noChangeAspect="1"/>
           </p:cNvPicPr>
@@ -8871,48 +8906,14 @@
         </p:blipFill>
         <p:spPr>
           <a:xfrm>
-            <a:off x="1602889" y="1143000"/>
-            <a:ext cx="5938221" cy="3154680"/>
+            <a:off x="4892040" y="1371600"/>
+            <a:ext cx="3840480" cy="3136431"/>
           </a:xfrm>
           <a:prstGeom prst="rect">
             <a:avLst/>
           </a:prstGeom>
         </p:spPr>
       </p:pic>
-      <p:sp>
-        <p:nvSpPr>
-          <p:cNvPr id="5" name="TextBox 4"/>
-          <p:cNvSpPr txBox="1"/>
-          <p:nvPr/>
-        </p:nvSpPr>
-        <p:spPr>
-          <a:xfrm>
-            <a:off x="704088" y="4434840"/>
-            <a:ext cx="7744968" cy="457200"/>
-          </a:xfrm>
-          <a:prstGeom prst="rect">
-            <a:avLst/>
-          </a:prstGeom>
-          <a:noFill/>
-        </p:spPr>
-        <p:txBody>
-          <a:bodyPr wrap="square">
-            <a:spAutoFit/>
-          </a:bodyPr>
-          <a:lstStyle/>
-          <a:p>
-            <a:r>
-              <a:rPr sz="1300" b="0">
-                <a:solidFill>
-                  <a:srgbClr val="333333"/>
-                </a:solidFill>
-                <a:latin typeface="Fira Sans"/>
-              </a:rPr>
-              <a:t>El largo del pétalo separa casi perfectamente a las tres especies: centros y dispersiones distintas en una sola figura.</a:t>
-            </a:r>
-          </a:p>
-        </p:txBody>
-      </p:sp>
     </p:spTree>
   </p:cSld>
   <p:clrMapOvr>
@@ -9004,14 +9005,14 @@
                 </a:solidFill>
                 <a:latin typeface="Fira Sans"/>
               </a:rPr>
-              <a:t>Boxplots para comparar grupos: la EOD</a:t>
+              <a:t>Boxplots para comparar grupos: iris</a:t>
             </a:r>
           </a:p>
         </p:txBody>
       </p:sp>
       <p:pic>
         <p:nvPicPr>
-          <p:cNvPr id="4" name="Picture 3" descr="04_boxplot_modos.png"/>
+          <p:cNvPr id="4" name="Picture 3" descr="09_iris_boxplot.png"/>
           <p:cNvPicPr>
             <a:picLocks noChangeAspect="1"/>
           </p:cNvPicPr>
@@ -9025,8 +9026,8 @@
         </p:blipFill>
         <p:spPr>
           <a:xfrm>
-            <a:off x="1417319" y="1143000"/>
-            <a:ext cx="6309360" cy="2899161"/>
+            <a:off x="1602889" y="1143000"/>
+            <a:ext cx="5938221" cy="3154680"/>
           </a:xfrm>
           <a:prstGeom prst="rect">
             <a:avLst/>
@@ -9062,7 +9063,7 @@
                 </a:solidFill>
                 <a:latin typeface="Fira Sans"/>
               </a:rPr>
-              <a:t>La duración del viaje según el modo: centros y dispersiones distintas en una sola figura. Es el gráfico estándar para comparar una variable cuantitativa entre categorías.</a:t>
+              <a:t>El largo del pétalo separa casi perfectamente a las tres especies: centros y dispersiones distintas en una sola figura.</a:t>
             </a:r>
           </a:p>
         </p:txBody>
@@ -9100,7 +9101,7 @@
             <a:avLst/>
           </a:prstGeom>
           <a:solidFill>
-            <a:srgbClr val="1D3557"/>
+            <a:srgbClr val="FAFBFC"/>
           </a:solidFill>
           <a:ln>
             <a:noFill/>
@@ -9137,8 +9138,8 @@
         </p:nvSpPr>
         <p:spPr>
           <a:xfrm>
-            <a:off x="603504" y="1847088"/>
-            <a:ext cx="7946136" cy="1399032"/>
+            <a:off x="402336" y="301752"/>
+            <a:ext cx="8348472" cy="795528"/>
           </a:xfrm>
           <a:prstGeom prst="rect">
             <a:avLst/>
@@ -9152,24 +9153,71 @@
           <a:lstStyle/>
           <a:p>
             <a:r>
-              <a:rPr sz="3400" b="1">
-                <a:solidFill>
-                  <a:srgbClr val="FFFFFF"/>
-                </a:solidFill>
-                <a:latin typeface="Fira Sans"/>
-              </a:rPr>
-              <a:t>Calidad y limpieza de datos</a:t>
-            </a:r>
-          </a:p>
-          <a:p>
-            <a:r>
-              <a:rPr sz="1800" b="0">
-                <a:solidFill>
-                  <a:srgbClr val="E0A437"/>
-                </a:solidFill>
-                <a:latin typeface="Fira Sans"/>
-              </a:rPr>
-              <a:t>Los resúmenes valen lo que valen los datos</a:t>
+              <a:rPr sz="2800" b="1">
+                <a:solidFill>
+                  <a:srgbClr val="0F0F0F"/>
+                </a:solidFill>
+                <a:latin typeface="Fira Sans"/>
+              </a:rPr>
+              <a:t>Boxplots para comparar grupos: la EOD</a:t>
+            </a:r>
+          </a:p>
+        </p:txBody>
+      </p:sp>
+      <p:pic>
+        <p:nvPicPr>
+          <p:cNvPr id="4" name="Picture 3" descr="04_boxplot_modos.png"/>
+          <p:cNvPicPr>
+            <a:picLocks noChangeAspect="1"/>
+          </p:cNvPicPr>
+          <p:nvPr/>
+        </p:nvPicPr>
+        <p:blipFill>
+          <a:blip r:embed="rId2"/>
+          <a:stretch>
+            <a:fillRect/>
+          </a:stretch>
+        </p:blipFill>
+        <p:spPr>
+          <a:xfrm>
+            <a:off x="1417319" y="1143000"/>
+            <a:ext cx="6309360" cy="2899161"/>
+          </a:xfrm>
+          <a:prstGeom prst="rect">
+            <a:avLst/>
+          </a:prstGeom>
+        </p:spPr>
+      </p:pic>
+      <p:sp>
+        <p:nvSpPr>
+          <p:cNvPr id="5" name="TextBox 4"/>
+          <p:cNvSpPr txBox="1"/>
+          <p:nvPr/>
+        </p:nvSpPr>
+        <p:spPr>
+          <a:xfrm>
+            <a:off x="704088" y="4434840"/>
+            <a:ext cx="7744968" cy="457200"/>
+          </a:xfrm>
+          <a:prstGeom prst="rect">
+            <a:avLst/>
+          </a:prstGeom>
+          <a:noFill/>
+        </p:spPr>
+        <p:txBody>
+          <a:bodyPr wrap="square">
+            <a:spAutoFit/>
+          </a:bodyPr>
+          <a:lstStyle/>
+          <a:p>
+            <a:r>
+              <a:rPr sz="1300" b="0">
+                <a:solidFill>
+                  <a:srgbClr val="333333"/>
+                </a:solidFill>
+                <a:latin typeface="Fira Sans"/>
+              </a:rPr>
+              <a:t>La duración del viaje según el modo: centros y dispersiones distintas en una sola figura. Es el gráfico estándar para comparar una variable cuantitativa entre categorías.</a:t>
             </a:r>
           </a:p>
         </p:txBody>
@@ -9207,7 +9255,7 @@
             <a:avLst/>
           </a:prstGeom>
           <a:solidFill>
-            <a:srgbClr val="FAFBFC"/>
+            <a:srgbClr val="1D3557"/>
           </a:solidFill>
           <a:ln>
             <a:noFill/>
@@ -9244,8 +9292,8 @@
         </p:nvSpPr>
         <p:spPr>
           <a:xfrm>
-            <a:off x="402336" y="301752"/>
-            <a:ext cx="8348472" cy="795528"/>
+            <a:off x="603504" y="1847088"/>
+            <a:ext cx="7946136" cy="1399032"/>
           </a:xfrm>
           <a:prstGeom prst="rect">
             <a:avLst/>
@@ -9259,120 +9307,24 @@
           <a:lstStyle/>
           <a:p>
             <a:r>
-              <a:rPr sz="2800" b="1">
-                <a:solidFill>
-                  <a:srgbClr val="0F0F0F"/>
-                </a:solidFill>
-                <a:latin typeface="Fira Sans"/>
-              </a:rPr>
-              <a:t>iris viene casi limpio; los datos reales, no</a:t>
-            </a:r>
-          </a:p>
-        </p:txBody>
-      </p:sp>
-      <p:sp>
-        <p:nvSpPr>
-          <p:cNvPr id="4" name="TextBox 3"/>
-          <p:cNvSpPr txBox="1"/>
-          <p:nvPr/>
-        </p:nvSpPr>
-        <p:spPr>
-          <a:xfrm>
-            <a:off x="704088" y="1353312"/>
-            <a:ext cx="7744968" cy="3300984"/>
-          </a:xfrm>
-          <a:prstGeom prst="rect">
-            <a:avLst/>
-          </a:prstGeom>
-          <a:noFill/>
-        </p:spPr>
-        <p:txBody>
-          <a:bodyPr wrap="square">
-            <a:spAutoFit/>
-          </a:bodyPr>
-          <a:lstStyle/>
-          <a:p>
-            <a:pPr>
-              <a:lnSpc>
-                <a:spcPct val="112000"/>
-              </a:lnSpc>
-              <a:spcAft>
-                <a:spcPts val="900"/>
-              </a:spcAft>
-            </a:pPr>
-            <a:r>
-              <a:rPr sz="1800" b="1">
+              <a:rPr sz="3400" b="1">
+                <a:solidFill>
+                  <a:srgbClr val="FFFFFF"/>
+                </a:solidFill>
+                <a:latin typeface="Fira Sans"/>
+              </a:rPr>
+              <a:t>Calidad y limpieza de datos</a:t>
+            </a:r>
+          </a:p>
+          <a:p>
+            <a:r>
+              <a:rPr sz="1800" b="0">
                 <a:solidFill>
                   <a:srgbClr val="E0A437"/>
                 </a:solidFill>
                 <a:latin typeface="Fira Sans"/>
               </a:rPr>
-              <a:t>▸ </a:t>
-            </a:r>
-            <a:r>
-              <a:rPr sz="1800" b="0">
-                <a:solidFill>
-                  <a:srgbClr val="000000"/>
-                </a:solidFill>
-                <a:latin typeface="Fira Sans"/>
-              </a:rPr>
-              <a:t>iris: cero faltantes en sus 150 filas... y aun así tiene una fila duplicada. Hasta el dataset más famoso trae un problema de calidad.</a:t>
-            </a:r>
-          </a:p>
-          <a:p>
-            <a:pPr>
-              <a:lnSpc>
-                <a:spcPct val="112000"/>
-              </a:lnSpc>
-              <a:spcAft>
-                <a:spcPts val="900"/>
-              </a:spcAft>
-            </a:pPr>
-            <a:r>
-              <a:rPr sz="1800" b="1">
-                <a:solidFill>
-                  <a:srgbClr val="E0A437"/>
-                </a:solidFill>
-                <a:latin typeface="Fira Sans"/>
-              </a:rPr>
-              <a:t>▸ </a:t>
-            </a:r>
-            <a:r>
-              <a:rPr sz="1800" b="0">
-                <a:solidFill>
-                  <a:srgbClr val="000000"/>
-                </a:solidFill>
-                <a:latin typeface="Fira Sans"/>
-              </a:rPr>
-              <a:t>La EOD: 278 duraciones faltantes, códigos que traducir, colas sospechosas y factores que son NaN por diseño.</a:t>
-            </a:r>
-          </a:p>
-          <a:p>
-            <a:pPr>
-              <a:lnSpc>
-                <a:spcPct val="112000"/>
-              </a:lnSpc>
-              <a:spcAft>
-                <a:spcPts val="900"/>
-              </a:spcAft>
-            </a:pPr>
-            <a:r>
-              <a:rPr sz="1800" b="1">
-                <a:solidFill>
-                  <a:srgbClr val="E0A437"/>
-                </a:solidFill>
-                <a:latin typeface="Fira Sans"/>
-              </a:rPr>
-              <a:t>▸ </a:t>
-            </a:r>
-            <a:r>
-              <a:rPr sz="1800" b="1">
-                <a:solidFill>
-                  <a:srgbClr val="1D3557"/>
-                </a:solidFill>
-                <a:latin typeface="Fira Sans"/>
-              </a:rPr>
-              <a:t>Por eso el checklist de calidad se aplica siempre, también al dataset del proyecto.</a:t>
+              <a:t>Los resúmenes valen lo que valen los datos</a:t>
             </a:r>
           </a:p>
         </p:txBody>
@@ -9468,7 +9420,7 @@
                 </a:solidFill>
                 <a:latin typeface="Fira Sans"/>
               </a:rPr>
-              <a:t>Valores faltantes</a:t>
+              <a:t>iris viene casi limpio; los datos reales, no</a:t>
             </a:r>
           </a:p>
         </p:txBody>
@@ -9519,7 +9471,7 @@
                 </a:solidFill>
                 <a:latin typeface="Fira Sans"/>
               </a:rPr>
-              <a:t>Detección: isna().sum(), o el count de describe() contra len.</a:t>
+              <a:t>iris: cero faltantes en sus 150 filas... y aun así tiene una fila duplicada. Hasta el dataset más famoso trae un problema de calidad.</a:t>
             </a:r>
           </a:p>
           <a:p>
@@ -9547,7 +9499,7 @@
                 </a:solidFill>
                 <a:latin typeface="Fira Sans"/>
               </a:rPr>
-              <a:t>En la EOD: TiempoViaje tiene 278 faltantes entre 113.591 viajes.</a:t>
+              <a:t>La EOD: 278 duraciones faltantes, códigos que traducir, colas sospechosas y factores que son NaN por diseño.</a:t>
             </a:r>
           </a:p>
           <a:p>
@@ -9575,35 +9527,7 @@
                 </a:solidFill>
                 <a:latin typeface="Fira Sans"/>
               </a:rPr>
-              <a:t>Un NaN no siempre es error: en los factores de expansión significa "no aplica".</a:t>
-            </a:r>
-          </a:p>
-          <a:p>
-            <a:pPr>
-              <a:lnSpc>
-                <a:spcPct val="112000"/>
-              </a:lnSpc>
-              <a:spcAft>
-                <a:spcPts val="900"/>
-              </a:spcAft>
-            </a:pPr>
-            <a:r>
-              <a:rPr sz="1800" b="1">
-                <a:solidFill>
-                  <a:srgbClr val="E0A437"/>
-                </a:solidFill>
-                <a:latin typeface="Fira Sans"/>
-              </a:rPr>
-              <a:t>▸ </a:t>
-            </a:r>
-            <a:r>
-              <a:rPr sz="1800" b="0">
-                <a:solidFill>
-                  <a:srgbClr val="000000"/>
-                </a:solidFill>
-                <a:latin typeface="Fira Sans"/>
-              </a:rPr>
-              <a:t>Opciones: eliminar, imputar o dejar que cada cálculo los excluya. Lo obligatorio: decidir y documentar.</a:t>
+              <a:t>Por eso el checklist de calidad se aplica siempre, también al dataset del proyecto.</a:t>
             </a:r>
           </a:p>
         </p:txBody>
@@ -9699,7 +9623,7 @@
                 </a:solidFill>
                 <a:latin typeface="Fira Sans"/>
               </a:rPr>
-              <a:t>Duplicados</a:t>
+              <a:t>Valores faltantes</a:t>
             </a:r>
           </a:p>
         </p:txBody>
@@ -9750,7 +9674,7 @@
                 </a:solidFill>
                 <a:latin typeface="Fira Sans"/>
               </a:rPr>
-              <a:t>duplicated() marca filas repetidas; drop_duplicates() las elimina.</a:t>
+              <a:t>Detección: isna().sum(), o el count de describe() contra len.</a:t>
             </a:r>
           </a:p>
           <a:p>
@@ -9778,7 +9702,7 @@
                 </a:solidFill>
                 <a:latin typeface="Fira Sans"/>
               </a:rPr>
-              <a:t>Dos niveles: la fila completa y la llave que debería ser única.</a:t>
+              <a:t>En la EOD: TiempoViaje tiene 278 faltantes entre 113.591 viajes.</a:t>
             </a:r>
           </a:p>
           <a:p>
@@ -9800,13 +9724,13 @@
               <a:t>▸ </a:t>
             </a:r>
             <a:r>
-              <a:rPr sz="1800" b="0">
-                <a:solidFill>
-                  <a:srgbClr val="000000"/>
-                </a:solidFill>
-                <a:latin typeface="Fira Sans"/>
-              </a:rPr>
-              <a:t>En la EOD ambos chequeos dan cero; un cero también es un hallazgo.</a:t>
+              <a:rPr sz="1800" b="1">
+                <a:solidFill>
+                  <a:srgbClr val="1D3557"/>
+                </a:solidFill>
+                <a:latin typeface="Fira Sans"/>
+              </a:rPr>
+              <a:t>Un NaN no siempre es error: en los factores de expansión significa "no aplica".</a:t>
             </a:r>
           </a:p>
           <a:p>
@@ -9834,7 +9758,7 @@
                 </a:solidFill>
                 <a:latin typeface="Fira Sans"/>
               </a:rPr>
-              <a:t>El riesgo típico: un merge con llaves repetidas multiplica filas.</a:t>
+              <a:t>Opciones: eliminar, imputar o dejar que cada cálculo los excluya. Lo obligatorio: decidir y documentar.</a:t>
             </a:r>
           </a:p>
         </p:txBody>
@@ -10084,45 +10008,21 @@
                 </a:solidFill>
                 <a:latin typeface="Fira Sans"/>
               </a:rPr>
-              <a:t>Valores sospechosos</a:t>
-            </a:r>
-          </a:p>
-        </p:txBody>
-      </p:sp>
-      <p:pic>
-        <p:nvPicPr>
-          <p:cNvPr id="4" name="Picture 3" descr="05_cola_imposibles.png"/>
-          <p:cNvPicPr>
-            <a:picLocks noChangeAspect="1"/>
-          </p:cNvPicPr>
-          <p:nvPr/>
-        </p:nvPicPr>
-        <p:blipFill>
-          <a:blip r:embed="rId2"/>
-          <a:stretch>
-            <a:fillRect/>
-          </a:stretch>
-        </p:blipFill>
-        <p:spPr>
-          <a:xfrm>
-            <a:off x="1648218" y="1143000"/>
-            <a:ext cx="5847563" cy="3154680"/>
-          </a:xfrm>
-          <a:prstGeom prst="rect">
-            <a:avLst/>
-          </a:prstGeom>
-        </p:spPr>
-      </p:pic>
-      <p:sp>
-        <p:nvSpPr>
-          <p:cNvPr id="5" name="TextBox 4"/>
+              <a:t>Duplicados</a:t>
+            </a:r>
+          </a:p>
+        </p:txBody>
+      </p:sp>
+      <p:sp>
+        <p:nvSpPr>
+          <p:cNvPr id="4" name="TextBox 3"/>
           <p:cNvSpPr txBox="1"/>
           <p:nvPr/>
         </p:nvSpPr>
         <p:spPr>
           <a:xfrm>
-            <a:off x="704088" y="4434840"/>
-            <a:ext cx="7744968" cy="457200"/>
+            <a:off x="704088" y="1353312"/>
+            <a:ext cx="7744968" cy="3300984"/>
           </a:xfrm>
           <a:prstGeom prst="rect">
             <a:avLst/>
@@ -10135,14 +10035,115 @@
           </a:bodyPr>
           <a:lstStyle/>
           <a:p>
-            <a:r>
-              <a:rPr sz="1300" b="0">
-                <a:solidFill>
-                  <a:srgbClr val="333333"/>
-                </a:solidFill>
-                <a:latin typeface="Fira Sans"/>
-              </a:rPr>
-              <a:t>116 viajes declaran más de 5 horas y el máximo es de 22 horas. ¿Error de registro o viaje real? La respuesta exige criterio del dominio; la decisión (mantener, corregir o excluir) se toma en el código y se documenta.</a:t>
+            <a:pPr>
+              <a:lnSpc>
+                <a:spcPct val="112000"/>
+              </a:lnSpc>
+              <a:spcAft>
+                <a:spcPts val="900"/>
+              </a:spcAft>
+            </a:pPr>
+            <a:r>
+              <a:rPr sz="1800" b="1">
+                <a:solidFill>
+                  <a:srgbClr val="E0A437"/>
+                </a:solidFill>
+                <a:latin typeface="Fira Sans"/>
+              </a:rPr>
+              <a:t>▸ </a:t>
+            </a:r>
+            <a:r>
+              <a:rPr sz="1800" b="0">
+                <a:solidFill>
+                  <a:srgbClr val="000000"/>
+                </a:solidFill>
+                <a:latin typeface="Fira Sans"/>
+              </a:rPr>
+              <a:t>duplicated() marca filas repetidas; drop_duplicates() las elimina.</a:t>
+            </a:r>
+          </a:p>
+          <a:p>
+            <a:pPr>
+              <a:lnSpc>
+                <a:spcPct val="112000"/>
+              </a:lnSpc>
+              <a:spcAft>
+                <a:spcPts val="900"/>
+              </a:spcAft>
+            </a:pPr>
+            <a:r>
+              <a:rPr sz="1800" b="1">
+                <a:solidFill>
+                  <a:srgbClr val="E0A437"/>
+                </a:solidFill>
+                <a:latin typeface="Fira Sans"/>
+              </a:rPr>
+              <a:t>▸ </a:t>
+            </a:r>
+            <a:r>
+              <a:rPr sz="1800" b="0">
+                <a:solidFill>
+                  <a:srgbClr val="000000"/>
+                </a:solidFill>
+                <a:latin typeface="Fira Sans"/>
+              </a:rPr>
+              <a:t>Dos niveles: la fila completa y la llave que debería ser única.</a:t>
+            </a:r>
+          </a:p>
+          <a:p>
+            <a:pPr>
+              <a:lnSpc>
+                <a:spcPct val="112000"/>
+              </a:lnSpc>
+              <a:spcAft>
+                <a:spcPts val="900"/>
+              </a:spcAft>
+            </a:pPr>
+            <a:r>
+              <a:rPr sz="1800" b="1">
+                <a:solidFill>
+                  <a:srgbClr val="E0A437"/>
+                </a:solidFill>
+                <a:latin typeface="Fira Sans"/>
+              </a:rPr>
+              <a:t>▸ </a:t>
+            </a:r>
+            <a:r>
+              <a:rPr sz="1800" b="0">
+                <a:solidFill>
+                  <a:srgbClr val="000000"/>
+                </a:solidFill>
+                <a:latin typeface="Fira Sans"/>
+              </a:rPr>
+              <a:t>En la EOD ambos chequeos dan cero; un cero también es un hallazgo.</a:t>
+            </a:r>
+          </a:p>
+          <a:p>
+            <a:pPr>
+              <a:lnSpc>
+                <a:spcPct val="112000"/>
+              </a:lnSpc>
+              <a:spcAft>
+                <a:spcPts val="900"/>
+              </a:spcAft>
+            </a:pPr>
+            <a:r>
+              <a:rPr sz="1800" b="1">
+                <a:solidFill>
+                  <a:srgbClr val="E0A437"/>
+                </a:solidFill>
+                <a:latin typeface="Fira Sans"/>
+              </a:rPr>
+              <a:t>▸ </a:t>
+            </a:r>
+            <a:r>
+              <a:rPr sz="1800" b="0">
+                <a:solidFill>
+                  <a:srgbClr val="000000"/>
+                </a:solidFill>
+                <a:latin typeface="Fira Sans"/>
+              </a:rPr>
+              <a:t>El riesgo típico: un merge con llaves repetidas multiplica filas.</a:t>
             </a:r>
           </a:p>
         </p:txBody>
@@ -10238,90 +10239,35 @@
                 </a:solidFill>
                 <a:latin typeface="Fira Sans"/>
               </a:rPr>
-              <a:t>Tapar valores con mask</a:t>
-            </a:r>
-          </a:p>
-        </p:txBody>
-      </p:sp>
-      <p:sp>
-        <p:nvSpPr>
-          <p:cNvPr id="4" name="Rectangle 3"/>
-          <p:cNvSpPr/>
-          <p:nvPr/>
-        </p:nvSpPr>
-        <p:spPr>
-          <a:xfrm>
-            <a:off x="704088" y="1280160"/>
-            <a:ext cx="7744968" cy="1874520"/>
-          </a:xfrm>
-          <a:prstGeom prst="rect">
-            <a:avLst/>
-          </a:prstGeom>
-          <a:solidFill>
-            <a:srgbClr val="F0F2F5"/>
-          </a:solidFill>
-          <a:ln>
-            <a:solidFill>
-              <a:srgbClr val="D8DDE3"/>
-            </a:solidFill>
-          </a:ln>
-          <a:effectLst/>
-        </p:spPr>
-        <p:style>
-          <a:lnRef idx="1">
-            <a:schemeClr val="accent1"/>
-          </a:lnRef>
-          <a:fillRef idx="3">
-            <a:schemeClr val="accent1"/>
-          </a:fillRef>
-          <a:effectRef idx="2">
-            <a:schemeClr val="accent1"/>
-          </a:effectRef>
-          <a:fontRef idx="minor">
-            <a:schemeClr val="lt1"/>
-          </a:fontRef>
-        </p:style>
-        <p:txBody>
-          <a:bodyPr rtlCol="0" anchor="ctr" wrap="square" lIns="228600" tIns="137160"/>
-          <a:lstStyle/>
-          <a:p>
-            <a:pPr/>
-            <a:r>
-              <a:rPr sz="1500" b="0">
-                <a:solidFill>
-                  <a:srgbClr val="1D3557"/>
-                </a:solidFill>
-                <a:latin typeface="Menlo"/>
-              </a:rPr>
-              <a:t># donde la condición se cumple, reemplaza (aquí, por NaN)</a:t>
-            </a:r>
-          </a:p>
-          <a:p>
-            <a:pPr/>
-            <a:r>
-              <a:rPr sz="1500" b="0">
-                <a:solidFill>
-                  <a:srgbClr val="1D3557"/>
-                </a:solidFill>
-                <a:latin typeface="Menlo"/>
-              </a:rPr>
-              <a:t>viajes["TiempoViaje"] = viajes["TiempoViaje"].mask(</a:t>
-            </a:r>
-          </a:p>
-          <a:p>
-            <a:pPr/>
-            <a:r>
-              <a:rPr sz="1500" b="0">
-                <a:solidFill>
-                  <a:srgbClr val="1D3557"/>
-                </a:solidFill>
-                <a:latin typeface="Menlo"/>
-              </a:rPr>
-              <a:t>    viajes["TiempoViaje"] &gt; 300)</a:t>
-            </a:r>
-          </a:p>
-        </p:txBody>
-      </p:sp>
+              <a:t>Valores sospechosos</a:t>
+            </a:r>
+          </a:p>
+        </p:txBody>
+      </p:sp>
+      <p:pic>
+        <p:nvPicPr>
+          <p:cNvPr id="4" name="Picture 3" descr="05_cola_imposibles.png"/>
+          <p:cNvPicPr>
+            <a:picLocks noChangeAspect="1"/>
+          </p:cNvPicPr>
+          <p:nvPr/>
+        </p:nvPicPr>
+        <p:blipFill>
+          <a:blip r:embed="rId2"/>
+          <a:stretch>
+            <a:fillRect/>
+          </a:stretch>
+        </p:blipFill>
+        <p:spPr>
+          <a:xfrm>
+            <a:off x="1648218" y="1143000"/>
+            <a:ext cx="5847563" cy="3154680"/>
+          </a:xfrm>
+          <a:prstGeom prst="rect">
+            <a:avLst/>
+          </a:prstGeom>
+        </p:spPr>
+      </p:pic>
       <p:sp>
         <p:nvSpPr>
           <p:cNvPr id="5" name="TextBox 4"/>
@@ -10330,8 +10276,8 @@
         </p:nvSpPr>
         <p:spPr>
           <a:xfrm>
-            <a:off x="704088" y="3383279"/>
-            <a:ext cx="7744968" cy="1097280"/>
+            <a:off x="704088" y="4434840"/>
+            <a:ext cx="7744968" cy="457200"/>
           </a:xfrm>
           <a:prstGeom prst="rect">
             <a:avLst/>
@@ -10344,31 +10290,14 @@
           </a:bodyPr>
           <a:lstStyle/>
           <a:p>
-            <a:pPr>
-              <a:lnSpc>
-                <a:spcPct val="112000"/>
-              </a:lnSpc>
-              <a:spcAft>
-                <a:spcPts val="900"/>
-              </a:spcAft>
-            </a:pPr>
-            <a:r>
-              <a:rPr sz="1600" b="1">
-                <a:solidFill>
-                  <a:srgbClr val="E0A437"/>
-                </a:solidFill>
-                <a:latin typeface="Fira Sans"/>
-              </a:rPr>
-              <a:t>▸ </a:t>
-            </a:r>
-            <a:r>
-              <a:rPr sz="1600" b="0">
-                <a:solidFill>
-                  <a:srgbClr val="000000"/>
-                </a:solidFill>
-                <a:latin typeface="Fira Sans"/>
-              </a:rPr>
-              <a:t>mask reemplaza donde la condición es verdadera; where, su espejo, conserva donde es verdadera y reemplaza el resto. Regla nemotécnica: mask es dónde tapar, where es dónde quedarse.</a:t>
+            <a:r>
+              <a:rPr sz="1300" b="0">
+                <a:solidFill>
+                  <a:srgbClr val="333333"/>
+                </a:solidFill>
+                <a:latin typeface="Fira Sans"/>
+              </a:rPr>
+              <a:t>116 viajes declaran más de 5 horas y el máximo es de 22 horas. ¿Error de registro o viaje real? La respuesta exige criterio del dominio; la decisión (mantener, corregir o excluir) se toma en el código y se documenta.</a:t>
             </a:r>
           </a:p>
         </p:txBody>
@@ -10464,21 +10393,100 @@
                 </a:solidFill>
                 <a:latin typeface="Fira Sans"/>
               </a:rPr>
-              <a:t>Revisar cada merge</a:t>
-            </a:r>
-          </a:p>
-        </p:txBody>
-      </p:sp>
-      <p:sp>
-        <p:nvSpPr>
-          <p:cNvPr id="4" name="TextBox 3"/>
+              <a:t>Tapar valores con mask</a:t>
+            </a:r>
+          </a:p>
+        </p:txBody>
+      </p:sp>
+      <p:sp>
+        <p:nvSpPr>
+          <p:cNvPr id="4" name="Rectangle 3"/>
+          <p:cNvSpPr/>
+          <p:nvPr/>
+        </p:nvSpPr>
+        <p:spPr>
+          <a:xfrm>
+            <a:off x="704088" y="1280160"/>
+            <a:ext cx="7744968" cy="1874520"/>
+          </a:xfrm>
+          <a:prstGeom prst="rect">
+            <a:avLst/>
+          </a:prstGeom>
+          <a:solidFill>
+            <a:srgbClr val="F0F2F5"/>
+          </a:solidFill>
+          <a:ln>
+            <a:solidFill>
+              <a:srgbClr val="D8DDE3"/>
+            </a:solidFill>
+          </a:ln>
+          <a:effectLst/>
+        </p:spPr>
+        <p:style>
+          <a:lnRef idx="1">
+            <a:schemeClr val="accent1"/>
+          </a:lnRef>
+          <a:fillRef idx="3">
+            <a:schemeClr val="accent1"/>
+          </a:fillRef>
+          <a:effectRef idx="2">
+            <a:schemeClr val="accent1"/>
+          </a:effectRef>
+          <a:fontRef idx="minor">
+            <a:schemeClr val="lt1"/>
+          </a:fontRef>
+        </p:style>
+        <p:txBody>
+          <a:bodyPr rtlCol="0" anchor="ctr" wrap="square" lIns="228600" tIns="137160"/>
+          <a:lstStyle/>
+          <a:p>
+            <a:pPr/>
+            <a:r>
+              <a:rPr sz="1500" b="0">
+                <a:solidFill>
+                  <a:srgbClr val="1D3557"/>
+                </a:solidFill>
+                <a:latin typeface="Menlo"/>
+              </a:rPr>
+              <a:t># donde la condición se cumple, reemplaza (aquí, por NaN)</a:t>
+            </a:r>
+          </a:p>
+          <a:p>
+            <a:pPr/>
+            <a:r>
+              <a:rPr sz="1500" b="0">
+                <a:solidFill>
+                  <a:srgbClr val="1D3557"/>
+                </a:solidFill>
+                <a:latin typeface="Menlo"/>
+              </a:rPr>
+              <a:t>viajes["TiempoViaje"] = viajes["TiempoViaje"].mask(</a:t>
+            </a:r>
+          </a:p>
+          <a:p>
+            <a:pPr/>
+            <a:r>
+              <a:rPr sz="1500" b="0">
+                <a:solidFill>
+                  <a:srgbClr val="1D3557"/>
+                </a:solidFill>
+                <a:latin typeface="Menlo"/>
+              </a:rPr>
+              <a:t>    viajes["TiempoViaje"] &gt; 300)</a:t>
+            </a:r>
+          </a:p>
+        </p:txBody>
+      </p:sp>
+      <p:sp>
+        <p:nvSpPr>
+          <p:cNvPr id="5" name="TextBox 4"/>
           <p:cNvSpPr txBox="1"/>
           <p:nvPr/>
         </p:nvSpPr>
         <p:spPr>
           <a:xfrm>
-            <a:off x="704088" y="1353312"/>
-            <a:ext cx="7744968" cy="3300984"/>
+            <a:off x="704088" y="3383279"/>
+            <a:ext cx="7744968" cy="1097280"/>
           </a:xfrm>
           <a:prstGeom prst="rect">
             <a:avLst/>
@@ -10500,7 +10508,7 @@
               </a:spcAft>
             </a:pPr>
             <a:r>
-              <a:rPr sz="1800" b="1">
+              <a:rPr sz="1600" b="1">
                 <a:solidFill>
                   <a:srgbClr val="E0A437"/>
                 </a:solidFill>
@@ -10509,69 +10517,13 @@
               <a:t>▸ </a:t>
             </a:r>
             <a:r>
-              <a:rPr sz="1800" b="0">
+              <a:rPr sz="1600" b="0">
                 <a:solidFill>
                   <a:srgbClr val="000000"/>
                 </a:solidFill>
                 <a:latin typeface="Fira Sans"/>
               </a:rPr>
-              <a:t>Comparar el número de filas antes y después: un inner descarta las filas sin pareja; en la clase 1, 113.591 viajes quedaron en 111.393.</a:t>
-            </a:r>
-          </a:p>
-          <a:p>
-            <a:pPr>
-              <a:lnSpc>
-                <a:spcPct val="112000"/>
-              </a:lnSpc>
-              <a:spcAft>
-                <a:spcPts val="900"/>
-              </a:spcAft>
-            </a:pPr>
-            <a:r>
-              <a:rPr sz="1800" b="1">
-                <a:solidFill>
-                  <a:srgbClr val="E0A437"/>
-                </a:solidFill>
-                <a:latin typeface="Fira Sans"/>
-              </a:rPr>
-              <a:t>▸ </a:t>
-            </a:r>
-            <a:r>
-              <a:rPr sz="1800" b="0">
-                <a:solidFill>
-                  <a:srgbClr val="000000"/>
-                </a:solidFill>
-                <a:latin typeface="Fira Sans"/>
-              </a:rPr>
-              <a:t>Contar los NaN de las columnas nuevas cuando se usa how="left": ahí quedan visibles las filas sin correspondencia (2.198 comunas).</a:t>
-            </a:r>
-          </a:p>
-          <a:p>
-            <a:pPr>
-              <a:lnSpc>
-                <a:spcPct val="112000"/>
-              </a:lnSpc>
-              <a:spcAft>
-                <a:spcPts val="900"/>
-              </a:spcAft>
-            </a:pPr>
-            <a:r>
-              <a:rPr sz="1800" b="1">
-                <a:solidFill>
-                  <a:srgbClr val="E0A437"/>
-                </a:solidFill>
-                <a:latin typeface="Fira Sans"/>
-              </a:rPr>
-              <a:t>▸ </a:t>
-            </a:r>
-            <a:r>
-              <a:rPr sz="1800" b="0">
-                <a:solidFill>
-                  <a:srgbClr val="000000"/>
-                </a:solidFill>
-                <a:latin typeface="Fira Sans"/>
-              </a:rPr>
-              <a:t>Verificar que la llave sea única en la tabla de parámetros: si está repetida, el merge multiplica filas.</a:t>
+              <a:t>mask reemplaza donde la condición es verdadera; where, su espejo, conserva donde es verdadera y reemplaza el resto. Regla nemotécnica: mask es dónde tapar, where es dónde quedarse.</a:t>
             </a:r>
           </a:p>
         </p:txBody>
@@ -10585,6 +10537,209 @@
 </file>
 
 <file path=ppt/slides/slide43.xml><?xml version="1.0" encoding="utf-8"?>
+<p:sld xmlns:a="http://schemas.openxmlformats.org/drawingml/2006/main" xmlns:p="http://schemas.openxmlformats.org/presentationml/2006/main" xmlns:r="http://schemas.openxmlformats.org/officeDocument/2006/relationships">
+  <p:cSld>
+    <p:spTree>
+      <p:nvGrpSpPr>
+        <p:cNvPr id="1" name=""/>
+        <p:cNvGrpSpPr/>
+        <p:nvPr/>
+      </p:nvGrpSpPr>
+      <p:grpSpPr/>
+      <p:sp>
+        <p:nvSpPr>
+          <p:cNvPr id="2" name="Rectangle 1"/>
+          <p:cNvSpPr/>
+          <p:nvPr/>
+        </p:nvSpPr>
+        <p:spPr>
+          <a:xfrm>
+            <a:off x="0" y="0"/>
+            <a:ext cx="9144000" cy="5138928"/>
+          </a:xfrm>
+          <a:prstGeom prst="rect">
+            <a:avLst/>
+          </a:prstGeom>
+          <a:solidFill>
+            <a:srgbClr val="FAFBFC"/>
+          </a:solidFill>
+          <a:ln>
+            <a:noFill/>
+          </a:ln>
+          <a:effectLst/>
+        </p:spPr>
+        <p:style>
+          <a:lnRef idx="1">
+            <a:schemeClr val="accent1"/>
+          </a:lnRef>
+          <a:fillRef idx="3">
+            <a:schemeClr val="accent1"/>
+          </a:fillRef>
+          <a:effectRef idx="2">
+            <a:schemeClr val="accent1"/>
+          </a:effectRef>
+          <a:fontRef idx="minor">
+            <a:schemeClr val="lt1"/>
+          </a:fontRef>
+        </p:style>
+        <p:txBody>
+          <a:bodyPr rtlCol="0" anchor="ctr"/>
+          <a:lstStyle/>
+          <a:p>
+            <a:pPr algn="ctr"/>
+          </a:p>
+        </p:txBody>
+      </p:sp>
+      <p:sp>
+        <p:nvSpPr>
+          <p:cNvPr id="3" name="TextBox 2"/>
+          <p:cNvSpPr txBox="1"/>
+          <p:nvPr/>
+        </p:nvSpPr>
+        <p:spPr>
+          <a:xfrm>
+            <a:off x="402336" y="301752"/>
+            <a:ext cx="8348472" cy="795528"/>
+          </a:xfrm>
+          <a:prstGeom prst="rect">
+            <a:avLst/>
+          </a:prstGeom>
+          <a:noFill/>
+        </p:spPr>
+        <p:txBody>
+          <a:bodyPr wrap="square">
+            <a:spAutoFit/>
+          </a:bodyPr>
+          <a:lstStyle/>
+          <a:p>
+            <a:r>
+              <a:rPr sz="2800" b="1">
+                <a:solidFill>
+                  <a:srgbClr val="0F0F0F"/>
+                </a:solidFill>
+                <a:latin typeface="Fira Sans"/>
+              </a:rPr>
+              <a:t>Revisar cada merge</a:t>
+            </a:r>
+          </a:p>
+        </p:txBody>
+      </p:sp>
+      <p:sp>
+        <p:nvSpPr>
+          <p:cNvPr id="4" name="TextBox 3"/>
+          <p:cNvSpPr txBox="1"/>
+          <p:nvPr/>
+        </p:nvSpPr>
+        <p:spPr>
+          <a:xfrm>
+            <a:off x="704088" y="1353312"/>
+            <a:ext cx="7744968" cy="3300984"/>
+          </a:xfrm>
+          <a:prstGeom prst="rect">
+            <a:avLst/>
+          </a:prstGeom>
+          <a:noFill/>
+        </p:spPr>
+        <p:txBody>
+          <a:bodyPr wrap="square">
+            <a:spAutoFit/>
+          </a:bodyPr>
+          <a:lstStyle/>
+          <a:p>
+            <a:pPr>
+              <a:lnSpc>
+                <a:spcPct val="112000"/>
+              </a:lnSpc>
+              <a:spcAft>
+                <a:spcPts val="900"/>
+              </a:spcAft>
+            </a:pPr>
+            <a:r>
+              <a:rPr sz="1800" b="1">
+                <a:solidFill>
+                  <a:srgbClr val="E0A437"/>
+                </a:solidFill>
+                <a:latin typeface="Fira Sans"/>
+              </a:rPr>
+              <a:t>▸ </a:t>
+            </a:r>
+            <a:r>
+              <a:rPr sz="1800" b="0">
+                <a:solidFill>
+                  <a:srgbClr val="000000"/>
+                </a:solidFill>
+                <a:latin typeface="Fira Sans"/>
+              </a:rPr>
+              <a:t>Comparar el número de filas antes y después: un inner descarta las filas sin pareja; en la clase 1, 113.591 viajes quedaron en 111.393.</a:t>
+            </a:r>
+          </a:p>
+          <a:p>
+            <a:pPr>
+              <a:lnSpc>
+                <a:spcPct val="112000"/>
+              </a:lnSpc>
+              <a:spcAft>
+                <a:spcPts val="900"/>
+              </a:spcAft>
+            </a:pPr>
+            <a:r>
+              <a:rPr sz="1800" b="1">
+                <a:solidFill>
+                  <a:srgbClr val="E0A437"/>
+                </a:solidFill>
+                <a:latin typeface="Fira Sans"/>
+              </a:rPr>
+              <a:t>▸ </a:t>
+            </a:r>
+            <a:r>
+              <a:rPr sz="1800" b="0">
+                <a:solidFill>
+                  <a:srgbClr val="000000"/>
+                </a:solidFill>
+                <a:latin typeface="Fira Sans"/>
+              </a:rPr>
+              <a:t>Contar los NaN de las columnas nuevas cuando se usa how="left": ahí quedan visibles las filas sin correspondencia (2.198 comunas).</a:t>
+            </a:r>
+          </a:p>
+          <a:p>
+            <a:pPr>
+              <a:lnSpc>
+                <a:spcPct val="112000"/>
+              </a:lnSpc>
+              <a:spcAft>
+                <a:spcPts val="900"/>
+              </a:spcAft>
+            </a:pPr>
+            <a:r>
+              <a:rPr sz="1800" b="1">
+                <a:solidFill>
+                  <a:srgbClr val="E0A437"/>
+                </a:solidFill>
+                <a:latin typeface="Fira Sans"/>
+              </a:rPr>
+              <a:t>▸ </a:t>
+            </a:r>
+            <a:r>
+              <a:rPr sz="1800" b="0">
+                <a:solidFill>
+                  <a:srgbClr val="000000"/>
+                </a:solidFill>
+                <a:latin typeface="Fira Sans"/>
+              </a:rPr>
+              <a:t>Verificar que la llave sea única en la tabla de parámetros: si está repetida, el merge multiplica filas.</a:t>
+            </a:r>
+          </a:p>
+        </p:txBody>
+      </p:sp>
+    </p:spTree>
+  </p:cSld>
+  <p:clrMapOvr>
+    <a:masterClrMapping/>
+  </p:clrMapOvr>
+</p:sld>
+</file>
+
+<file path=ppt/slides/slide44.xml><?xml version="1.0" encoding="utf-8"?>
 <p:sld xmlns:a="http://schemas.openxmlformats.org/drawingml/2006/main" xmlns:p="http://schemas.openxmlformats.org/presentationml/2006/main" xmlns:r="http://schemas.openxmlformats.org/officeDocument/2006/relationships">
   <p:cSld>
     <p:spTree>
@@ -11076,7 +11231,7 @@
 </p:sld>
 </file>
 
-<file path=ppt/slides/slide44.xml><?xml version="1.0" encoding="utf-8"?>
+<file path=ppt/slides/slide45.xml><?xml version="1.0" encoding="utf-8"?>
 <p:sld xmlns:a="http://schemas.openxmlformats.org/drawingml/2006/main" xmlns:p="http://schemas.openxmlformats.org/presentationml/2006/main" xmlns:r="http://schemas.openxmlformats.org/officeDocument/2006/relationships">
   <p:cSld>
     <p:spTree>
@@ -11335,7 +11490,7 @@
 </p:sld>
 </file>
 
-<file path=ppt/slides/slide45.xml><?xml version="1.0" encoding="utf-8"?>
+<file path=ppt/slides/slide46.xml><?xml version="1.0" encoding="utf-8"?>
 <p:sld xmlns:a="http://schemas.openxmlformats.org/drawingml/2006/main" xmlns:p="http://schemas.openxmlformats.org/presentationml/2006/main" xmlns:r="http://schemas.openxmlformats.org/officeDocument/2006/relationships">
   <p:cSld>
     <p:spTree>

</xml_diff>

<commit_message>
Clase 2: diapos del IQR calculado sobre los diagramas de percentiles (iris y EOD)
Co-Authored-By: Claude Fable 5 <noreply@anthropic.com>
</commit_message>
<xml_diff>
--- a/presentaciones/clase02_eda_descriptiva.pptx
+++ b/presentaciones/clase02_eda_descriptiva.pptx
@@ -51,6 +51,8 @@
     <p:sldId id="299" r:id="rId50"/>
     <p:sldId id="300" r:id="rId51"/>
     <p:sldId id="301" r:id="rId52"/>
+    <p:sldId id="302" r:id="rId53"/>
+    <p:sldId id="303" r:id="rId54"/>
   </p:sldIdLst>
   <p:sldSz cx="9144000" cy="5138928" type="screen4x3"/>
   <p:notesSz cx="6858000" cy="9144000"/>
@@ -8442,14 +8444,14 @@
                 </a:solidFill>
                 <a:latin typeface="Fira Sans"/>
               </a:rPr>
-              <a:t>La media no basta</a:t>
+              <a:t>El IQR en iris</a:t>
             </a:r>
           </a:p>
         </p:txBody>
       </p:sp>
       <p:pic>
         <p:nvPicPr>
-          <p:cNvPr id="4" name="Picture 3" descr="02_dispersion_comunas.png"/>
+          <p:cNvPr id="4" name="Picture 3" descr="20_iqr_iris.png"/>
           <p:cNvPicPr>
             <a:picLocks noChangeAspect="1"/>
           </p:cNvPicPr>
@@ -8463,8 +8465,8 @@
         </p:blipFill>
         <p:spPr>
           <a:xfrm>
-            <a:off x="1822348" y="1143000"/>
-            <a:ext cx="5499302" cy="3154680"/>
+            <a:off x="1417319" y="1143000"/>
+            <a:ext cx="6309360" cy="2571587"/>
           </a:xfrm>
           <a:prstGeom prst="rect">
             <a:avLst/>
@@ -8500,7 +8502,7 @@
                 </a:solidFill>
                 <a:latin typeface="Fira Sans"/>
               </a:rPr>
-              <a:t>Providencia y Talagante tienen la misma duración media de viaje (40,7 minutos), pero la desviación estándar de Talagante es el doble: dos realidades distintas detrás del mismo promedio.</a:t>
+              <a:t>Entre Q1 y Q3 queda el 50% central de las flores. El IQR es el ancho de ese tramo: 6,4 − 5,1 = 1,3 cm.</a:t>
             </a:r>
           </a:p>
         </p:txBody>
@@ -8596,14 +8598,14 @@
                 </a:solidFill>
                 <a:latin typeface="Fira Sans"/>
               </a:rPr>
-              <a:t>El boxplot</a:t>
+              <a:t>El IQR en la duración</a:t>
             </a:r>
           </a:p>
         </p:txBody>
       </p:sp>
       <p:pic>
         <p:nvPicPr>
-          <p:cNvPr id="4" name="Picture 3" descr="03_boxplot_anatomia.png"/>
+          <p:cNvPr id="4" name="Picture 3" descr="21_iqr_eod.png"/>
           <p:cNvPicPr>
             <a:picLocks noChangeAspect="1"/>
           </p:cNvPicPr>
@@ -8617,8 +8619,8 @@
         </p:blipFill>
         <p:spPr>
           <a:xfrm>
-            <a:off x="1740020" y="1143000"/>
-            <a:ext cx="5663958" cy="3154680"/>
+            <a:off x="1417319" y="1143000"/>
+            <a:ext cx="6309360" cy="2574638"/>
           </a:xfrm>
           <a:prstGeom prst="rect">
             <a:avLst/>
@@ -8654,7 +8656,7 @@
                 </a:solidFill>
                 <a:latin typeface="Fira Sans"/>
               </a:rPr>
-              <a:t>Cinco números en un solo gráfico: mediana, cuartiles, bigotes y valores atípicos. La regla de los bigotes (1,5 veces el IQR) es una convención para marcar valores inusuales, no un veredicto.</a:t>
+              <a:t>El 50% central de los viajes cabe en 35 minutos. La mitad central es angosta; lo que se estira es la cola, y al IQR eso no lo afecta.</a:t>
             </a:r>
           </a:p>
         </p:txBody>
@@ -8750,149 +8752,14 @@
                 </a:solidFill>
                 <a:latin typeface="Fira Sans"/>
               </a:rPr>
-              <a:t>Valores atípicos (outliers)</a:t>
-            </a:r>
-          </a:p>
-        </p:txBody>
-      </p:sp>
-      <p:sp>
-        <p:nvSpPr>
-          <p:cNvPr id="4" name="TextBox 3"/>
-          <p:cNvSpPr txBox="1"/>
-          <p:nvPr/>
-        </p:nvSpPr>
-        <p:spPr>
-          <a:xfrm>
-            <a:off x="502920" y="1252728"/>
-            <a:ext cx="4023360" cy="3200400"/>
-          </a:xfrm>
-          <a:prstGeom prst="rect">
-            <a:avLst/>
-          </a:prstGeom>
-          <a:noFill/>
-        </p:spPr>
-        <p:txBody>
-          <a:bodyPr wrap="square">
-            <a:spAutoFit/>
-          </a:bodyPr>
-          <a:lstStyle/>
-          <a:p>
-            <a:pPr>
-              <a:lnSpc>
-                <a:spcPct val="112000"/>
-              </a:lnSpc>
-              <a:spcAft>
-                <a:spcPts val="900"/>
-              </a:spcAft>
-            </a:pPr>
-            <a:r>
-              <a:rPr sz="1500" b="1">
-                <a:solidFill>
-                  <a:srgbClr val="E0A437"/>
-                </a:solidFill>
-                <a:latin typeface="Fira Sans"/>
-              </a:rPr>
-              <a:t>▸ </a:t>
-            </a:r>
-            <a:r>
-              <a:rPr sz="1500" b="1">
-                <a:solidFill>
-                  <a:srgbClr val="1D3557"/>
-                </a:solidFill>
-                <a:latin typeface="Fira Sans"/>
-              </a:rPr>
-              <a:t>Un valor atípico es una observación que se aleja notoriamente del resto.</a:t>
-            </a:r>
-          </a:p>
-          <a:p>
-            <a:pPr>
-              <a:lnSpc>
-                <a:spcPct val="112000"/>
-              </a:lnSpc>
-              <a:spcAft>
-                <a:spcPts val="900"/>
-              </a:spcAft>
-            </a:pPr>
-            <a:r>
-              <a:rPr sz="1500" b="1">
-                <a:solidFill>
-                  <a:srgbClr val="E0A437"/>
-                </a:solidFill>
-                <a:latin typeface="Fira Sans"/>
-              </a:rPr>
-              <a:t>▸ </a:t>
-            </a:r>
-            <a:r>
-              <a:rPr sz="1500" b="0">
-                <a:solidFill>
-                  <a:srgbClr val="000000"/>
-                </a:solidFill>
-                <a:latin typeface="Fira Sans"/>
-              </a:rPr>
-              <a:t>Convención de Tukey: fuera de Q1 − 1,5·IQR y de Q3 + 1,5·IQR.</a:t>
-            </a:r>
-          </a:p>
-          <a:p>
-            <a:pPr>
-              <a:lnSpc>
-                <a:spcPct val="112000"/>
-              </a:lnSpc>
-              <a:spcAft>
-                <a:spcPts val="900"/>
-              </a:spcAft>
-            </a:pPr>
-            <a:r>
-              <a:rPr sz="1500" b="1">
-                <a:solidFill>
-                  <a:srgbClr val="E0A437"/>
-                </a:solidFill>
-                <a:latin typeface="Fira Sans"/>
-              </a:rPr>
-              <a:t>▸ </a:t>
-            </a:r>
-            <a:r>
-              <a:rPr sz="1500" b="0">
-                <a:solidFill>
-                  <a:srgbClr val="000000"/>
-                </a:solidFill>
-                <a:latin typeface="Fira Sans"/>
-              </a:rPr>
-              <a:t>Atípico no significa error: puede ser un caso real e informativo. Distinguirlo exige criterio del dominio.</a:t>
-            </a:r>
-          </a:p>
-          <a:p>
-            <a:pPr>
-              <a:lnSpc>
-                <a:spcPct val="112000"/>
-              </a:lnSpc>
-              <a:spcAft>
-                <a:spcPts val="900"/>
-              </a:spcAft>
-            </a:pPr>
-            <a:r>
-              <a:rPr sz="1500" b="1">
-                <a:solidFill>
-                  <a:srgbClr val="E0A437"/>
-                </a:solidFill>
-                <a:latin typeface="Fira Sans"/>
-              </a:rPr>
-              <a:t>▸ </a:t>
-            </a:r>
-            <a:r>
-              <a:rPr sz="1500" b="0">
-                <a:solidFill>
-                  <a:srgbClr val="000000"/>
-                </a:solidFill>
-                <a:latin typeface="Fira Sans"/>
-              </a:rPr>
-              <a:t>No hay una regla universal para excluirlos: es materia de la estadística robusta.</a:t>
+              <a:t>La media no basta</a:t>
             </a:r>
           </a:p>
         </p:txBody>
       </p:sp>
       <p:pic>
         <p:nvPicPr>
-          <p:cNvPr id="5" name="Picture 4" descr="15_outliers_tukey.png"/>
+          <p:cNvPr id="4" name="Picture 3" descr="02_dispersion_comunas.png"/>
           <p:cNvPicPr>
             <a:picLocks noChangeAspect="1"/>
           </p:cNvPicPr>
@@ -8906,14 +8773,48 @@
         </p:blipFill>
         <p:spPr>
           <a:xfrm>
-            <a:off x="4892040" y="1371600"/>
-            <a:ext cx="3840480" cy="3136431"/>
+            <a:off x="1822348" y="1143000"/>
+            <a:ext cx="5499302" cy="3154680"/>
           </a:xfrm>
           <a:prstGeom prst="rect">
             <a:avLst/>
           </a:prstGeom>
         </p:spPr>
       </p:pic>
+      <p:sp>
+        <p:nvSpPr>
+          <p:cNvPr id="5" name="TextBox 4"/>
+          <p:cNvSpPr txBox="1"/>
+          <p:nvPr/>
+        </p:nvSpPr>
+        <p:spPr>
+          <a:xfrm>
+            <a:off x="704088" y="4434840"/>
+            <a:ext cx="7744968" cy="457200"/>
+          </a:xfrm>
+          <a:prstGeom prst="rect">
+            <a:avLst/>
+          </a:prstGeom>
+          <a:noFill/>
+        </p:spPr>
+        <p:txBody>
+          <a:bodyPr wrap="square">
+            <a:spAutoFit/>
+          </a:bodyPr>
+          <a:lstStyle/>
+          <a:p>
+            <a:r>
+              <a:rPr sz="1300" b="0">
+                <a:solidFill>
+                  <a:srgbClr val="333333"/>
+                </a:solidFill>
+                <a:latin typeface="Fira Sans"/>
+              </a:rPr>
+              <a:t>Providencia y Talagante tienen la misma duración media de viaje (40,7 minutos), pero la desviación estándar de Talagante es el doble: dos realidades distintas detrás del mismo promedio.</a:t>
+            </a:r>
+          </a:p>
+        </p:txBody>
+      </p:sp>
     </p:spTree>
   </p:cSld>
   <p:clrMapOvr>
@@ -9005,14 +8906,14 @@
                 </a:solidFill>
                 <a:latin typeface="Fira Sans"/>
               </a:rPr>
-              <a:t>Boxplots para comparar grupos: iris</a:t>
+              <a:t>El boxplot</a:t>
             </a:r>
           </a:p>
         </p:txBody>
       </p:sp>
       <p:pic>
         <p:nvPicPr>
-          <p:cNvPr id="4" name="Picture 3" descr="09_iris_boxplot.png"/>
+          <p:cNvPr id="4" name="Picture 3" descr="03_boxplot_anatomia.png"/>
           <p:cNvPicPr>
             <a:picLocks noChangeAspect="1"/>
           </p:cNvPicPr>
@@ -9026,8 +8927,8 @@
         </p:blipFill>
         <p:spPr>
           <a:xfrm>
-            <a:off x="1602889" y="1143000"/>
-            <a:ext cx="5938221" cy="3154680"/>
+            <a:off x="1740020" y="1143000"/>
+            <a:ext cx="5663958" cy="3154680"/>
           </a:xfrm>
           <a:prstGeom prst="rect">
             <a:avLst/>
@@ -9063,7 +8964,7 @@
                 </a:solidFill>
                 <a:latin typeface="Fira Sans"/>
               </a:rPr>
-              <a:t>El largo del pétalo separa casi perfectamente a las tres especies: centros y dispersiones distintas en una sola figura.</a:t>
+              <a:t>Cinco números en un solo gráfico: mediana, cuartiles, bigotes y valores atípicos. La regla de los bigotes (1,5 veces el IQR) es una convención para marcar valores inusuales, no un veredicto.</a:t>
             </a:r>
           </a:p>
         </p:txBody>
@@ -9159,14 +9060,149 @@
                 </a:solidFill>
                 <a:latin typeface="Fira Sans"/>
               </a:rPr>
-              <a:t>Boxplots para comparar grupos: la EOD</a:t>
+              <a:t>Valores atípicos (outliers)</a:t>
+            </a:r>
+          </a:p>
+        </p:txBody>
+      </p:sp>
+      <p:sp>
+        <p:nvSpPr>
+          <p:cNvPr id="4" name="TextBox 3"/>
+          <p:cNvSpPr txBox="1"/>
+          <p:nvPr/>
+        </p:nvSpPr>
+        <p:spPr>
+          <a:xfrm>
+            <a:off x="502920" y="1252728"/>
+            <a:ext cx="4023360" cy="3200400"/>
+          </a:xfrm>
+          <a:prstGeom prst="rect">
+            <a:avLst/>
+          </a:prstGeom>
+          <a:noFill/>
+        </p:spPr>
+        <p:txBody>
+          <a:bodyPr wrap="square">
+            <a:spAutoFit/>
+          </a:bodyPr>
+          <a:lstStyle/>
+          <a:p>
+            <a:pPr>
+              <a:lnSpc>
+                <a:spcPct val="112000"/>
+              </a:lnSpc>
+              <a:spcAft>
+                <a:spcPts val="900"/>
+              </a:spcAft>
+            </a:pPr>
+            <a:r>
+              <a:rPr sz="1500" b="1">
+                <a:solidFill>
+                  <a:srgbClr val="E0A437"/>
+                </a:solidFill>
+                <a:latin typeface="Fira Sans"/>
+              </a:rPr>
+              <a:t>▸ </a:t>
+            </a:r>
+            <a:r>
+              <a:rPr sz="1500" b="1">
+                <a:solidFill>
+                  <a:srgbClr val="1D3557"/>
+                </a:solidFill>
+                <a:latin typeface="Fira Sans"/>
+              </a:rPr>
+              <a:t>Un valor atípico es una observación que se aleja notoriamente del resto.</a:t>
+            </a:r>
+          </a:p>
+          <a:p>
+            <a:pPr>
+              <a:lnSpc>
+                <a:spcPct val="112000"/>
+              </a:lnSpc>
+              <a:spcAft>
+                <a:spcPts val="900"/>
+              </a:spcAft>
+            </a:pPr>
+            <a:r>
+              <a:rPr sz="1500" b="1">
+                <a:solidFill>
+                  <a:srgbClr val="E0A437"/>
+                </a:solidFill>
+                <a:latin typeface="Fira Sans"/>
+              </a:rPr>
+              <a:t>▸ </a:t>
+            </a:r>
+            <a:r>
+              <a:rPr sz="1500" b="0">
+                <a:solidFill>
+                  <a:srgbClr val="000000"/>
+                </a:solidFill>
+                <a:latin typeface="Fira Sans"/>
+              </a:rPr>
+              <a:t>Convención de Tukey: fuera de Q1 − 1,5·IQR y de Q3 + 1,5·IQR.</a:t>
+            </a:r>
+          </a:p>
+          <a:p>
+            <a:pPr>
+              <a:lnSpc>
+                <a:spcPct val="112000"/>
+              </a:lnSpc>
+              <a:spcAft>
+                <a:spcPts val="900"/>
+              </a:spcAft>
+            </a:pPr>
+            <a:r>
+              <a:rPr sz="1500" b="1">
+                <a:solidFill>
+                  <a:srgbClr val="E0A437"/>
+                </a:solidFill>
+                <a:latin typeface="Fira Sans"/>
+              </a:rPr>
+              <a:t>▸ </a:t>
+            </a:r>
+            <a:r>
+              <a:rPr sz="1500" b="0">
+                <a:solidFill>
+                  <a:srgbClr val="000000"/>
+                </a:solidFill>
+                <a:latin typeface="Fira Sans"/>
+              </a:rPr>
+              <a:t>Atípico no significa error: puede ser un caso real e informativo. Distinguirlo exige criterio del dominio.</a:t>
+            </a:r>
+          </a:p>
+          <a:p>
+            <a:pPr>
+              <a:lnSpc>
+                <a:spcPct val="112000"/>
+              </a:lnSpc>
+              <a:spcAft>
+                <a:spcPts val="900"/>
+              </a:spcAft>
+            </a:pPr>
+            <a:r>
+              <a:rPr sz="1500" b="1">
+                <a:solidFill>
+                  <a:srgbClr val="E0A437"/>
+                </a:solidFill>
+                <a:latin typeface="Fira Sans"/>
+              </a:rPr>
+              <a:t>▸ </a:t>
+            </a:r>
+            <a:r>
+              <a:rPr sz="1500" b="0">
+                <a:solidFill>
+                  <a:srgbClr val="000000"/>
+                </a:solidFill>
+                <a:latin typeface="Fira Sans"/>
+              </a:rPr>
+              <a:t>No hay una regla universal para excluirlos: es materia de la estadística robusta.</a:t>
             </a:r>
           </a:p>
         </p:txBody>
       </p:sp>
       <p:pic>
         <p:nvPicPr>
-          <p:cNvPr id="4" name="Picture 3" descr="04_boxplot_modos.png"/>
+          <p:cNvPr id="5" name="Picture 4" descr="15_outliers_tukey.png"/>
           <p:cNvPicPr>
             <a:picLocks noChangeAspect="1"/>
           </p:cNvPicPr>
@@ -9180,48 +9216,14 @@
         </p:blipFill>
         <p:spPr>
           <a:xfrm>
-            <a:off x="1417319" y="1143000"/>
-            <a:ext cx="6309360" cy="2899161"/>
+            <a:off x="4892040" y="1371600"/>
+            <a:ext cx="3840480" cy="3136431"/>
           </a:xfrm>
           <a:prstGeom prst="rect">
             <a:avLst/>
           </a:prstGeom>
         </p:spPr>
       </p:pic>
-      <p:sp>
-        <p:nvSpPr>
-          <p:cNvPr id="5" name="TextBox 4"/>
-          <p:cNvSpPr txBox="1"/>
-          <p:nvPr/>
-        </p:nvSpPr>
-        <p:spPr>
-          <a:xfrm>
-            <a:off x="704088" y="4434840"/>
-            <a:ext cx="7744968" cy="457200"/>
-          </a:xfrm>
-          <a:prstGeom prst="rect">
-            <a:avLst/>
-          </a:prstGeom>
-          <a:noFill/>
-        </p:spPr>
-        <p:txBody>
-          <a:bodyPr wrap="square">
-            <a:spAutoFit/>
-          </a:bodyPr>
-          <a:lstStyle/>
-          <a:p>
-            <a:r>
-              <a:rPr sz="1300" b="0">
-                <a:solidFill>
-                  <a:srgbClr val="333333"/>
-                </a:solidFill>
-                <a:latin typeface="Fira Sans"/>
-              </a:rPr>
-              <a:t>La duración del viaje según el modo: centros y dispersiones distintas en una sola figura. Es el gráfico estándar para comparar una variable cuantitativa entre categorías.</a:t>
-            </a:r>
-          </a:p>
-        </p:txBody>
-      </p:sp>
     </p:spTree>
   </p:cSld>
   <p:clrMapOvr>
@@ -9255,7 +9257,7 @@
             <a:avLst/>
           </a:prstGeom>
           <a:solidFill>
-            <a:srgbClr val="1D3557"/>
+            <a:srgbClr val="FAFBFC"/>
           </a:solidFill>
           <a:ln>
             <a:noFill/>
@@ -9292,8 +9294,8 @@
         </p:nvSpPr>
         <p:spPr>
           <a:xfrm>
-            <a:off x="603504" y="1847088"/>
-            <a:ext cx="7946136" cy="1399032"/>
+            <a:off x="402336" y="301752"/>
+            <a:ext cx="8348472" cy="795528"/>
           </a:xfrm>
           <a:prstGeom prst="rect">
             <a:avLst/>
@@ -9307,24 +9309,71 @@
           <a:lstStyle/>
           <a:p>
             <a:r>
-              <a:rPr sz="3400" b="1">
-                <a:solidFill>
-                  <a:srgbClr val="FFFFFF"/>
-                </a:solidFill>
-                <a:latin typeface="Fira Sans"/>
-              </a:rPr>
-              <a:t>Calidad y limpieza de datos</a:t>
-            </a:r>
-          </a:p>
-          <a:p>
-            <a:r>
-              <a:rPr sz="1800" b="0">
-                <a:solidFill>
-                  <a:srgbClr val="E0A437"/>
-                </a:solidFill>
-                <a:latin typeface="Fira Sans"/>
-              </a:rPr>
-              <a:t>Los resúmenes valen lo que valen los datos</a:t>
+              <a:rPr sz="2800" b="1">
+                <a:solidFill>
+                  <a:srgbClr val="0F0F0F"/>
+                </a:solidFill>
+                <a:latin typeface="Fira Sans"/>
+              </a:rPr>
+              <a:t>Boxplots para comparar grupos: iris</a:t>
+            </a:r>
+          </a:p>
+        </p:txBody>
+      </p:sp>
+      <p:pic>
+        <p:nvPicPr>
+          <p:cNvPr id="4" name="Picture 3" descr="09_iris_boxplot.png"/>
+          <p:cNvPicPr>
+            <a:picLocks noChangeAspect="1"/>
+          </p:cNvPicPr>
+          <p:nvPr/>
+        </p:nvPicPr>
+        <p:blipFill>
+          <a:blip r:embed="rId2"/>
+          <a:stretch>
+            <a:fillRect/>
+          </a:stretch>
+        </p:blipFill>
+        <p:spPr>
+          <a:xfrm>
+            <a:off x="1602889" y="1143000"/>
+            <a:ext cx="5938221" cy="3154680"/>
+          </a:xfrm>
+          <a:prstGeom prst="rect">
+            <a:avLst/>
+          </a:prstGeom>
+        </p:spPr>
+      </p:pic>
+      <p:sp>
+        <p:nvSpPr>
+          <p:cNvPr id="5" name="TextBox 4"/>
+          <p:cNvSpPr txBox="1"/>
+          <p:nvPr/>
+        </p:nvSpPr>
+        <p:spPr>
+          <a:xfrm>
+            <a:off x="704088" y="4434840"/>
+            <a:ext cx="7744968" cy="457200"/>
+          </a:xfrm>
+          <a:prstGeom prst="rect">
+            <a:avLst/>
+          </a:prstGeom>
+          <a:noFill/>
+        </p:spPr>
+        <p:txBody>
+          <a:bodyPr wrap="square">
+            <a:spAutoFit/>
+          </a:bodyPr>
+          <a:lstStyle/>
+          <a:p>
+            <a:r>
+              <a:rPr sz="1300" b="0">
+                <a:solidFill>
+                  <a:srgbClr val="333333"/>
+                </a:solidFill>
+                <a:latin typeface="Fira Sans"/>
+              </a:rPr>
+              <a:t>El largo del pétalo separa casi perfectamente a las tres especies: centros y dispersiones distintas en una sola figura.</a:t>
             </a:r>
           </a:p>
         </p:txBody>
@@ -9420,21 +9469,45 @@
                 </a:solidFill>
                 <a:latin typeface="Fira Sans"/>
               </a:rPr>
-              <a:t>iris viene casi limpio; los datos reales, no</a:t>
-            </a:r>
-          </a:p>
-        </p:txBody>
-      </p:sp>
-      <p:sp>
-        <p:nvSpPr>
-          <p:cNvPr id="4" name="TextBox 3"/>
+              <a:t>Boxplots para comparar grupos: la EOD</a:t>
+            </a:r>
+          </a:p>
+        </p:txBody>
+      </p:sp>
+      <p:pic>
+        <p:nvPicPr>
+          <p:cNvPr id="4" name="Picture 3" descr="04_boxplot_modos.png"/>
+          <p:cNvPicPr>
+            <a:picLocks noChangeAspect="1"/>
+          </p:cNvPicPr>
+          <p:nvPr/>
+        </p:nvPicPr>
+        <p:blipFill>
+          <a:blip r:embed="rId2"/>
+          <a:stretch>
+            <a:fillRect/>
+          </a:stretch>
+        </p:blipFill>
+        <p:spPr>
+          <a:xfrm>
+            <a:off x="1417319" y="1143000"/>
+            <a:ext cx="6309360" cy="2899161"/>
+          </a:xfrm>
+          <a:prstGeom prst="rect">
+            <a:avLst/>
+          </a:prstGeom>
+        </p:spPr>
+      </p:pic>
+      <p:sp>
+        <p:nvSpPr>
+          <p:cNvPr id="5" name="TextBox 4"/>
           <p:cNvSpPr txBox="1"/>
           <p:nvPr/>
         </p:nvSpPr>
         <p:spPr>
           <a:xfrm>
-            <a:off x="704088" y="1353312"/>
-            <a:ext cx="7744968" cy="3300984"/>
+            <a:off x="704088" y="4434840"/>
+            <a:ext cx="7744968" cy="457200"/>
           </a:xfrm>
           <a:prstGeom prst="rect">
             <a:avLst/>
@@ -9447,87 +9520,14 @@
           </a:bodyPr>
           <a:lstStyle/>
           <a:p>
-            <a:pPr>
-              <a:lnSpc>
-                <a:spcPct val="112000"/>
-              </a:lnSpc>
-              <a:spcAft>
-                <a:spcPts val="900"/>
-              </a:spcAft>
-            </a:pPr>
-            <a:r>
-              <a:rPr sz="1800" b="1">
-                <a:solidFill>
-                  <a:srgbClr val="E0A437"/>
-                </a:solidFill>
-                <a:latin typeface="Fira Sans"/>
-              </a:rPr>
-              <a:t>▸ </a:t>
-            </a:r>
-            <a:r>
-              <a:rPr sz="1800" b="0">
-                <a:solidFill>
-                  <a:srgbClr val="000000"/>
-                </a:solidFill>
-                <a:latin typeface="Fira Sans"/>
-              </a:rPr>
-              <a:t>iris: cero faltantes en sus 150 filas... y aun así tiene una fila duplicada. Hasta el dataset más famoso trae un problema de calidad.</a:t>
-            </a:r>
-          </a:p>
-          <a:p>
-            <a:pPr>
-              <a:lnSpc>
-                <a:spcPct val="112000"/>
-              </a:lnSpc>
-              <a:spcAft>
-                <a:spcPts val="900"/>
-              </a:spcAft>
-            </a:pPr>
-            <a:r>
-              <a:rPr sz="1800" b="1">
-                <a:solidFill>
-                  <a:srgbClr val="E0A437"/>
-                </a:solidFill>
-                <a:latin typeface="Fira Sans"/>
-              </a:rPr>
-              <a:t>▸ </a:t>
-            </a:r>
-            <a:r>
-              <a:rPr sz="1800" b="0">
-                <a:solidFill>
-                  <a:srgbClr val="000000"/>
-                </a:solidFill>
-                <a:latin typeface="Fira Sans"/>
-              </a:rPr>
-              <a:t>La EOD: 278 duraciones faltantes, códigos que traducir, colas sospechosas y factores que son NaN por diseño.</a:t>
-            </a:r>
-          </a:p>
-          <a:p>
-            <a:pPr>
-              <a:lnSpc>
-                <a:spcPct val="112000"/>
-              </a:lnSpc>
-              <a:spcAft>
-                <a:spcPts val="900"/>
-              </a:spcAft>
-            </a:pPr>
-            <a:r>
-              <a:rPr sz="1800" b="1">
-                <a:solidFill>
-                  <a:srgbClr val="E0A437"/>
-                </a:solidFill>
-                <a:latin typeface="Fira Sans"/>
-              </a:rPr>
-              <a:t>▸ </a:t>
-            </a:r>
-            <a:r>
-              <a:rPr sz="1800" b="1">
-                <a:solidFill>
-                  <a:srgbClr val="1D3557"/>
-                </a:solidFill>
-                <a:latin typeface="Fira Sans"/>
-              </a:rPr>
-              <a:t>Por eso el checklist de calidad se aplica siempre, también al dataset del proyecto.</a:t>
+            <a:r>
+              <a:rPr sz="1300" b="0">
+                <a:solidFill>
+                  <a:srgbClr val="333333"/>
+                </a:solidFill>
+                <a:latin typeface="Fira Sans"/>
+              </a:rPr>
+              <a:t>La duración del viaje según el modo: centros y dispersiones distintas en una sola figura. Es el gráfico estándar para comparar una variable cuantitativa entre categorías.</a:t>
             </a:r>
           </a:p>
         </p:txBody>
@@ -9565,7 +9565,7 @@
             <a:avLst/>
           </a:prstGeom>
           <a:solidFill>
-            <a:srgbClr val="FAFBFC"/>
+            <a:srgbClr val="1D3557"/>
           </a:solidFill>
           <a:ln>
             <a:noFill/>
@@ -9602,8 +9602,8 @@
         </p:nvSpPr>
         <p:spPr>
           <a:xfrm>
-            <a:off x="402336" y="301752"/>
-            <a:ext cx="8348472" cy="795528"/>
+            <a:off x="603504" y="1847088"/>
+            <a:ext cx="7946136" cy="1399032"/>
           </a:xfrm>
           <a:prstGeom prst="rect">
             <a:avLst/>
@@ -9617,148 +9617,24 @@
           <a:lstStyle/>
           <a:p>
             <a:r>
-              <a:rPr sz="2800" b="1">
-                <a:solidFill>
-                  <a:srgbClr val="0F0F0F"/>
-                </a:solidFill>
-                <a:latin typeface="Fira Sans"/>
-              </a:rPr>
-              <a:t>Valores faltantes</a:t>
-            </a:r>
-          </a:p>
-        </p:txBody>
-      </p:sp>
-      <p:sp>
-        <p:nvSpPr>
-          <p:cNvPr id="4" name="TextBox 3"/>
-          <p:cNvSpPr txBox="1"/>
-          <p:nvPr/>
-        </p:nvSpPr>
-        <p:spPr>
-          <a:xfrm>
-            <a:off x="704088" y="1353312"/>
-            <a:ext cx="7744968" cy="3300984"/>
-          </a:xfrm>
-          <a:prstGeom prst="rect">
-            <a:avLst/>
-          </a:prstGeom>
-          <a:noFill/>
-        </p:spPr>
-        <p:txBody>
-          <a:bodyPr wrap="square">
-            <a:spAutoFit/>
-          </a:bodyPr>
-          <a:lstStyle/>
-          <a:p>
-            <a:pPr>
-              <a:lnSpc>
-                <a:spcPct val="112000"/>
-              </a:lnSpc>
-              <a:spcAft>
-                <a:spcPts val="900"/>
-              </a:spcAft>
-            </a:pPr>
-            <a:r>
-              <a:rPr sz="1800" b="1">
+              <a:rPr sz="3400" b="1">
+                <a:solidFill>
+                  <a:srgbClr val="FFFFFF"/>
+                </a:solidFill>
+                <a:latin typeface="Fira Sans"/>
+              </a:rPr>
+              <a:t>Calidad y limpieza de datos</a:t>
+            </a:r>
+          </a:p>
+          <a:p>
+            <a:r>
+              <a:rPr sz="1800" b="0">
                 <a:solidFill>
                   <a:srgbClr val="E0A437"/>
                 </a:solidFill>
                 <a:latin typeface="Fira Sans"/>
               </a:rPr>
-              <a:t>▸ </a:t>
-            </a:r>
-            <a:r>
-              <a:rPr sz="1800" b="0">
-                <a:solidFill>
-                  <a:srgbClr val="000000"/>
-                </a:solidFill>
-                <a:latin typeface="Fira Sans"/>
-              </a:rPr>
-              <a:t>Detección: isna().sum(), o el count de describe() contra len.</a:t>
-            </a:r>
-          </a:p>
-          <a:p>
-            <a:pPr>
-              <a:lnSpc>
-                <a:spcPct val="112000"/>
-              </a:lnSpc>
-              <a:spcAft>
-                <a:spcPts val="900"/>
-              </a:spcAft>
-            </a:pPr>
-            <a:r>
-              <a:rPr sz="1800" b="1">
-                <a:solidFill>
-                  <a:srgbClr val="E0A437"/>
-                </a:solidFill>
-                <a:latin typeface="Fira Sans"/>
-              </a:rPr>
-              <a:t>▸ </a:t>
-            </a:r>
-            <a:r>
-              <a:rPr sz="1800" b="0">
-                <a:solidFill>
-                  <a:srgbClr val="000000"/>
-                </a:solidFill>
-                <a:latin typeface="Fira Sans"/>
-              </a:rPr>
-              <a:t>En la EOD: TiempoViaje tiene 278 faltantes entre 113.591 viajes.</a:t>
-            </a:r>
-          </a:p>
-          <a:p>
-            <a:pPr>
-              <a:lnSpc>
-                <a:spcPct val="112000"/>
-              </a:lnSpc>
-              <a:spcAft>
-                <a:spcPts val="900"/>
-              </a:spcAft>
-            </a:pPr>
-            <a:r>
-              <a:rPr sz="1800" b="1">
-                <a:solidFill>
-                  <a:srgbClr val="E0A437"/>
-                </a:solidFill>
-                <a:latin typeface="Fira Sans"/>
-              </a:rPr>
-              <a:t>▸ </a:t>
-            </a:r>
-            <a:r>
-              <a:rPr sz="1800" b="1">
-                <a:solidFill>
-                  <a:srgbClr val="1D3557"/>
-                </a:solidFill>
-                <a:latin typeface="Fira Sans"/>
-              </a:rPr>
-              <a:t>Un NaN no siempre es error: en los factores de expansión significa "no aplica".</a:t>
-            </a:r>
-          </a:p>
-          <a:p>
-            <a:pPr>
-              <a:lnSpc>
-                <a:spcPct val="112000"/>
-              </a:lnSpc>
-              <a:spcAft>
-                <a:spcPts val="900"/>
-              </a:spcAft>
-            </a:pPr>
-            <a:r>
-              <a:rPr sz="1800" b="1">
-                <a:solidFill>
-                  <a:srgbClr val="E0A437"/>
-                </a:solidFill>
-                <a:latin typeface="Fira Sans"/>
-              </a:rPr>
-              <a:t>▸ </a:t>
-            </a:r>
-            <a:r>
-              <a:rPr sz="1800" b="0">
-                <a:solidFill>
-                  <a:srgbClr val="000000"/>
-                </a:solidFill>
-                <a:latin typeface="Fira Sans"/>
-              </a:rPr>
-              <a:t>Opciones: eliminar, imputar o dejar que cada cálculo los excluya. Lo obligatorio: decidir y documentar.</a:t>
+              <a:t>Los resúmenes valen lo que valen los datos</a:t>
             </a:r>
           </a:p>
         </p:txBody>
@@ -10008,7 +9884,7 @@
                 </a:solidFill>
                 <a:latin typeface="Fira Sans"/>
               </a:rPr>
-              <a:t>Duplicados</a:t>
+              <a:t>iris viene casi limpio; los datos reales, no</a:t>
             </a:r>
           </a:p>
         </p:txBody>
@@ -10059,7 +9935,7 @@
                 </a:solidFill>
                 <a:latin typeface="Fira Sans"/>
               </a:rPr>
-              <a:t>duplicated() marca filas repetidas; drop_duplicates() las elimina.</a:t>
+              <a:t>iris: cero faltantes en sus 150 filas... y aun así tiene una fila duplicada. Hasta el dataset más famoso trae un problema de calidad.</a:t>
             </a:r>
           </a:p>
           <a:p>
@@ -10087,7 +9963,7 @@
                 </a:solidFill>
                 <a:latin typeface="Fira Sans"/>
               </a:rPr>
-              <a:t>Dos niveles: la fila completa y la llave que debería ser única.</a:t>
+              <a:t>La EOD: 278 duraciones faltantes, códigos que traducir, colas sospechosas y factores que son NaN por diseño.</a:t>
             </a:r>
           </a:p>
           <a:p>
@@ -10109,41 +9985,13 @@
               <a:t>▸ </a:t>
             </a:r>
             <a:r>
-              <a:rPr sz="1800" b="0">
-                <a:solidFill>
-                  <a:srgbClr val="000000"/>
-                </a:solidFill>
-                <a:latin typeface="Fira Sans"/>
-              </a:rPr>
-              <a:t>En la EOD ambos chequeos dan cero; un cero también es un hallazgo.</a:t>
-            </a:r>
-          </a:p>
-          <a:p>
-            <a:pPr>
-              <a:lnSpc>
-                <a:spcPct val="112000"/>
-              </a:lnSpc>
-              <a:spcAft>
-                <a:spcPts val="900"/>
-              </a:spcAft>
-            </a:pPr>
-            <a:r>
               <a:rPr sz="1800" b="1">
                 <a:solidFill>
-                  <a:srgbClr val="E0A437"/>
-                </a:solidFill>
-                <a:latin typeface="Fira Sans"/>
-              </a:rPr>
-              <a:t>▸ </a:t>
-            </a:r>
-            <a:r>
-              <a:rPr sz="1800" b="0">
-                <a:solidFill>
-                  <a:srgbClr val="000000"/>
-                </a:solidFill>
-                <a:latin typeface="Fira Sans"/>
-              </a:rPr>
-              <a:t>El riesgo típico: un merge con llaves repetidas multiplica filas.</a:t>
+                  <a:srgbClr val="1D3557"/>
+                </a:solidFill>
+                <a:latin typeface="Fira Sans"/>
+              </a:rPr>
+              <a:t>Por eso el checklist de calidad se aplica siempre, también al dataset del proyecto.</a:t>
             </a:r>
           </a:p>
         </p:txBody>
@@ -10239,45 +10087,21 @@
                 </a:solidFill>
                 <a:latin typeface="Fira Sans"/>
               </a:rPr>
-              <a:t>Valores sospechosos</a:t>
-            </a:r>
-          </a:p>
-        </p:txBody>
-      </p:sp>
-      <p:pic>
-        <p:nvPicPr>
-          <p:cNvPr id="4" name="Picture 3" descr="05_cola_imposibles.png"/>
-          <p:cNvPicPr>
-            <a:picLocks noChangeAspect="1"/>
-          </p:cNvPicPr>
-          <p:nvPr/>
-        </p:nvPicPr>
-        <p:blipFill>
-          <a:blip r:embed="rId2"/>
-          <a:stretch>
-            <a:fillRect/>
-          </a:stretch>
-        </p:blipFill>
-        <p:spPr>
-          <a:xfrm>
-            <a:off x="1648218" y="1143000"/>
-            <a:ext cx="5847563" cy="3154680"/>
-          </a:xfrm>
-          <a:prstGeom prst="rect">
-            <a:avLst/>
-          </a:prstGeom>
-        </p:spPr>
-      </p:pic>
-      <p:sp>
-        <p:nvSpPr>
-          <p:cNvPr id="5" name="TextBox 4"/>
+              <a:t>Valores faltantes</a:t>
+            </a:r>
+          </a:p>
+        </p:txBody>
+      </p:sp>
+      <p:sp>
+        <p:nvSpPr>
+          <p:cNvPr id="4" name="TextBox 3"/>
           <p:cNvSpPr txBox="1"/>
           <p:nvPr/>
         </p:nvSpPr>
         <p:spPr>
           <a:xfrm>
-            <a:off x="704088" y="4434840"/>
-            <a:ext cx="7744968" cy="457200"/>
+            <a:off x="704088" y="1353312"/>
+            <a:ext cx="7744968" cy="3300984"/>
           </a:xfrm>
           <a:prstGeom prst="rect">
             <a:avLst/>
@@ -10290,14 +10114,115 @@
           </a:bodyPr>
           <a:lstStyle/>
           <a:p>
-            <a:r>
-              <a:rPr sz="1300" b="0">
-                <a:solidFill>
-                  <a:srgbClr val="333333"/>
-                </a:solidFill>
-                <a:latin typeface="Fira Sans"/>
-              </a:rPr>
-              <a:t>116 viajes declaran más de 5 horas y el máximo es de 22 horas. ¿Error de registro o viaje real? La respuesta exige criterio del dominio; la decisión (mantener, corregir o excluir) se toma en el código y se documenta.</a:t>
+            <a:pPr>
+              <a:lnSpc>
+                <a:spcPct val="112000"/>
+              </a:lnSpc>
+              <a:spcAft>
+                <a:spcPts val="900"/>
+              </a:spcAft>
+            </a:pPr>
+            <a:r>
+              <a:rPr sz="1800" b="1">
+                <a:solidFill>
+                  <a:srgbClr val="E0A437"/>
+                </a:solidFill>
+                <a:latin typeface="Fira Sans"/>
+              </a:rPr>
+              <a:t>▸ </a:t>
+            </a:r>
+            <a:r>
+              <a:rPr sz="1800" b="0">
+                <a:solidFill>
+                  <a:srgbClr val="000000"/>
+                </a:solidFill>
+                <a:latin typeface="Fira Sans"/>
+              </a:rPr>
+              <a:t>Detección: isna().sum(), o el count de describe() contra len.</a:t>
+            </a:r>
+          </a:p>
+          <a:p>
+            <a:pPr>
+              <a:lnSpc>
+                <a:spcPct val="112000"/>
+              </a:lnSpc>
+              <a:spcAft>
+                <a:spcPts val="900"/>
+              </a:spcAft>
+            </a:pPr>
+            <a:r>
+              <a:rPr sz="1800" b="1">
+                <a:solidFill>
+                  <a:srgbClr val="E0A437"/>
+                </a:solidFill>
+                <a:latin typeface="Fira Sans"/>
+              </a:rPr>
+              <a:t>▸ </a:t>
+            </a:r>
+            <a:r>
+              <a:rPr sz="1800" b="0">
+                <a:solidFill>
+                  <a:srgbClr val="000000"/>
+                </a:solidFill>
+                <a:latin typeface="Fira Sans"/>
+              </a:rPr>
+              <a:t>En la EOD: TiempoViaje tiene 278 faltantes entre 113.591 viajes.</a:t>
+            </a:r>
+          </a:p>
+          <a:p>
+            <a:pPr>
+              <a:lnSpc>
+                <a:spcPct val="112000"/>
+              </a:lnSpc>
+              <a:spcAft>
+                <a:spcPts val="900"/>
+              </a:spcAft>
+            </a:pPr>
+            <a:r>
+              <a:rPr sz="1800" b="1">
+                <a:solidFill>
+                  <a:srgbClr val="E0A437"/>
+                </a:solidFill>
+                <a:latin typeface="Fira Sans"/>
+              </a:rPr>
+              <a:t>▸ </a:t>
+            </a:r>
+            <a:r>
+              <a:rPr sz="1800" b="1">
+                <a:solidFill>
+                  <a:srgbClr val="1D3557"/>
+                </a:solidFill>
+                <a:latin typeface="Fira Sans"/>
+              </a:rPr>
+              <a:t>Un NaN no siempre es error: en los factores de expansión significa "no aplica".</a:t>
+            </a:r>
+          </a:p>
+          <a:p>
+            <a:pPr>
+              <a:lnSpc>
+                <a:spcPct val="112000"/>
+              </a:lnSpc>
+              <a:spcAft>
+                <a:spcPts val="900"/>
+              </a:spcAft>
+            </a:pPr>
+            <a:r>
+              <a:rPr sz="1800" b="1">
+                <a:solidFill>
+                  <a:srgbClr val="E0A437"/>
+                </a:solidFill>
+                <a:latin typeface="Fira Sans"/>
+              </a:rPr>
+              <a:t>▸ </a:t>
+            </a:r>
+            <a:r>
+              <a:rPr sz="1800" b="0">
+                <a:solidFill>
+                  <a:srgbClr val="000000"/>
+                </a:solidFill>
+                <a:latin typeface="Fira Sans"/>
+              </a:rPr>
+              <a:t>Opciones: eliminar, imputar o dejar que cada cálculo los excluya. Lo obligatorio: decidir y documentar.</a:t>
             </a:r>
           </a:p>
         </p:txBody>
@@ -10393,100 +10318,21 @@
                 </a:solidFill>
                 <a:latin typeface="Fira Sans"/>
               </a:rPr>
-              <a:t>Tapar valores con mask</a:t>
-            </a:r>
-          </a:p>
-        </p:txBody>
-      </p:sp>
-      <p:sp>
-        <p:nvSpPr>
-          <p:cNvPr id="4" name="Rectangle 3"/>
-          <p:cNvSpPr/>
-          <p:nvPr/>
-        </p:nvSpPr>
-        <p:spPr>
-          <a:xfrm>
-            <a:off x="704088" y="1280160"/>
-            <a:ext cx="7744968" cy="1874520"/>
-          </a:xfrm>
-          <a:prstGeom prst="rect">
-            <a:avLst/>
-          </a:prstGeom>
-          <a:solidFill>
-            <a:srgbClr val="F0F2F5"/>
-          </a:solidFill>
-          <a:ln>
-            <a:solidFill>
-              <a:srgbClr val="D8DDE3"/>
-            </a:solidFill>
-          </a:ln>
-          <a:effectLst/>
-        </p:spPr>
-        <p:style>
-          <a:lnRef idx="1">
-            <a:schemeClr val="accent1"/>
-          </a:lnRef>
-          <a:fillRef idx="3">
-            <a:schemeClr val="accent1"/>
-          </a:fillRef>
-          <a:effectRef idx="2">
-            <a:schemeClr val="accent1"/>
-          </a:effectRef>
-          <a:fontRef idx="minor">
-            <a:schemeClr val="lt1"/>
-          </a:fontRef>
-        </p:style>
-        <p:txBody>
-          <a:bodyPr rtlCol="0" anchor="ctr" wrap="square" lIns="228600" tIns="137160"/>
-          <a:lstStyle/>
-          <a:p>
-            <a:pPr/>
-            <a:r>
-              <a:rPr sz="1500" b="0">
-                <a:solidFill>
-                  <a:srgbClr val="1D3557"/>
-                </a:solidFill>
-                <a:latin typeface="Menlo"/>
-              </a:rPr>
-              <a:t># donde la condición se cumple, reemplaza (aquí, por NaN)</a:t>
-            </a:r>
-          </a:p>
-          <a:p>
-            <a:pPr/>
-            <a:r>
-              <a:rPr sz="1500" b="0">
-                <a:solidFill>
-                  <a:srgbClr val="1D3557"/>
-                </a:solidFill>
-                <a:latin typeface="Menlo"/>
-              </a:rPr>
-              <a:t>viajes["TiempoViaje"] = viajes["TiempoViaje"].mask(</a:t>
-            </a:r>
-          </a:p>
-          <a:p>
-            <a:pPr/>
-            <a:r>
-              <a:rPr sz="1500" b="0">
-                <a:solidFill>
-                  <a:srgbClr val="1D3557"/>
-                </a:solidFill>
-                <a:latin typeface="Menlo"/>
-              </a:rPr>
-              <a:t>    viajes["TiempoViaje"] &gt; 300)</a:t>
-            </a:r>
-          </a:p>
-        </p:txBody>
-      </p:sp>
-      <p:sp>
-        <p:nvSpPr>
-          <p:cNvPr id="5" name="TextBox 4"/>
+              <a:t>Duplicados</a:t>
+            </a:r>
+          </a:p>
+        </p:txBody>
+      </p:sp>
+      <p:sp>
+        <p:nvSpPr>
+          <p:cNvPr id="4" name="TextBox 3"/>
           <p:cNvSpPr txBox="1"/>
           <p:nvPr/>
         </p:nvSpPr>
         <p:spPr>
           <a:xfrm>
-            <a:off x="704088" y="3383279"/>
-            <a:ext cx="7744968" cy="1097280"/>
+            <a:off x="704088" y="1353312"/>
+            <a:ext cx="7744968" cy="3300984"/>
           </a:xfrm>
           <a:prstGeom prst="rect">
             <a:avLst/>
@@ -10508,7 +10354,7 @@
               </a:spcAft>
             </a:pPr>
             <a:r>
-              <a:rPr sz="1600" b="1">
+              <a:rPr sz="1800" b="1">
                 <a:solidFill>
                   <a:srgbClr val="E0A437"/>
                 </a:solidFill>
@@ -10517,13 +10363,97 @@
               <a:t>▸ </a:t>
             </a:r>
             <a:r>
-              <a:rPr sz="1600" b="0">
+              <a:rPr sz="1800" b="0">
                 <a:solidFill>
                   <a:srgbClr val="000000"/>
                 </a:solidFill>
                 <a:latin typeface="Fira Sans"/>
               </a:rPr>
-              <a:t>mask reemplaza donde la condición es verdadera; where, su espejo, conserva donde es verdadera y reemplaza el resto. Regla nemotécnica: mask es dónde tapar, where es dónde quedarse.</a:t>
+              <a:t>duplicated() marca filas repetidas; drop_duplicates() las elimina.</a:t>
+            </a:r>
+          </a:p>
+          <a:p>
+            <a:pPr>
+              <a:lnSpc>
+                <a:spcPct val="112000"/>
+              </a:lnSpc>
+              <a:spcAft>
+                <a:spcPts val="900"/>
+              </a:spcAft>
+            </a:pPr>
+            <a:r>
+              <a:rPr sz="1800" b="1">
+                <a:solidFill>
+                  <a:srgbClr val="E0A437"/>
+                </a:solidFill>
+                <a:latin typeface="Fira Sans"/>
+              </a:rPr>
+              <a:t>▸ </a:t>
+            </a:r>
+            <a:r>
+              <a:rPr sz="1800" b="0">
+                <a:solidFill>
+                  <a:srgbClr val="000000"/>
+                </a:solidFill>
+                <a:latin typeface="Fira Sans"/>
+              </a:rPr>
+              <a:t>Dos niveles: la fila completa y la llave que debería ser única.</a:t>
+            </a:r>
+          </a:p>
+          <a:p>
+            <a:pPr>
+              <a:lnSpc>
+                <a:spcPct val="112000"/>
+              </a:lnSpc>
+              <a:spcAft>
+                <a:spcPts val="900"/>
+              </a:spcAft>
+            </a:pPr>
+            <a:r>
+              <a:rPr sz="1800" b="1">
+                <a:solidFill>
+                  <a:srgbClr val="E0A437"/>
+                </a:solidFill>
+                <a:latin typeface="Fira Sans"/>
+              </a:rPr>
+              <a:t>▸ </a:t>
+            </a:r>
+            <a:r>
+              <a:rPr sz="1800" b="0">
+                <a:solidFill>
+                  <a:srgbClr val="000000"/>
+                </a:solidFill>
+                <a:latin typeface="Fira Sans"/>
+              </a:rPr>
+              <a:t>En la EOD ambos chequeos dan cero; un cero también es un hallazgo.</a:t>
+            </a:r>
+          </a:p>
+          <a:p>
+            <a:pPr>
+              <a:lnSpc>
+                <a:spcPct val="112000"/>
+              </a:lnSpc>
+              <a:spcAft>
+                <a:spcPts val="900"/>
+              </a:spcAft>
+            </a:pPr>
+            <a:r>
+              <a:rPr sz="1800" b="1">
+                <a:solidFill>
+                  <a:srgbClr val="E0A437"/>
+                </a:solidFill>
+                <a:latin typeface="Fira Sans"/>
+              </a:rPr>
+              <a:t>▸ </a:t>
+            </a:r>
+            <a:r>
+              <a:rPr sz="1800" b="0">
+                <a:solidFill>
+                  <a:srgbClr val="000000"/>
+                </a:solidFill>
+                <a:latin typeface="Fira Sans"/>
+              </a:rPr>
+              <a:t>El riesgo típico: un merge con llaves repetidas multiplica filas.</a:t>
             </a:r>
           </a:p>
         </p:txBody>
@@ -10619,21 +10549,45 @@
                 </a:solidFill>
                 <a:latin typeface="Fira Sans"/>
               </a:rPr>
-              <a:t>Revisar cada merge</a:t>
-            </a:r>
-          </a:p>
-        </p:txBody>
-      </p:sp>
-      <p:sp>
-        <p:nvSpPr>
-          <p:cNvPr id="4" name="TextBox 3"/>
+              <a:t>Valores sospechosos</a:t>
+            </a:r>
+          </a:p>
+        </p:txBody>
+      </p:sp>
+      <p:pic>
+        <p:nvPicPr>
+          <p:cNvPr id="4" name="Picture 3" descr="05_cola_imposibles.png"/>
+          <p:cNvPicPr>
+            <a:picLocks noChangeAspect="1"/>
+          </p:cNvPicPr>
+          <p:nvPr/>
+        </p:nvPicPr>
+        <p:blipFill>
+          <a:blip r:embed="rId2"/>
+          <a:stretch>
+            <a:fillRect/>
+          </a:stretch>
+        </p:blipFill>
+        <p:spPr>
+          <a:xfrm>
+            <a:off x="1648218" y="1143000"/>
+            <a:ext cx="5847563" cy="3154680"/>
+          </a:xfrm>
+          <a:prstGeom prst="rect">
+            <a:avLst/>
+          </a:prstGeom>
+        </p:spPr>
+      </p:pic>
+      <p:sp>
+        <p:nvSpPr>
+          <p:cNvPr id="5" name="TextBox 4"/>
           <p:cNvSpPr txBox="1"/>
           <p:nvPr/>
         </p:nvSpPr>
         <p:spPr>
           <a:xfrm>
-            <a:off x="704088" y="1353312"/>
-            <a:ext cx="7744968" cy="3300984"/>
+            <a:off x="704088" y="4434840"/>
+            <a:ext cx="7744968" cy="457200"/>
           </a:xfrm>
           <a:prstGeom prst="rect">
             <a:avLst/>
@@ -10646,87 +10600,14 @@
           </a:bodyPr>
           <a:lstStyle/>
           <a:p>
-            <a:pPr>
-              <a:lnSpc>
-                <a:spcPct val="112000"/>
-              </a:lnSpc>
-              <a:spcAft>
-                <a:spcPts val="900"/>
-              </a:spcAft>
-            </a:pPr>
-            <a:r>
-              <a:rPr sz="1800" b="1">
-                <a:solidFill>
-                  <a:srgbClr val="E0A437"/>
-                </a:solidFill>
-                <a:latin typeface="Fira Sans"/>
-              </a:rPr>
-              <a:t>▸ </a:t>
-            </a:r>
-            <a:r>
-              <a:rPr sz="1800" b="0">
-                <a:solidFill>
-                  <a:srgbClr val="000000"/>
-                </a:solidFill>
-                <a:latin typeface="Fira Sans"/>
-              </a:rPr>
-              <a:t>Comparar el número de filas antes y después: un inner descarta las filas sin pareja; en la clase 1, 113.591 viajes quedaron en 111.393.</a:t>
-            </a:r>
-          </a:p>
-          <a:p>
-            <a:pPr>
-              <a:lnSpc>
-                <a:spcPct val="112000"/>
-              </a:lnSpc>
-              <a:spcAft>
-                <a:spcPts val="900"/>
-              </a:spcAft>
-            </a:pPr>
-            <a:r>
-              <a:rPr sz="1800" b="1">
-                <a:solidFill>
-                  <a:srgbClr val="E0A437"/>
-                </a:solidFill>
-                <a:latin typeface="Fira Sans"/>
-              </a:rPr>
-              <a:t>▸ </a:t>
-            </a:r>
-            <a:r>
-              <a:rPr sz="1800" b="0">
-                <a:solidFill>
-                  <a:srgbClr val="000000"/>
-                </a:solidFill>
-                <a:latin typeface="Fira Sans"/>
-              </a:rPr>
-              <a:t>Contar los NaN de las columnas nuevas cuando se usa how="left": ahí quedan visibles las filas sin correspondencia (2.198 comunas).</a:t>
-            </a:r>
-          </a:p>
-          <a:p>
-            <a:pPr>
-              <a:lnSpc>
-                <a:spcPct val="112000"/>
-              </a:lnSpc>
-              <a:spcAft>
-                <a:spcPts val="900"/>
-              </a:spcAft>
-            </a:pPr>
-            <a:r>
-              <a:rPr sz="1800" b="1">
-                <a:solidFill>
-                  <a:srgbClr val="E0A437"/>
-                </a:solidFill>
-                <a:latin typeface="Fira Sans"/>
-              </a:rPr>
-              <a:t>▸ </a:t>
-            </a:r>
-            <a:r>
-              <a:rPr sz="1800" b="0">
-                <a:solidFill>
-                  <a:srgbClr val="000000"/>
-                </a:solidFill>
-                <a:latin typeface="Fira Sans"/>
-              </a:rPr>
-              <a:t>Verificar que la llave sea única en la tabla de parámetros: si está repetida, el merge multiplica filas.</a:t>
+            <a:r>
+              <a:rPr sz="1300" b="0">
+                <a:solidFill>
+                  <a:srgbClr val="333333"/>
+                </a:solidFill>
+                <a:latin typeface="Fira Sans"/>
+              </a:rPr>
+              <a:t>116 viajes declaran más de 5 horas y el máximo es de 22 horas. ¿Error de registro o viaje real? La respuesta exige criterio del dominio; la decisión (mantener, corregir o excluir) se toma en el código y se documenta.</a:t>
             </a:r>
           </a:p>
         </p:txBody>
@@ -10740,6 +10621,435 @@
 </file>
 
 <file path=ppt/slides/slide44.xml><?xml version="1.0" encoding="utf-8"?>
+<p:sld xmlns:a="http://schemas.openxmlformats.org/drawingml/2006/main" xmlns:p="http://schemas.openxmlformats.org/presentationml/2006/main" xmlns:r="http://schemas.openxmlformats.org/officeDocument/2006/relationships">
+  <p:cSld>
+    <p:spTree>
+      <p:nvGrpSpPr>
+        <p:cNvPr id="1" name=""/>
+        <p:cNvGrpSpPr/>
+        <p:nvPr/>
+      </p:nvGrpSpPr>
+      <p:grpSpPr/>
+      <p:sp>
+        <p:nvSpPr>
+          <p:cNvPr id="2" name="Rectangle 1"/>
+          <p:cNvSpPr/>
+          <p:nvPr/>
+        </p:nvSpPr>
+        <p:spPr>
+          <a:xfrm>
+            <a:off x="0" y="0"/>
+            <a:ext cx="9144000" cy="5138928"/>
+          </a:xfrm>
+          <a:prstGeom prst="rect">
+            <a:avLst/>
+          </a:prstGeom>
+          <a:solidFill>
+            <a:srgbClr val="FAFBFC"/>
+          </a:solidFill>
+          <a:ln>
+            <a:noFill/>
+          </a:ln>
+          <a:effectLst/>
+        </p:spPr>
+        <p:style>
+          <a:lnRef idx="1">
+            <a:schemeClr val="accent1"/>
+          </a:lnRef>
+          <a:fillRef idx="3">
+            <a:schemeClr val="accent1"/>
+          </a:fillRef>
+          <a:effectRef idx="2">
+            <a:schemeClr val="accent1"/>
+          </a:effectRef>
+          <a:fontRef idx="minor">
+            <a:schemeClr val="lt1"/>
+          </a:fontRef>
+        </p:style>
+        <p:txBody>
+          <a:bodyPr rtlCol="0" anchor="ctr"/>
+          <a:lstStyle/>
+          <a:p>
+            <a:pPr algn="ctr"/>
+          </a:p>
+        </p:txBody>
+      </p:sp>
+      <p:sp>
+        <p:nvSpPr>
+          <p:cNvPr id="3" name="TextBox 2"/>
+          <p:cNvSpPr txBox="1"/>
+          <p:nvPr/>
+        </p:nvSpPr>
+        <p:spPr>
+          <a:xfrm>
+            <a:off x="402336" y="301752"/>
+            <a:ext cx="8348472" cy="795528"/>
+          </a:xfrm>
+          <a:prstGeom prst="rect">
+            <a:avLst/>
+          </a:prstGeom>
+          <a:noFill/>
+        </p:spPr>
+        <p:txBody>
+          <a:bodyPr wrap="square">
+            <a:spAutoFit/>
+          </a:bodyPr>
+          <a:lstStyle/>
+          <a:p>
+            <a:r>
+              <a:rPr sz="2800" b="1">
+                <a:solidFill>
+                  <a:srgbClr val="0F0F0F"/>
+                </a:solidFill>
+                <a:latin typeface="Fira Sans"/>
+              </a:rPr>
+              <a:t>Tapar valores con mask</a:t>
+            </a:r>
+          </a:p>
+        </p:txBody>
+      </p:sp>
+      <p:sp>
+        <p:nvSpPr>
+          <p:cNvPr id="4" name="Rectangle 3"/>
+          <p:cNvSpPr/>
+          <p:nvPr/>
+        </p:nvSpPr>
+        <p:spPr>
+          <a:xfrm>
+            <a:off x="704088" y="1280160"/>
+            <a:ext cx="7744968" cy="1874520"/>
+          </a:xfrm>
+          <a:prstGeom prst="rect">
+            <a:avLst/>
+          </a:prstGeom>
+          <a:solidFill>
+            <a:srgbClr val="F0F2F5"/>
+          </a:solidFill>
+          <a:ln>
+            <a:solidFill>
+              <a:srgbClr val="D8DDE3"/>
+            </a:solidFill>
+          </a:ln>
+          <a:effectLst/>
+        </p:spPr>
+        <p:style>
+          <a:lnRef idx="1">
+            <a:schemeClr val="accent1"/>
+          </a:lnRef>
+          <a:fillRef idx="3">
+            <a:schemeClr val="accent1"/>
+          </a:fillRef>
+          <a:effectRef idx="2">
+            <a:schemeClr val="accent1"/>
+          </a:effectRef>
+          <a:fontRef idx="minor">
+            <a:schemeClr val="lt1"/>
+          </a:fontRef>
+        </p:style>
+        <p:txBody>
+          <a:bodyPr rtlCol="0" anchor="ctr" wrap="square" lIns="228600" tIns="137160"/>
+          <a:lstStyle/>
+          <a:p>
+            <a:pPr/>
+            <a:r>
+              <a:rPr sz="1500" b="0">
+                <a:solidFill>
+                  <a:srgbClr val="1D3557"/>
+                </a:solidFill>
+                <a:latin typeface="Menlo"/>
+              </a:rPr>
+              <a:t># donde la condición se cumple, reemplaza (aquí, por NaN)</a:t>
+            </a:r>
+          </a:p>
+          <a:p>
+            <a:pPr/>
+            <a:r>
+              <a:rPr sz="1500" b="0">
+                <a:solidFill>
+                  <a:srgbClr val="1D3557"/>
+                </a:solidFill>
+                <a:latin typeface="Menlo"/>
+              </a:rPr>
+              <a:t>viajes["TiempoViaje"] = viajes["TiempoViaje"].mask(</a:t>
+            </a:r>
+          </a:p>
+          <a:p>
+            <a:pPr/>
+            <a:r>
+              <a:rPr sz="1500" b="0">
+                <a:solidFill>
+                  <a:srgbClr val="1D3557"/>
+                </a:solidFill>
+                <a:latin typeface="Menlo"/>
+              </a:rPr>
+              <a:t>    viajes["TiempoViaje"] &gt; 300)</a:t>
+            </a:r>
+          </a:p>
+        </p:txBody>
+      </p:sp>
+      <p:sp>
+        <p:nvSpPr>
+          <p:cNvPr id="5" name="TextBox 4"/>
+          <p:cNvSpPr txBox="1"/>
+          <p:nvPr/>
+        </p:nvSpPr>
+        <p:spPr>
+          <a:xfrm>
+            <a:off x="704088" y="3383279"/>
+            <a:ext cx="7744968" cy="1097280"/>
+          </a:xfrm>
+          <a:prstGeom prst="rect">
+            <a:avLst/>
+          </a:prstGeom>
+          <a:noFill/>
+        </p:spPr>
+        <p:txBody>
+          <a:bodyPr wrap="square">
+            <a:spAutoFit/>
+          </a:bodyPr>
+          <a:lstStyle/>
+          <a:p>
+            <a:pPr>
+              <a:lnSpc>
+                <a:spcPct val="112000"/>
+              </a:lnSpc>
+              <a:spcAft>
+                <a:spcPts val="900"/>
+              </a:spcAft>
+            </a:pPr>
+            <a:r>
+              <a:rPr sz="1600" b="1">
+                <a:solidFill>
+                  <a:srgbClr val="E0A437"/>
+                </a:solidFill>
+                <a:latin typeface="Fira Sans"/>
+              </a:rPr>
+              <a:t>▸ </a:t>
+            </a:r>
+            <a:r>
+              <a:rPr sz="1600" b="0">
+                <a:solidFill>
+                  <a:srgbClr val="000000"/>
+                </a:solidFill>
+                <a:latin typeface="Fira Sans"/>
+              </a:rPr>
+              <a:t>mask reemplaza donde la condición es verdadera; where, su espejo, conserva donde es verdadera y reemplaza el resto. Regla nemotécnica: mask es dónde tapar, where es dónde quedarse.</a:t>
+            </a:r>
+          </a:p>
+        </p:txBody>
+      </p:sp>
+    </p:spTree>
+  </p:cSld>
+  <p:clrMapOvr>
+    <a:masterClrMapping/>
+  </p:clrMapOvr>
+</p:sld>
+</file>
+
+<file path=ppt/slides/slide45.xml><?xml version="1.0" encoding="utf-8"?>
+<p:sld xmlns:a="http://schemas.openxmlformats.org/drawingml/2006/main" xmlns:p="http://schemas.openxmlformats.org/presentationml/2006/main" xmlns:r="http://schemas.openxmlformats.org/officeDocument/2006/relationships">
+  <p:cSld>
+    <p:spTree>
+      <p:nvGrpSpPr>
+        <p:cNvPr id="1" name=""/>
+        <p:cNvGrpSpPr/>
+        <p:nvPr/>
+      </p:nvGrpSpPr>
+      <p:grpSpPr/>
+      <p:sp>
+        <p:nvSpPr>
+          <p:cNvPr id="2" name="Rectangle 1"/>
+          <p:cNvSpPr/>
+          <p:nvPr/>
+        </p:nvSpPr>
+        <p:spPr>
+          <a:xfrm>
+            <a:off x="0" y="0"/>
+            <a:ext cx="9144000" cy="5138928"/>
+          </a:xfrm>
+          <a:prstGeom prst="rect">
+            <a:avLst/>
+          </a:prstGeom>
+          <a:solidFill>
+            <a:srgbClr val="FAFBFC"/>
+          </a:solidFill>
+          <a:ln>
+            <a:noFill/>
+          </a:ln>
+          <a:effectLst/>
+        </p:spPr>
+        <p:style>
+          <a:lnRef idx="1">
+            <a:schemeClr val="accent1"/>
+          </a:lnRef>
+          <a:fillRef idx="3">
+            <a:schemeClr val="accent1"/>
+          </a:fillRef>
+          <a:effectRef idx="2">
+            <a:schemeClr val="accent1"/>
+          </a:effectRef>
+          <a:fontRef idx="minor">
+            <a:schemeClr val="lt1"/>
+          </a:fontRef>
+        </p:style>
+        <p:txBody>
+          <a:bodyPr rtlCol="0" anchor="ctr"/>
+          <a:lstStyle/>
+          <a:p>
+            <a:pPr algn="ctr"/>
+          </a:p>
+        </p:txBody>
+      </p:sp>
+      <p:sp>
+        <p:nvSpPr>
+          <p:cNvPr id="3" name="TextBox 2"/>
+          <p:cNvSpPr txBox="1"/>
+          <p:nvPr/>
+        </p:nvSpPr>
+        <p:spPr>
+          <a:xfrm>
+            <a:off x="402336" y="301752"/>
+            <a:ext cx="8348472" cy="795528"/>
+          </a:xfrm>
+          <a:prstGeom prst="rect">
+            <a:avLst/>
+          </a:prstGeom>
+          <a:noFill/>
+        </p:spPr>
+        <p:txBody>
+          <a:bodyPr wrap="square">
+            <a:spAutoFit/>
+          </a:bodyPr>
+          <a:lstStyle/>
+          <a:p>
+            <a:r>
+              <a:rPr sz="2800" b="1">
+                <a:solidFill>
+                  <a:srgbClr val="0F0F0F"/>
+                </a:solidFill>
+                <a:latin typeface="Fira Sans"/>
+              </a:rPr>
+              <a:t>Revisar cada merge</a:t>
+            </a:r>
+          </a:p>
+        </p:txBody>
+      </p:sp>
+      <p:sp>
+        <p:nvSpPr>
+          <p:cNvPr id="4" name="TextBox 3"/>
+          <p:cNvSpPr txBox="1"/>
+          <p:nvPr/>
+        </p:nvSpPr>
+        <p:spPr>
+          <a:xfrm>
+            <a:off x="704088" y="1353312"/>
+            <a:ext cx="7744968" cy="3300984"/>
+          </a:xfrm>
+          <a:prstGeom prst="rect">
+            <a:avLst/>
+          </a:prstGeom>
+          <a:noFill/>
+        </p:spPr>
+        <p:txBody>
+          <a:bodyPr wrap="square">
+            <a:spAutoFit/>
+          </a:bodyPr>
+          <a:lstStyle/>
+          <a:p>
+            <a:pPr>
+              <a:lnSpc>
+                <a:spcPct val="112000"/>
+              </a:lnSpc>
+              <a:spcAft>
+                <a:spcPts val="900"/>
+              </a:spcAft>
+            </a:pPr>
+            <a:r>
+              <a:rPr sz="1800" b="1">
+                <a:solidFill>
+                  <a:srgbClr val="E0A437"/>
+                </a:solidFill>
+                <a:latin typeface="Fira Sans"/>
+              </a:rPr>
+              <a:t>▸ </a:t>
+            </a:r>
+            <a:r>
+              <a:rPr sz="1800" b="0">
+                <a:solidFill>
+                  <a:srgbClr val="000000"/>
+                </a:solidFill>
+                <a:latin typeface="Fira Sans"/>
+              </a:rPr>
+              <a:t>Comparar el número de filas antes y después: un inner descarta las filas sin pareja; en la clase 1, 113.591 viajes quedaron en 111.393.</a:t>
+            </a:r>
+          </a:p>
+          <a:p>
+            <a:pPr>
+              <a:lnSpc>
+                <a:spcPct val="112000"/>
+              </a:lnSpc>
+              <a:spcAft>
+                <a:spcPts val="900"/>
+              </a:spcAft>
+            </a:pPr>
+            <a:r>
+              <a:rPr sz="1800" b="1">
+                <a:solidFill>
+                  <a:srgbClr val="E0A437"/>
+                </a:solidFill>
+                <a:latin typeface="Fira Sans"/>
+              </a:rPr>
+              <a:t>▸ </a:t>
+            </a:r>
+            <a:r>
+              <a:rPr sz="1800" b="0">
+                <a:solidFill>
+                  <a:srgbClr val="000000"/>
+                </a:solidFill>
+                <a:latin typeface="Fira Sans"/>
+              </a:rPr>
+              <a:t>Contar los NaN de las columnas nuevas cuando se usa how="left": ahí quedan visibles las filas sin correspondencia (2.198 comunas).</a:t>
+            </a:r>
+          </a:p>
+          <a:p>
+            <a:pPr>
+              <a:lnSpc>
+                <a:spcPct val="112000"/>
+              </a:lnSpc>
+              <a:spcAft>
+                <a:spcPts val="900"/>
+              </a:spcAft>
+            </a:pPr>
+            <a:r>
+              <a:rPr sz="1800" b="1">
+                <a:solidFill>
+                  <a:srgbClr val="E0A437"/>
+                </a:solidFill>
+                <a:latin typeface="Fira Sans"/>
+              </a:rPr>
+              <a:t>▸ </a:t>
+            </a:r>
+            <a:r>
+              <a:rPr sz="1800" b="0">
+                <a:solidFill>
+                  <a:srgbClr val="000000"/>
+                </a:solidFill>
+                <a:latin typeface="Fira Sans"/>
+              </a:rPr>
+              <a:t>Verificar que la llave sea única en la tabla de parámetros: si está repetida, el merge multiplica filas.</a:t>
+            </a:r>
+          </a:p>
+        </p:txBody>
+      </p:sp>
+    </p:spTree>
+  </p:cSld>
+  <p:clrMapOvr>
+    <a:masterClrMapping/>
+  </p:clrMapOvr>
+</p:sld>
+</file>
+
+<file path=ppt/slides/slide46.xml><?xml version="1.0" encoding="utf-8"?>
 <p:sld xmlns:a="http://schemas.openxmlformats.org/drawingml/2006/main" xmlns:p="http://schemas.openxmlformats.org/presentationml/2006/main" xmlns:r="http://schemas.openxmlformats.org/officeDocument/2006/relationships">
   <p:cSld>
     <p:spTree>
@@ -11231,7 +11541,7 @@
 </p:sld>
 </file>
 
-<file path=ppt/slides/slide45.xml><?xml version="1.0" encoding="utf-8"?>
+<file path=ppt/slides/slide47.xml><?xml version="1.0" encoding="utf-8"?>
 <p:sld xmlns:a="http://schemas.openxmlformats.org/drawingml/2006/main" xmlns:p="http://schemas.openxmlformats.org/presentationml/2006/main" xmlns:r="http://schemas.openxmlformats.org/officeDocument/2006/relationships">
   <p:cSld>
     <p:spTree>
@@ -11490,7 +11800,7 @@
 </p:sld>
 </file>
 
-<file path=ppt/slides/slide46.xml><?xml version="1.0" encoding="utf-8"?>
+<file path=ppt/slides/slide48.xml><?xml version="1.0" encoding="utf-8"?>
 <p:sld xmlns:a="http://schemas.openxmlformats.org/drawingml/2006/main" xmlns:p="http://schemas.openxmlformats.org/presentationml/2006/main" xmlns:r="http://schemas.openxmlformats.org/officeDocument/2006/relationships">
   <p:cSld>
     <p:spTree>

</xml_diff>

<commit_message>
Clase 2: diapo de otros criterios para marcar atipicos, con referencia Iglewicz y Hoaglin 1993
Co-Authored-By: Claude Fable 5 <noreply@anthropic.com>
</commit_message>
<xml_diff>
--- a/presentaciones/clase02_eda_descriptiva.pptx
+++ b/presentaciones/clase02_eda_descriptiva.pptx
@@ -53,6 +53,7 @@
     <p:sldId id="301" r:id="rId52"/>
     <p:sldId id="302" r:id="rId53"/>
     <p:sldId id="303" r:id="rId54"/>
+    <p:sldId id="304" r:id="rId55"/>
   </p:sldIdLst>
   <p:sldSz cx="9144000" cy="5138928" type="screen4x3"/>
   <p:notesSz cx="6858000" cy="9144000"/>
@@ -9315,45 +9316,21 @@
                 </a:solidFill>
                 <a:latin typeface="Fira Sans"/>
               </a:rPr>
-              <a:t>Boxplots para comparar grupos: iris</a:t>
-            </a:r>
-          </a:p>
-        </p:txBody>
-      </p:sp>
-      <p:pic>
-        <p:nvPicPr>
-          <p:cNvPr id="4" name="Picture 3" descr="09_iris_boxplot.png"/>
-          <p:cNvPicPr>
-            <a:picLocks noChangeAspect="1"/>
-          </p:cNvPicPr>
-          <p:nvPr/>
-        </p:nvPicPr>
-        <p:blipFill>
-          <a:blip r:embed="rId2"/>
-          <a:stretch>
-            <a:fillRect/>
-          </a:stretch>
-        </p:blipFill>
-        <p:spPr>
-          <a:xfrm>
-            <a:off x="1602889" y="1143000"/>
-            <a:ext cx="5938221" cy="3154680"/>
-          </a:xfrm>
-          <a:prstGeom prst="rect">
-            <a:avLst/>
-          </a:prstGeom>
-        </p:spPr>
-      </p:pic>
-      <p:sp>
-        <p:nvSpPr>
-          <p:cNvPr id="5" name="TextBox 4"/>
+              <a:t>Otros criterios para marcar atípicos</a:t>
+            </a:r>
+          </a:p>
+        </p:txBody>
+      </p:sp>
+      <p:sp>
+        <p:nvSpPr>
+          <p:cNvPr id="4" name="TextBox 3"/>
           <p:cNvSpPr txBox="1"/>
           <p:nvPr/>
         </p:nvSpPr>
         <p:spPr>
           <a:xfrm>
-            <a:off x="704088" y="4434840"/>
-            <a:ext cx="7744968" cy="457200"/>
+            <a:off x="704088" y="1353312"/>
+            <a:ext cx="7744968" cy="3300984"/>
           </a:xfrm>
           <a:prstGeom prst="rect">
             <a:avLst/>
@@ -9366,14 +9343,143 @@
           </a:bodyPr>
           <a:lstStyle/>
           <a:p>
-            <a:r>
-              <a:rPr sz="1300" b="0">
-                <a:solidFill>
-                  <a:srgbClr val="333333"/>
-                </a:solidFill>
-                <a:latin typeface="Fira Sans"/>
-              </a:rPr>
-              <a:t>El largo del pétalo separa casi perfectamente a las tres especies: centros y dispersiones distintas en una sola figura.</a:t>
+            <a:pPr>
+              <a:lnSpc>
+                <a:spcPct val="112000"/>
+              </a:lnSpc>
+              <a:spcAft>
+                <a:spcPts val="900"/>
+              </a:spcAft>
+            </a:pPr>
+            <a:r>
+              <a:rPr sz="1800" b="1">
+                <a:solidFill>
+                  <a:srgbClr val="E0A437"/>
+                </a:solidFill>
+                <a:latin typeface="Fira Sans"/>
+              </a:rPr>
+              <a:t>▸ </a:t>
+            </a:r>
+            <a:r>
+              <a:rPr sz="1800" b="1">
+                <a:solidFill>
+                  <a:srgbClr val="1D3557"/>
+                </a:solidFill>
+                <a:latin typeface="Fira Sans"/>
+              </a:rPr>
+              <a:t>La regla de Tukey es una convención entre varias; marcar no es eliminar.</a:t>
+            </a:r>
+          </a:p>
+          <a:p>
+            <a:pPr>
+              <a:lnSpc>
+                <a:spcPct val="112000"/>
+              </a:lnSpc>
+              <a:spcAft>
+                <a:spcPts val="900"/>
+              </a:spcAft>
+            </a:pPr>
+            <a:r>
+              <a:rPr sz="1800" b="1">
+                <a:solidFill>
+                  <a:srgbClr val="E0A437"/>
+                </a:solidFill>
+                <a:latin typeface="Fira Sans"/>
+              </a:rPr>
+              <a:t>▸ </a:t>
+            </a:r>
+            <a:r>
+              <a:rPr sz="1800" b="0">
+                <a:solidFill>
+                  <a:srgbClr val="000000"/>
+                </a:solidFill>
+                <a:latin typeface="Fira Sans"/>
+              </a:rPr>
+              <a:t>Tres sigmas: a más de 3 desviaciones estándar de la media. El clásico, pero los propios atípicos inflan la vara con que se mide.</a:t>
+            </a:r>
+          </a:p>
+          <a:p>
+            <a:pPr>
+              <a:lnSpc>
+                <a:spcPct val="112000"/>
+              </a:lnSpc>
+              <a:spcAft>
+                <a:spcPts val="900"/>
+              </a:spcAft>
+            </a:pPr>
+            <a:r>
+              <a:rPr sz="1800" b="1">
+                <a:solidFill>
+                  <a:srgbClr val="E0A437"/>
+                </a:solidFill>
+                <a:latin typeface="Fira Sans"/>
+              </a:rPr>
+              <a:t>▸ </a:t>
+            </a:r>
+            <a:r>
+              <a:rPr sz="1800" b="0">
+                <a:solidFill>
+                  <a:srgbClr val="000000"/>
+                </a:solidFill>
+                <a:latin typeface="Fira Sans"/>
+              </a:rPr>
+              <a:t>Z-score modificado: la misma idea con mediana y MAD, que resisten los extremos; corte sugerido en 3,5 (Iglewicz y Hoaglin, 1993).</a:t>
+            </a:r>
+          </a:p>
+          <a:p>
+            <a:pPr>
+              <a:lnSpc>
+                <a:spcPct val="112000"/>
+              </a:lnSpc>
+              <a:spcAft>
+                <a:spcPts val="900"/>
+              </a:spcAft>
+            </a:pPr>
+            <a:r>
+              <a:rPr sz="1800" b="1">
+                <a:solidFill>
+                  <a:srgbClr val="E0A437"/>
+                </a:solidFill>
+                <a:latin typeface="Fira Sans"/>
+              </a:rPr>
+              <a:t>▸ </a:t>
+            </a:r>
+            <a:r>
+              <a:rPr sz="1800" b="0">
+                <a:solidFill>
+                  <a:srgbClr val="000000"/>
+                </a:solidFill>
+                <a:latin typeface="Fira Sans"/>
+              </a:rPr>
+              <a:t>Criterio del dominio: rangos de validez del problema. Un viaje de 22 horas en Santiago no es raro: es imposible. El más defendible.</a:t>
+            </a:r>
+          </a:p>
+          <a:p>
+            <a:pPr>
+              <a:lnSpc>
+                <a:spcPct val="112000"/>
+              </a:lnSpc>
+              <a:spcAft>
+                <a:spcPts val="900"/>
+              </a:spcAft>
+            </a:pPr>
+            <a:r>
+              <a:rPr sz="1800" b="1">
+                <a:solidFill>
+                  <a:srgbClr val="E0A437"/>
+                </a:solidFill>
+                <a:latin typeface="Fira Sans"/>
+              </a:rPr>
+              <a:t>▸ </a:t>
+            </a:r>
+            <a:r>
+              <a:rPr sz="1800" b="0">
+                <a:solidFill>
+                  <a:srgbClr val="000000"/>
+                </a:solidFill>
+                <a:latin typeface="Fira Sans"/>
+              </a:rPr>
+              <a:t>En modelos: residuos en regresión y detección de anomalías. Los veremos en las próximas clases; hoy bastan Tukey y el dominio.</a:t>
             </a:r>
           </a:p>
         </p:txBody>
@@ -9469,14 +9575,14 @@
                 </a:solidFill>
                 <a:latin typeface="Fira Sans"/>
               </a:rPr>
-              <a:t>Boxplots para comparar grupos: la EOD</a:t>
+              <a:t>Boxplots para comparar grupos: iris</a:t>
             </a:r>
           </a:p>
         </p:txBody>
       </p:sp>
       <p:pic>
         <p:nvPicPr>
-          <p:cNvPr id="4" name="Picture 3" descr="04_boxplot_modos.png"/>
+          <p:cNvPr id="4" name="Picture 3" descr="09_iris_boxplot.png"/>
           <p:cNvPicPr>
             <a:picLocks noChangeAspect="1"/>
           </p:cNvPicPr>
@@ -9490,8 +9596,8 @@
         </p:blipFill>
         <p:spPr>
           <a:xfrm>
-            <a:off x="1417319" y="1143000"/>
-            <a:ext cx="6309360" cy="2899161"/>
+            <a:off x="1602889" y="1143000"/>
+            <a:ext cx="5938221" cy="3154680"/>
           </a:xfrm>
           <a:prstGeom prst="rect">
             <a:avLst/>
@@ -9527,7 +9633,7 @@
                 </a:solidFill>
                 <a:latin typeface="Fira Sans"/>
               </a:rPr>
-              <a:t>La duración del viaje según el modo: centros y dispersiones distintas en una sola figura. Es el gráfico estándar para comparar una variable cuantitativa entre categorías.</a:t>
+              <a:t>El largo del pétalo separa casi perfectamente a las tres especies: centros y dispersiones distintas en una sola figura.</a:t>
             </a:r>
           </a:p>
         </p:txBody>
@@ -9565,7 +9671,7 @@
             <a:avLst/>
           </a:prstGeom>
           <a:solidFill>
-            <a:srgbClr val="1D3557"/>
+            <a:srgbClr val="FAFBFC"/>
           </a:solidFill>
           <a:ln>
             <a:noFill/>
@@ -9602,8 +9708,8 @@
         </p:nvSpPr>
         <p:spPr>
           <a:xfrm>
-            <a:off x="603504" y="1847088"/>
-            <a:ext cx="7946136" cy="1399032"/>
+            <a:off x="402336" y="301752"/>
+            <a:ext cx="8348472" cy="795528"/>
           </a:xfrm>
           <a:prstGeom prst="rect">
             <a:avLst/>
@@ -9617,24 +9723,71 @@
           <a:lstStyle/>
           <a:p>
             <a:r>
-              <a:rPr sz="3400" b="1">
-                <a:solidFill>
-                  <a:srgbClr val="FFFFFF"/>
-                </a:solidFill>
-                <a:latin typeface="Fira Sans"/>
-              </a:rPr>
-              <a:t>Calidad y limpieza de datos</a:t>
-            </a:r>
-          </a:p>
-          <a:p>
-            <a:r>
-              <a:rPr sz="1800" b="0">
-                <a:solidFill>
-                  <a:srgbClr val="E0A437"/>
-                </a:solidFill>
-                <a:latin typeface="Fira Sans"/>
-              </a:rPr>
-              <a:t>Los resúmenes valen lo que valen los datos</a:t>
+              <a:rPr sz="2800" b="1">
+                <a:solidFill>
+                  <a:srgbClr val="0F0F0F"/>
+                </a:solidFill>
+                <a:latin typeface="Fira Sans"/>
+              </a:rPr>
+              <a:t>Boxplots para comparar grupos: la EOD</a:t>
+            </a:r>
+          </a:p>
+        </p:txBody>
+      </p:sp>
+      <p:pic>
+        <p:nvPicPr>
+          <p:cNvPr id="4" name="Picture 3" descr="04_boxplot_modos.png"/>
+          <p:cNvPicPr>
+            <a:picLocks noChangeAspect="1"/>
+          </p:cNvPicPr>
+          <p:nvPr/>
+        </p:nvPicPr>
+        <p:blipFill>
+          <a:blip r:embed="rId2"/>
+          <a:stretch>
+            <a:fillRect/>
+          </a:stretch>
+        </p:blipFill>
+        <p:spPr>
+          <a:xfrm>
+            <a:off x="1417319" y="1143000"/>
+            <a:ext cx="6309360" cy="2899161"/>
+          </a:xfrm>
+          <a:prstGeom prst="rect">
+            <a:avLst/>
+          </a:prstGeom>
+        </p:spPr>
+      </p:pic>
+      <p:sp>
+        <p:nvSpPr>
+          <p:cNvPr id="5" name="TextBox 4"/>
+          <p:cNvSpPr txBox="1"/>
+          <p:nvPr/>
+        </p:nvSpPr>
+        <p:spPr>
+          <a:xfrm>
+            <a:off x="704088" y="4434840"/>
+            <a:ext cx="7744968" cy="457200"/>
+          </a:xfrm>
+          <a:prstGeom prst="rect">
+            <a:avLst/>
+          </a:prstGeom>
+          <a:noFill/>
+        </p:spPr>
+        <p:txBody>
+          <a:bodyPr wrap="square">
+            <a:spAutoFit/>
+          </a:bodyPr>
+          <a:lstStyle/>
+          <a:p>
+            <a:r>
+              <a:rPr sz="1300" b="0">
+                <a:solidFill>
+                  <a:srgbClr val="333333"/>
+                </a:solidFill>
+                <a:latin typeface="Fira Sans"/>
+              </a:rPr>
+              <a:t>La duración del viaje según el modo: centros y dispersiones distintas en una sola figura. Es el gráfico estándar para comparar una variable cuantitativa entre categorías.</a:t>
             </a:r>
           </a:p>
         </p:txBody>
@@ -9826,7 +9979,7 @@
             <a:avLst/>
           </a:prstGeom>
           <a:solidFill>
-            <a:srgbClr val="FAFBFC"/>
+            <a:srgbClr val="1D3557"/>
           </a:solidFill>
           <a:ln>
             <a:noFill/>
@@ -9863,8 +10016,8 @@
         </p:nvSpPr>
         <p:spPr>
           <a:xfrm>
-            <a:off x="402336" y="301752"/>
-            <a:ext cx="8348472" cy="795528"/>
+            <a:off x="603504" y="1847088"/>
+            <a:ext cx="7946136" cy="1399032"/>
           </a:xfrm>
           <a:prstGeom prst="rect">
             <a:avLst/>
@@ -9878,120 +10031,24 @@
           <a:lstStyle/>
           <a:p>
             <a:r>
-              <a:rPr sz="2800" b="1">
-                <a:solidFill>
-                  <a:srgbClr val="0F0F0F"/>
-                </a:solidFill>
-                <a:latin typeface="Fira Sans"/>
-              </a:rPr>
-              <a:t>iris viene casi limpio; los datos reales, no</a:t>
-            </a:r>
-          </a:p>
-        </p:txBody>
-      </p:sp>
-      <p:sp>
-        <p:nvSpPr>
-          <p:cNvPr id="4" name="TextBox 3"/>
-          <p:cNvSpPr txBox="1"/>
-          <p:nvPr/>
-        </p:nvSpPr>
-        <p:spPr>
-          <a:xfrm>
-            <a:off x="704088" y="1353312"/>
-            <a:ext cx="7744968" cy="3300984"/>
-          </a:xfrm>
-          <a:prstGeom prst="rect">
-            <a:avLst/>
-          </a:prstGeom>
-          <a:noFill/>
-        </p:spPr>
-        <p:txBody>
-          <a:bodyPr wrap="square">
-            <a:spAutoFit/>
-          </a:bodyPr>
-          <a:lstStyle/>
-          <a:p>
-            <a:pPr>
-              <a:lnSpc>
-                <a:spcPct val="112000"/>
-              </a:lnSpc>
-              <a:spcAft>
-                <a:spcPts val="900"/>
-              </a:spcAft>
-            </a:pPr>
-            <a:r>
-              <a:rPr sz="1800" b="1">
+              <a:rPr sz="3400" b="1">
+                <a:solidFill>
+                  <a:srgbClr val="FFFFFF"/>
+                </a:solidFill>
+                <a:latin typeface="Fira Sans"/>
+              </a:rPr>
+              <a:t>Calidad y limpieza de datos</a:t>
+            </a:r>
+          </a:p>
+          <a:p>
+            <a:r>
+              <a:rPr sz="1800" b="0">
                 <a:solidFill>
                   <a:srgbClr val="E0A437"/>
                 </a:solidFill>
                 <a:latin typeface="Fira Sans"/>
               </a:rPr>
-              <a:t>▸ </a:t>
-            </a:r>
-            <a:r>
-              <a:rPr sz="1800" b="0">
-                <a:solidFill>
-                  <a:srgbClr val="000000"/>
-                </a:solidFill>
-                <a:latin typeface="Fira Sans"/>
-              </a:rPr>
-              <a:t>iris: cero faltantes en sus 150 filas... y aun así tiene una fila duplicada. Hasta el dataset más famoso trae un problema de calidad.</a:t>
-            </a:r>
-          </a:p>
-          <a:p>
-            <a:pPr>
-              <a:lnSpc>
-                <a:spcPct val="112000"/>
-              </a:lnSpc>
-              <a:spcAft>
-                <a:spcPts val="900"/>
-              </a:spcAft>
-            </a:pPr>
-            <a:r>
-              <a:rPr sz="1800" b="1">
-                <a:solidFill>
-                  <a:srgbClr val="E0A437"/>
-                </a:solidFill>
-                <a:latin typeface="Fira Sans"/>
-              </a:rPr>
-              <a:t>▸ </a:t>
-            </a:r>
-            <a:r>
-              <a:rPr sz="1800" b="0">
-                <a:solidFill>
-                  <a:srgbClr val="000000"/>
-                </a:solidFill>
-                <a:latin typeface="Fira Sans"/>
-              </a:rPr>
-              <a:t>La EOD: 278 duraciones faltantes, códigos que traducir, colas sospechosas y factores que son NaN por diseño.</a:t>
-            </a:r>
-          </a:p>
-          <a:p>
-            <a:pPr>
-              <a:lnSpc>
-                <a:spcPct val="112000"/>
-              </a:lnSpc>
-              <a:spcAft>
-                <a:spcPts val="900"/>
-              </a:spcAft>
-            </a:pPr>
-            <a:r>
-              <a:rPr sz="1800" b="1">
-                <a:solidFill>
-                  <a:srgbClr val="E0A437"/>
-                </a:solidFill>
-                <a:latin typeface="Fira Sans"/>
-              </a:rPr>
-              <a:t>▸ </a:t>
-            </a:r>
-            <a:r>
-              <a:rPr sz="1800" b="1">
-                <a:solidFill>
-                  <a:srgbClr val="1D3557"/>
-                </a:solidFill>
-                <a:latin typeface="Fira Sans"/>
-              </a:rPr>
-              <a:t>Por eso el checklist de calidad se aplica siempre, también al dataset del proyecto.</a:t>
+              <a:t>Los resúmenes valen lo que valen los datos</a:t>
             </a:r>
           </a:p>
         </p:txBody>
@@ -10087,7 +10144,7 @@
                 </a:solidFill>
                 <a:latin typeface="Fira Sans"/>
               </a:rPr>
-              <a:t>Valores faltantes</a:t>
+              <a:t>iris viene casi limpio; los datos reales, no</a:t>
             </a:r>
           </a:p>
         </p:txBody>
@@ -10138,7 +10195,7 @@
                 </a:solidFill>
                 <a:latin typeface="Fira Sans"/>
               </a:rPr>
-              <a:t>Detección: isna().sum(), o el count de describe() contra len.</a:t>
+              <a:t>iris: cero faltantes en sus 150 filas... y aun así tiene una fila duplicada. Hasta el dataset más famoso trae un problema de calidad.</a:t>
             </a:r>
           </a:p>
           <a:p>
@@ -10166,7 +10223,7 @@
                 </a:solidFill>
                 <a:latin typeface="Fira Sans"/>
               </a:rPr>
-              <a:t>En la EOD: TiempoViaje tiene 278 faltantes entre 113.591 viajes.</a:t>
+              <a:t>La EOD: 278 duraciones faltantes, códigos que traducir, colas sospechosas y factores que son NaN por diseño.</a:t>
             </a:r>
           </a:p>
           <a:p>
@@ -10194,35 +10251,7 @@
                 </a:solidFill>
                 <a:latin typeface="Fira Sans"/>
               </a:rPr>
-              <a:t>Un NaN no siempre es error: en los factores de expansión significa "no aplica".</a:t>
-            </a:r>
-          </a:p>
-          <a:p>
-            <a:pPr>
-              <a:lnSpc>
-                <a:spcPct val="112000"/>
-              </a:lnSpc>
-              <a:spcAft>
-                <a:spcPts val="900"/>
-              </a:spcAft>
-            </a:pPr>
-            <a:r>
-              <a:rPr sz="1800" b="1">
-                <a:solidFill>
-                  <a:srgbClr val="E0A437"/>
-                </a:solidFill>
-                <a:latin typeface="Fira Sans"/>
-              </a:rPr>
-              <a:t>▸ </a:t>
-            </a:r>
-            <a:r>
-              <a:rPr sz="1800" b="0">
-                <a:solidFill>
-                  <a:srgbClr val="000000"/>
-                </a:solidFill>
-                <a:latin typeface="Fira Sans"/>
-              </a:rPr>
-              <a:t>Opciones: eliminar, imputar o dejar que cada cálculo los excluya. Lo obligatorio: decidir y documentar.</a:t>
+              <a:t>Por eso el checklist de calidad se aplica siempre, también al dataset del proyecto.</a:t>
             </a:r>
           </a:p>
         </p:txBody>
@@ -10318,7 +10347,7 @@
                 </a:solidFill>
                 <a:latin typeface="Fira Sans"/>
               </a:rPr>
-              <a:t>Duplicados</a:t>
+              <a:t>Valores faltantes</a:t>
             </a:r>
           </a:p>
         </p:txBody>
@@ -10369,7 +10398,7 @@
                 </a:solidFill>
                 <a:latin typeface="Fira Sans"/>
               </a:rPr>
-              <a:t>duplicated() marca filas repetidas; drop_duplicates() las elimina.</a:t>
+              <a:t>Detección: isna().sum(), o el count de describe() contra len.</a:t>
             </a:r>
           </a:p>
           <a:p>
@@ -10397,7 +10426,7 @@
                 </a:solidFill>
                 <a:latin typeface="Fira Sans"/>
               </a:rPr>
-              <a:t>Dos niveles: la fila completa y la llave que debería ser única.</a:t>
+              <a:t>En la EOD: TiempoViaje tiene 278 faltantes entre 113.591 viajes.</a:t>
             </a:r>
           </a:p>
           <a:p>
@@ -10419,13 +10448,13 @@
               <a:t>▸ </a:t>
             </a:r>
             <a:r>
-              <a:rPr sz="1800" b="0">
-                <a:solidFill>
-                  <a:srgbClr val="000000"/>
-                </a:solidFill>
-                <a:latin typeface="Fira Sans"/>
-              </a:rPr>
-              <a:t>En la EOD ambos chequeos dan cero; un cero también es un hallazgo.</a:t>
+              <a:rPr sz="1800" b="1">
+                <a:solidFill>
+                  <a:srgbClr val="1D3557"/>
+                </a:solidFill>
+                <a:latin typeface="Fira Sans"/>
+              </a:rPr>
+              <a:t>Un NaN no siempre es error: en los factores de expansión significa "no aplica".</a:t>
             </a:r>
           </a:p>
           <a:p>
@@ -10453,7 +10482,7 @@
                 </a:solidFill>
                 <a:latin typeface="Fira Sans"/>
               </a:rPr>
-              <a:t>El riesgo típico: un merge con llaves repetidas multiplica filas.</a:t>
+              <a:t>Opciones: eliminar, imputar o dejar que cada cálculo los excluya. Lo obligatorio: decidir y documentar.</a:t>
             </a:r>
           </a:p>
         </p:txBody>
@@ -10549,45 +10578,21 @@
                 </a:solidFill>
                 <a:latin typeface="Fira Sans"/>
               </a:rPr>
-              <a:t>Valores sospechosos</a:t>
-            </a:r>
-          </a:p>
-        </p:txBody>
-      </p:sp>
-      <p:pic>
-        <p:nvPicPr>
-          <p:cNvPr id="4" name="Picture 3" descr="05_cola_imposibles.png"/>
-          <p:cNvPicPr>
-            <a:picLocks noChangeAspect="1"/>
-          </p:cNvPicPr>
-          <p:nvPr/>
-        </p:nvPicPr>
-        <p:blipFill>
-          <a:blip r:embed="rId2"/>
-          <a:stretch>
-            <a:fillRect/>
-          </a:stretch>
-        </p:blipFill>
-        <p:spPr>
-          <a:xfrm>
-            <a:off x="1648218" y="1143000"/>
-            <a:ext cx="5847563" cy="3154680"/>
-          </a:xfrm>
-          <a:prstGeom prst="rect">
-            <a:avLst/>
-          </a:prstGeom>
-        </p:spPr>
-      </p:pic>
-      <p:sp>
-        <p:nvSpPr>
-          <p:cNvPr id="5" name="TextBox 4"/>
+              <a:t>Duplicados</a:t>
+            </a:r>
+          </a:p>
+        </p:txBody>
+      </p:sp>
+      <p:sp>
+        <p:nvSpPr>
+          <p:cNvPr id="4" name="TextBox 3"/>
           <p:cNvSpPr txBox="1"/>
           <p:nvPr/>
         </p:nvSpPr>
         <p:spPr>
           <a:xfrm>
-            <a:off x="704088" y="4434840"/>
-            <a:ext cx="7744968" cy="457200"/>
+            <a:off x="704088" y="1353312"/>
+            <a:ext cx="7744968" cy="3300984"/>
           </a:xfrm>
           <a:prstGeom prst="rect">
             <a:avLst/>
@@ -10600,14 +10605,115 @@
           </a:bodyPr>
           <a:lstStyle/>
           <a:p>
-            <a:r>
-              <a:rPr sz="1300" b="0">
-                <a:solidFill>
-                  <a:srgbClr val="333333"/>
-                </a:solidFill>
-                <a:latin typeface="Fira Sans"/>
-              </a:rPr>
-              <a:t>116 viajes declaran más de 5 horas y el máximo es de 22 horas. ¿Error de registro o viaje real? La respuesta exige criterio del dominio; la decisión (mantener, corregir o excluir) se toma en el código y se documenta.</a:t>
+            <a:pPr>
+              <a:lnSpc>
+                <a:spcPct val="112000"/>
+              </a:lnSpc>
+              <a:spcAft>
+                <a:spcPts val="900"/>
+              </a:spcAft>
+            </a:pPr>
+            <a:r>
+              <a:rPr sz="1800" b="1">
+                <a:solidFill>
+                  <a:srgbClr val="E0A437"/>
+                </a:solidFill>
+                <a:latin typeface="Fira Sans"/>
+              </a:rPr>
+              <a:t>▸ </a:t>
+            </a:r>
+            <a:r>
+              <a:rPr sz="1800" b="0">
+                <a:solidFill>
+                  <a:srgbClr val="000000"/>
+                </a:solidFill>
+                <a:latin typeface="Fira Sans"/>
+              </a:rPr>
+              <a:t>duplicated() marca filas repetidas; drop_duplicates() las elimina.</a:t>
+            </a:r>
+          </a:p>
+          <a:p>
+            <a:pPr>
+              <a:lnSpc>
+                <a:spcPct val="112000"/>
+              </a:lnSpc>
+              <a:spcAft>
+                <a:spcPts val="900"/>
+              </a:spcAft>
+            </a:pPr>
+            <a:r>
+              <a:rPr sz="1800" b="1">
+                <a:solidFill>
+                  <a:srgbClr val="E0A437"/>
+                </a:solidFill>
+                <a:latin typeface="Fira Sans"/>
+              </a:rPr>
+              <a:t>▸ </a:t>
+            </a:r>
+            <a:r>
+              <a:rPr sz="1800" b="0">
+                <a:solidFill>
+                  <a:srgbClr val="000000"/>
+                </a:solidFill>
+                <a:latin typeface="Fira Sans"/>
+              </a:rPr>
+              <a:t>Dos niveles: la fila completa y la llave que debería ser única.</a:t>
+            </a:r>
+          </a:p>
+          <a:p>
+            <a:pPr>
+              <a:lnSpc>
+                <a:spcPct val="112000"/>
+              </a:lnSpc>
+              <a:spcAft>
+                <a:spcPts val="900"/>
+              </a:spcAft>
+            </a:pPr>
+            <a:r>
+              <a:rPr sz="1800" b="1">
+                <a:solidFill>
+                  <a:srgbClr val="E0A437"/>
+                </a:solidFill>
+                <a:latin typeface="Fira Sans"/>
+              </a:rPr>
+              <a:t>▸ </a:t>
+            </a:r>
+            <a:r>
+              <a:rPr sz="1800" b="0">
+                <a:solidFill>
+                  <a:srgbClr val="000000"/>
+                </a:solidFill>
+                <a:latin typeface="Fira Sans"/>
+              </a:rPr>
+              <a:t>En la EOD ambos chequeos dan cero; un cero también es un hallazgo.</a:t>
+            </a:r>
+          </a:p>
+          <a:p>
+            <a:pPr>
+              <a:lnSpc>
+                <a:spcPct val="112000"/>
+              </a:lnSpc>
+              <a:spcAft>
+                <a:spcPts val="900"/>
+              </a:spcAft>
+            </a:pPr>
+            <a:r>
+              <a:rPr sz="1800" b="1">
+                <a:solidFill>
+                  <a:srgbClr val="E0A437"/>
+                </a:solidFill>
+                <a:latin typeface="Fira Sans"/>
+              </a:rPr>
+              <a:t>▸ </a:t>
+            </a:r>
+            <a:r>
+              <a:rPr sz="1800" b="0">
+                <a:solidFill>
+                  <a:srgbClr val="000000"/>
+                </a:solidFill>
+                <a:latin typeface="Fira Sans"/>
+              </a:rPr>
+              <a:t>El riesgo típico: un merge con llaves repetidas multiplica filas.</a:t>
             </a:r>
           </a:p>
         </p:txBody>
@@ -10703,90 +10809,35 @@
                 </a:solidFill>
                 <a:latin typeface="Fira Sans"/>
               </a:rPr>
-              <a:t>Tapar valores con mask</a:t>
-            </a:r>
-          </a:p>
-        </p:txBody>
-      </p:sp>
-      <p:sp>
-        <p:nvSpPr>
-          <p:cNvPr id="4" name="Rectangle 3"/>
-          <p:cNvSpPr/>
-          <p:nvPr/>
-        </p:nvSpPr>
-        <p:spPr>
-          <a:xfrm>
-            <a:off x="704088" y="1280160"/>
-            <a:ext cx="7744968" cy="1874520"/>
-          </a:xfrm>
-          <a:prstGeom prst="rect">
-            <a:avLst/>
-          </a:prstGeom>
-          <a:solidFill>
-            <a:srgbClr val="F0F2F5"/>
-          </a:solidFill>
-          <a:ln>
-            <a:solidFill>
-              <a:srgbClr val="D8DDE3"/>
-            </a:solidFill>
-          </a:ln>
-          <a:effectLst/>
-        </p:spPr>
-        <p:style>
-          <a:lnRef idx="1">
-            <a:schemeClr val="accent1"/>
-          </a:lnRef>
-          <a:fillRef idx="3">
-            <a:schemeClr val="accent1"/>
-          </a:fillRef>
-          <a:effectRef idx="2">
-            <a:schemeClr val="accent1"/>
-          </a:effectRef>
-          <a:fontRef idx="minor">
-            <a:schemeClr val="lt1"/>
-          </a:fontRef>
-        </p:style>
-        <p:txBody>
-          <a:bodyPr rtlCol="0" anchor="ctr" wrap="square" lIns="228600" tIns="137160"/>
-          <a:lstStyle/>
-          <a:p>
-            <a:pPr/>
-            <a:r>
-              <a:rPr sz="1500" b="0">
-                <a:solidFill>
-                  <a:srgbClr val="1D3557"/>
-                </a:solidFill>
-                <a:latin typeface="Menlo"/>
-              </a:rPr>
-              <a:t># donde la condición se cumple, reemplaza (aquí, por NaN)</a:t>
-            </a:r>
-          </a:p>
-          <a:p>
-            <a:pPr/>
-            <a:r>
-              <a:rPr sz="1500" b="0">
-                <a:solidFill>
-                  <a:srgbClr val="1D3557"/>
-                </a:solidFill>
-                <a:latin typeface="Menlo"/>
-              </a:rPr>
-              <a:t>viajes["TiempoViaje"] = viajes["TiempoViaje"].mask(</a:t>
-            </a:r>
-          </a:p>
-          <a:p>
-            <a:pPr/>
-            <a:r>
-              <a:rPr sz="1500" b="0">
-                <a:solidFill>
-                  <a:srgbClr val="1D3557"/>
-                </a:solidFill>
-                <a:latin typeface="Menlo"/>
-              </a:rPr>
-              <a:t>    viajes["TiempoViaje"] &gt; 300)</a:t>
-            </a:r>
-          </a:p>
-        </p:txBody>
-      </p:sp>
+              <a:t>Valores sospechosos</a:t>
+            </a:r>
+          </a:p>
+        </p:txBody>
+      </p:sp>
+      <p:pic>
+        <p:nvPicPr>
+          <p:cNvPr id="4" name="Picture 3" descr="05_cola_imposibles.png"/>
+          <p:cNvPicPr>
+            <a:picLocks noChangeAspect="1"/>
+          </p:cNvPicPr>
+          <p:nvPr/>
+        </p:nvPicPr>
+        <p:blipFill>
+          <a:blip r:embed="rId2"/>
+          <a:stretch>
+            <a:fillRect/>
+          </a:stretch>
+        </p:blipFill>
+        <p:spPr>
+          <a:xfrm>
+            <a:off x="1648218" y="1143000"/>
+            <a:ext cx="5847563" cy="3154680"/>
+          </a:xfrm>
+          <a:prstGeom prst="rect">
+            <a:avLst/>
+          </a:prstGeom>
+        </p:spPr>
+      </p:pic>
       <p:sp>
         <p:nvSpPr>
           <p:cNvPr id="5" name="TextBox 4"/>
@@ -10795,8 +10846,8 @@
         </p:nvSpPr>
         <p:spPr>
           <a:xfrm>
-            <a:off x="704088" y="3383279"/>
-            <a:ext cx="7744968" cy="1097280"/>
+            <a:off x="704088" y="4434840"/>
+            <a:ext cx="7744968" cy="457200"/>
           </a:xfrm>
           <a:prstGeom prst="rect">
             <a:avLst/>
@@ -10809,31 +10860,14 @@
           </a:bodyPr>
           <a:lstStyle/>
           <a:p>
-            <a:pPr>
-              <a:lnSpc>
-                <a:spcPct val="112000"/>
-              </a:lnSpc>
-              <a:spcAft>
-                <a:spcPts val="900"/>
-              </a:spcAft>
-            </a:pPr>
-            <a:r>
-              <a:rPr sz="1600" b="1">
-                <a:solidFill>
-                  <a:srgbClr val="E0A437"/>
-                </a:solidFill>
-                <a:latin typeface="Fira Sans"/>
-              </a:rPr>
-              <a:t>▸ </a:t>
-            </a:r>
-            <a:r>
-              <a:rPr sz="1600" b="0">
-                <a:solidFill>
-                  <a:srgbClr val="000000"/>
-                </a:solidFill>
-                <a:latin typeface="Fira Sans"/>
-              </a:rPr>
-              <a:t>mask reemplaza donde la condición es verdadera; where, su espejo, conserva donde es verdadera y reemplaza el resto. Regla nemotécnica: mask es dónde tapar, where es dónde quedarse.</a:t>
+            <a:r>
+              <a:rPr sz="1300" b="0">
+                <a:solidFill>
+                  <a:srgbClr val="333333"/>
+                </a:solidFill>
+                <a:latin typeface="Fira Sans"/>
+              </a:rPr>
+              <a:t>116 viajes declaran más de 5 horas y el máximo es de 22 horas. ¿Error de registro o viaje real? La respuesta exige criterio del dominio; la decisión (mantener, corregir o excluir) se toma en el código y se documenta.</a:t>
             </a:r>
           </a:p>
         </p:txBody>
@@ -10929,21 +10963,100 @@
                 </a:solidFill>
                 <a:latin typeface="Fira Sans"/>
               </a:rPr>
-              <a:t>Revisar cada merge</a:t>
-            </a:r>
-          </a:p>
-        </p:txBody>
-      </p:sp>
-      <p:sp>
-        <p:nvSpPr>
-          <p:cNvPr id="4" name="TextBox 3"/>
+              <a:t>Tapar valores con mask</a:t>
+            </a:r>
+          </a:p>
+        </p:txBody>
+      </p:sp>
+      <p:sp>
+        <p:nvSpPr>
+          <p:cNvPr id="4" name="Rectangle 3"/>
+          <p:cNvSpPr/>
+          <p:nvPr/>
+        </p:nvSpPr>
+        <p:spPr>
+          <a:xfrm>
+            <a:off x="704088" y="1280160"/>
+            <a:ext cx="7744968" cy="1874520"/>
+          </a:xfrm>
+          <a:prstGeom prst="rect">
+            <a:avLst/>
+          </a:prstGeom>
+          <a:solidFill>
+            <a:srgbClr val="F0F2F5"/>
+          </a:solidFill>
+          <a:ln>
+            <a:solidFill>
+              <a:srgbClr val="D8DDE3"/>
+            </a:solidFill>
+          </a:ln>
+          <a:effectLst/>
+        </p:spPr>
+        <p:style>
+          <a:lnRef idx="1">
+            <a:schemeClr val="accent1"/>
+          </a:lnRef>
+          <a:fillRef idx="3">
+            <a:schemeClr val="accent1"/>
+          </a:fillRef>
+          <a:effectRef idx="2">
+            <a:schemeClr val="accent1"/>
+          </a:effectRef>
+          <a:fontRef idx="minor">
+            <a:schemeClr val="lt1"/>
+          </a:fontRef>
+        </p:style>
+        <p:txBody>
+          <a:bodyPr rtlCol="0" anchor="ctr" wrap="square" lIns="228600" tIns="137160"/>
+          <a:lstStyle/>
+          <a:p>
+            <a:pPr/>
+            <a:r>
+              <a:rPr sz="1500" b="0">
+                <a:solidFill>
+                  <a:srgbClr val="1D3557"/>
+                </a:solidFill>
+                <a:latin typeface="Menlo"/>
+              </a:rPr>
+              <a:t># donde la condición se cumple, reemplaza (aquí, por NaN)</a:t>
+            </a:r>
+          </a:p>
+          <a:p>
+            <a:pPr/>
+            <a:r>
+              <a:rPr sz="1500" b="0">
+                <a:solidFill>
+                  <a:srgbClr val="1D3557"/>
+                </a:solidFill>
+                <a:latin typeface="Menlo"/>
+              </a:rPr>
+              <a:t>viajes["TiempoViaje"] = viajes["TiempoViaje"].mask(</a:t>
+            </a:r>
+          </a:p>
+          <a:p>
+            <a:pPr/>
+            <a:r>
+              <a:rPr sz="1500" b="0">
+                <a:solidFill>
+                  <a:srgbClr val="1D3557"/>
+                </a:solidFill>
+                <a:latin typeface="Menlo"/>
+              </a:rPr>
+              <a:t>    viajes["TiempoViaje"] &gt; 300)</a:t>
+            </a:r>
+          </a:p>
+        </p:txBody>
+      </p:sp>
+      <p:sp>
+        <p:nvSpPr>
+          <p:cNvPr id="5" name="TextBox 4"/>
           <p:cNvSpPr txBox="1"/>
           <p:nvPr/>
         </p:nvSpPr>
         <p:spPr>
           <a:xfrm>
-            <a:off x="704088" y="1353312"/>
-            <a:ext cx="7744968" cy="3300984"/>
+            <a:off x="704088" y="3383279"/>
+            <a:ext cx="7744968" cy="1097280"/>
           </a:xfrm>
           <a:prstGeom prst="rect">
             <a:avLst/>
@@ -10965,7 +11078,7 @@
               </a:spcAft>
             </a:pPr>
             <a:r>
-              <a:rPr sz="1800" b="1">
+              <a:rPr sz="1600" b="1">
                 <a:solidFill>
                   <a:srgbClr val="E0A437"/>
                 </a:solidFill>
@@ -10974,69 +11087,13 @@
               <a:t>▸ </a:t>
             </a:r>
             <a:r>
-              <a:rPr sz="1800" b="0">
+              <a:rPr sz="1600" b="0">
                 <a:solidFill>
                   <a:srgbClr val="000000"/>
                 </a:solidFill>
                 <a:latin typeface="Fira Sans"/>
               </a:rPr>
-              <a:t>Comparar el número de filas antes y después: un inner descarta las filas sin pareja; en la clase 1, 113.591 viajes quedaron en 111.393.</a:t>
-            </a:r>
-          </a:p>
-          <a:p>
-            <a:pPr>
-              <a:lnSpc>
-                <a:spcPct val="112000"/>
-              </a:lnSpc>
-              <a:spcAft>
-                <a:spcPts val="900"/>
-              </a:spcAft>
-            </a:pPr>
-            <a:r>
-              <a:rPr sz="1800" b="1">
-                <a:solidFill>
-                  <a:srgbClr val="E0A437"/>
-                </a:solidFill>
-                <a:latin typeface="Fira Sans"/>
-              </a:rPr>
-              <a:t>▸ </a:t>
-            </a:r>
-            <a:r>
-              <a:rPr sz="1800" b="0">
-                <a:solidFill>
-                  <a:srgbClr val="000000"/>
-                </a:solidFill>
-                <a:latin typeface="Fira Sans"/>
-              </a:rPr>
-              <a:t>Contar los NaN de las columnas nuevas cuando se usa how="left": ahí quedan visibles las filas sin correspondencia (2.198 comunas).</a:t>
-            </a:r>
-          </a:p>
-          <a:p>
-            <a:pPr>
-              <a:lnSpc>
-                <a:spcPct val="112000"/>
-              </a:lnSpc>
-              <a:spcAft>
-                <a:spcPts val="900"/>
-              </a:spcAft>
-            </a:pPr>
-            <a:r>
-              <a:rPr sz="1800" b="1">
-                <a:solidFill>
-                  <a:srgbClr val="E0A437"/>
-                </a:solidFill>
-                <a:latin typeface="Fira Sans"/>
-              </a:rPr>
-              <a:t>▸ </a:t>
-            </a:r>
-            <a:r>
-              <a:rPr sz="1800" b="0">
-                <a:solidFill>
-                  <a:srgbClr val="000000"/>
-                </a:solidFill>
-                <a:latin typeface="Fira Sans"/>
-              </a:rPr>
-              <a:t>Verificar que la llave sea única en la tabla de parámetros: si está repetida, el merge multiplica filas.</a:t>
+              <a:t>mask reemplaza donde la condición es verdadera; where, su espejo, conserva donde es verdadera y reemplaza el resto. Regla nemotécnica: mask es dónde tapar, where es dónde quedarse.</a:t>
             </a:r>
           </a:p>
         </p:txBody>
@@ -11050,6 +11107,209 @@
 </file>
 
 <file path=ppt/slides/slide46.xml><?xml version="1.0" encoding="utf-8"?>
+<p:sld xmlns:a="http://schemas.openxmlformats.org/drawingml/2006/main" xmlns:p="http://schemas.openxmlformats.org/presentationml/2006/main" xmlns:r="http://schemas.openxmlformats.org/officeDocument/2006/relationships">
+  <p:cSld>
+    <p:spTree>
+      <p:nvGrpSpPr>
+        <p:cNvPr id="1" name=""/>
+        <p:cNvGrpSpPr/>
+        <p:nvPr/>
+      </p:nvGrpSpPr>
+      <p:grpSpPr/>
+      <p:sp>
+        <p:nvSpPr>
+          <p:cNvPr id="2" name="Rectangle 1"/>
+          <p:cNvSpPr/>
+          <p:nvPr/>
+        </p:nvSpPr>
+        <p:spPr>
+          <a:xfrm>
+            <a:off x="0" y="0"/>
+            <a:ext cx="9144000" cy="5138928"/>
+          </a:xfrm>
+          <a:prstGeom prst="rect">
+            <a:avLst/>
+          </a:prstGeom>
+          <a:solidFill>
+            <a:srgbClr val="FAFBFC"/>
+          </a:solidFill>
+          <a:ln>
+            <a:noFill/>
+          </a:ln>
+          <a:effectLst/>
+        </p:spPr>
+        <p:style>
+          <a:lnRef idx="1">
+            <a:schemeClr val="accent1"/>
+          </a:lnRef>
+          <a:fillRef idx="3">
+            <a:schemeClr val="accent1"/>
+          </a:fillRef>
+          <a:effectRef idx="2">
+            <a:schemeClr val="accent1"/>
+          </a:effectRef>
+          <a:fontRef idx="minor">
+            <a:schemeClr val="lt1"/>
+          </a:fontRef>
+        </p:style>
+        <p:txBody>
+          <a:bodyPr rtlCol="0" anchor="ctr"/>
+          <a:lstStyle/>
+          <a:p>
+            <a:pPr algn="ctr"/>
+          </a:p>
+        </p:txBody>
+      </p:sp>
+      <p:sp>
+        <p:nvSpPr>
+          <p:cNvPr id="3" name="TextBox 2"/>
+          <p:cNvSpPr txBox="1"/>
+          <p:nvPr/>
+        </p:nvSpPr>
+        <p:spPr>
+          <a:xfrm>
+            <a:off x="402336" y="301752"/>
+            <a:ext cx="8348472" cy="795528"/>
+          </a:xfrm>
+          <a:prstGeom prst="rect">
+            <a:avLst/>
+          </a:prstGeom>
+          <a:noFill/>
+        </p:spPr>
+        <p:txBody>
+          <a:bodyPr wrap="square">
+            <a:spAutoFit/>
+          </a:bodyPr>
+          <a:lstStyle/>
+          <a:p>
+            <a:r>
+              <a:rPr sz="2800" b="1">
+                <a:solidFill>
+                  <a:srgbClr val="0F0F0F"/>
+                </a:solidFill>
+                <a:latin typeface="Fira Sans"/>
+              </a:rPr>
+              <a:t>Revisar cada merge</a:t>
+            </a:r>
+          </a:p>
+        </p:txBody>
+      </p:sp>
+      <p:sp>
+        <p:nvSpPr>
+          <p:cNvPr id="4" name="TextBox 3"/>
+          <p:cNvSpPr txBox="1"/>
+          <p:nvPr/>
+        </p:nvSpPr>
+        <p:spPr>
+          <a:xfrm>
+            <a:off x="704088" y="1353312"/>
+            <a:ext cx="7744968" cy="3300984"/>
+          </a:xfrm>
+          <a:prstGeom prst="rect">
+            <a:avLst/>
+          </a:prstGeom>
+          <a:noFill/>
+        </p:spPr>
+        <p:txBody>
+          <a:bodyPr wrap="square">
+            <a:spAutoFit/>
+          </a:bodyPr>
+          <a:lstStyle/>
+          <a:p>
+            <a:pPr>
+              <a:lnSpc>
+                <a:spcPct val="112000"/>
+              </a:lnSpc>
+              <a:spcAft>
+                <a:spcPts val="900"/>
+              </a:spcAft>
+            </a:pPr>
+            <a:r>
+              <a:rPr sz="1800" b="1">
+                <a:solidFill>
+                  <a:srgbClr val="E0A437"/>
+                </a:solidFill>
+                <a:latin typeface="Fira Sans"/>
+              </a:rPr>
+              <a:t>▸ </a:t>
+            </a:r>
+            <a:r>
+              <a:rPr sz="1800" b="0">
+                <a:solidFill>
+                  <a:srgbClr val="000000"/>
+                </a:solidFill>
+                <a:latin typeface="Fira Sans"/>
+              </a:rPr>
+              <a:t>Comparar el número de filas antes y después: un inner descarta las filas sin pareja; en la clase 1, 113.591 viajes quedaron en 111.393.</a:t>
+            </a:r>
+          </a:p>
+          <a:p>
+            <a:pPr>
+              <a:lnSpc>
+                <a:spcPct val="112000"/>
+              </a:lnSpc>
+              <a:spcAft>
+                <a:spcPts val="900"/>
+              </a:spcAft>
+            </a:pPr>
+            <a:r>
+              <a:rPr sz="1800" b="1">
+                <a:solidFill>
+                  <a:srgbClr val="E0A437"/>
+                </a:solidFill>
+                <a:latin typeface="Fira Sans"/>
+              </a:rPr>
+              <a:t>▸ </a:t>
+            </a:r>
+            <a:r>
+              <a:rPr sz="1800" b="0">
+                <a:solidFill>
+                  <a:srgbClr val="000000"/>
+                </a:solidFill>
+                <a:latin typeface="Fira Sans"/>
+              </a:rPr>
+              <a:t>Contar los NaN de las columnas nuevas cuando se usa how="left": ahí quedan visibles las filas sin correspondencia (2.198 comunas).</a:t>
+            </a:r>
+          </a:p>
+          <a:p>
+            <a:pPr>
+              <a:lnSpc>
+                <a:spcPct val="112000"/>
+              </a:lnSpc>
+              <a:spcAft>
+                <a:spcPts val="900"/>
+              </a:spcAft>
+            </a:pPr>
+            <a:r>
+              <a:rPr sz="1800" b="1">
+                <a:solidFill>
+                  <a:srgbClr val="E0A437"/>
+                </a:solidFill>
+                <a:latin typeface="Fira Sans"/>
+              </a:rPr>
+              <a:t>▸ </a:t>
+            </a:r>
+            <a:r>
+              <a:rPr sz="1800" b="0">
+                <a:solidFill>
+                  <a:srgbClr val="000000"/>
+                </a:solidFill>
+                <a:latin typeface="Fira Sans"/>
+              </a:rPr>
+              <a:t>Verificar que la llave sea única en la tabla de parámetros: si está repetida, el merge multiplica filas.</a:t>
+            </a:r>
+          </a:p>
+        </p:txBody>
+      </p:sp>
+    </p:spTree>
+  </p:cSld>
+  <p:clrMapOvr>
+    <a:masterClrMapping/>
+  </p:clrMapOvr>
+</p:sld>
+</file>
+
+<file path=ppt/slides/slide47.xml><?xml version="1.0" encoding="utf-8"?>
 <p:sld xmlns:a="http://schemas.openxmlformats.org/drawingml/2006/main" xmlns:p="http://schemas.openxmlformats.org/presentationml/2006/main" xmlns:r="http://schemas.openxmlformats.org/officeDocument/2006/relationships">
   <p:cSld>
     <p:spTree>
@@ -11541,265 +11801,6 @@
 </p:sld>
 </file>
 
-<file path=ppt/slides/slide47.xml><?xml version="1.0" encoding="utf-8"?>
-<p:sld xmlns:a="http://schemas.openxmlformats.org/drawingml/2006/main" xmlns:p="http://schemas.openxmlformats.org/presentationml/2006/main" xmlns:r="http://schemas.openxmlformats.org/officeDocument/2006/relationships">
-  <p:cSld>
-    <p:spTree>
-      <p:nvGrpSpPr>
-        <p:cNvPr id="1" name=""/>
-        <p:cNvGrpSpPr/>
-        <p:nvPr/>
-      </p:nvGrpSpPr>
-      <p:grpSpPr/>
-      <p:sp>
-        <p:nvSpPr>
-          <p:cNvPr id="2" name="Rectangle 1"/>
-          <p:cNvSpPr/>
-          <p:nvPr/>
-        </p:nvSpPr>
-        <p:spPr>
-          <a:xfrm>
-            <a:off x="0" y="0"/>
-            <a:ext cx="9144000" cy="5138928"/>
-          </a:xfrm>
-          <a:prstGeom prst="rect">
-            <a:avLst/>
-          </a:prstGeom>
-          <a:solidFill>
-            <a:srgbClr val="FAFBFC"/>
-          </a:solidFill>
-          <a:ln>
-            <a:noFill/>
-          </a:ln>
-          <a:effectLst/>
-        </p:spPr>
-        <p:style>
-          <a:lnRef idx="1">
-            <a:schemeClr val="accent1"/>
-          </a:lnRef>
-          <a:fillRef idx="3">
-            <a:schemeClr val="accent1"/>
-          </a:fillRef>
-          <a:effectRef idx="2">
-            <a:schemeClr val="accent1"/>
-          </a:effectRef>
-          <a:fontRef idx="minor">
-            <a:schemeClr val="lt1"/>
-          </a:fontRef>
-        </p:style>
-        <p:txBody>
-          <a:bodyPr rtlCol="0" anchor="ctr"/>
-          <a:lstStyle/>
-          <a:p>
-            <a:pPr algn="ctr"/>
-          </a:p>
-        </p:txBody>
-      </p:sp>
-      <p:sp>
-        <p:nvSpPr>
-          <p:cNvPr id="3" name="TextBox 2"/>
-          <p:cNvSpPr txBox="1"/>
-          <p:nvPr/>
-        </p:nvSpPr>
-        <p:spPr>
-          <a:xfrm>
-            <a:off x="402336" y="301752"/>
-            <a:ext cx="8348472" cy="795528"/>
-          </a:xfrm>
-          <a:prstGeom prst="rect">
-            <a:avLst/>
-          </a:prstGeom>
-          <a:noFill/>
-        </p:spPr>
-        <p:txBody>
-          <a:bodyPr wrap="square">
-            <a:spAutoFit/>
-          </a:bodyPr>
-          <a:lstStyle/>
-          <a:p>
-            <a:r>
-              <a:rPr sz="2800" b="1">
-                <a:solidFill>
-                  <a:srgbClr val="0F0F0F"/>
-                </a:solidFill>
-                <a:latin typeface="Fira Sans"/>
-              </a:rPr>
-              <a:t>Síntesis</a:t>
-            </a:r>
-          </a:p>
-        </p:txBody>
-      </p:sp>
-      <p:sp>
-        <p:nvSpPr>
-          <p:cNvPr id="4" name="TextBox 3"/>
-          <p:cNvSpPr txBox="1"/>
-          <p:nvPr/>
-        </p:nvSpPr>
-        <p:spPr>
-          <a:xfrm>
-            <a:off x="704088" y="1353312"/>
-            <a:ext cx="7744968" cy="3300984"/>
-          </a:xfrm>
-          <a:prstGeom prst="rect">
-            <a:avLst/>
-          </a:prstGeom>
-          <a:noFill/>
-        </p:spPr>
-        <p:txBody>
-          <a:bodyPr wrap="square">
-            <a:spAutoFit/>
-          </a:bodyPr>
-          <a:lstStyle/>
-          <a:p>
-            <a:pPr>
-              <a:lnSpc>
-                <a:spcPct val="112000"/>
-              </a:lnSpc>
-              <a:spcAft>
-                <a:spcPts val="900"/>
-              </a:spcAft>
-            </a:pPr>
-            <a:r>
-              <a:rPr sz="1800" b="1">
-                <a:solidFill>
-                  <a:srgbClr val="E0A437"/>
-                </a:solidFill>
-                <a:latin typeface="Fira Sans"/>
-              </a:rPr>
-              <a:t>▸ </a:t>
-            </a:r>
-            <a:r>
-              <a:rPr sz="1800" b="0">
-                <a:solidFill>
-                  <a:srgbClr val="000000"/>
-                </a:solidFill>
-                <a:latin typeface="Fira Sans"/>
-              </a:rPr>
-              <a:t>Describir una variable exige tres miradas: centro (media, mediana), dispersión (desviación, IQR) y forma (histograma, boxplot).</a:t>
-            </a:r>
-          </a:p>
-          <a:p>
-            <a:pPr>
-              <a:lnSpc>
-                <a:spcPct val="112000"/>
-              </a:lnSpc>
-              <a:spcAft>
-                <a:spcPts val="900"/>
-              </a:spcAft>
-            </a:pPr>
-            <a:r>
-              <a:rPr sz="1800" b="1">
-                <a:solidFill>
-                  <a:srgbClr val="E0A437"/>
-                </a:solidFill>
-                <a:latin typeface="Fira Sans"/>
-              </a:rPr>
-              <a:t>▸ </a:t>
-            </a:r>
-            <a:r>
-              <a:rPr sz="1800" b="0">
-                <a:solidFill>
-                  <a:srgbClr val="000000"/>
-                </a:solidFill>
-                <a:latin typeface="Fira Sans"/>
-              </a:rPr>
-              <a:t>Con asimetría, la mediana acompaña o reemplaza a la media.</a:t>
-            </a:r>
-          </a:p>
-          <a:p>
-            <a:pPr>
-              <a:lnSpc>
-                <a:spcPct val="112000"/>
-              </a:lnSpc>
-              <a:spcAft>
-                <a:spcPts val="900"/>
-              </a:spcAft>
-            </a:pPr>
-            <a:r>
-              <a:rPr sz="1800" b="1">
-                <a:solidFill>
-                  <a:srgbClr val="E0A437"/>
-                </a:solidFill>
-                <a:latin typeface="Fira Sans"/>
-              </a:rPr>
-              <a:t>▸ </a:t>
-            </a:r>
-            <a:r>
-              <a:rPr sz="1800" b="0">
-                <a:solidFill>
-                  <a:srgbClr val="000000"/>
-                </a:solidFill>
-                <a:latin typeface="Fira Sans"/>
-              </a:rPr>
-              <a:t>La limpieza es parte del análisis: faltantes, duplicados, rangos válidos y merges verificados, con decisiones documentadas.</a:t>
-            </a:r>
-          </a:p>
-          <a:p>
-            <a:pPr>
-              <a:lnSpc>
-                <a:spcPct val="112000"/>
-              </a:lnSpc>
-              <a:spcAft>
-                <a:spcPts val="900"/>
-              </a:spcAft>
-            </a:pPr>
-            <a:r>
-              <a:rPr sz="1800" b="1">
-                <a:solidFill>
-                  <a:srgbClr val="E0A437"/>
-                </a:solidFill>
-                <a:latin typeface="Fira Sans"/>
-              </a:rPr>
-              <a:t>▸ </a:t>
-            </a:r>
-            <a:r>
-              <a:rPr sz="1800" b="0">
-                <a:solidFill>
-                  <a:srgbClr val="000000"/>
-                </a:solidFill>
-                <a:latin typeface="Fira Sans"/>
-              </a:rPr>
-              <a:t>La pregunta del proyecto debe ser específica y la hipótesis, verificable con variables medibles.</a:t>
-            </a:r>
-          </a:p>
-          <a:p>
-            <a:pPr>
-              <a:lnSpc>
-                <a:spcPct val="112000"/>
-              </a:lnSpc>
-              <a:spcAft>
-                <a:spcPts val="900"/>
-              </a:spcAft>
-            </a:pPr>
-            <a:r>
-              <a:rPr sz="1800" b="1">
-                <a:solidFill>
-                  <a:srgbClr val="E0A437"/>
-                </a:solidFill>
-                <a:latin typeface="Fira Sans"/>
-              </a:rPr>
-              <a:t>▸ </a:t>
-            </a:r>
-            <a:r>
-              <a:rPr sz="1800" b="0">
-                <a:solidFill>
-                  <a:srgbClr val="000000"/>
-                </a:solidFill>
-                <a:latin typeface="Fira Sans"/>
-              </a:rPr>
-              <a:t>Próxima clase (martes 01-sep): EDA II, relaciones entre variables y correlación.</a:t>
-            </a:r>
-          </a:p>
-        </p:txBody>
-      </p:sp>
-    </p:spTree>
-  </p:cSld>
-  <p:clrMapOvr>
-    <a:masterClrMapping/>
-  </p:clrMapOvr>
-</p:sld>
-</file>
-
 <file path=ppt/slides/slide48.xml><?xml version="1.0" encoding="utf-8"?>
 <p:sld xmlns:a="http://schemas.openxmlformats.org/drawingml/2006/main" xmlns:p="http://schemas.openxmlformats.org/presentationml/2006/main" xmlns:r="http://schemas.openxmlformats.org/officeDocument/2006/relationships">
   <p:cSld>
@@ -11883,6 +11884,265 @@
                 </a:solidFill>
                 <a:latin typeface="Fira Sans"/>
               </a:rPr>
+              <a:t>Síntesis</a:t>
+            </a:r>
+          </a:p>
+        </p:txBody>
+      </p:sp>
+      <p:sp>
+        <p:nvSpPr>
+          <p:cNvPr id="4" name="TextBox 3"/>
+          <p:cNvSpPr txBox="1"/>
+          <p:nvPr/>
+        </p:nvSpPr>
+        <p:spPr>
+          <a:xfrm>
+            <a:off x="704088" y="1353312"/>
+            <a:ext cx="7744968" cy="3300984"/>
+          </a:xfrm>
+          <a:prstGeom prst="rect">
+            <a:avLst/>
+          </a:prstGeom>
+          <a:noFill/>
+        </p:spPr>
+        <p:txBody>
+          <a:bodyPr wrap="square">
+            <a:spAutoFit/>
+          </a:bodyPr>
+          <a:lstStyle/>
+          <a:p>
+            <a:pPr>
+              <a:lnSpc>
+                <a:spcPct val="112000"/>
+              </a:lnSpc>
+              <a:spcAft>
+                <a:spcPts val="900"/>
+              </a:spcAft>
+            </a:pPr>
+            <a:r>
+              <a:rPr sz="1800" b="1">
+                <a:solidFill>
+                  <a:srgbClr val="E0A437"/>
+                </a:solidFill>
+                <a:latin typeface="Fira Sans"/>
+              </a:rPr>
+              <a:t>▸ </a:t>
+            </a:r>
+            <a:r>
+              <a:rPr sz="1800" b="0">
+                <a:solidFill>
+                  <a:srgbClr val="000000"/>
+                </a:solidFill>
+                <a:latin typeface="Fira Sans"/>
+              </a:rPr>
+              <a:t>Describir una variable exige tres miradas: centro (media, mediana), dispersión (desviación, IQR) y forma (histograma, boxplot).</a:t>
+            </a:r>
+          </a:p>
+          <a:p>
+            <a:pPr>
+              <a:lnSpc>
+                <a:spcPct val="112000"/>
+              </a:lnSpc>
+              <a:spcAft>
+                <a:spcPts val="900"/>
+              </a:spcAft>
+            </a:pPr>
+            <a:r>
+              <a:rPr sz="1800" b="1">
+                <a:solidFill>
+                  <a:srgbClr val="E0A437"/>
+                </a:solidFill>
+                <a:latin typeface="Fira Sans"/>
+              </a:rPr>
+              <a:t>▸ </a:t>
+            </a:r>
+            <a:r>
+              <a:rPr sz="1800" b="0">
+                <a:solidFill>
+                  <a:srgbClr val="000000"/>
+                </a:solidFill>
+                <a:latin typeface="Fira Sans"/>
+              </a:rPr>
+              <a:t>Con asimetría, la mediana acompaña o reemplaza a la media.</a:t>
+            </a:r>
+          </a:p>
+          <a:p>
+            <a:pPr>
+              <a:lnSpc>
+                <a:spcPct val="112000"/>
+              </a:lnSpc>
+              <a:spcAft>
+                <a:spcPts val="900"/>
+              </a:spcAft>
+            </a:pPr>
+            <a:r>
+              <a:rPr sz="1800" b="1">
+                <a:solidFill>
+                  <a:srgbClr val="E0A437"/>
+                </a:solidFill>
+                <a:latin typeface="Fira Sans"/>
+              </a:rPr>
+              <a:t>▸ </a:t>
+            </a:r>
+            <a:r>
+              <a:rPr sz="1800" b="0">
+                <a:solidFill>
+                  <a:srgbClr val="000000"/>
+                </a:solidFill>
+                <a:latin typeface="Fira Sans"/>
+              </a:rPr>
+              <a:t>La limpieza es parte del análisis: faltantes, duplicados, rangos válidos y merges verificados, con decisiones documentadas.</a:t>
+            </a:r>
+          </a:p>
+          <a:p>
+            <a:pPr>
+              <a:lnSpc>
+                <a:spcPct val="112000"/>
+              </a:lnSpc>
+              <a:spcAft>
+                <a:spcPts val="900"/>
+              </a:spcAft>
+            </a:pPr>
+            <a:r>
+              <a:rPr sz="1800" b="1">
+                <a:solidFill>
+                  <a:srgbClr val="E0A437"/>
+                </a:solidFill>
+                <a:latin typeface="Fira Sans"/>
+              </a:rPr>
+              <a:t>▸ </a:t>
+            </a:r>
+            <a:r>
+              <a:rPr sz="1800" b="0">
+                <a:solidFill>
+                  <a:srgbClr val="000000"/>
+                </a:solidFill>
+                <a:latin typeface="Fira Sans"/>
+              </a:rPr>
+              <a:t>La pregunta del proyecto debe ser específica y la hipótesis, verificable con variables medibles.</a:t>
+            </a:r>
+          </a:p>
+          <a:p>
+            <a:pPr>
+              <a:lnSpc>
+                <a:spcPct val="112000"/>
+              </a:lnSpc>
+              <a:spcAft>
+                <a:spcPts val="900"/>
+              </a:spcAft>
+            </a:pPr>
+            <a:r>
+              <a:rPr sz="1800" b="1">
+                <a:solidFill>
+                  <a:srgbClr val="E0A437"/>
+                </a:solidFill>
+                <a:latin typeface="Fira Sans"/>
+              </a:rPr>
+              <a:t>▸ </a:t>
+            </a:r>
+            <a:r>
+              <a:rPr sz="1800" b="0">
+                <a:solidFill>
+                  <a:srgbClr val="000000"/>
+                </a:solidFill>
+                <a:latin typeface="Fira Sans"/>
+              </a:rPr>
+              <a:t>Próxima clase (martes 01-sep): EDA II, relaciones entre variables y correlación.</a:t>
+            </a:r>
+          </a:p>
+        </p:txBody>
+      </p:sp>
+    </p:spTree>
+  </p:cSld>
+  <p:clrMapOvr>
+    <a:masterClrMapping/>
+  </p:clrMapOvr>
+</p:sld>
+</file>
+
+<file path=ppt/slides/slide49.xml><?xml version="1.0" encoding="utf-8"?>
+<p:sld xmlns:a="http://schemas.openxmlformats.org/drawingml/2006/main" xmlns:p="http://schemas.openxmlformats.org/presentationml/2006/main" xmlns:r="http://schemas.openxmlformats.org/officeDocument/2006/relationships">
+  <p:cSld>
+    <p:spTree>
+      <p:nvGrpSpPr>
+        <p:cNvPr id="1" name=""/>
+        <p:cNvGrpSpPr/>
+        <p:nvPr/>
+      </p:nvGrpSpPr>
+      <p:grpSpPr/>
+      <p:sp>
+        <p:nvSpPr>
+          <p:cNvPr id="2" name="Rectangle 1"/>
+          <p:cNvSpPr/>
+          <p:nvPr/>
+        </p:nvSpPr>
+        <p:spPr>
+          <a:xfrm>
+            <a:off x="0" y="0"/>
+            <a:ext cx="9144000" cy="5138928"/>
+          </a:xfrm>
+          <a:prstGeom prst="rect">
+            <a:avLst/>
+          </a:prstGeom>
+          <a:solidFill>
+            <a:srgbClr val="FAFBFC"/>
+          </a:solidFill>
+          <a:ln>
+            <a:noFill/>
+          </a:ln>
+          <a:effectLst/>
+        </p:spPr>
+        <p:style>
+          <a:lnRef idx="1">
+            <a:schemeClr val="accent1"/>
+          </a:lnRef>
+          <a:fillRef idx="3">
+            <a:schemeClr val="accent1"/>
+          </a:fillRef>
+          <a:effectRef idx="2">
+            <a:schemeClr val="accent1"/>
+          </a:effectRef>
+          <a:fontRef idx="minor">
+            <a:schemeClr val="lt1"/>
+          </a:fontRef>
+        </p:style>
+        <p:txBody>
+          <a:bodyPr rtlCol="0" anchor="ctr"/>
+          <a:lstStyle/>
+          <a:p>
+            <a:pPr algn="ctr"/>
+          </a:p>
+        </p:txBody>
+      </p:sp>
+      <p:sp>
+        <p:nvSpPr>
+          <p:cNvPr id="3" name="TextBox 2"/>
+          <p:cNvSpPr txBox="1"/>
+          <p:nvPr/>
+        </p:nvSpPr>
+        <p:spPr>
+          <a:xfrm>
+            <a:off x="402336" y="301752"/>
+            <a:ext cx="8348472" cy="795528"/>
+          </a:xfrm>
+          <a:prstGeom prst="rect">
+            <a:avLst/>
+          </a:prstGeom>
+          <a:noFill/>
+        </p:spPr>
+        <p:txBody>
+          <a:bodyPr wrap="square">
+            <a:spAutoFit/>
+          </a:bodyPr>
+          <a:lstStyle/>
+          <a:p>
+            <a:r>
+              <a:rPr sz="2800" b="1">
+                <a:solidFill>
+                  <a:srgbClr val="0F0F0F"/>
+                </a:solidFill>
+                <a:latin typeface="Fira Sans"/>
+              </a:rPr>
               <a:t>Referencias</a:t>
             </a:r>
           </a:p>
@@ -11945,6 +12205,25 @@
                 <a:latin typeface="Fira Sans"/>
               </a:rPr>
               <a:t>Tukey, J. W. (1977). Exploratory Data Analysis. Addison-Wesley.</a:t>
+            </a:r>
+          </a:p>
+          <a:p>
+            <a:pPr>
+              <a:lnSpc>
+                <a:spcPct val="115000"/>
+              </a:lnSpc>
+              <a:spcAft>
+                <a:spcPts val="700"/>
+              </a:spcAft>
+            </a:pPr>
+            <a:r>
+              <a:rPr sz="1300" b="0">
+                <a:solidFill>
+                  <a:srgbClr val="333333"/>
+                </a:solidFill>
+                <a:latin typeface="Fira Sans"/>
+              </a:rPr>
+              <a:t>Iglewicz, B. y Hoaglin, D. C. (1993). How to Detect and Handle Outliers. ASQC Quality Press.</a:t>
             </a:r>
           </a:p>
           <a:p>

</xml_diff>

<commit_message>
Clase 2: resumir la diapo de otros criterios, sin siglas innecesarias
Co-Authored-By: Claude Fable 5 <noreply@anthropic.com>
</commit_message>
<xml_diff>
--- a/presentaciones/clase02_eda_descriptiva.pptx
+++ b/presentaciones/clase02_eda_descriptiva.pptx
@@ -9395,7 +9395,7 @@
                 </a:solidFill>
                 <a:latin typeface="Fira Sans"/>
               </a:rPr>
-              <a:t>Tres sigmas: a más de 3 desviaciones estándar de la media. El clásico, pero los propios atípicos inflan la vara con que se mide.</a:t>
+              <a:t>Tres sigmas: distancia a la media, en desviaciones estándar.</a:t>
             </a:r>
           </a:p>
           <a:p>
@@ -9423,7 +9423,7 @@
                 </a:solidFill>
                 <a:latin typeface="Fira Sans"/>
               </a:rPr>
-              <a:t>Z-score modificado: la misma idea con mediana y MAD, que resisten los extremos; corte sugerido en 3,5 (Iglewicz y Hoaglin, 1993).</a:t>
+              <a:t>Z-score modificado: lo mismo, pero robusto, medido desde la mediana (Iglewicz y Hoaglin, 1993).</a:t>
             </a:r>
           </a:p>
           <a:p>
@@ -9451,7 +9451,7 @@
                 </a:solidFill>
                 <a:latin typeface="Fira Sans"/>
               </a:rPr>
-              <a:t>Criterio del dominio: rangos de validez del problema. Un viaje de 22 horas en Santiago no es raro: es imposible. El más defendible.</a:t>
+              <a:t>Criterio del dominio: qué valores son posibles. El más defendible.</a:t>
             </a:r>
           </a:p>
           <a:p>
@@ -9479,7 +9479,7 @@
                 </a:solidFill>
                 <a:latin typeface="Fira Sans"/>
               </a:rPr>
-              <a:t>En modelos: residuos en regresión y detección de anomalías. Los veremos en las próximas clases; hoy bastan Tukey y el dominio.</a:t>
+              <a:t>Residuos de modelos y detección de anomalías: en las próximas clases.</a:t>
             </a:r>
           </a:p>
         </p:txBody>

</xml_diff>

<commit_message>
Clase 2: actualizar la diapo de la rubrica a los cinco criterios nuevos
Co-Authored-By: Claude Fable 5 <noreply@anthropic.com>
</commit_message>
<xml_diff>
--- a/presentaciones/clase02_eda_descriptiva.pptx
+++ b/presentaciones/clase02_eda_descriptiva.pptx
@@ -4396,7 +4396,7 @@
                 </a:solidFill>
                 <a:latin typeface="Fira Sans"/>
               </a:rPr>
-              <a:t>Se publica hoy la rúbrica, con seis criterios: problema (20 pts), datos y metadatos (20), estrategia de obtención (15), novedad (15), viabilidad técnica (15) e impacto esperado (15).</a:t>
+              <a:t>Se publica hoy la rúbrica, con cinco criterios: problema (25 pts), datos y metadatos (25), estrategia de obtención (15), viabilidad técnica (15), y novedad e impacto (20).</a:t>
             </a:r>
           </a:p>
           <a:p>
@@ -4424,7 +4424,7 @@
                 </a:solidFill>
                 <a:latin typeface="Fira Sans"/>
               </a:rPr>
-              <a:t>Documento de 2 a 3 páginas, un envío por equipo (máximo 2 personas), por el aula virtual.</a:t>
+              <a:t>El impacto se evalúa como uso esperado, no como efecto medido.</a:t>
             </a:r>
           </a:p>
           <a:p>
@@ -4446,13 +4446,13 @@
               <a:t>▸ </a:t>
             </a:r>
             <a:r>
-              <a:rPr sz="1800" b="1">
-                <a:solidFill>
-                  <a:srgbClr val="1D3557"/>
-                </a:solidFill>
-                <a:latin typeface="Fira Sans"/>
-              </a:rPr>
-              <a:t>Entrega: lunes 7 de septiembre. Presentación breve de la idea: jueves 3, con retroalimentación y sin nota.</a:t>
+              <a:rPr sz="1800" b="0">
+                <a:solidFill>
+                  <a:srgbClr val="000000"/>
+                </a:solidFill>
+                <a:latin typeface="Fira Sans"/>
+              </a:rPr>
+              <a:t>Documento de 2 a 3 páginas, un envío por equipo (máximo 2 personas), por el aula virtual.</a:t>
             </a:r>
           </a:p>
           <a:p>
@@ -4474,13 +4474,41 @@
               <a:t>▸ </a:t>
             </a:r>
             <a:r>
+              <a:rPr sz="1800" b="1">
+                <a:solidFill>
+                  <a:srgbClr val="1D3557"/>
+                </a:solidFill>
+                <a:latin typeface="Fira Sans"/>
+              </a:rPr>
+              <a:t>Entrega: lunes 7 de septiembre. Presentación breve de la idea: jueves 3, con retroalimentación y sin nota.</a:t>
+            </a:r>
+          </a:p>
+          <a:p>
+            <a:pPr>
+              <a:lnSpc>
+                <a:spcPct val="112000"/>
+              </a:lnSpc>
+              <a:spcAft>
+                <a:spcPts val="900"/>
+              </a:spcAft>
+            </a:pPr>
+            <a:r>
+              <a:rPr sz="1800" b="1">
+                <a:solidFill>
+                  <a:srgbClr val="E0A437"/>
+                </a:solidFill>
+                <a:latin typeface="Fira Sans"/>
+              </a:rPr>
+              <a:t>▸ </a:t>
+            </a:r>
+            <a:r>
               <a:rPr sz="1800" b="0">
                 <a:solidFill>
                   <a:srgbClr val="000000"/>
                 </a:solidFill>
                 <a:latin typeface="Fira Sans"/>
               </a:rPr>
-              <a:t>Quienes no usen datos de su trabajo pueden partir de la lista de datos sugeridos del repositorio.</a:t>
+              <a:t>Datos del trabajo o públicos valen igual; hay ideas de datos en el repositorio.</a:t>
             </a:r>
           </a:p>
         </p:txBody>

</xml_diff>